<commit_message>
future: add consent-gated AI summary and SMS reminders
Co-authored-by: Copilot <223556219+Copilot@users.noreply.github.com>
</commit_message>
<xml_diff>
--- a/docs/project-presentation.pptx
+++ b/docs/project-presentation.pptx
@@ -141,7 +141,7 @@
           <p:cNvPr id="2" name="Tiêu đề 1">
             <a:extLst>
               <a:ext uri="{FF2B5EF4-FFF2-40B4-BE49-F238E27FC236}">
-                <a16:creationId xmlns:a16="http://schemas.microsoft.com/office/drawing/2014/main" id="{CD001FDB-46BD-191D-0949-4A9D8F2CAA50}"/>
+                <a16:creationId xmlns:a16="http://schemas.microsoft.com/office/drawing/2014/main" id="{047B60B9-1780-EFAD-CC0C-76B3EF1EEF16}"/>
               </a:ext>
             </a:extLst>
           </p:cNvPr>
@@ -178,7 +178,7 @@
           <p:cNvPr id="3" name="Tiêu đề phụ 2">
             <a:extLst>
               <a:ext uri="{FF2B5EF4-FFF2-40B4-BE49-F238E27FC236}">
-                <a16:creationId xmlns:a16="http://schemas.microsoft.com/office/drawing/2014/main" id="{21A968AF-0D25-2541-9C8B-C02765562A27}"/>
+                <a16:creationId xmlns:a16="http://schemas.microsoft.com/office/drawing/2014/main" id="{0B2840CE-26AA-289D-6E7A-BEDE590572AB}"/>
               </a:ext>
             </a:extLst>
           </p:cNvPr>
@@ -248,7 +248,7 @@
           <p:cNvPr id="4" name="Chỗ dành sẵn cho Ngày tháng 3">
             <a:extLst>
               <a:ext uri="{FF2B5EF4-FFF2-40B4-BE49-F238E27FC236}">
-                <a16:creationId xmlns:a16="http://schemas.microsoft.com/office/drawing/2014/main" id="{FC2457FD-6C30-3D1F-0D9D-DCC2B0892E7D}"/>
+                <a16:creationId xmlns:a16="http://schemas.microsoft.com/office/drawing/2014/main" id="{05C90F22-CF3D-9EF8-A64F-DE878F6CDCC3}"/>
               </a:ext>
             </a:extLst>
           </p:cNvPr>
@@ -264,7 +264,7 @@
           <a:bodyPr/>
           <a:lstStyle/>
           <a:p>
-            <a:fld id="{BE4967DC-81E8-40D5-81A8-0D625F75E3D3}" type="datetimeFigureOut">
+            <a:fld id="{88986470-4349-47FE-9583-3F8A6EA241D7}" type="datetimeFigureOut">
               <a:rPr lang="vi-VN" smtClean="0"/>
               <a:t>18/10/2026</a:t>
             </a:fld>
@@ -277,7 +277,7 @@
           <p:cNvPr id="5" name="Chỗ dành sẵn cho Chân trang 4">
             <a:extLst>
               <a:ext uri="{FF2B5EF4-FFF2-40B4-BE49-F238E27FC236}">
-                <a16:creationId xmlns:a16="http://schemas.microsoft.com/office/drawing/2014/main" id="{A0A315AD-95C3-0681-4702-DE25629DADF7}"/>
+                <a16:creationId xmlns:a16="http://schemas.microsoft.com/office/drawing/2014/main" id="{69272B15-48A6-EE84-3493-4419C9687153}"/>
               </a:ext>
             </a:extLst>
           </p:cNvPr>
@@ -302,7 +302,7 @@
           <p:cNvPr id="6" name="Chỗ dành sẵn cho Số hiệu Bản chiếu 5">
             <a:extLst>
               <a:ext uri="{FF2B5EF4-FFF2-40B4-BE49-F238E27FC236}">
-                <a16:creationId xmlns:a16="http://schemas.microsoft.com/office/drawing/2014/main" id="{DF9D7B09-35F3-08DC-58BF-32D9F8C8DFEC}"/>
+                <a16:creationId xmlns:a16="http://schemas.microsoft.com/office/drawing/2014/main" id="{C2D1BDA4-B6FE-1DE2-F99B-A438E6649533}"/>
               </a:ext>
             </a:extLst>
           </p:cNvPr>
@@ -318,7 +318,7 @@
           <a:bodyPr/>
           <a:lstStyle/>
           <a:p>
-            <a:fld id="{3F5F16BE-67EA-4F6D-86FE-98E4BE054E9B}" type="slidenum">
+            <a:fld id="{01D1AEF7-2044-4839-8C56-918BADCD9CB9}" type="slidenum">
               <a:rPr lang="vi-VN" smtClean="0"/>
               <a:t>‹#›</a:t>
             </a:fld>
@@ -329,7 +329,7 @@
     </p:spTree>
     <p:extLst>
       <p:ext uri="{BB962C8B-B14F-4D97-AF65-F5344CB8AC3E}">
-        <p14:creationId xmlns:p14="http://schemas.microsoft.com/office/powerpoint/2010/main" val="3467537798"/>
+        <p14:creationId xmlns:p14="http://schemas.microsoft.com/office/powerpoint/2010/main" val="1056873217"/>
       </p:ext>
     </p:extLst>
   </p:cSld>
@@ -361,7 +361,7 @@
           <p:cNvPr id="2" name="Tiêu đề 1">
             <a:extLst>
               <a:ext uri="{FF2B5EF4-FFF2-40B4-BE49-F238E27FC236}">
-                <a16:creationId xmlns:a16="http://schemas.microsoft.com/office/drawing/2014/main" id="{8304DB3A-16C2-04FD-0088-D895E362C458}"/>
+                <a16:creationId xmlns:a16="http://schemas.microsoft.com/office/drawing/2014/main" id="{ACE9BF3E-1005-CBA6-1F8B-25A6A8D1FE26}"/>
               </a:ext>
             </a:extLst>
           </p:cNvPr>
@@ -389,7 +389,7 @@
           <p:cNvPr id="3" name="Chỗ dành sẵn cho Văn bản Dọc 2">
             <a:extLst>
               <a:ext uri="{FF2B5EF4-FFF2-40B4-BE49-F238E27FC236}">
-                <a16:creationId xmlns:a16="http://schemas.microsoft.com/office/drawing/2014/main" id="{2E5C9E8B-066F-DE93-DA30-FF1A1881DC9E}"/>
+                <a16:creationId xmlns:a16="http://schemas.microsoft.com/office/drawing/2014/main" id="{8246C1E6-A1B2-D655-84C2-615BD02BF374}"/>
               </a:ext>
             </a:extLst>
           </p:cNvPr>
@@ -446,7 +446,7 @@
           <p:cNvPr id="4" name="Chỗ dành sẵn cho Ngày tháng 3">
             <a:extLst>
               <a:ext uri="{FF2B5EF4-FFF2-40B4-BE49-F238E27FC236}">
-                <a16:creationId xmlns:a16="http://schemas.microsoft.com/office/drawing/2014/main" id="{45D3D5E5-6199-0AE9-D607-5A15BC59DF26}"/>
+                <a16:creationId xmlns:a16="http://schemas.microsoft.com/office/drawing/2014/main" id="{3D1C91B2-7FBD-C7F4-3A1A-E1B48B34CB51}"/>
               </a:ext>
             </a:extLst>
           </p:cNvPr>
@@ -462,7 +462,7 @@
           <a:bodyPr/>
           <a:lstStyle/>
           <a:p>
-            <a:fld id="{BE4967DC-81E8-40D5-81A8-0D625F75E3D3}" type="datetimeFigureOut">
+            <a:fld id="{88986470-4349-47FE-9583-3F8A6EA241D7}" type="datetimeFigureOut">
               <a:rPr lang="vi-VN" smtClean="0"/>
               <a:t>18/10/2026</a:t>
             </a:fld>
@@ -475,7 +475,7 @@
           <p:cNvPr id="5" name="Chỗ dành sẵn cho Chân trang 4">
             <a:extLst>
               <a:ext uri="{FF2B5EF4-FFF2-40B4-BE49-F238E27FC236}">
-                <a16:creationId xmlns:a16="http://schemas.microsoft.com/office/drawing/2014/main" id="{2C302B96-13EB-889A-135B-393724ABB700}"/>
+                <a16:creationId xmlns:a16="http://schemas.microsoft.com/office/drawing/2014/main" id="{A92368BA-CBC0-F6E9-9002-83D11859E4B1}"/>
               </a:ext>
             </a:extLst>
           </p:cNvPr>
@@ -500,7 +500,7 @@
           <p:cNvPr id="6" name="Chỗ dành sẵn cho Số hiệu Bản chiếu 5">
             <a:extLst>
               <a:ext uri="{FF2B5EF4-FFF2-40B4-BE49-F238E27FC236}">
-                <a16:creationId xmlns:a16="http://schemas.microsoft.com/office/drawing/2014/main" id="{D5DF589F-79C8-0B3F-D0D1-9066449232E9}"/>
+                <a16:creationId xmlns:a16="http://schemas.microsoft.com/office/drawing/2014/main" id="{E006AF5B-DCFE-C57A-C810-4620AE60A349}"/>
               </a:ext>
             </a:extLst>
           </p:cNvPr>
@@ -516,7 +516,7 @@
           <a:bodyPr/>
           <a:lstStyle/>
           <a:p>
-            <a:fld id="{3F5F16BE-67EA-4F6D-86FE-98E4BE054E9B}" type="slidenum">
+            <a:fld id="{01D1AEF7-2044-4839-8C56-918BADCD9CB9}" type="slidenum">
               <a:rPr lang="vi-VN" smtClean="0"/>
               <a:t>‹#›</a:t>
             </a:fld>
@@ -527,7 +527,7 @@
     </p:spTree>
     <p:extLst>
       <p:ext uri="{BB962C8B-B14F-4D97-AF65-F5344CB8AC3E}">
-        <p14:creationId xmlns:p14="http://schemas.microsoft.com/office/powerpoint/2010/main" val="3378087920"/>
+        <p14:creationId xmlns:p14="http://schemas.microsoft.com/office/powerpoint/2010/main" val="406333280"/>
       </p:ext>
     </p:extLst>
   </p:cSld>
@@ -559,7 +559,7 @@
           <p:cNvPr id="2" name="Tiêu đề Dọc 1">
             <a:extLst>
               <a:ext uri="{FF2B5EF4-FFF2-40B4-BE49-F238E27FC236}">
-                <a16:creationId xmlns:a16="http://schemas.microsoft.com/office/drawing/2014/main" id="{87E17429-5A9C-A43C-72CD-D6E77D984013}"/>
+                <a16:creationId xmlns:a16="http://schemas.microsoft.com/office/drawing/2014/main" id="{14B92B92-A3D6-9694-49C7-3747E7CB4E3C}"/>
               </a:ext>
             </a:extLst>
           </p:cNvPr>
@@ -592,7 +592,7 @@
           <p:cNvPr id="3" name="Chỗ dành sẵn cho Văn bản Dọc 2">
             <a:extLst>
               <a:ext uri="{FF2B5EF4-FFF2-40B4-BE49-F238E27FC236}">
-                <a16:creationId xmlns:a16="http://schemas.microsoft.com/office/drawing/2014/main" id="{589C710B-4002-1CB1-DDE3-88E6BC431F14}"/>
+                <a16:creationId xmlns:a16="http://schemas.microsoft.com/office/drawing/2014/main" id="{F8E03225-D89F-41FD-78E7-F8617DB65DC8}"/>
               </a:ext>
             </a:extLst>
           </p:cNvPr>
@@ -654,7 +654,7 @@
           <p:cNvPr id="4" name="Chỗ dành sẵn cho Ngày tháng 3">
             <a:extLst>
               <a:ext uri="{FF2B5EF4-FFF2-40B4-BE49-F238E27FC236}">
-                <a16:creationId xmlns:a16="http://schemas.microsoft.com/office/drawing/2014/main" id="{9B1A4A7C-2244-5FE0-3243-1BC85D602AAC}"/>
+                <a16:creationId xmlns:a16="http://schemas.microsoft.com/office/drawing/2014/main" id="{2C961FC3-9C13-4146-4FC1-4E218EADEADB}"/>
               </a:ext>
             </a:extLst>
           </p:cNvPr>
@@ -670,7 +670,7 @@
           <a:bodyPr/>
           <a:lstStyle/>
           <a:p>
-            <a:fld id="{BE4967DC-81E8-40D5-81A8-0D625F75E3D3}" type="datetimeFigureOut">
+            <a:fld id="{88986470-4349-47FE-9583-3F8A6EA241D7}" type="datetimeFigureOut">
               <a:rPr lang="vi-VN" smtClean="0"/>
               <a:t>18/10/2026</a:t>
             </a:fld>
@@ -683,7 +683,7 @@
           <p:cNvPr id="5" name="Chỗ dành sẵn cho Chân trang 4">
             <a:extLst>
               <a:ext uri="{FF2B5EF4-FFF2-40B4-BE49-F238E27FC236}">
-                <a16:creationId xmlns:a16="http://schemas.microsoft.com/office/drawing/2014/main" id="{76CE6E8D-8448-A749-05F9-4913131A6411}"/>
+                <a16:creationId xmlns:a16="http://schemas.microsoft.com/office/drawing/2014/main" id="{1CDA6838-6544-C5DC-B6B3-FDACDD63E1E9}"/>
               </a:ext>
             </a:extLst>
           </p:cNvPr>
@@ -708,7 +708,7 @@
           <p:cNvPr id="6" name="Chỗ dành sẵn cho Số hiệu Bản chiếu 5">
             <a:extLst>
               <a:ext uri="{FF2B5EF4-FFF2-40B4-BE49-F238E27FC236}">
-                <a16:creationId xmlns:a16="http://schemas.microsoft.com/office/drawing/2014/main" id="{8392E8FC-66D8-0F36-767F-004C2B5E41BF}"/>
+                <a16:creationId xmlns:a16="http://schemas.microsoft.com/office/drawing/2014/main" id="{47E35A9C-713A-F6D1-23E2-D401293FDCF7}"/>
               </a:ext>
             </a:extLst>
           </p:cNvPr>
@@ -724,7 +724,7 @@
           <a:bodyPr/>
           <a:lstStyle/>
           <a:p>
-            <a:fld id="{3F5F16BE-67EA-4F6D-86FE-98E4BE054E9B}" type="slidenum">
+            <a:fld id="{01D1AEF7-2044-4839-8C56-918BADCD9CB9}" type="slidenum">
               <a:rPr lang="vi-VN" smtClean="0"/>
               <a:t>‹#›</a:t>
             </a:fld>
@@ -735,7 +735,7 @@
     </p:spTree>
     <p:extLst>
       <p:ext uri="{BB962C8B-B14F-4D97-AF65-F5344CB8AC3E}">
-        <p14:creationId xmlns:p14="http://schemas.microsoft.com/office/powerpoint/2010/main" val="3509317358"/>
+        <p14:creationId xmlns:p14="http://schemas.microsoft.com/office/powerpoint/2010/main" val="1160184589"/>
       </p:ext>
     </p:extLst>
   </p:cSld>
@@ -767,7 +767,7 @@
           <p:cNvPr id="2" name="Tiêu đề 1">
             <a:extLst>
               <a:ext uri="{FF2B5EF4-FFF2-40B4-BE49-F238E27FC236}">
-                <a16:creationId xmlns:a16="http://schemas.microsoft.com/office/drawing/2014/main" id="{2D9D4283-AF13-2AC6-AA3D-DF330FBAB348}"/>
+                <a16:creationId xmlns:a16="http://schemas.microsoft.com/office/drawing/2014/main" id="{325C4ACD-20D9-F63A-C501-D1DFABB8CAF4}"/>
               </a:ext>
             </a:extLst>
           </p:cNvPr>
@@ -795,7 +795,7 @@
           <p:cNvPr id="3" name="Chỗ dành sẵn cho Nội dung 2">
             <a:extLst>
               <a:ext uri="{FF2B5EF4-FFF2-40B4-BE49-F238E27FC236}">
-                <a16:creationId xmlns:a16="http://schemas.microsoft.com/office/drawing/2014/main" id="{99D53FA4-79F9-D31B-3C38-74055275897D}"/>
+                <a16:creationId xmlns:a16="http://schemas.microsoft.com/office/drawing/2014/main" id="{9B36183D-FB56-99AB-F3A9-32B11293A963}"/>
               </a:ext>
             </a:extLst>
           </p:cNvPr>
@@ -852,7 +852,7 @@
           <p:cNvPr id="4" name="Chỗ dành sẵn cho Ngày tháng 3">
             <a:extLst>
               <a:ext uri="{FF2B5EF4-FFF2-40B4-BE49-F238E27FC236}">
-                <a16:creationId xmlns:a16="http://schemas.microsoft.com/office/drawing/2014/main" id="{DA1BB85E-A5F7-0E40-94A0-09A28CE324B2}"/>
+                <a16:creationId xmlns:a16="http://schemas.microsoft.com/office/drawing/2014/main" id="{1CE1EBF3-D0E3-0584-F8B2-38BDA5E3353F}"/>
               </a:ext>
             </a:extLst>
           </p:cNvPr>
@@ -868,7 +868,7 @@
           <a:bodyPr/>
           <a:lstStyle/>
           <a:p>
-            <a:fld id="{BE4967DC-81E8-40D5-81A8-0D625F75E3D3}" type="datetimeFigureOut">
+            <a:fld id="{88986470-4349-47FE-9583-3F8A6EA241D7}" type="datetimeFigureOut">
               <a:rPr lang="vi-VN" smtClean="0"/>
               <a:t>18/10/2026</a:t>
             </a:fld>
@@ -881,7 +881,7 @@
           <p:cNvPr id="5" name="Chỗ dành sẵn cho Chân trang 4">
             <a:extLst>
               <a:ext uri="{FF2B5EF4-FFF2-40B4-BE49-F238E27FC236}">
-                <a16:creationId xmlns:a16="http://schemas.microsoft.com/office/drawing/2014/main" id="{F86CEAA0-2B84-ED40-0D41-DB1E26868AE6}"/>
+                <a16:creationId xmlns:a16="http://schemas.microsoft.com/office/drawing/2014/main" id="{9AF76373-ECEB-6529-AF7A-A6ADF8212162}"/>
               </a:ext>
             </a:extLst>
           </p:cNvPr>
@@ -906,7 +906,7 @@
           <p:cNvPr id="6" name="Chỗ dành sẵn cho Số hiệu Bản chiếu 5">
             <a:extLst>
               <a:ext uri="{FF2B5EF4-FFF2-40B4-BE49-F238E27FC236}">
-                <a16:creationId xmlns:a16="http://schemas.microsoft.com/office/drawing/2014/main" id="{5AAA929E-3223-C465-C742-F9AFEC267880}"/>
+                <a16:creationId xmlns:a16="http://schemas.microsoft.com/office/drawing/2014/main" id="{933DB131-04BD-2B62-38F5-35F6BD385C9E}"/>
               </a:ext>
             </a:extLst>
           </p:cNvPr>
@@ -922,7 +922,7 @@
           <a:bodyPr/>
           <a:lstStyle/>
           <a:p>
-            <a:fld id="{3F5F16BE-67EA-4F6D-86FE-98E4BE054E9B}" type="slidenum">
+            <a:fld id="{01D1AEF7-2044-4839-8C56-918BADCD9CB9}" type="slidenum">
               <a:rPr lang="vi-VN" smtClean="0"/>
               <a:t>‹#›</a:t>
             </a:fld>
@@ -933,7 +933,7 @@
     </p:spTree>
     <p:extLst>
       <p:ext uri="{BB962C8B-B14F-4D97-AF65-F5344CB8AC3E}">
-        <p14:creationId xmlns:p14="http://schemas.microsoft.com/office/powerpoint/2010/main" val="1152074821"/>
+        <p14:creationId xmlns:p14="http://schemas.microsoft.com/office/powerpoint/2010/main" val="3619412692"/>
       </p:ext>
     </p:extLst>
   </p:cSld>
@@ -965,7 +965,7 @@
           <p:cNvPr id="2" name="Tiêu đề 1">
             <a:extLst>
               <a:ext uri="{FF2B5EF4-FFF2-40B4-BE49-F238E27FC236}">
-                <a16:creationId xmlns:a16="http://schemas.microsoft.com/office/drawing/2014/main" id="{E47418DD-211B-8FC9-7039-636C8621CA9C}"/>
+                <a16:creationId xmlns:a16="http://schemas.microsoft.com/office/drawing/2014/main" id="{AF002784-8C25-FE3F-BA40-2A5705758374}"/>
               </a:ext>
             </a:extLst>
           </p:cNvPr>
@@ -1002,7 +1002,7 @@
           <p:cNvPr id="3" name="Chỗ dành sẵn cho Văn bản 2">
             <a:extLst>
               <a:ext uri="{FF2B5EF4-FFF2-40B4-BE49-F238E27FC236}">
-                <a16:creationId xmlns:a16="http://schemas.microsoft.com/office/drawing/2014/main" id="{CE5EAE09-1F95-D321-9712-D616FDBE90A2}"/>
+                <a16:creationId xmlns:a16="http://schemas.microsoft.com/office/drawing/2014/main" id="{AEB6BF32-26D1-BD27-12E4-4D14A3547F1F}"/>
               </a:ext>
             </a:extLst>
           </p:cNvPr>
@@ -1127,7 +1127,7 @@
           <p:cNvPr id="4" name="Chỗ dành sẵn cho Ngày tháng 3">
             <a:extLst>
               <a:ext uri="{FF2B5EF4-FFF2-40B4-BE49-F238E27FC236}">
-                <a16:creationId xmlns:a16="http://schemas.microsoft.com/office/drawing/2014/main" id="{05129345-BF79-5550-31A9-C2C2538F70FA}"/>
+                <a16:creationId xmlns:a16="http://schemas.microsoft.com/office/drawing/2014/main" id="{90C06895-752E-FD72-44B1-795B3326A6FB}"/>
               </a:ext>
             </a:extLst>
           </p:cNvPr>
@@ -1143,7 +1143,7 @@
           <a:bodyPr/>
           <a:lstStyle/>
           <a:p>
-            <a:fld id="{BE4967DC-81E8-40D5-81A8-0D625F75E3D3}" type="datetimeFigureOut">
+            <a:fld id="{88986470-4349-47FE-9583-3F8A6EA241D7}" type="datetimeFigureOut">
               <a:rPr lang="vi-VN" smtClean="0"/>
               <a:t>18/10/2026</a:t>
             </a:fld>
@@ -1156,7 +1156,7 @@
           <p:cNvPr id="5" name="Chỗ dành sẵn cho Chân trang 4">
             <a:extLst>
               <a:ext uri="{FF2B5EF4-FFF2-40B4-BE49-F238E27FC236}">
-                <a16:creationId xmlns:a16="http://schemas.microsoft.com/office/drawing/2014/main" id="{9C990D2B-B99C-49F5-9733-3C70D58136C2}"/>
+                <a16:creationId xmlns:a16="http://schemas.microsoft.com/office/drawing/2014/main" id="{6CE77149-5284-A5E4-79A1-288246AE54EF}"/>
               </a:ext>
             </a:extLst>
           </p:cNvPr>
@@ -1181,7 +1181,7 @@
           <p:cNvPr id="6" name="Chỗ dành sẵn cho Số hiệu Bản chiếu 5">
             <a:extLst>
               <a:ext uri="{FF2B5EF4-FFF2-40B4-BE49-F238E27FC236}">
-                <a16:creationId xmlns:a16="http://schemas.microsoft.com/office/drawing/2014/main" id="{03958576-5891-183A-59A5-1750EBE82B85}"/>
+                <a16:creationId xmlns:a16="http://schemas.microsoft.com/office/drawing/2014/main" id="{8972522D-F68B-6526-3C0D-4FC04009DEA1}"/>
               </a:ext>
             </a:extLst>
           </p:cNvPr>
@@ -1197,7 +1197,7 @@
           <a:bodyPr/>
           <a:lstStyle/>
           <a:p>
-            <a:fld id="{3F5F16BE-67EA-4F6D-86FE-98E4BE054E9B}" type="slidenum">
+            <a:fld id="{01D1AEF7-2044-4839-8C56-918BADCD9CB9}" type="slidenum">
               <a:rPr lang="vi-VN" smtClean="0"/>
               <a:t>‹#›</a:t>
             </a:fld>
@@ -1208,7 +1208,7 @@
     </p:spTree>
     <p:extLst>
       <p:ext uri="{BB962C8B-B14F-4D97-AF65-F5344CB8AC3E}">
-        <p14:creationId xmlns:p14="http://schemas.microsoft.com/office/powerpoint/2010/main" val="2009729052"/>
+        <p14:creationId xmlns:p14="http://schemas.microsoft.com/office/powerpoint/2010/main" val="1671780771"/>
       </p:ext>
     </p:extLst>
   </p:cSld>
@@ -1240,7 +1240,7 @@
           <p:cNvPr id="2" name="Tiêu đề 1">
             <a:extLst>
               <a:ext uri="{FF2B5EF4-FFF2-40B4-BE49-F238E27FC236}">
-                <a16:creationId xmlns:a16="http://schemas.microsoft.com/office/drawing/2014/main" id="{567F3A90-BAF5-7C0A-0A49-E1E277D4AE73}"/>
+                <a16:creationId xmlns:a16="http://schemas.microsoft.com/office/drawing/2014/main" id="{7E02C192-6E14-CEC4-4E3B-E7328908A4B6}"/>
               </a:ext>
             </a:extLst>
           </p:cNvPr>
@@ -1268,7 +1268,7 @@
           <p:cNvPr id="3" name="Chỗ dành sẵn cho Nội dung 2">
             <a:extLst>
               <a:ext uri="{FF2B5EF4-FFF2-40B4-BE49-F238E27FC236}">
-                <a16:creationId xmlns:a16="http://schemas.microsoft.com/office/drawing/2014/main" id="{1DC3C6D6-0966-2D3D-EBED-6A5FF8116A26}"/>
+                <a16:creationId xmlns:a16="http://schemas.microsoft.com/office/drawing/2014/main" id="{E2729160-1C22-4A03-3A4B-0F253A8B972A}"/>
               </a:ext>
             </a:extLst>
           </p:cNvPr>
@@ -1330,7 +1330,7 @@
           <p:cNvPr id="4" name="Chỗ dành sẵn cho Nội dung 3">
             <a:extLst>
               <a:ext uri="{FF2B5EF4-FFF2-40B4-BE49-F238E27FC236}">
-                <a16:creationId xmlns:a16="http://schemas.microsoft.com/office/drawing/2014/main" id="{316094C3-A8A7-2A69-230E-AC47EFB6D254}"/>
+                <a16:creationId xmlns:a16="http://schemas.microsoft.com/office/drawing/2014/main" id="{6A12CCBA-B2D9-0F51-B98D-B186F4656DB8}"/>
               </a:ext>
             </a:extLst>
           </p:cNvPr>
@@ -1392,7 +1392,7 @@
           <p:cNvPr id="5" name="Chỗ dành sẵn cho Ngày tháng 4">
             <a:extLst>
               <a:ext uri="{FF2B5EF4-FFF2-40B4-BE49-F238E27FC236}">
-                <a16:creationId xmlns:a16="http://schemas.microsoft.com/office/drawing/2014/main" id="{C3B048AC-D3D9-111B-0816-C5D13A49AE90}"/>
+                <a16:creationId xmlns:a16="http://schemas.microsoft.com/office/drawing/2014/main" id="{273CA9D0-622C-057C-AE88-960728A33F0D}"/>
               </a:ext>
             </a:extLst>
           </p:cNvPr>
@@ -1408,7 +1408,7 @@
           <a:bodyPr/>
           <a:lstStyle/>
           <a:p>
-            <a:fld id="{BE4967DC-81E8-40D5-81A8-0D625F75E3D3}" type="datetimeFigureOut">
+            <a:fld id="{88986470-4349-47FE-9583-3F8A6EA241D7}" type="datetimeFigureOut">
               <a:rPr lang="vi-VN" smtClean="0"/>
               <a:t>18/10/2026</a:t>
             </a:fld>
@@ -1421,7 +1421,7 @@
           <p:cNvPr id="6" name="Chỗ dành sẵn cho Chân trang 5">
             <a:extLst>
               <a:ext uri="{FF2B5EF4-FFF2-40B4-BE49-F238E27FC236}">
-                <a16:creationId xmlns:a16="http://schemas.microsoft.com/office/drawing/2014/main" id="{553B44EF-8914-89A5-884D-D0CD1D0A7797}"/>
+                <a16:creationId xmlns:a16="http://schemas.microsoft.com/office/drawing/2014/main" id="{A571B3F3-31ED-51D8-85FE-689383DB5A83}"/>
               </a:ext>
             </a:extLst>
           </p:cNvPr>
@@ -1446,7 +1446,7 @@
           <p:cNvPr id="7" name="Chỗ dành sẵn cho Số hiệu Bản chiếu 6">
             <a:extLst>
               <a:ext uri="{FF2B5EF4-FFF2-40B4-BE49-F238E27FC236}">
-                <a16:creationId xmlns:a16="http://schemas.microsoft.com/office/drawing/2014/main" id="{31BD9353-95FC-6359-C327-E212E033E1A5}"/>
+                <a16:creationId xmlns:a16="http://schemas.microsoft.com/office/drawing/2014/main" id="{4F17399C-1FAD-41E3-898A-DD4E756C8666}"/>
               </a:ext>
             </a:extLst>
           </p:cNvPr>
@@ -1462,7 +1462,7 @@
           <a:bodyPr/>
           <a:lstStyle/>
           <a:p>
-            <a:fld id="{3F5F16BE-67EA-4F6D-86FE-98E4BE054E9B}" type="slidenum">
+            <a:fld id="{01D1AEF7-2044-4839-8C56-918BADCD9CB9}" type="slidenum">
               <a:rPr lang="vi-VN" smtClean="0"/>
               <a:t>‹#›</a:t>
             </a:fld>
@@ -1473,7 +1473,7 @@
     </p:spTree>
     <p:extLst>
       <p:ext uri="{BB962C8B-B14F-4D97-AF65-F5344CB8AC3E}">
-        <p14:creationId xmlns:p14="http://schemas.microsoft.com/office/powerpoint/2010/main" val="223324838"/>
+        <p14:creationId xmlns:p14="http://schemas.microsoft.com/office/powerpoint/2010/main" val="576490803"/>
       </p:ext>
     </p:extLst>
   </p:cSld>
@@ -1505,7 +1505,7 @@
           <p:cNvPr id="2" name="Tiêu đề 1">
             <a:extLst>
               <a:ext uri="{FF2B5EF4-FFF2-40B4-BE49-F238E27FC236}">
-                <a16:creationId xmlns:a16="http://schemas.microsoft.com/office/drawing/2014/main" id="{26C20588-04CF-C67D-2E95-80BE03CDD275}"/>
+                <a16:creationId xmlns:a16="http://schemas.microsoft.com/office/drawing/2014/main" id="{43D59D18-8ADE-0565-33F0-3520958226BA}"/>
               </a:ext>
             </a:extLst>
           </p:cNvPr>
@@ -1538,7 +1538,7 @@
           <p:cNvPr id="3" name="Chỗ dành sẵn cho Văn bản 2">
             <a:extLst>
               <a:ext uri="{FF2B5EF4-FFF2-40B4-BE49-F238E27FC236}">
-                <a16:creationId xmlns:a16="http://schemas.microsoft.com/office/drawing/2014/main" id="{7A206C37-B696-557F-3B61-3FE047F519D4}"/>
+                <a16:creationId xmlns:a16="http://schemas.microsoft.com/office/drawing/2014/main" id="{C93B0984-F3DE-4481-FDCF-BCDC2F88D53C}"/>
               </a:ext>
             </a:extLst>
           </p:cNvPr>
@@ -1609,7 +1609,7 @@
           <p:cNvPr id="4" name="Chỗ dành sẵn cho Nội dung 3">
             <a:extLst>
               <a:ext uri="{FF2B5EF4-FFF2-40B4-BE49-F238E27FC236}">
-                <a16:creationId xmlns:a16="http://schemas.microsoft.com/office/drawing/2014/main" id="{157121A1-0101-D248-091E-FAF4270472AC}"/>
+                <a16:creationId xmlns:a16="http://schemas.microsoft.com/office/drawing/2014/main" id="{73D867AE-9BF9-6CC2-07B7-E4238671585A}"/>
               </a:ext>
             </a:extLst>
           </p:cNvPr>
@@ -1671,7 +1671,7 @@
           <p:cNvPr id="5" name="Chỗ dành sẵn cho Văn bản 4">
             <a:extLst>
               <a:ext uri="{FF2B5EF4-FFF2-40B4-BE49-F238E27FC236}">
-                <a16:creationId xmlns:a16="http://schemas.microsoft.com/office/drawing/2014/main" id="{21B56859-7205-2881-B62F-456B40686721}"/>
+                <a16:creationId xmlns:a16="http://schemas.microsoft.com/office/drawing/2014/main" id="{EF75A8A5-BD24-A88F-7663-A3002785FCA5}"/>
               </a:ext>
             </a:extLst>
           </p:cNvPr>
@@ -1742,7 +1742,7 @@
           <p:cNvPr id="6" name="Chỗ dành sẵn cho Nội dung 5">
             <a:extLst>
               <a:ext uri="{FF2B5EF4-FFF2-40B4-BE49-F238E27FC236}">
-                <a16:creationId xmlns:a16="http://schemas.microsoft.com/office/drawing/2014/main" id="{29AF2355-BBF8-2B62-5BCE-08486E05DBE7}"/>
+                <a16:creationId xmlns:a16="http://schemas.microsoft.com/office/drawing/2014/main" id="{5E64F6E4-01E5-2499-CE65-87C1C3016868}"/>
               </a:ext>
             </a:extLst>
           </p:cNvPr>
@@ -1804,7 +1804,7 @@
           <p:cNvPr id="7" name="Chỗ dành sẵn cho Ngày tháng 6">
             <a:extLst>
               <a:ext uri="{FF2B5EF4-FFF2-40B4-BE49-F238E27FC236}">
-                <a16:creationId xmlns:a16="http://schemas.microsoft.com/office/drawing/2014/main" id="{02E45D68-D369-1A14-CC78-158C53F3495C}"/>
+                <a16:creationId xmlns:a16="http://schemas.microsoft.com/office/drawing/2014/main" id="{F85BFA5A-A9A3-3F26-DCDD-FC8096C7149C}"/>
               </a:ext>
             </a:extLst>
           </p:cNvPr>
@@ -1820,7 +1820,7 @@
           <a:bodyPr/>
           <a:lstStyle/>
           <a:p>
-            <a:fld id="{BE4967DC-81E8-40D5-81A8-0D625F75E3D3}" type="datetimeFigureOut">
+            <a:fld id="{88986470-4349-47FE-9583-3F8A6EA241D7}" type="datetimeFigureOut">
               <a:rPr lang="vi-VN" smtClean="0"/>
               <a:t>18/10/2026</a:t>
             </a:fld>
@@ -1833,7 +1833,7 @@
           <p:cNvPr id="8" name="Chỗ dành sẵn cho Chân trang 7">
             <a:extLst>
               <a:ext uri="{FF2B5EF4-FFF2-40B4-BE49-F238E27FC236}">
-                <a16:creationId xmlns:a16="http://schemas.microsoft.com/office/drawing/2014/main" id="{E3F6AF7A-73DA-3ADC-C3ED-A34C5FAC302F}"/>
+                <a16:creationId xmlns:a16="http://schemas.microsoft.com/office/drawing/2014/main" id="{79B7E381-DEF3-D5A2-1B8A-4198A49AD3BC}"/>
               </a:ext>
             </a:extLst>
           </p:cNvPr>
@@ -1858,7 +1858,7 @@
           <p:cNvPr id="9" name="Chỗ dành sẵn cho Số hiệu Bản chiếu 8">
             <a:extLst>
               <a:ext uri="{FF2B5EF4-FFF2-40B4-BE49-F238E27FC236}">
-                <a16:creationId xmlns:a16="http://schemas.microsoft.com/office/drawing/2014/main" id="{227562EA-D8FF-5BCC-ECB7-189221BD8812}"/>
+                <a16:creationId xmlns:a16="http://schemas.microsoft.com/office/drawing/2014/main" id="{FD84674E-EDAF-AAE9-562C-4C8A7274C8B5}"/>
               </a:ext>
             </a:extLst>
           </p:cNvPr>
@@ -1874,7 +1874,7 @@
           <a:bodyPr/>
           <a:lstStyle/>
           <a:p>
-            <a:fld id="{3F5F16BE-67EA-4F6D-86FE-98E4BE054E9B}" type="slidenum">
+            <a:fld id="{01D1AEF7-2044-4839-8C56-918BADCD9CB9}" type="slidenum">
               <a:rPr lang="vi-VN" smtClean="0"/>
               <a:t>‹#›</a:t>
             </a:fld>
@@ -1885,7 +1885,7 @@
     </p:spTree>
     <p:extLst>
       <p:ext uri="{BB962C8B-B14F-4D97-AF65-F5344CB8AC3E}">
-        <p14:creationId xmlns:p14="http://schemas.microsoft.com/office/powerpoint/2010/main" val="2499014645"/>
+        <p14:creationId xmlns:p14="http://schemas.microsoft.com/office/powerpoint/2010/main" val="3964253664"/>
       </p:ext>
     </p:extLst>
   </p:cSld>
@@ -1917,7 +1917,7 @@
           <p:cNvPr id="2" name="Tiêu đề 1">
             <a:extLst>
               <a:ext uri="{FF2B5EF4-FFF2-40B4-BE49-F238E27FC236}">
-                <a16:creationId xmlns:a16="http://schemas.microsoft.com/office/drawing/2014/main" id="{14C4C4EC-D9F4-7E6A-D076-C1768CC853B3}"/>
+                <a16:creationId xmlns:a16="http://schemas.microsoft.com/office/drawing/2014/main" id="{E9D4150D-CB0E-3AE1-3AF4-E314B8F34AD4}"/>
               </a:ext>
             </a:extLst>
           </p:cNvPr>
@@ -1945,7 +1945,7 @@
           <p:cNvPr id="3" name="Chỗ dành sẵn cho Ngày tháng 2">
             <a:extLst>
               <a:ext uri="{FF2B5EF4-FFF2-40B4-BE49-F238E27FC236}">
-                <a16:creationId xmlns:a16="http://schemas.microsoft.com/office/drawing/2014/main" id="{2E0048A7-508A-EAA6-55DA-CCD3072FD9AA}"/>
+                <a16:creationId xmlns:a16="http://schemas.microsoft.com/office/drawing/2014/main" id="{685D4C9E-DE78-27CF-5561-657DA0142DD8}"/>
               </a:ext>
             </a:extLst>
           </p:cNvPr>
@@ -1961,7 +1961,7 @@
           <a:bodyPr/>
           <a:lstStyle/>
           <a:p>
-            <a:fld id="{BE4967DC-81E8-40D5-81A8-0D625F75E3D3}" type="datetimeFigureOut">
+            <a:fld id="{88986470-4349-47FE-9583-3F8A6EA241D7}" type="datetimeFigureOut">
               <a:rPr lang="vi-VN" smtClean="0"/>
               <a:t>18/10/2026</a:t>
             </a:fld>
@@ -1974,7 +1974,7 @@
           <p:cNvPr id="4" name="Chỗ dành sẵn cho Chân trang 3">
             <a:extLst>
               <a:ext uri="{FF2B5EF4-FFF2-40B4-BE49-F238E27FC236}">
-                <a16:creationId xmlns:a16="http://schemas.microsoft.com/office/drawing/2014/main" id="{6C05CD6C-9EDB-25CF-68E2-080864660DFF}"/>
+                <a16:creationId xmlns:a16="http://schemas.microsoft.com/office/drawing/2014/main" id="{09C58AC0-F038-9373-82E3-938FD721A706}"/>
               </a:ext>
             </a:extLst>
           </p:cNvPr>
@@ -1999,7 +1999,7 @@
           <p:cNvPr id="5" name="Chỗ dành sẵn cho Số hiệu Bản chiếu 4">
             <a:extLst>
               <a:ext uri="{FF2B5EF4-FFF2-40B4-BE49-F238E27FC236}">
-                <a16:creationId xmlns:a16="http://schemas.microsoft.com/office/drawing/2014/main" id="{5F49CF0F-9B9D-180F-DDA7-3FBE82D018CA}"/>
+                <a16:creationId xmlns:a16="http://schemas.microsoft.com/office/drawing/2014/main" id="{BB61D831-E51F-2764-1F3A-7C27E71F69D4}"/>
               </a:ext>
             </a:extLst>
           </p:cNvPr>
@@ -2015,7 +2015,7 @@
           <a:bodyPr/>
           <a:lstStyle/>
           <a:p>
-            <a:fld id="{3F5F16BE-67EA-4F6D-86FE-98E4BE054E9B}" type="slidenum">
+            <a:fld id="{01D1AEF7-2044-4839-8C56-918BADCD9CB9}" type="slidenum">
               <a:rPr lang="vi-VN" smtClean="0"/>
               <a:t>‹#›</a:t>
             </a:fld>
@@ -2026,7 +2026,7 @@
     </p:spTree>
     <p:extLst>
       <p:ext uri="{BB962C8B-B14F-4D97-AF65-F5344CB8AC3E}">
-        <p14:creationId xmlns:p14="http://schemas.microsoft.com/office/powerpoint/2010/main" val="164960501"/>
+        <p14:creationId xmlns:p14="http://schemas.microsoft.com/office/powerpoint/2010/main" val="923588217"/>
       </p:ext>
     </p:extLst>
   </p:cSld>
@@ -2058,7 +2058,7 @@
           <p:cNvPr id="2" name="Chỗ dành sẵn cho Ngày tháng 1">
             <a:extLst>
               <a:ext uri="{FF2B5EF4-FFF2-40B4-BE49-F238E27FC236}">
-                <a16:creationId xmlns:a16="http://schemas.microsoft.com/office/drawing/2014/main" id="{D12076FE-E3AC-B0F2-ADEB-E6597A5F55BA}"/>
+                <a16:creationId xmlns:a16="http://schemas.microsoft.com/office/drawing/2014/main" id="{CF988EB6-F185-421B-F2EA-F795B570103C}"/>
               </a:ext>
             </a:extLst>
           </p:cNvPr>
@@ -2074,7 +2074,7 @@
           <a:bodyPr/>
           <a:lstStyle/>
           <a:p>
-            <a:fld id="{BE4967DC-81E8-40D5-81A8-0D625F75E3D3}" type="datetimeFigureOut">
+            <a:fld id="{88986470-4349-47FE-9583-3F8A6EA241D7}" type="datetimeFigureOut">
               <a:rPr lang="vi-VN" smtClean="0"/>
               <a:t>18/10/2026</a:t>
             </a:fld>
@@ -2087,7 +2087,7 @@
           <p:cNvPr id="3" name="Chỗ dành sẵn cho Chân trang 2">
             <a:extLst>
               <a:ext uri="{FF2B5EF4-FFF2-40B4-BE49-F238E27FC236}">
-                <a16:creationId xmlns:a16="http://schemas.microsoft.com/office/drawing/2014/main" id="{7AAF4438-CEA0-4987-F9D0-D0C536DA8E85}"/>
+                <a16:creationId xmlns:a16="http://schemas.microsoft.com/office/drawing/2014/main" id="{E1AF201E-E6AF-87B0-E4B4-523381386E2F}"/>
               </a:ext>
             </a:extLst>
           </p:cNvPr>
@@ -2112,7 +2112,7 @@
           <p:cNvPr id="4" name="Chỗ dành sẵn cho Số hiệu Bản chiếu 3">
             <a:extLst>
               <a:ext uri="{FF2B5EF4-FFF2-40B4-BE49-F238E27FC236}">
-                <a16:creationId xmlns:a16="http://schemas.microsoft.com/office/drawing/2014/main" id="{3847BADD-1BE9-7DB8-3E0D-B66DC613AA66}"/>
+                <a16:creationId xmlns:a16="http://schemas.microsoft.com/office/drawing/2014/main" id="{3F38D755-1DCC-1373-F7C0-22BD5F93B049}"/>
               </a:ext>
             </a:extLst>
           </p:cNvPr>
@@ -2128,7 +2128,7 @@
           <a:bodyPr/>
           <a:lstStyle/>
           <a:p>
-            <a:fld id="{3F5F16BE-67EA-4F6D-86FE-98E4BE054E9B}" type="slidenum">
+            <a:fld id="{01D1AEF7-2044-4839-8C56-918BADCD9CB9}" type="slidenum">
               <a:rPr lang="vi-VN" smtClean="0"/>
               <a:t>‹#›</a:t>
             </a:fld>
@@ -2139,7 +2139,7 @@
     </p:spTree>
     <p:extLst>
       <p:ext uri="{BB962C8B-B14F-4D97-AF65-F5344CB8AC3E}">
-        <p14:creationId xmlns:p14="http://schemas.microsoft.com/office/powerpoint/2010/main" val="693919528"/>
+        <p14:creationId xmlns:p14="http://schemas.microsoft.com/office/powerpoint/2010/main" val="1813543002"/>
       </p:ext>
     </p:extLst>
   </p:cSld>
@@ -2171,7 +2171,7 @@
           <p:cNvPr id="2" name="Tiêu đề 1">
             <a:extLst>
               <a:ext uri="{FF2B5EF4-FFF2-40B4-BE49-F238E27FC236}">
-                <a16:creationId xmlns:a16="http://schemas.microsoft.com/office/drawing/2014/main" id="{948F47CC-ABA4-69AA-406A-91FE3D47457D}"/>
+                <a16:creationId xmlns:a16="http://schemas.microsoft.com/office/drawing/2014/main" id="{F961A397-83C0-33A0-3A2A-91B6523CDEB9}"/>
               </a:ext>
             </a:extLst>
           </p:cNvPr>
@@ -2208,7 +2208,7 @@
           <p:cNvPr id="3" name="Chỗ dành sẵn cho Nội dung 2">
             <a:extLst>
               <a:ext uri="{FF2B5EF4-FFF2-40B4-BE49-F238E27FC236}">
-                <a16:creationId xmlns:a16="http://schemas.microsoft.com/office/drawing/2014/main" id="{A5AF1DAA-BA0A-87AB-5300-38B277D7B9C8}"/>
+                <a16:creationId xmlns:a16="http://schemas.microsoft.com/office/drawing/2014/main" id="{36487D19-3AE0-AC54-6BEA-E56CE4088061}"/>
               </a:ext>
             </a:extLst>
           </p:cNvPr>
@@ -2298,7 +2298,7 @@
           <p:cNvPr id="4" name="Chỗ dành sẵn cho Văn bản 3">
             <a:extLst>
               <a:ext uri="{FF2B5EF4-FFF2-40B4-BE49-F238E27FC236}">
-                <a16:creationId xmlns:a16="http://schemas.microsoft.com/office/drawing/2014/main" id="{758B002D-0343-380B-1812-25163710CA25}"/>
+                <a16:creationId xmlns:a16="http://schemas.microsoft.com/office/drawing/2014/main" id="{738345E5-1939-CC40-456B-9CAB9FEBEDF0}"/>
               </a:ext>
             </a:extLst>
           </p:cNvPr>
@@ -2369,7 +2369,7 @@
           <p:cNvPr id="5" name="Chỗ dành sẵn cho Ngày tháng 4">
             <a:extLst>
               <a:ext uri="{FF2B5EF4-FFF2-40B4-BE49-F238E27FC236}">
-                <a16:creationId xmlns:a16="http://schemas.microsoft.com/office/drawing/2014/main" id="{7890C21F-C65D-CF35-C762-A7B9224E903E}"/>
+                <a16:creationId xmlns:a16="http://schemas.microsoft.com/office/drawing/2014/main" id="{C34CA9A1-0E0A-8D4E-06CB-BA66461C75AB}"/>
               </a:ext>
             </a:extLst>
           </p:cNvPr>
@@ -2385,7 +2385,7 @@
           <a:bodyPr/>
           <a:lstStyle/>
           <a:p>
-            <a:fld id="{BE4967DC-81E8-40D5-81A8-0D625F75E3D3}" type="datetimeFigureOut">
+            <a:fld id="{88986470-4349-47FE-9583-3F8A6EA241D7}" type="datetimeFigureOut">
               <a:rPr lang="vi-VN" smtClean="0"/>
               <a:t>18/10/2026</a:t>
             </a:fld>
@@ -2398,7 +2398,7 @@
           <p:cNvPr id="6" name="Chỗ dành sẵn cho Chân trang 5">
             <a:extLst>
               <a:ext uri="{FF2B5EF4-FFF2-40B4-BE49-F238E27FC236}">
-                <a16:creationId xmlns:a16="http://schemas.microsoft.com/office/drawing/2014/main" id="{A0A54780-AC09-67CA-8A03-C1D85523E44B}"/>
+                <a16:creationId xmlns:a16="http://schemas.microsoft.com/office/drawing/2014/main" id="{75B98C8C-E64F-16D7-8D14-B81CE7DE6A86}"/>
               </a:ext>
             </a:extLst>
           </p:cNvPr>
@@ -2423,7 +2423,7 @@
           <p:cNvPr id="7" name="Chỗ dành sẵn cho Số hiệu Bản chiếu 6">
             <a:extLst>
               <a:ext uri="{FF2B5EF4-FFF2-40B4-BE49-F238E27FC236}">
-                <a16:creationId xmlns:a16="http://schemas.microsoft.com/office/drawing/2014/main" id="{990D2C5C-A7E3-C7CB-FC69-CEFA2109EB9C}"/>
+                <a16:creationId xmlns:a16="http://schemas.microsoft.com/office/drawing/2014/main" id="{E6FEFDC4-2FE7-010D-D409-ED226D1B6F80}"/>
               </a:ext>
             </a:extLst>
           </p:cNvPr>
@@ -2439,7 +2439,7 @@
           <a:bodyPr/>
           <a:lstStyle/>
           <a:p>
-            <a:fld id="{3F5F16BE-67EA-4F6D-86FE-98E4BE054E9B}" type="slidenum">
+            <a:fld id="{01D1AEF7-2044-4839-8C56-918BADCD9CB9}" type="slidenum">
               <a:rPr lang="vi-VN" smtClean="0"/>
               <a:t>‹#›</a:t>
             </a:fld>
@@ -2450,7 +2450,7 @@
     </p:spTree>
     <p:extLst>
       <p:ext uri="{BB962C8B-B14F-4D97-AF65-F5344CB8AC3E}">
-        <p14:creationId xmlns:p14="http://schemas.microsoft.com/office/powerpoint/2010/main" val="2326322362"/>
+        <p14:creationId xmlns:p14="http://schemas.microsoft.com/office/powerpoint/2010/main" val="1741840010"/>
       </p:ext>
     </p:extLst>
   </p:cSld>
@@ -2482,7 +2482,7 @@
           <p:cNvPr id="2" name="Tiêu đề 1">
             <a:extLst>
               <a:ext uri="{FF2B5EF4-FFF2-40B4-BE49-F238E27FC236}">
-                <a16:creationId xmlns:a16="http://schemas.microsoft.com/office/drawing/2014/main" id="{08012A22-B2FC-56D3-A68B-23FBFAF3097C}"/>
+                <a16:creationId xmlns:a16="http://schemas.microsoft.com/office/drawing/2014/main" id="{C4E27209-009B-4A77-F5E8-5A59FF164533}"/>
               </a:ext>
             </a:extLst>
           </p:cNvPr>
@@ -2519,7 +2519,7 @@
           <p:cNvPr id="3" name="Chỗ dành sẵn cho Hình ảnh 2">
             <a:extLst>
               <a:ext uri="{FF2B5EF4-FFF2-40B4-BE49-F238E27FC236}">
-                <a16:creationId xmlns:a16="http://schemas.microsoft.com/office/drawing/2014/main" id="{1D18183C-AE42-40E0-C61F-AEE64583E18B}"/>
+                <a16:creationId xmlns:a16="http://schemas.microsoft.com/office/drawing/2014/main" id="{5349951D-3C33-A8F5-1DA4-F97D30BF4C72}"/>
               </a:ext>
             </a:extLst>
           </p:cNvPr>
@@ -2586,7 +2586,7 @@
           <p:cNvPr id="4" name="Chỗ dành sẵn cho Văn bản 3">
             <a:extLst>
               <a:ext uri="{FF2B5EF4-FFF2-40B4-BE49-F238E27FC236}">
-                <a16:creationId xmlns:a16="http://schemas.microsoft.com/office/drawing/2014/main" id="{5986BE6E-60BA-17B0-E44C-BA865F9A4067}"/>
+                <a16:creationId xmlns:a16="http://schemas.microsoft.com/office/drawing/2014/main" id="{E2401BA7-5B99-9C36-4A7D-8B0898D6074A}"/>
               </a:ext>
             </a:extLst>
           </p:cNvPr>
@@ -2657,7 +2657,7 @@
           <p:cNvPr id="5" name="Chỗ dành sẵn cho Ngày tháng 4">
             <a:extLst>
               <a:ext uri="{FF2B5EF4-FFF2-40B4-BE49-F238E27FC236}">
-                <a16:creationId xmlns:a16="http://schemas.microsoft.com/office/drawing/2014/main" id="{723F3659-3129-3426-8951-6443739620CB}"/>
+                <a16:creationId xmlns:a16="http://schemas.microsoft.com/office/drawing/2014/main" id="{6F4E8CB3-806D-E4B3-D19E-36119C17F62B}"/>
               </a:ext>
             </a:extLst>
           </p:cNvPr>
@@ -2673,7 +2673,7 @@
           <a:bodyPr/>
           <a:lstStyle/>
           <a:p>
-            <a:fld id="{BE4967DC-81E8-40D5-81A8-0D625F75E3D3}" type="datetimeFigureOut">
+            <a:fld id="{88986470-4349-47FE-9583-3F8A6EA241D7}" type="datetimeFigureOut">
               <a:rPr lang="vi-VN" smtClean="0"/>
               <a:t>18/10/2026</a:t>
             </a:fld>
@@ -2686,7 +2686,7 @@
           <p:cNvPr id="6" name="Chỗ dành sẵn cho Chân trang 5">
             <a:extLst>
               <a:ext uri="{FF2B5EF4-FFF2-40B4-BE49-F238E27FC236}">
-                <a16:creationId xmlns:a16="http://schemas.microsoft.com/office/drawing/2014/main" id="{2E9F6D57-58CF-6B8E-94CA-45F4C22D4825}"/>
+                <a16:creationId xmlns:a16="http://schemas.microsoft.com/office/drawing/2014/main" id="{1FD99099-37C0-F920-AE59-A5F05D7445EB}"/>
               </a:ext>
             </a:extLst>
           </p:cNvPr>
@@ -2711,7 +2711,7 @@
           <p:cNvPr id="7" name="Chỗ dành sẵn cho Số hiệu Bản chiếu 6">
             <a:extLst>
               <a:ext uri="{FF2B5EF4-FFF2-40B4-BE49-F238E27FC236}">
-                <a16:creationId xmlns:a16="http://schemas.microsoft.com/office/drawing/2014/main" id="{119D9351-8387-A728-C314-AAFC64621333}"/>
+                <a16:creationId xmlns:a16="http://schemas.microsoft.com/office/drawing/2014/main" id="{F099ABA9-7E6F-48AF-C486-04D280858546}"/>
               </a:ext>
             </a:extLst>
           </p:cNvPr>
@@ -2727,7 +2727,7 @@
           <a:bodyPr/>
           <a:lstStyle/>
           <a:p>
-            <a:fld id="{3F5F16BE-67EA-4F6D-86FE-98E4BE054E9B}" type="slidenum">
+            <a:fld id="{01D1AEF7-2044-4839-8C56-918BADCD9CB9}" type="slidenum">
               <a:rPr lang="vi-VN" smtClean="0"/>
               <a:t>‹#›</a:t>
             </a:fld>
@@ -2738,7 +2738,7 @@
     </p:spTree>
     <p:extLst>
       <p:ext uri="{BB962C8B-B14F-4D97-AF65-F5344CB8AC3E}">
-        <p14:creationId xmlns:p14="http://schemas.microsoft.com/office/powerpoint/2010/main" val="218435717"/>
+        <p14:creationId xmlns:p14="http://schemas.microsoft.com/office/powerpoint/2010/main" val="1014553500"/>
       </p:ext>
     </p:extLst>
   </p:cSld>
@@ -2775,7 +2775,7 @@
           <p:cNvPr id="2" name="Chỗ dành sẵn cho Tiêu đề 1">
             <a:extLst>
               <a:ext uri="{FF2B5EF4-FFF2-40B4-BE49-F238E27FC236}">
-                <a16:creationId xmlns:a16="http://schemas.microsoft.com/office/drawing/2014/main" id="{D4814B6A-87B3-6C37-7541-57852AB7C710}"/>
+                <a16:creationId xmlns:a16="http://schemas.microsoft.com/office/drawing/2014/main" id="{7946D0F9-8BB9-724B-4CD7-4609F54D5D33}"/>
               </a:ext>
             </a:extLst>
           </p:cNvPr>
@@ -2813,7 +2813,7 @@
           <p:cNvPr id="3" name="Chỗ dành sẵn cho Văn bản 2">
             <a:extLst>
               <a:ext uri="{FF2B5EF4-FFF2-40B4-BE49-F238E27FC236}">
-                <a16:creationId xmlns:a16="http://schemas.microsoft.com/office/drawing/2014/main" id="{5C965FFA-23AD-D90F-F0E1-52D77601796E}"/>
+                <a16:creationId xmlns:a16="http://schemas.microsoft.com/office/drawing/2014/main" id="{BBF22DDF-FABF-84F4-DC70-7042F552C876}"/>
               </a:ext>
             </a:extLst>
           </p:cNvPr>
@@ -2880,7 +2880,7 @@
           <p:cNvPr id="4" name="Chỗ dành sẵn cho Ngày tháng 3">
             <a:extLst>
               <a:ext uri="{FF2B5EF4-FFF2-40B4-BE49-F238E27FC236}">
-                <a16:creationId xmlns:a16="http://schemas.microsoft.com/office/drawing/2014/main" id="{B900CFFE-2069-0429-96C0-ACD1BC05ABC6}"/>
+                <a16:creationId xmlns:a16="http://schemas.microsoft.com/office/drawing/2014/main" id="{01E2253B-92D2-555C-DCD7-4F27B210D6CA}"/>
               </a:ext>
             </a:extLst>
           </p:cNvPr>
@@ -2914,7 +2914,7 @@
             </a:lvl1pPr>
           </a:lstStyle>
           <a:p>
-            <a:fld id="{BE4967DC-81E8-40D5-81A8-0D625F75E3D3}" type="datetimeFigureOut">
+            <a:fld id="{88986470-4349-47FE-9583-3F8A6EA241D7}" type="datetimeFigureOut">
               <a:rPr lang="vi-VN" smtClean="0"/>
               <a:t>18/10/2026</a:t>
             </a:fld>
@@ -2927,7 +2927,7 @@
           <p:cNvPr id="5" name="Chỗ dành sẵn cho Chân trang 4">
             <a:extLst>
               <a:ext uri="{FF2B5EF4-FFF2-40B4-BE49-F238E27FC236}">
-                <a16:creationId xmlns:a16="http://schemas.microsoft.com/office/drawing/2014/main" id="{1696AAE4-8223-EC7F-6633-37263CA12663}"/>
+                <a16:creationId xmlns:a16="http://schemas.microsoft.com/office/drawing/2014/main" id="{CB05AE87-C5C1-6B75-F212-2C78F5919FB3}"/>
               </a:ext>
             </a:extLst>
           </p:cNvPr>
@@ -2970,7 +2970,7 @@
           <p:cNvPr id="6" name="Chỗ dành sẵn cho Số hiệu Bản chiếu 5">
             <a:extLst>
               <a:ext uri="{FF2B5EF4-FFF2-40B4-BE49-F238E27FC236}">
-                <a16:creationId xmlns:a16="http://schemas.microsoft.com/office/drawing/2014/main" id="{B1886786-CF9A-9872-4D0A-CFF34BE372C0}"/>
+                <a16:creationId xmlns:a16="http://schemas.microsoft.com/office/drawing/2014/main" id="{5DA9DDCB-8937-4564-2B39-8EEA6285CD5A}"/>
               </a:ext>
             </a:extLst>
           </p:cNvPr>
@@ -3004,7 +3004,7 @@
             </a:lvl1pPr>
           </a:lstStyle>
           <a:p>
-            <a:fld id="{3F5F16BE-67EA-4F6D-86FE-98E4BE054E9B}" type="slidenum">
+            <a:fld id="{01D1AEF7-2044-4839-8C56-918BADCD9CB9}" type="slidenum">
               <a:rPr lang="vi-VN" smtClean="0"/>
               <a:t>‹#›</a:t>
             </a:fld>
@@ -3015,7 +3015,7 @@
     </p:spTree>
     <p:extLst>
       <p:ext uri="{BB962C8B-B14F-4D97-AF65-F5344CB8AC3E}">
-        <p14:creationId xmlns:p14="http://schemas.microsoft.com/office/powerpoint/2010/main" val="1393266608"/>
+        <p14:creationId xmlns:p14="http://schemas.microsoft.com/office/powerpoint/2010/main" val="4059987004"/>
       </p:ext>
     </p:extLst>
   </p:cSld>
@@ -3338,7 +3338,7 @@
           <p:cNvPr id="2" name="Hình chữ nhật 1">
             <a:extLst>
               <a:ext uri="{FF2B5EF4-FFF2-40B4-BE49-F238E27FC236}">
-                <a16:creationId xmlns:a16="http://schemas.microsoft.com/office/drawing/2014/main" id="{FF4C59B5-91ED-8455-2E29-3D5CF79D1A91}"/>
+                <a16:creationId xmlns:a16="http://schemas.microsoft.com/office/drawing/2014/main" id="{2683630D-F01A-BFE2-5A89-0D254335E0BC}"/>
               </a:ext>
             </a:extLst>
           </p:cNvPr>
@@ -3406,7 +3406,7 @@
           <p:cNvPr id="3" name="Hình chữ nhật: Góc Tròn 2">
             <a:extLst>
               <a:ext uri="{FF2B5EF4-FFF2-40B4-BE49-F238E27FC236}">
-                <a16:creationId xmlns:a16="http://schemas.microsoft.com/office/drawing/2014/main" id="{F04D786C-9A60-ED28-0CAB-B5FAD19A09FA}"/>
+                <a16:creationId xmlns:a16="http://schemas.microsoft.com/office/drawing/2014/main" id="{400C46C1-164E-E8E4-33C9-E62C94D8AF2A}"/>
               </a:ext>
             </a:extLst>
           </p:cNvPr>
@@ -3474,7 +3474,7 @@
           <p:cNvPr id="4" name="Hộp Văn bản 3">
             <a:extLst>
               <a:ext uri="{FF2B5EF4-FFF2-40B4-BE49-F238E27FC236}">
-                <a16:creationId xmlns:a16="http://schemas.microsoft.com/office/drawing/2014/main" id="{84A85A82-3597-98E6-6528-0036DF302A2B}"/>
+                <a16:creationId xmlns:a16="http://schemas.microsoft.com/office/drawing/2014/main" id="{5777D749-FB92-B3BF-DFFB-85522E614460}"/>
               </a:ext>
             </a:extLst>
           </p:cNvPr>
@@ -3519,7 +3519,7 @@
           <p:cNvPr id="5" name="Hộp Văn bản 4">
             <a:extLst>
               <a:ext uri="{FF2B5EF4-FFF2-40B4-BE49-F238E27FC236}">
-                <a16:creationId xmlns:a16="http://schemas.microsoft.com/office/drawing/2014/main" id="{ED01BBEC-712C-D54F-7271-23ED26C7C764}"/>
+                <a16:creationId xmlns:a16="http://schemas.microsoft.com/office/drawing/2014/main" id="{750B6C1F-1724-F390-81F4-2EDAABB4CCC3}"/>
               </a:ext>
             </a:extLst>
           </p:cNvPr>
@@ -3580,7 +3580,7 @@
           <p:cNvPr id="6" name="Hộp Văn bản 5">
             <a:extLst>
               <a:ext uri="{FF2B5EF4-FFF2-40B4-BE49-F238E27FC236}">
-                <a16:creationId xmlns:a16="http://schemas.microsoft.com/office/drawing/2014/main" id="{52595E60-4717-B33C-FD46-F9876592076A}"/>
+                <a16:creationId xmlns:a16="http://schemas.microsoft.com/office/drawing/2014/main" id="{AC76B986-2162-9299-2E9E-6D1D114C6EFE}"/>
               </a:ext>
             </a:extLst>
           </p:cNvPr>
@@ -3625,7 +3625,7 @@
           <p:cNvPr id="7" name="Hộp Văn bản 6">
             <a:extLst>
               <a:ext uri="{FF2B5EF4-FFF2-40B4-BE49-F238E27FC236}">
-                <a16:creationId xmlns:a16="http://schemas.microsoft.com/office/drawing/2014/main" id="{747FE495-4CEB-0F6F-065B-2CC29DB94F89}"/>
+                <a16:creationId xmlns:a16="http://schemas.microsoft.com/office/drawing/2014/main" id="{E9ACC1FE-EE1B-32C2-F1D5-0D970CC4B327}"/>
               </a:ext>
             </a:extLst>
           </p:cNvPr>
@@ -3670,7 +3670,7 @@
           <p:cNvPr id="8" name="Hình chữ nhật: Góc Tròn 7">
             <a:extLst>
               <a:ext uri="{FF2B5EF4-FFF2-40B4-BE49-F238E27FC236}">
-                <a16:creationId xmlns:a16="http://schemas.microsoft.com/office/drawing/2014/main" id="{519BBCC0-6527-3735-F05A-9D8281AA2424}"/>
+                <a16:creationId xmlns:a16="http://schemas.microsoft.com/office/drawing/2014/main" id="{1A4E9048-6C04-C0A5-E371-A8FAE9C69272}"/>
               </a:ext>
             </a:extLst>
           </p:cNvPr>
@@ -3738,7 +3738,7 @@
           <p:cNvPr id="9" name="Hộp Văn bản 8">
             <a:extLst>
               <a:ext uri="{FF2B5EF4-FFF2-40B4-BE49-F238E27FC236}">
-                <a16:creationId xmlns:a16="http://schemas.microsoft.com/office/drawing/2014/main" id="{FE89E29F-DCEA-3554-2F64-FBC0529BA2A3}"/>
+                <a16:creationId xmlns:a16="http://schemas.microsoft.com/office/drawing/2014/main" id="{0E6B2657-86EF-6DEE-EDE3-B3ECF80CD8A9}"/>
               </a:ext>
             </a:extLst>
           </p:cNvPr>
@@ -3773,7 +3773,7 @@
                 </a:solidFill>
                 <a:latin typeface="Aptos" panose="020B0004020202020204" pitchFamily="34" charset="0"/>
               </a:rPr>
-              <a:t>HIỆN TRẠNG + ĐỊNH HƯỚNG AI</a:t>
+              <a:t>NGHIỆP VỤ + AI TÙY CHỌN</a:t>
             </a:r>
           </a:p>
         </p:txBody>
@@ -3783,7 +3783,7 @@
           <p:cNvPr id="10" name="Hình chữ nhật: Góc Tròn 9">
             <a:extLst>
               <a:ext uri="{FF2B5EF4-FFF2-40B4-BE49-F238E27FC236}">
-                <a16:creationId xmlns:a16="http://schemas.microsoft.com/office/drawing/2014/main" id="{7A688EF5-CB24-7CE3-8037-7FEBB744CEFE}"/>
+                <a16:creationId xmlns:a16="http://schemas.microsoft.com/office/drawing/2014/main" id="{164C50CC-C142-9421-6B6D-DA65AC6CB208}"/>
               </a:ext>
             </a:extLst>
           </p:cNvPr>
@@ -3851,7 +3851,7 @@
           <p:cNvPr id="12" name="Hình ảnh 11">
             <a:extLst>
               <a:ext uri="{FF2B5EF4-FFF2-40B4-BE49-F238E27FC236}">
-                <a16:creationId xmlns:a16="http://schemas.microsoft.com/office/drawing/2014/main" id="{1CF8708A-3CF9-B3BB-F0C6-57524C6924ED}"/>
+                <a16:creationId xmlns:a16="http://schemas.microsoft.com/office/drawing/2014/main" id="{C4C34D72-961F-00EC-7A5F-11B7A8C1960C}"/>
               </a:ext>
             </a:extLst>
           </p:cNvPr>
@@ -3887,7 +3887,7 @@
           <p:cNvPr id="13" name="Hộp Văn bản 12">
             <a:extLst>
               <a:ext uri="{FF2B5EF4-FFF2-40B4-BE49-F238E27FC236}">
-                <a16:creationId xmlns:a16="http://schemas.microsoft.com/office/drawing/2014/main" id="{DAE13EA1-E2CF-C3DF-BF27-0E17750FA840}"/>
+                <a16:creationId xmlns:a16="http://schemas.microsoft.com/office/drawing/2014/main" id="{26281422-5484-47CC-2952-41D630AC1CA3}"/>
               </a:ext>
             </a:extLst>
           </p:cNvPr>
@@ -3932,7 +3932,7 @@
           <p:cNvPr id="14" name="Hình chữ nhật 13">
             <a:extLst>
               <a:ext uri="{FF2B5EF4-FFF2-40B4-BE49-F238E27FC236}">
-                <a16:creationId xmlns:a16="http://schemas.microsoft.com/office/drawing/2014/main" id="{7A57AB89-B61D-7FBE-E346-AFC340605673}"/>
+                <a16:creationId xmlns:a16="http://schemas.microsoft.com/office/drawing/2014/main" id="{CEB7F7CB-E482-8304-3EFA-492904AB82C2}"/>
               </a:ext>
             </a:extLst>
           </p:cNvPr>
@@ -4000,7 +4000,7 @@
           <p:cNvPr id="15" name="Hộp Văn bản 14">
             <a:extLst>
               <a:ext uri="{FF2B5EF4-FFF2-40B4-BE49-F238E27FC236}">
-                <a16:creationId xmlns:a16="http://schemas.microsoft.com/office/drawing/2014/main" id="{DEA400AF-8C38-C539-8A2C-61581D62D734}"/>
+                <a16:creationId xmlns:a16="http://schemas.microsoft.com/office/drawing/2014/main" id="{023077F4-210B-5A4A-5461-23E1022E4B32}"/>
               </a:ext>
             </a:extLst>
           </p:cNvPr>
@@ -4045,7 +4045,7 @@
           <p:cNvPr id="16" name="Hộp Văn bản 15">
             <a:extLst>
               <a:ext uri="{FF2B5EF4-FFF2-40B4-BE49-F238E27FC236}">
-                <a16:creationId xmlns:a16="http://schemas.microsoft.com/office/drawing/2014/main" id="{6EAD4EEE-FE8F-14B1-E12C-13E84A1EF7E5}"/>
+                <a16:creationId xmlns:a16="http://schemas.microsoft.com/office/drawing/2014/main" id="{CE23F9D3-0A12-F03D-59FE-46DC185CCC17}"/>
               </a:ext>
             </a:extLst>
           </p:cNvPr>
@@ -4088,7 +4088,7 @@
     </p:spTree>
     <p:extLst>
       <p:ext uri="{BB962C8B-B14F-4D97-AF65-F5344CB8AC3E}">
-        <p14:creationId xmlns:p14="http://schemas.microsoft.com/office/powerpoint/2010/main" val="2124590418"/>
+        <p14:creationId xmlns:p14="http://schemas.microsoft.com/office/powerpoint/2010/main" val="2466369297"/>
       </p:ext>
     </p:extLst>
   </p:cSld>
@@ -4120,7 +4120,7 @@
           <p:cNvPr id="2" name="Hộp Văn bản 1">
             <a:extLst>
               <a:ext uri="{FF2B5EF4-FFF2-40B4-BE49-F238E27FC236}">
-                <a16:creationId xmlns:a16="http://schemas.microsoft.com/office/drawing/2014/main" id="{41CC65F0-70A1-E3D9-C512-DD4FBAF46645}"/>
+                <a16:creationId xmlns:a16="http://schemas.microsoft.com/office/drawing/2014/main" id="{E99C391E-96A1-60BD-47E9-D8FE16B9497A}"/>
               </a:ext>
             </a:extLst>
           </p:cNvPr>
@@ -4155,7 +4155,7 @@
                 </a:solidFill>
                 <a:latin typeface="Aptos" panose="020B0004020202020204" pitchFamily="34" charset="0"/>
               </a:rPr>
-              <a:t>09 / ĐỊNH HƯỚNG AI</a:t>
+              <a:t>09 / AI TÙY CHỌN</a:t>
             </a:r>
           </a:p>
         </p:txBody>
@@ -4165,7 +4165,7 @@
           <p:cNvPr id="3" name="Hộp Văn bản 2">
             <a:extLst>
               <a:ext uri="{FF2B5EF4-FFF2-40B4-BE49-F238E27FC236}">
-                <a16:creationId xmlns:a16="http://schemas.microsoft.com/office/drawing/2014/main" id="{9E77EFA5-24B6-D58A-D617-FE43A479910B}"/>
+                <a16:creationId xmlns:a16="http://schemas.microsoft.com/office/drawing/2014/main" id="{0C3F82A2-AC11-2FBE-B7BD-33653E686DB4}"/>
               </a:ext>
             </a:extLst>
           </p:cNvPr>
@@ -4200,7 +4200,7 @@
                 </a:solidFill>
                 <a:latin typeface="Aptos" panose="020B0004020202020204" pitchFamily="34" charset="0"/>
               </a:rPr>
-              <a:t>Hai luồng AI là đề xuất, chưa triển khai</a:t>
+              <a:t>Hai luồng đã có trong source, cần cấu hình</a:t>
             </a:r>
           </a:p>
         </p:txBody>
@@ -4210,7 +4210,7 @@
           <p:cNvPr id="4" name="Hộp Văn bản 3">
             <a:extLst>
               <a:ext uri="{FF2B5EF4-FFF2-40B4-BE49-F238E27FC236}">
-                <a16:creationId xmlns:a16="http://schemas.microsoft.com/office/drawing/2014/main" id="{9279220B-F756-02BF-517A-97A551A383D2}"/>
+                <a16:creationId xmlns:a16="http://schemas.microsoft.com/office/drawing/2014/main" id="{CE734F9C-FA6F-E89B-7AC8-BB2E82C64D14}"/>
               </a:ext>
             </a:extLst>
           </p:cNvPr>
@@ -4245,7 +4245,7 @@
                 </a:solidFill>
                 <a:latin typeface="Aptos" panose="020B0004020202020204" pitchFamily="34" charset="0"/>
               </a:rPr>
-              <a:t>Chưa có API, dịch vụ AI, lịch chạy nền hay kênh nhắc trong source hiện tại.</a:t>
+              <a:t>Gemini/Twilio chưa hoạt động nếu thiếu consent, credentials và lịch Task Scheduler.</a:t>
             </a:r>
           </a:p>
         </p:txBody>
@@ -4255,7 +4255,7 @@
           <p:cNvPr id="5" name="Hình chữ nhật 4">
             <a:extLst>
               <a:ext uri="{FF2B5EF4-FFF2-40B4-BE49-F238E27FC236}">
-                <a16:creationId xmlns:a16="http://schemas.microsoft.com/office/drawing/2014/main" id="{EC95FF69-D2DE-BCEC-8C78-AD635448CF06}"/>
+                <a16:creationId xmlns:a16="http://schemas.microsoft.com/office/drawing/2014/main" id="{36058E55-79A8-E025-DCD9-5B0B253F47F7}"/>
               </a:ext>
             </a:extLst>
           </p:cNvPr>
@@ -4323,7 +4323,7 @@
           <p:cNvPr id="6" name="Hộp Văn bản 5">
             <a:extLst>
               <a:ext uri="{FF2B5EF4-FFF2-40B4-BE49-F238E27FC236}">
-                <a16:creationId xmlns:a16="http://schemas.microsoft.com/office/drawing/2014/main" id="{AD7295C3-1322-E882-1466-4179D084E968}"/>
+                <a16:creationId xmlns:a16="http://schemas.microsoft.com/office/drawing/2014/main" id="{772E06FE-3501-EC14-D205-DE47AA496794}"/>
               </a:ext>
             </a:extLst>
           </p:cNvPr>
@@ -4368,7 +4368,7 @@
           <p:cNvPr id="7" name="Hộp Văn bản 6">
             <a:extLst>
               <a:ext uri="{FF2B5EF4-FFF2-40B4-BE49-F238E27FC236}">
-                <a16:creationId xmlns:a16="http://schemas.microsoft.com/office/drawing/2014/main" id="{85655D29-1580-F8A3-3F52-A9E6EBBF0BF5}"/>
+                <a16:creationId xmlns:a16="http://schemas.microsoft.com/office/drawing/2014/main" id="{DE5AF7A4-6DAE-30B8-2BC7-216E3FB89C2F}"/>
               </a:ext>
             </a:extLst>
           </p:cNvPr>
@@ -4413,7 +4413,7 @@
           <p:cNvPr id="8" name="Hình chữ nhật: Góc Tròn 7">
             <a:extLst>
               <a:ext uri="{FF2B5EF4-FFF2-40B4-BE49-F238E27FC236}">
-                <a16:creationId xmlns:a16="http://schemas.microsoft.com/office/drawing/2014/main" id="{049A7F54-439C-9E36-8969-017CC225A697}"/>
+                <a16:creationId xmlns:a16="http://schemas.microsoft.com/office/drawing/2014/main" id="{9A16AD5D-AE90-4B2A-FD2F-7FABC217D289}"/>
               </a:ext>
             </a:extLst>
           </p:cNvPr>
@@ -4481,7 +4481,7 @@
           <p:cNvPr id="9" name="Hình chữ nhật: Góc Tròn 8">
             <a:extLst>
               <a:ext uri="{FF2B5EF4-FFF2-40B4-BE49-F238E27FC236}">
-                <a16:creationId xmlns:a16="http://schemas.microsoft.com/office/drawing/2014/main" id="{19A41AF2-320E-8AC3-0657-E0E2B3979F42}"/>
+                <a16:creationId xmlns:a16="http://schemas.microsoft.com/office/drawing/2014/main" id="{F1E574E0-9E44-6398-3D14-9084A53C592B}"/>
               </a:ext>
             </a:extLst>
           </p:cNvPr>
@@ -4549,7 +4549,7 @@
           <p:cNvPr id="10" name="Hộp Văn bản 9">
             <a:extLst>
               <a:ext uri="{FF2B5EF4-FFF2-40B4-BE49-F238E27FC236}">
-                <a16:creationId xmlns:a16="http://schemas.microsoft.com/office/drawing/2014/main" id="{7AA0F2D1-E7F2-1BE1-A945-EF39C204606C}"/>
+                <a16:creationId xmlns:a16="http://schemas.microsoft.com/office/drawing/2014/main" id="{D745B973-347B-76B5-9412-4BE5966BB624}"/>
               </a:ext>
             </a:extLst>
           </p:cNvPr>
@@ -4584,7 +4584,7 @@
                 </a:solidFill>
                 <a:latin typeface="Aptos" panose="020B0004020202020204" pitchFamily="34" charset="0"/>
               </a:rPr>
-              <a:t>TÓM TẮT EMR · ĐỀ XUẤT</a:t>
+              <a:t>TÓM TẮT EMR · GEMINI</a:t>
             </a:r>
           </a:p>
         </p:txBody>
@@ -4594,7 +4594,7 @@
           <p:cNvPr id="11" name="Hộp Văn bản 10">
             <a:extLst>
               <a:ext uri="{FF2B5EF4-FFF2-40B4-BE49-F238E27FC236}">
-                <a16:creationId xmlns:a16="http://schemas.microsoft.com/office/drawing/2014/main" id="{690FDAAC-04CC-BCFF-BA6A-104673F9B8AB}"/>
+                <a16:creationId xmlns:a16="http://schemas.microsoft.com/office/drawing/2014/main" id="{A8FA7458-85E2-C1A8-14B2-0D873A63E6AA}"/>
               </a:ext>
             </a:extLst>
           </p:cNvPr>
@@ -4629,7 +4629,7 @@
                 </a:solidFill>
                 <a:latin typeface="Aptos" panose="020B0004020202020204" pitchFamily="34" charset="0"/>
               </a:rPr>
-              <a:t>Bác sĩ chọn hồ sơ</a:t>
+              <a:t>Bác sĩ chọn hồ sơ + đã có consent</a:t>
             </a:r>
           </a:p>
           <a:p>
@@ -4661,7 +4661,7 @@
                 </a:solidFill>
                 <a:latin typeface="Aptos" panose="020B0004020202020204" pitchFamily="34" charset="0"/>
               </a:rPr>
-              <a:t>API kiểm tra quyền, giảm thiểu dữ liệu</a:t>
+              <a:t>API kiểm tra role / quyền hồ sơ</a:t>
             </a:r>
           </a:p>
           <a:p>
@@ -4693,7 +4693,7 @@
                 </a:solidFill>
                 <a:latin typeface="Aptos" panose="020B0004020202020204" pitchFamily="34" charset="0"/>
               </a:rPr>
-              <a:t>AI tạo bản nháp</a:t>
+              <a:t>Lọc định danh theo mẫu → Gemini</a:t>
             </a:r>
           </a:p>
           <a:p>
@@ -4725,7 +4725,7 @@
                 </a:solidFill>
                 <a:latin typeface="Aptos" panose="020B0004020202020204" pitchFamily="34" charset="0"/>
               </a:rPr>
-              <a:t>Bác sĩ rà soát / chỉnh sửa</a:t>
+              <a:t>Trả bản nháp cho bác sĩ rà soát</a:t>
             </a:r>
           </a:p>
           <a:p>
@@ -4757,7 +4757,7 @@
                 </a:solidFill>
                 <a:latin typeface="Aptos" panose="020B0004020202020204" pitchFamily="34" charset="0"/>
               </a:rPr>
-              <a:t>Chỉ lưu khi được duyệt</a:t>
+              <a:t>Không tự lưu vào bệnh án</a:t>
             </a:r>
           </a:p>
         </p:txBody>
@@ -4767,7 +4767,7 @@
           <p:cNvPr id="12" name="Hình chữ nhật: Góc Tròn 11">
             <a:extLst>
               <a:ext uri="{FF2B5EF4-FFF2-40B4-BE49-F238E27FC236}">
-                <a16:creationId xmlns:a16="http://schemas.microsoft.com/office/drawing/2014/main" id="{EA1575CF-3982-19DF-EEAC-30073EBE271E}"/>
+                <a16:creationId xmlns:a16="http://schemas.microsoft.com/office/drawing/2014/main" id="{9B088D06-B878-DFFF-FD5A-B62BD92F6770}"/>
               </a:ext>
             </a:extLst>
           </p:cNvPr>
@@ -4835,7 +4835,7 @@
           <p:cNvPr id="13" name="Hình chữ nhật: Góc Tròn 12">
             <a:extLst>
               <a:ext uri="{FF2B5EF4-FFF2-40B4-BE49-F238E27FC236}">
-                <a16:creationId xmlns:a16="http://schemas.microsoft.com/office/drawing/2014/main" id="{8207F344-B790-E8A8-8B82-6B76B1305E9D}"/>
+                <a16:creationId xmlns:a16="http://schemas.microsoft.com/office/drawing/2014/main" id="{5459D595-7C47-BD07-2AC2-B4CFDA90C7A0}"/>
               </a:ext>
             </a:extLst>
           </p:cNvPr>
@@ -4903,7 +4903,7 @@
           <p:cNvPr id="14" name="Hộp Văn bản 13">
             <a:extLst>
               <a:ext uri="{FF2B5EF4-FFF2-40B4-BE49-F238E27FC236}">
-                <a16:creationId xmlns:a16="http://schemas.microsoft.com/office/drawing/2014/main" id="{3C5FAAF9-6F81-C298-4C6E-4A1712C432F0}"/>
+                <a16:creationId xmlns:a16="http://schemas.microsoft.com/office/drawing/2014/main" id="{EBD96928-3E63-F674-8C43-2CB08B5F38E0}"/>
               </a:ext>
             </a:extLst>
           </p:cNvPr>
@@ -4938,7 +4938,7 @@
                 </a:solidFill>
                 <a:latin typeface="Aptos" panose="020B0004020202020204" pitchFamily="34" charset="0"/>
               </a:rPr>
-              <a:t>NHẮC TÁI KHÁM · ĐỀ XUẤT</a:t>
+              <a:t>TÁI KHÁM · GEMINI + TWILIO</a:t>
             </a:r>
           </a:p>
         </p:txBody>
@@ -4948,7 +4948,7 @@
           <p:cNvPr id="15" name="Hộp Văn bản 14">
             <a:extLst>
               <a:ext uri="{FF2B5EF4-FFF2-40B4-BE49-F238E27FC236}">
-                <a16:creationId xmlns:a16="http://schemas.microsoft.com/office/drawing/2014/main" id="{870DCA64-ADE4-8428-4EAD-1B1081110A7F}"/>
+                <a16:creationId xmlns:a16="http://schemas.microsoft.com/office/drawing/2014/main" id="{8DAA31A0-3CC7-0697-19B7-5D095720EE19}"/>
               </a:ext>
             </a:extLst>
           </p:cNvPr>
@@ -4983,7 +4983,7 @@
                 </a:solidFill>
                 <a:latin typeface="Aptos" panose="020B0004020202020204" pitchFamily="34" charset="0"/>
               </a:rPr>
-              <a:t>Xác nhận ngày + đồng thuận</a:t>
+              <a:t>Ngày tái khám + SMS consent</a:t>
             </a:r>
           </a:p>
           <a:p>
@@ -5015,7 +5015,7 @@
                 </a:solidFill>
                 <a:latin typeface="Aptos" panose="020B0004020202020204" pitchFamily="34" charset="0"/>
               </a:rPr>
-              <a:t>AI soạn nháp không chẩn đoán</a:t>
+              <a:t>Task Scheduler gọi lệnh hằng ngày</a:t>
             </a:r>
           </a:p>
           <a:p>
@@ -5047,7 +5047,7 @@
                 </a:solidFill>
                 <a:latin typeface="Aptos" panose="020B0004020202020204" pitchFamily="34" charset="0"/>
               </a:rPr>
-              <a:t>Nhân viên / bác sĩ duyệt</a:t>
+              <a:t>Gemini soạn lời mời chung</a:t>
             </a:r>
           </a:p>
           <a:p>
@@ -5079,7 +5079,7 @@
                 </a:solidFill>
                 <a:latin typeface="Aptos" panose="020B0004020202020204" pitchFamily="34" charset="0"/>
               </a:rPr>
-              <a:t>Lưu lịch gửi + audit</a:t>
+              <a:t>Twilio gửi SMS + lưu trạng thái</a:t>
             </a:r>
           </a:p>
           <a:p>
@@ -5111,7 +5111,7 @@
                 </a:solidFill>
                 <a:latin typeface="Aptos" panose="020B0004020202020204" pitchFamily="34" charset="0"/>
               </a:rPr>
-              <a:t>Job nền gửi, lưu kết quả</a:t>
+              <a:t>Không gửi bệnh án; UNKNOWN không retry</a:t>
             </a:r>
           </a:p>
         </p:txBody>
@@ -5121,7 +5121,7 @@
           <p:cNvPr id="16" name="Hình chữ nhật: Góc Tròn 15">
             <a:extLst>
               <a:ext uri="{FF2B5EF4-FFF2-40B4-BE49-F238E27FC236}">
-                <a16:creationId xmlns:a16="http://schemas.microsoft.com/office/drawing/2014/main" id="{F9629CEC-FD07-EAC8-692A-1A43EB147DD5}"/>
+                <a16:creationId xmlns:a16="http://schemas.microsoft.com/office/drawing/2014/main" id="{67CF0161-43C5-79B0-D0BC-52778ED4A23E}"/>
               </a:ext>
             </a:extLst>
           </p:cNvPr>
@@ -5189,7 +5189,7 @@
           <p:cNvPr id="17" name="Hộp Văn bản 16">
             <a:extLst>
               <a:ext uri="{FF2B5EF4-FFF2-40B4-BE49-F238E27FC236}">
-                <a16:creationId xmlns:a16="http://schemas.microsoft.com/office/drawing/2014/main" id="{665B8F07-8CAF-C3C4-7ADA-369A91AAA6C3}"/>
+                <a16:creationId xmlns:a16="http://schemas.microsoft.com/office/drawing/2014/main" id="{87EABF06-9F58-DD91-7DC7-929FF71E9AE8}"/>
               </a:ext>
             </a:extLst>
           </p:cNvPr>
@@ -5218,21 +5218,27 @@
               </a:spcAft>
             </a:pPr>
             <a:r>
-              <a:rPr lang="vi-VN" sz="900" b="1">
+              <a:rPr lang="en-US" sz="900" b="1">
                 <a:solidFill>
                   <a:srgbClr val="CF755F"/>
                 </a:solidFill>
                 <a:latin typeface="Aptos" panose="020B0004020202020204" pitchFamily="34" charset="0"/>
               </a:rPr>
-              <a:t>CHƯA CÓ API · DỊCH VỤ AI · LỊCH NỀN</a:t>
-            </a:r>
+              <a:t>TÙY CHỌN · CẦN API KEYS + TASK SCHEDULER</a:t>
+            </a:r>
+            <a:endParaRPr lang="vi-VN" sz="900" b="1">
+              <a:solidFill>
+                <a:srgbClr val="CF755F"/>
+              </a:solidFill>
+              <a:latin typeface="Aptos" panose="020B0004020202020204" pitchFamily="34" charset="0"/>
+            </a:endParaRPr>
           </a:p>
         </p:txBody>
       </p:sp>
     </p:spTree>
     <p:extLst>
       <p:ext uri="{BB962C8B-B14F-4D97-AF65-F5344CB8AC3E}">
-        <p14:creationId xmlns:p14="http://schemas.microsoft.com/office/powerpoint/2010/main" val="3270074541"/>
+        <p14:creationId xmlns:p14="http://schemas.microsoft.com/office/powerpoint/2010/main" val="825656413"/>
       </p:ext>
     </p:extLst>
   </p:cSld>
@@ -5264,7 +5270,7 @@
           <p:cNvPr id="2" name="Hộp Văn bản 1">
             <a:extLst>
               <a:ext uri="{FF2B5EF4-FFF2-40B4-BE49-F238E27FC236}">
-                <a16:creationId xmlns:a16="http://schemas.microsoft.com/office/drawing/2014/main" id="{1281540E-9D94-94A3-7909-B981A01974F4}"/>
+                <a16:creationId xmlns:a16="http://schemas.microsoft.com/office/drawing/2014/main" id="{7258574D-1F66-C536-0D64-CC7DBA4C0C3F}"/>
               </a:ext>
             </a:extLst>
           </p:cNvPr>
@@ -5309,7 +5315,7 @@
           <p:cNvPr id="3" name="Hộp Văn bản 2">
             <a:extLst>
               <a:ext uri="{FF2B5EF4-FFF2-40B4-BE49-F238E27FC236}">
-                <a16:creationId xmlns:a16="http://schemas.microsoft.com/office/drawing/2014/main" id="{578DDD6B-AFAD-9381-E53B-0EC0B8A1498D}"/>
+                <a16:creationId xmlns:a16="http://schemas.microsoft.com/office/drawing/2014/main" id="{B0BF9A6A-B8FD-04EB-143C-0B760F799A44}"/>
               </a:ext>
             </a:extLst>
           </p:cNvPr>
@@ -5354,7 +5360,7 @@
           <p:cNvPr id="4" name="Hộp Văn bản 3">
             <a:extLst>
               <a:ext uri="{FF2B5EF4-FFF2-40B4-BE49-F238E27FC236}">
-                <a16:creationId xmlns:a16="http://schemas.microsoft.com/office/drawing/2014/main" id="{42E54834-328C-56C3-06F5-75AA86E721A2}"/>
+                <a16:creationId xmlns:a16="http://schemas.microsoft.com/office/drawing/2014/main" id="{A5EE9EAE-1478-03C7-DD6F-A9597E244EC3}"/>
               </a:ext>
             </a:extLst>
           </p:cNvPr>
@@ -5389,7 +5395,7 @@
                 </a:solidFill>
                 <a:latin typeface="Aptos" panose="020B0004020202020204" pitchFamily="34" charset="0"/>
               </a:rPr>
-              <a:t>Phân biệt biện pháp hiện có với điều kiện cần có trước khi triển khai AI tương lai.</a:t>
+              <a:t>Biện pháp đang có và các điều kiện bắt buộc trước khi kích hoạt tích hợp.</a:t>
             </a:r>
           </a:p>
         </p:txBody>
@@ -5399,7 +5405,7 @@
           <p:cNvPr id="5" name="Hình chữ nhật 4">
             <a:extLst>
               <a:ext uri="{FF2B5EF4-FFF2-40B4-BE49-F238E27FC236}">
-                <a16:creationId xmlns:a16="http://schemas.microsoft.com/office/drawing/2014/main" id="{125C718C-F964-0BDB-DD85-ED80E0123DE1}"/>
+                <a16:creationId xmlns:a16="http://schemas.microsoft.com/office/drawing/2014/main" id="{7DD99FE3-5004-CB4A-EA52-0FE4CCD95670}"/>
               </a:ext>
             </a:extLst>
           </p:cNvPr>
@@ -5467,7 +5473,7 @@
           <p:cNvPr id="6" name="Hộp Văn bản 5">
             <a:extLst>
               <a:ext uri="{FF2B5EF4-FFF2-40B4-BE49-F238E27FC236}">
-                <a16:creationId xmlns:a16="http://schemas.microsoft.com/office/drawing/2014/main" id="{ECB4434C-5EAF-00E3-C047-C30A247FF996}"/>
+                <a16:creationId xmlns:a16="http://schemas.microsoft.com/office/drawing/2014/main" id="{F1BCAEB6-CE18-CFB4-89FF-886981EF8423}"/>
               </a:ext>
             </a:extLst>
           </p:cNvPr>
@@ -5512,7 +5518,7 @@
           <p:cNvPr id="7" name="Hộp Văn bản 6">
             <a:extLst>
               <a:ext uri="{FF2B5EF4-FFF2-40B4-BE49-F238E27FC236}">
-                <a16:creationId xmlns:a16="http://schemas.microsoft.com/office/drawing/2014/main" id="{25E5FAAE-3E8A-1C5D-01E1-8B9C62D1209A}"/>
+                <a16:creationId xmlns:a16="http://schemas.microsoft.com/office/drawing/2014/main" id="{7303BA07-0173-C085-150C-0CF37727735E}"/>
               </a:ext>
             </a:extLst>
           </p:cNvPr>
@@ -5557,7 +5563,7 @@
           <p:cNvPr id="8" name="Hình chữ nhật: Góc Tròn 7">
             <a:extLst>
               <a:ext uri="{FF2B5EF4-FFF2-40B4-BE49-F238E27FC236}">
-                <a16:creationId xmlns:a16="http://schemas.microsoft.com/office/drawing/2014/main" id="{1F853A1C-0755-A084-3FE3-AACE9BF04992}"/>
+                <a16:creationId xmlns:a16="http://schemas.microsoft.com/office/drawing/2014/main" id="{92420AAD-C7F5-F6E5-A379-4E93268F3E8C}"/>
               </a:ext>
             </a:extLst>
           </p:cNvPr>
@@ -5625,7 +5631,7 @@
           <p:cNvPr id="9" name="Hộp Văn bản 8">
             <a:extLst>
               <a:ext uri="{FF2B5EF4-FFF2-40B4-BE49-F238E27FC236}">
-                <a16:creationId xmlns:a16="http://schemas.microsoft.com/office/drawing/2014/main" id="{10486E10-E242-43F8-4BD6-83B3B5F38A0D}"/>
+                <a16:creationId xmlns:a16="http://schemas.microsoft.com/office/drawing/2014/main" id="{1552EA90-69E0-D345-B113-F3B81F875B72}"/>
               </a:ext>
             </a:extLst>
           </p:cNvPr>
@@ -5670,7 +5676,7 @@
           <p:cNvPr id="10" name="Hộp Văn bản 9">
             <a:extLst>
               <a:ext uri="{FF2B5EF4-FFF2-40B4-BE49-F238E27FC236}">
-                <a16:creationId xmlns:a16="http://schemas.microsoft.com/office/drawing/2014/main" id="{5CEAFFBE-1151-F92B-561E-3F3E031A6A02}"/>
+                <a16:creationId xmlns:a16="http://schemas.microsoft.com/office/drawing/2014/main" id="{9BDAFFEC-A662-CFB6-D7D2-140E938D49EB}"/>
               </a:ext>
             </a:extLst>
           </p:cNvPr>
@@ -5705,7 +5711,7 @@
                 </a:solidFill>
                 <a:latin typeface="Aptos" panose="020B0004020202020204" pitchFamily="34" charset="0"/>
               </a:rPr>
-              <a:t>• API nghiệp vụ phân quyền theo vai trò</a:t>
+              <a:t>• Role + quyền hồ sơ; consent bắt buộc</a:t>
             </a:r>
           </a:p>
           <a:p>
@@ -5721,7 +5727,7 @@
                 </a:solidFill>
                 <a:latin typeface="Aptos" panose="020B0004020202020204" pitchFamily="34" charset="0"/>
               </a:rPr>
-              <a:t>• Chatbot không cần dữ liệu bệnh nhân</a:t>
+              <a:t>• Lọc định danh theo mẫu trước Gemini</a:t>
             </a:r>
           </a:p>
           <a:p>
@@ -5737,7 +5743,7 @@
                 </a:solidFill>
                 <a:latin typeface="Aptos" panose="020B0004020202020204" pitchFamily="34" charset="0"/>
               </a:rPr>
-              <a:t>• Trả lời dựa trên danh mục / lịch</a:t>
+              <a:t>• Summary chỉ là bản nháp, không tự lưu</a:t>
             </a:r>
           </a:p>
           <a:p>
@@ -5753,7 +5759,7 @@
                 </a:solidFill>
                 <a:latin typeface="Aptos" panose="020B0004020202020204" pitchFamily="34" charset="0"/>
               </a:rPr>
-              <a:t>• Thiếu dữ liệu: báo rõ, hướng lễ tân</a:t>
+              <a:t>• SMS chỉ là lời mời chung + ngày hẹn</a:t>
             </a:r>
           </a:p>
           <a:p>
@@ -5769,7 +5775,7 @@
                 </a:solidFill>
                 <a:latin typeface="Aptos" panose="020B0004020202020204" pitchFamily="34" charset="0"/>
               </a:rPr>
-              <a:t>• QR chỉ cập nhật sau đối soát</a:t>
+              <a:t>• Theo dõi trạng thái; UNKNOWN không retry</a:t>
             </a:r>
           </a:p>
         </p:txBody>
@@ -5779,7 +5785,7 @@
           <p:cNvPr id="11" name="Hình chữ nhật: Góc Tròn 10">
             <a:extLst>
               <a:ext uri="{FF2B5EF4-FFF2-40B4-BE49-F238E27FC236}">
-                <a16:creationId xmlns:a16="http://schemas.microsoft.com/office/drawing/2014/main" id="{F0B248AF-A757-4A6D-E04E-6BE1754D4803}"/>
+                <a16:creationId xmlns:a16="http://schemas.microsoft.com/office/drawing/2014/main" id="{1524C78E-B7B5-535C-B208-D9C6EDDC9C7D}"/>
               </a:ext>
             </a:extLst>
           </p:cNvPr>
@@ -5847,7 +5853,7 @@
           <p:cNvPr id="12" name="Hộp Văn bản 11">
             <a:extLst>
               <a:ext uri="{FF2B5EF4-FFF2-40B4-BE49-F238E27FC236}">
-                <a16:creationId xmlns:a16="http://schemas.microsoft.com/office/drawing/2014/main" id="{18399091-6F2B-10E8-7DF3-856D50C553EC}"/>
+                <a16:creationId xmlns:a16="http://schemas.microsoft.com/office/drawing/2014/main" id="{6543B2BF-07A1-1EE3-A1B6-63CC0337C472}"/>
               </a:ext>
             </a:extLst>
           </p:cNvPr>
@@ -5882,7 +5888,7 @@
                 </a:solidFill>
                 <a:latin typeface="Aptos" panose="020B0004020202020204" pitchFamily="34" charset="0"/>
               </a:rPr>
-              <a:t>TRƯỚC KHI BẬT AI</a:t>
+              <a:t>TRƯỚC KHI KÍCH HOẠT</a:t>
             </a:r>
           </a:p>
         </p:txBody>
@@ -5892,7 +5898,7 @@
           <p:cNvPr id="13" name="Hộp Văn bản 12">
             <a:extLst>
               <a:ext uri="{FF2B5EF4-FFF2-40B4-BE49-F238E27FC236}">
-                <a16:creationId xmlns:a16="http://schemas.microsoft.com/office/drawing/2014/main" id="{B9A466F9-49F0-F2A5-5A70-6F7636149855}"/>
+                <a16:creationId xmlns:a16="http://schemas.microsoft.com/office/drawing/2014/main" id="{49C28B94-9C66-65B2-A047-737B0C088C16}"/>
               </a:ext>
             </a:extLst>
           </p:cNvPr>
@@ -5927,7 +5933,7 @@
                 </a:solidFill>
                 <a:latin typeface="Aptos" panose="020B0004020202020204" pitchFamily="34" charset="0"/>
               </a:rPr>
-              <a:t>• Duyệt quyền và sự đồng thuận</a:t>
+              <a:t>• Phê duyệt xử lý dữ liệu sức khỏe</a:t>
             </a:r>
           </a:p>
           <a:p>
@@ -5943,7 +5949,7 @@
                 </a:solidFill>
                 <a:latin typeface="Aptos" panose="020B0004020202020204" pitchFamily="34" charset="0"/>
               </a:rPr>
-              <a:t>• Giảm thiểu dữ liệu gửi đi</a:t>
+              <a:t>• Cấu hình key Gemini / Twilio an toàn</a:t>
             </a:r>
           </a:p>
           <a:p>
@@ -5959,7 +5965,7 @@
                 </a:solidFill>
                 <a:latin typeface="Aptos" panose="020B0004020202020204" pitchFamily="34" charset="0"/>
               </a:rPr>
-              <a:t>• Bác sĩ / nhân viên duyệt bản nháp</a:t>
+              <a:t>• Chạy dry-run và xác minh số gửi</a:t>
             </a:r>
           </a:p>
           <a:p>
@@ -5975,7 +5981,7 @@
                 </a:solidFill>
                 <a:latin typeface="Aptos" panose="020B0004020202020204" pitchFamily="34" charset="0"/>
               </a:rPr>
-              <a:t>• Lưu nguồn, phiên bản, nhật ký kiểm toán</a:t>
+              <a:t>• Xác nhận tuyến SMS + chi phí Twilio</a:t>
             </a:r>
           </a:p>
           <a:p>
@@ -5991,7 +5997,7 @@
                 </a:solidFill>
                 <a:latin typeface="Aptos" panose="020B0004020202020204" pitchFamily="34" charset="0"/>
               </a:rPr>
-              <a:t>• Lỗi: báo rõ, chuyển người phụ trách</a:t>
+              <a:t>• Tự cấu hình Task Scheduler; không bật sẵn</a:t>
             </a:r>
           </a:p>
         </p:txBody>
@@ -6001,7 +6007,7 @@
           <p:cNvPr id="14" name="Hộp Văn bản 13">
             <a:extLst>
               <a:ext uri="{FF2B5EF4-FFF2-40B4-BE49-F238E27FC236}">
-                <a16:creationId xmlns:a16="http://schemas.microsoft.com/office/drawing/2014/main" id="{3AF0AAFE-C9F9-03A8-AB89-17B37B108497}"/>
+                <a16:creationId xmlns:a16="http://schemas.microsoft.com/office/drawing/2014/main" id="{4E1705C8-51DB-C4A8-CBD2-394C80023500}"/>
               </a:ext>
             </a:extLst>
           </p:cNvPr>
@@ -6036,7 +6042,7 @@
                 </a:solidFill>
                 <a:latin typeface="Aptos" panose="020B0004020202020204" pitchFamily="34" charset="0"/>
               </a:rPr>
-              <a:t>Hiện tại chưa gửi hồ sơ bệnh án tới nhà cung cấp AI.</a:t>
+              <a:t>Không chẩn đoán hay quyết định điều trị bằng AI; bác sĩ chịu trách nhiệm chuyên môn.</a:t>
             </a:r>
           </a:p>
         </p:txBody>
@@ -6044,7 +6050,7 @@
     </p:spTree>
     <p:extLst>
       <p:ext uri="{BB962C8B-B14F-4D97-AF65-F5344CB8AC3E}">
-        <p14:creationId xmlns:p14="http://schemas.microsoft.com/office/powerpoint/2010/main" val="3128286582"/>
+        <p14:creationId xmlns:p14="http://schemas.microsoft.com/office/powerpoint/2010/main" val="899283255"/>
       </p:ext>
     </p:extLst>
   </p:cSld>
@@ -6076,7 +6082,7 @@
           <p:cNvPr id="2" name="Hộp Văn bản 1">
             <a:extLst>
               <a:ext uri="{FF2B5EF4-FFF2-40B4-BE49-F238E27FC236}">
-                <a16:creationId xmlns:a16="http://schemas.microsoft.com/office/drawing/2014/main" id="{B0D124E2-50B5-079C-791A-7A34F2FFB5F9}"/>
+                <a16:creationId xmlns:a16="http://schemas.microsoft.com/office/drawing/2014/main" id="{59EB209B-7BA7-092F-67E2-4C868B83AF7E}"/>
               </a:ext>
             </a:extLst>
           </p:cNvPr>
@@ -6121,7 +6127,7 @@
           <p:cNvPr id="3" name="Hộp Văn bản 2">
             <a:extLst>
               <a:ext uri="{FF2B5EF4-FFF2-40B4-BE49-F238E27FC236}">
-                <a16:creationId xmlns:a16="http://schemas.microsoft.com/office/drawing/2014/main" id="{5F05215F-206C-9B47-8E8B-D31012F23536}"/>
+                <a16:creationId xmlns:a16="http://schemas.microsoft.com/office/drawing/2014/main" id="{18B083F2-EC43-809B-FFBE-C4F32B4A3903}"/>
               </a:ext>
             </a:extLst>
           </p:cNvPr>
@@ -6166,7 +6172,7 @@
           <p:cNvPr id="4" name="Hộp Văn bản 3">
             <a:extLst>
               <a:ext uri="{FF2B5EF4-FFF2-40B4-BE49-F238E27FC236}">
-                <a16:creationId xmlns:a16="http://schemas.microsoft.com/office/drawing/2014/main" id="{8BBF6CE5-ED15-5882-5102-07EF922FB4E8}"/>
+                <a16:creationId xmlns:a16="http://schemas.microsoft.com/office/drawing/2014/main" id="{D23E3F3C-094F-8446-C15C-2F0F222C610B}"/>
               </a:ext>
             </a:extLst>
           </p:cNvPr>
@@ -6211,7 +6217,7 @@
           <p:cNvPr id="5" name="Hình chữ nhật 4">
             <a:extLst>
               <a:ext uri="{FF2B5EF4-FFF2-40B4-BE49-F238E27FC236}">
-                <a16:creationId xmlns:a16="http://schemas.microsoft.com/office/drawing/2014/main" id="{0B0D1A2C-A9D5-3E45-FC47-375336F295F0}"/>
+                <a16:creationId xmlns:a16="http://schemas.microsoft.com/office/drawing/2014/main" id="{FBCAAC6F-A348-4F7A-6373-E98552F8F7CD}"/>
               </a:ext>
             </a:extLst>
           </p:cNvPr>
@@ -6279,7 +6285,7 @@
           <p:cNvPr id="6" name="Hộp Văn bản 5">
             <a:extLst>
               <a:ext uri="{FF2B5EF4-FFF2-40B4-BE49-F238E27FC236}">
-                <a16:creationId xmlns:a16="http://schemas.microsoft.com/office/drawing/2014/main" id="{9F892B45-9113-247F-4595-F1AD6D7B3793}"/>
+                <a16:creationId xmlns:a16="http://schemas.microsoft.com/office/drawing/2014/main" id="{BE4CA1FF-6AB3-442F-982C-7DD96FAD22FA}"/>
               </a:ext>
             </a:extLst>
           </p:cNvPr>
@@ -6324,7 +6330,7 @@
           <p:cNvPr id="7" name="Hộp Văn bản 6">
             <a:extLst>
               <a:ext uri="{FF2B5EF4-FFF2-40B4-BE49-F238E27FC236}">
-                <a16:creationId xmlns:a16="http://schemas.microsoft.com/office/drawing/2014/main" id="{C7CD6ACE-1497-B25E-F1E2-B9015771ECFE}"/>
+                <a16:creationId xmlns:a16="http://schemas.microsoft.com/office/drawing/2014/main" id="{518D9661-AEF3-AE6E-7040-D7A982CBA3FA}"/>
               </a:ext>
             </a:extLst>
           </p:cNvPr>
@@ -6369,7 +6375,7 @@
           <p:cNvPr id="8" name="Hình chữ nhật: Góc Tròn 7">
             <a:extLst>
               <a:ext uri="{FF2B5EF4-FFF2-40B4-BE49-F238E27FC236}">
-                <a16:creationId xmlns:a16="http://schemas.microsoft.com/office/drawing/2014/main" id="{73796BFF-0965-DC69-7DA6-D3A7851BA879}"/>
+                <a16:creationId xmlns:a16="http://schemas.microsoft.com/office/drawing/2014/main" id="{50868ABD-5627-0FDA-5000-74FF672027E9}"/>
               </a:ext>
             </a:extLst>
           </p:cNvPr>
@@ -6437,7 +6443,7 @@
           <p:cNvPr id="9" name="Hộp Văn bản 8">
             <a:extLst>
               <a:ext uri="{FF2B5EF4-FFF2-40B4-BE49-F238E27FC236}">
-                <a16:creationId xmlns:a16="http://schemas.microsoft.com/office/drawing/2014/main" id="{CAE31297-602C-B9C1-88DE-078BD72AB4D5}"/>
+                <a16:creationId xmlns:a16="http://schemas.microsoft.com/office/drawing/2014/main" id="{64EF1677-F4C0-041E-3A3F-3EEB3F20A12E}"/>
               </a:ext>
             </a:extLst>
           </p:cNvPr>
@@ -6482,7 +6488,7 @@
           <p:cNvPr id="10" name="Hộp Văn bản 9">
             <a:extLst>
               <a:ext uri="{FF2B5EF4-FFF2-40B4-BE49-F238E27FC236}">
-                <a16:creationId xmlns:a16="http://schemas.microsoft.com/office/drawing/2014/main" id="{B7B27C5F-636F-E011-D5D1-D63C8A8C52B5}"/>
+                <a16:creationId xmlns:a16="http://schemas.microsoft.com/office/drawing/2014/main" id="{81AFE059-950B-55AE-A5E5-9A77540123F1}"/>
               </a:ext>
             </a:extLst>
           </p:cNvPr>
@@ -6527,7 +6533,7 @@
           <p:cNvPr id="11" name="Hộp Văn bản 10">
             <a:extLst>
               <a:ext uri="{FF2B5EF4-FFF2-40B4-BE49-F238E27FC236}">
-                <a16:creationId xmlns:a16="http://schemas.microsoft.com/office/drawing/2014/main" id="{2DCF0C0C-D1FB-C533-1BB0-EA38D224ABA8}"/>
+                <a16:creationId xmlns:a16="http://schemas.microsoft.com/office/drawing/2014/main" id="{0713CF42-AB2F-E5C0-8E9D-1D535AEF4FAC}"/>
               </a:ext>
             </a:extLst>
           </p:cNvPr>
@@ -6572,7 +6578,7 @@
           <p:cNvPr id="12" name="Hình chữ nhật: Góc Tròn 11">
             <a:extLst>
               <a:ext uri="{FF2B5EF4-FFF2-40B4-BE49-F238E27FC236}">
-                <a16:creationId xmlns:a16="http://schemas.microsoft.com/office/drawing/2014/main" id="{D832E6E2-1A73-6E30-1FA8-6F7161301771}"/>
+                <a16:creationId xmlns:a16="http://schemas.microsoft.com/office/drawing/2014/main" id="{187DCDA2-3842-132E-4FF2-E75C1ACB0606}"/>
               </a:ext>
             </a:extLst>
           </p:cNvPr>
@@ -6640,7 +6646,7 @@
           <p:cNvPr id="13" name="Hộp Văn bản 12">
             <a:extLst>
               <a:ext uri="{FF2B5EF4-FFF2-40B4-BE49-F238E27FC236}">
-                <a16:creationId xmlns:a16="http://schemas.microsoft.com/office/drawing/2014/main" id="{2C9B62A3-E4F9-D74F-65A3-85BEF89B8F98}"/>
+                <a16:creationId xmlns:a16="http://schemas.microsoft.com/office/drawing/2014/main" id="{C6E19829-0B50-5165-A728-83E2AB13866E}"/>
               </a:ext>
             </a:extLst>
           </p:cNvPr>
@@ -6685,7 +6691,7 @@
           <p:cNvPr id="14" name="Hộp Văn bản 13">
             <a:extLst>
               <a:ext uri="{FF2B5EF4-FFF2-40B4-BE49-F238E27FC236}">
-                <a16:creationId xmlns:a16="http://schemas.microsoft.com/office/drawing/2014/main" id="{90B11AE0-B9EC-F896-19B5-5136D9881E85}"/>
+                <a16:creationId xmlns:a16="http://schemas.microsoft.com/office/drawing/2014/main" id="{2CFE7A48-214A-C59D-EFE0-8BE259417003}"/>
               </a:ext>
             </a:extLst>
           </p:cNvPr>
@@ -6730,7 +6736,7 @@
           <p:cNvPr id="15" name="Hộp Văn bản 14">
             <a:extLst>
               <a:ext uri="{FF2B5EF4-FFF2-40B4-BE49-F238E27FC236}">
-                <a16:creationId xmlns:a16="http://schemas.microsoft.com/office/drawing/2014/main" id="{233BFB6E-BCF4-EAD9-C31F-CE74EF7B8A60}"/>
+                <a16:creationId xmlns:a16="http://schemas.microsoft.com/office/drawing/2014/main" id="{C34142C3-F289-CCF9-0CEA-8D848055E4DF}"/>
               </a:ext>
             </a:extLst>
           </p:cNvPr>
@@ -6775,7 +6781,7 @@
           <p:cNvPr id="16" name="Hình chữ nhật: Góc Tròn 15">
             <a:extLst>
               <a:ext uri="{FF2B5EF4-FFF2-40B4-BE49-F238E27FC236}">
-                <a16:creationId xmlns:a16="http://schemas.microsoft.com/office/drawing/2014/main" id="{DE2D5B35-B443-B32E-14AD-01C57BCD33FF}"/>
+                <a16:creationId xmlns:a16="http://schemas.microsoft.com/office/drawing/2014/main" id="{3FAA3876-3FB6-A482-0CE4-FBA88E1963C3}"/>
               </a:ext>
             </a:extLst>
           </p:cNvPr>
@@ -6843,7 +6849,7 @@
           <p:cNvPr id="17" name="Hộp Văn bản 16">
             <a:extLst>
               <a:ext uri="{FF2B5EF4-FFF2-40B4-BE49-F238E27FC236}">
-                <a16:creationId xmlns:a16="http://schemas.microsoft.com/office/drawing/2014/main" id="{6D23270B-73A2-5715-BC85-F6B763914B9D}"/>
+                <a16:creationId xmlns:a16="http://schemas.microsoft.com/office/drawing/2014/main" id="{870C105D-D2F7-8B71-87EB-2FB91A6BC355}"/>
               </a:ext>
             </a:extLst>
           </p:cNvPr>
@@ -6888,7 +6894,7 @@
           <p:cNvPr id="18" name="Hộp Văn bản 17">
             <a:extLst>
               <a:ext uri="{FF2B5EF4-FFF2-40B4-BE49-F238E27FC236}">
-                <a16:creationId xmlns:a16="http://schemas.microsoft.com/office/drawing/2014/main" id="{8CDE88C2-C15C-0BFE-5E1D-D7B40600B28B}"/>
+                <a16:creationId xmlns:a16="http://schemas.microsoft.com/office/drawing/2014/main" id="{08843267-A75F-BA1F-C89A-8DCED89ECAD5}"/>
               </a:ext>
             </a:extLst>
           </p:cNvPr>
@@ -6933,7 +6939,7 @@
           <p:cNvPr id="19" name="Hộp Văn bản 18">
             <a:extLst>
               <a:ext uri="{FF2B5EF4-FFF2-40B4-BE49-F238E27FC236}">
-                <a16:creationId xmlns:a16="http://schemas.microsoft.com/office/drawing/2014/main" id="{5C86644B-1AD6-FAC0-D132-85132E790359}"/>
+                <a16:creationId xmlns:a16="http://schemas.microsoft.com/office/drawing/2014/main" id="{496B3813-6BA2-E11A-DFAE-A2791F6B686B}"/>
               </a:ext>
             </a:extLst>
           </p:cNvPr>
@@ -6978,7 +6984,7 @@
           <p:cNvPr id="20" name="Hình chữ nhật: Góc Tròn 19">
             <a:extLst>
               <a:ext uri="{FF2B5EF4-FFF2-40B4-BE49-F238E27FC236}">
-                <a16:creationId xmlns:a16="http://schemas.microsoft.com/office/drawing/2014/main" id="{A6C602D8-58EE-F4C6-F3E2-72247F56EE37}"/>
+                <a16:creationId xmlns:a16="http://schemas.microsoft.com/office/drawing/2014/main" id="{08F024B2-F488-27FC-78C3-B882B442BC4F}"/>
               </a:ext>
             </a:extLst>
           </p:cNvPr>
@@ -7046,7 +7052,7 @@
           <p:cNvPr id="21" name="Hộp Văn bản 20">
             <a:extLst>
               <a:ext uri="{FF2B5EF4-FFF2-40B4-BE49-F238E27FC236}">
-                <a16:creationId xmlns:a16="http://schemas.microsoft.com/office/drawing/2014/main" id="{4D96289B-6979-0B8C-F3E7-A82DF7196ECC}"/>
+                <a16:creationId xmlns:a16="http://schemas.microsoft.com/office/drawing/2014/main" id="{EADA7973-23E9-E1F5-F727-EED6E987F1CC}"/>
               </a:ext>
             </a:extLst>
           </p:cNvPr>
@@ -7091,7 +7097,7 @@
           <p:cNvPr id="22" name="Hộp Văn bản 21">
             <a:extLst>
               <a:ext uri="{FF2B5EF4-FFF2-40B4-BE49-F238E27FC236}">
-                <a16:creationId xmlns:a16="http://schemas.microsoft.com/office/drawing/2014/main" id="{9252CC15-21E4-0635-D6D7-2ED106103716}"/>
+                <a16:creationId xmlns:a16="http://schemas.microsoft.com/office/drawing/2014/main" id="{0B33C7CC-DA1D-BB3E-79E6-02FB8A551FF4}"/>
               </a:ext>
             </a:extLst>
           </p:cNvPr>
@@ -7136,7 +7142,7 @@
           <p:cNvPr id="23" name="Hộp Văn bản 22">
             <a:extLst>
               <a:ext uri="{FF2B5EF4-FFF2-40B4-BE49-F238E27FC236}">
-                <a16:creationId xmlns:a16="http://schemas.microsoft.com/office/drawing/2014/main" id="{04AF3A35-AE94-BAC5-A2EE-AA7B582255A8}"/>
+                <a16:creationId xmlns:a16="http://schemas.microsoft.com/office/drawing/2014/main" id="{2343D1EE-3927-8663-2054-6C2B26F9C114}"/>
               </a:ext>
             </a:extLst>
           </p:cNvPr>
@@ -7181,7 +7187,7 @@
           <p:cNvPr id="24" name="Hộp Văn bản 23">
             <a:extLst>
               <a:ext uri="{FF2B5EF4-FFF2-40B4-BE49-F238E27FC236}">
-                <a16:creationId xmlns:a16="http://schemas.microsoft.com/office/drawing/2014/main" id="{4AFF467A-7B55-5F5C-E2A3-AB5736A63EC0}"/>
+                <a16:creationId xmlns:a16="http://schemas.microsoft.com/office/drawing/2014/main" id="{5F3AE1FF-4785-D2FE-DB3E-BF820051DADC}"/>
               </a:ext>
             </a:extLst>
           </p:cNvPr>
@@ -7216,7 +7222,7 @@
                 </a:solidFill>
                 <a:latin typeface="Aptos" panose="020B0004020202020204" pitchFamily="34" charset="0"/>
               </a:rPr>
-              <a:t>Không trình diễn AI tóm tắt EMR hoặc gửi nhắc tái khám như chức năng đã có. Trình bày đó là đề xuất ở trang 10.</a:t>
+              <a:t>AI/SMS đã có trong source nhưng chưa cấu hình ở môi trường demo: không khẳng định đã gọi Gemini/Twilio. Trình bày đây là tích hợp tùy chọn, cần consent và cấu hình vận hành.</a:t>
             </a:r>
           </a:p>
         </p:txBody>
@@ -7224,7 +7230,7 @@
     </p:spTree>
     <p:extLst>
       <p:ext uri="{BB962C8B-B14F-4D97-AF65-F5344CB8AC3E}">
-        <p14:creationId xmlns:p14="http://schemas.microsoft.com/office/powerpoint/2010/main" val="3096584165"/>
+        <p14:creationId xmlns:p14="http://schemas.microsoft.com/office/powerpoint/2010/main" val="3310595391"/>
       </p:ext>
     </p:extLst>
   </p:cSld>
@@ -7256,7 +7262,7 @@
           <p:cNvPr id="2" name="Hộp Văn bản 1">
             <a:extLst>
               <a:ext uri="{FF2B5EF4-FFF2-40B4-BE49-F238E27FC236}">
-                <a16:creationId xmlns:a16="http://schemas.microsoft.com/office/drawing/2014/main" id="{E990356F-9C3F-B22C-C5F3-1FA75F9DBDE5}"/>
+                <a16:creationId xmlns:a16="http://schemas.microsoft.com/office/drawing/2014/main" id="{D954A977-5143-8A50-D0B1-52E610F94482}"/>
               </a:ext>
             </a:extLst>
           </p:cNvPr>
@@ -7301,7 +7307,7 @@
           <p:cNvPr id="3" name="Hộp Văn bản 2">
             <a:extLst>
               <a:ext uri="{FF2B5EF4-FFF2-40B4-BE49-F238E27FC236}">
-                <a16:creationId xmlns:a16="http://schemas.microsoft.com/office/drawing/2014/main" id="{AEC6ED75-106C-A5AF-692A-2B4CCE34E9AC}"/>
+                <a16:creationId xmlns:a16="http://schemas.microsoft.com/office/drawing/2014/main" id="{E54E4A9E-EF5C-B699-A7BC-1EC93D66D968}"/>
               </a:ext>
             </a:extLst>
           </p:cNvPr>
@@ -7346,7 +7352,7 @@
           <p:cNvPr id="4" name="Hộp Văn bản 3">
             <a:extLst>
               <a:ext uri="{FF2B5EF4-FFF2-40B4-BE49-F238E27FC236}">
-                <a16:creationId xmlns:a16="http://schemas.microsoft.com/office/drawing/2014/main" id="{DB2AC467-5F92-A6EC-B031-B10B74FA5AE0}"/>
+                <a16:creationId xmlns:a16="http://schemas.microsoft.com/office/drawing/2014/main" id="{D5A950DF-F770-AA89-C624-62FF8A985109}"/>
               </a:ext>
             </a:extLst>
           </p:cNvPr>
@@ -7391,7 +7397,7 @@
           <p:cNvPr id="5" name="Hình chữ nhật 4">
             <a:extLst>
               <a:ext uri="{FF2B5EF4-FFF2-40B4-BE49-F238E27FC236}">
-                <a16:creationId xmlns:a16="http://schemas.microsoft.com/office/drawing/2014/main" id="{5B2B4751-43DB-6650-2DE8-B2893A9E6E65}"/>
+                <a16:creationId xmlns:a16="http://schemas.microsoft.com/office/drawing/2014/main" id="{754B55E5-FC7C-1AAF-D993-68AC01F45453}"/>
               </a:ext>
             </a:extLst>
           </p:cNvPr>
@@ -7459,7 +7465,7 @@
           <p:cNvPr id="6" name="Hộp Văn bản 5">
             <a:extLst>
               <a:ext uri="{FF2B5EF4-FFF2-40B4-BE49-F238E27FC236}">
-                <a16:creationId xmlns:a16="http://schemas.microsoft.com/office/drawing/2014/main" id="{83087726-FE9A-257D-B3C6-01E8733416F7}"/>
+                <a16:creationId xmlns:a16="http://schemas.microsoft.com/office/drawing/2014/main" id="{0CB82D30-43B9-5339-AABE-6AE35567F966}"/>
               </a:ext>
             </a:extLst>
           </p:cNvPr>
@@ -7504,7 +7510,7 @@
           <p:cNvPr id="7" name="Hộp Văn bản 6">
             <a:extLst>
               <a:ext uri="{FF2B5EF4-FFF2-40B4-BE49-F238E27FC236}">
-                <a16:creationId xmlns:a16="http://schemas.microsoft.com/office/drawing/2014/main" id="{BD6FCC94-F544-13FE-15D2-C93D1DD1D625}"/>
+                <a16:creationId xmlns:a16="http://schemas.microsoft.com/office/drawing/2014/main" id="{6DB2AF16-F603-6AD7-20BD-B579A0A5AA6A}"/>
               </a:ext>
             </a:extLst>
           </p:cNvPr>
@@ -7549,7 +7555,7 @@
           <p:cNvPr id="8" name="Hình chữ nhật: Góc Tròn 7">
             <a:extLst>
               <a:ext uri="{FF2B5EF4-FFF2-40B4-BE49-F238E27FC236}">
-                <a16:creationId xmlns:a16="http://schemas.microsoft.com/office/drawing/2014/main" id="{78B88997-F553-4D20-0F90-C8E79F4B9172}"/>
+                <a16:creationId xmlns:a16="http://schemas.microsoft.com/office/drawing/2014/main" id="{10A2FC4C-005F-EE57-8987-B2951F866121}"/>
               </a:ext>
             </a:extLst>
           </p:cNvPr>
@@ -7617,7 +7623,7 @@
           <p:cNvPr id="9" name="Hình chữ nhật 8">
             <a:extLst>
               <a:ext uri="{FF2B5EF4-FFF2-40B4-BE49-F238E27FC236}">
-                <a16:creationId xmlns:a16="http://schemas.microsoft.com/office/drawing/2014/main" id="{23B8870D-CEA5-18DA-1CF2-6FA3848B9DC2}"/>
+                <a16:creationId xmlns:a16="http://schemas.microsoft.com/office/drawing/2014/main" id="{1986D320-17CA-2B1A-A58D-1759B10C7552}"/>
               </a:ext>
             </a:extLst>
           </p:cNvPr>
@@ -7685,7 +7691,7 @@
           <p:cNvPr id="10" name="Hộp Văn bản 9">
             <a:extLst>
               <a:ext uri="{FF2B5EF4-FFF2-40B4-BE49-F238E27FC236}">
-                <a16:creationId xmlns:a16="http://schemas.microsoft.com/office/drawing/2014/main" id="{B566BE51-E6E3-3C5F-C6C2-53FD502AE0EE}"/>
+                <a16:creationId xmlns:a16="http://schemas.microsoft.com/office/drawing/2014/main" id="{776F82BD-FDDA-3CF1-A9A1-38F97D05A424}"/>
               </a:ext>
             </a:extLst>
           </p:cNvPr>
@@ -7736,7 +7742,7 @@
           <p:cNvPr id="11" name="Hộp Văn bản 10">
             <a:extLst>
               <a:ext uri="{FF2B5EF4-FFF2-40B4-BE49-F238E27FC236}">
-                <a16:creationId xmlns:a16="http://schemas.microsoft.com/office/drawing/2014/main" id="{22A36704-370C-9E94-647C-F3F45430581A}"/>
+                <a16:creationId xmlns:a16="http://schemas.microsoft.com/office/drawing/2014/main" id="{D44D5597-F371-BA09-EF5A-5BDDCA540433}"/>
               </a:ext>
             </a:extLst>
           </p:cNvPr>
@@ -7781,7 +7787,7 @@
           <p:cNvPr id="12" name="Hình chữ nhật: Góc Tròn 11">
             <a:extLst>
               <a:ext uri="{FF2B5EF4-FFF2-40B4-BE49-F238E27FC236}">
-                <a16:creationId xmlns:a16="http://schemas.microsoft.com/office/drawing/2014/main" id="{CA917AF5-B36F-1A3C-0DCB-E571FDBC94FA}"/>
+                <a16:creationId xmlns:a16="http://schemas.microsoft.com/office/drawing/2014/main" id="{C5FF5C1E-018F-2F80-CE20-4F71524F3FC3}"/>
               </a:ext>
             </a:extLst>
           </p:cNvPr>
@@ -7849,7 +7855,7 @@
           <p:cNvPr id="13" name="Hình chữ nhật 12">
             <a:extLst>
               <a:ext uri="{FF2B5EF4-FFF2-40B4-BE49-F238E27FC236}">
-                <a16:creationId xmlns:a16="http://schemas.microsoft.com/office/drawing/2014/main" id="{1972A591-CF8C-B1AD-A4BA-54B1CB01A5DE}"/>
+                <a16:creationId xmlns:a16="http://schemas.microsoft.com/office/drawing/2014/main" id="{975F05C2-F13D-B7E8-7B44-0FE88EF0BEE5}"/>
               </a:ext>
             </a:extLst>
           </p:cNvPr>
@@ -7917,7 +7923,7 @@
           <p:cNvPr id="14" name="Hộp Văn bản 13">
             <a:extLst>
               <a:ext uri="{FF2B5EF4-FFF2-40B4-BE49-F238E27FC236}">
-                <a16:creationId xmlns:a16="http://schemas.microsoft.com/office/drawing/2014/main" id="{ECD11F75-DE9C-1583-E2E9-D577E8F0CF71}"/>
+                <a16:creationId xmlns:a16="http://schemas.microsoft.com/office/drawing/2014/main" id="{40457EAB-79BD-926B-C62B-B3AA6181483C}"/>
               </a:ext>
             </a:extLst>
           </p:cNvPr>
@@ -7962,7 +7968,7 @@
           <p:cNvPr id="15" name="Hộp Văn bản 14">
             <a:extLst>
               <a:ext uri="{FF2B5EF4-FFF2-40B4-BE49-F238E27FC236}">
-                <a16:creationId xmlns:a16="http://schemas.microsoft.com/office/drawing/2014/main" id="{24EEDBFF-7284-2334-C21F-5FA1E56D9B57}"/>
+                <a16:creationId xmlns:a16="http://schemas.microsoft.com/office/drawing/2014/main" id="{0C3115BD-4F56-09EE-FCCD-747AE2A4BABB}"/>
               </a:ext>
             </a:extLst>
           </p:cNvPr>
@@ -8007,7 +8013,7 @@
           <p:cNvPr id="16" name="Hình chữ nhật: Góc Tròn 15">
             <a:extLst>
               <a:ext uri="{FF2B5EF4-FFF2-40B4-BE49-F238E27FC236}">
-                <a16:creationId xmlns:a16="http://schemas.microsoft.com/office/drawing/2014/main" id="{20C9498D-FB13-C622-B148-EC3C4AC974D4}"/>
+                <a16:creationId xmlns:a16="http://schemas.microsoft.com/office/drawing/2014/main" id="{B34F900A-0261-AB17-39C8-5AEF6CDC6514}"/>
               </a:ext>
             </a:extLst>
           </p:cNvPr>
@@ -8075,7 +8081,7 @@
           <p:cNvPr id="17" name="Hình chữ nhật 16">
             <a:extLst>
               <a:ext uri="{FF2B5EF4-FFF2-40B4-BE49-F238E27FC236}">
-                <a16:creationId xmlns:a16="http://schemas.microsoft.com/office/drawing/2014/main" id="{4211B158-70C2-30B3-5095-DE699C30A078}"/>
+                <a16:creationId xmlns:a16="http://schemas.microsoft.com/office/drawing/2014/main" id="{24165E2F-28B8-AAD4-773D-3FF7AEC922C1}"/>
               </a:ext>
             </a:extLst>
           </p:cNvPr>
@@ -8143,7 +8149,7 @@
           <p:cNvPr id="18" name="Hộp Văn bản 17">
             <a:extLst>
               <a:ext uri="{FF2B5EF4-FFF2-40B4-BE49-F238E27FC236}">
-                <a16:creationId xmlns:a16="http://schemas.microsoft.com/office/drawing/2014/main" id="{8507BF57-2363-2224-4FBC-574D31697D06}"/>
+                <a16:creationId xmlns:a16="http://schemas.microsoft.com/office/drawing/2014/main" id="{E0BD6D2B-9245-31DC-B626-0D7FBED4A521}"/>
               </a:ext>
             </a:extLst>
           </p:cNvPr>
@@ -8188,7 +8194,7 @@
           <p:cNvPr id="19" name="Hộp Văn bản 18">
             <a:extLst>
               <a:ext uri="{FF2B5EF4-FFF2-40B4-BE49-F238E27FC236}">
-                <a16:creationId xmlns:a16="http://schemas.microsoft.com/office/drawing/2014/main" id="{D0EA77E1-94E8-8F27-5877-332630167572}"/>
+                <a16:creationId xmlns:a16="http://schemas.microsoft.com/office/drawing/2014/main" id="{D1F7D142-6EF1-81BC-347B-2D7D4A55720D}"/>
               </a:ext>
             </a:extLst>
           </p:cNvPr>
@@ -8233,7 +8239,7 @@
           <p:cNvPr id="20" name="Hình chữ nhật: Góc Tròn 19">
             <a:extLst>
               <a:ext uri="{FF2B5EF4-FFF2-40B4-BE49-F238E27FC236}">
-                <a16:creationId xmlns:a16="http://schemas.microsoft.com/office/drawing/2014/main" id="{46DC4C10-0968-ED1D-64D0-2AA78ABADC7F}"/>
+                <a16:creationId xmlns:a16="http://schemas.microsoft.com/office/drawing/2014/main" id="{18B4A9E5-1C16-2477-D181-EE177D21D2D9}"/>
               </a:ext>
             </a:extLst>
           </p:cNvPr>
@@ -8301,7 +8307,7 @@
           <p:cNvPr id="21" name="Hộp Văn bản 20">
             <a:extLst>
               <a:ext uri="{FF2B5EF4-FFF2-40B4-BE49-F238E27FC236}">
-                <a16:creationId xmlns:a16="http://schemas.microsoft.com/office/drawing/2014/main" id="{A17A3F16-59A6-02E3-E8DF-EE36EE1FBB7A}"/>
+                <a16:creationId xmlns:a16="http://schemas.microsoft.com/office/drawing/2014/main" id="{23C37116-A4C0-8FF7-5583-1CE256751D1E}"/>
               </a:ext>
             </a:extLst>
           </p:cNvPr>
@@ -8344,7 +8350,7 @@
     </p:spTree>
     <p:extLst>
       <p:ext uri="{BB962C8B-B14F-4D97-AF65-F5344CB8AC3E}">
-        <p14:creationId xmlns:p14="http://schemas.microsoft.com/office/powerpoint/2010/main" val="3249573604"/>
+        <p14:creationId xmlns:p14="http://schemas.microsoft.com/office/powerpoint/2010/main" val="1627229475"/>
       </p:ext>
     </p:extLst>
   </p:cSld>
@@ -8376,7 +8382,7 @@
           <p:cNvPr id="2" name="Hộp Văn bản 1">
             <a:extLst>
               <a:ext uri="{FF2B5EF4-FFF2-40B4-BE49-F238E27FC236}">
-                <a16:creationId xmlns:a16="http://schemas.microsoft.com/office/drawing/2014/main" id="{48BFBCEA-6FCE-DB3B-0F34-5B2A1C1FFBC4}"/>
+                <a16:creationId xmlns:a16="http://schemas.microsoft.com/office/drawing/2014/main" id="{EC801E1C-5348-5DB4-BBF7-024DEBFE3613}"/>
               </a:ext>
             </a:extLst>
           </p:cNvPr>
@@ -8421,7 +8427,7 @@
           <p:cNvPr id="3" name="Hộp Văn bản 2">
             <a:extLst>
               <a:ext uri="{FF2B5EF4-FFF2-40B4-BE49-F238E27FC236}">
-                <a16:creationId xmlns:a16="http://schemas.microsoft.com/office/drawing/2014/main" id="{DADB7A87-A5DC-0C53-71A4-3F2401F06661}"/>
+                <a16:creationId xmlns:a16="http://schemas.microsoft.com/office/drawing/2014/main" id="{A522F758-F571-6370-B1FE-CC940C1C5B8B}"/>
               </a:ext>
             </a:extLst>
           </p:cNvPr>
@@ -8466,7 +8472,7 @@
           <p:cNvPr id="4" name="Hộp Văn bản 3">
             <a:extLst>
               <a:ext uri="{FF2B5EF4-FFF2-40B4-BE49-F238E27FC236}">
-                <a16:creationId xmlns:a16="http://schemas.microsoft.com/office/drawing/2014/main" id="{4B4AE960-7985-BCBE-3583-9E913BD4DAA0}"/>
+                <a16:creationId xmlns:a16="http://schemas.microsoft.com/office/drawing/2014/main" id="{C99FEBF7-5964-E335-2790-5448C5D4A19D}"/>
               </a:ext>
             </a:extLst>
           </p:cNvPr>
@@ -8511,7 +8517,7 @@
           <p:cNvPr id="5" name="Hình chữ nhật 4">
             <a:extLst>
               <a:ext uri="{FF2B5EF4-FFF2-40B4-BE49-F238E27FC236}">
-                <a16:creationId xmlns:a16="http://schemas.microsoft.com/office/drawing/2014/main" id="{30189FD9-F662-FE10-0DC0-766BDBA562D4}"/>
+                <a16:creationId xmlns:a16="http://schemas.microsoft.com/office/drawing/2014/main" id="{20E35455-1B3F-7F3C-79CE-4CB2927CD664}"/>
               </a:ext>
             </a:extLst>
           </p:cNvPr>
@@ -8579,7 +8585,7 @@
           <p:cNvPr id="6" name="Hộp Văn bản 5">
             <a:extLst>
               <a:ext uri="{FF2B5EF4-FFF2-40B4-BE49-F238E27FC236}">
-                <a16:creationId xmlns:a16="http://schemas.microsoft.com/office/drawing/2014/main" id="{DCA59BFB-622F-FEB5-FB18-CDBEE8E584C3}"/>
+                <a16:creationId xmlns:a16="http://schemas.microsoft.com/office/drawing/2014/main" id="{E7ACA612-597B-E92F-431F-1DC7DC5F5956}"/>
               </a:ext>
             </a:extLst>
           </p:cNvPr>
@@ -8624,7 +8630,7 @@
           <p:cNvPr id="7" name="Hộp Văn bản 6">
             <a:extLst>
               <a:ext uri="{FF2B5EF4-FFF2-40B4-BE49-F238E27FC236}">
-                <a16:creationId xmlns:a16="http://schemas.microsoft.com/office/drawing/2014/main" id="{0599A72A-5001-396A-EC22-03C6CC992947}"/>
+                <a16:creationId xmlns:a16="http://schemas.microsoft.com/office/drawing/2014/main" id="{43245514-7455-1AAD-3806-559E03E100FA}"/>
               </a:ext>
             </a:extLst>
           </p:cNvPr>
@@ -8669,7 +8675,7 @@
           <p:cNvPr id="8" name="Hình chữ nhật: Góc Tròn 7">
             <a:extLst>
               <a:ext uri="{FF2B5EF4-FFF2-40B4-BE49-F238E27FC236}">
-                <a16:creationId xmlns:a16="http://schemas.microsoft.com/office/drawing/2014/main" id="{CEBE457E-B993-C70A-7C88-7C15C1341056}"/>
+                <a16:creationId xmlns:a16="http://schemas.microsoft.com/office/drawing/2014/main" id="{7D7413B0-EEEE-5B1C-EF60-6B2A81E10061}"/>
               </a:ext>
             </a:extLst>
           </p:cNvPr>
@@ -8737,7 +8743,7 @@
           <p:cNvPr id="9" name="Hình chữ nhật 8">
             <a:extLst>
               <a:ext uri="{FF2B5EF4-FFF2-40B4-BE49-F238E27FC236}">
-                <a16:creationId xmlns:a16="http://schemas.microsoft.com/office/drawing/2014/main" id="{668090B9-7CCF-2786-A32D-974B8152CBC9}"/>
+                <a16:creationId xmlns:a16="http://schemas.microsoft.com/office/drawing/2014/main" id="{D60E516D-EF4D-6E44-8489-4D4BDAF2E5CC}"/>
               </a:ext>
             </a:extLst>
           </p:cNvPr>
@@ -8805,7 +8811,7 @@
           <p:cNvPr id="10" name="Hộp Văn bản 9">
             <a:extLst>
               <a:ext uri="{FF2B5EF4-FFF2-40B4-BE49-F238E27FC236}">
-                <a16:creationId xmlns:a16="http://schemas.microsoft.com/office/drawing/2014/main" id="{DE4D16DD-DB77-9023-2757-758EAA49EC58}"/>
+                <a16:creationId xmlns:a16="http://schemas.microsoft.com/office/drawing/2014/main" id="{49EA4315-F2F4-2901-5371-0743B25B54A3}"/>
               </a:ext>
             </a:extLst>
           </p:cNvPr>
@@ -8850,7 +8856,7 @@
           <p:cNvPr id="11" name="Hộp Văn bản 10">
             <a:extLst>
               <a:ext uri="{FF2B5EF4-FFF2-40B4-BE49-F238E27FC236}">
-                <a16:creationId xmlns:a16="http://schemas.microsoft.com/office/drawing/2014/main" id="{A7A3A238-4A1B-1793-21F3-CCB641F2B822}"/>
+                <a16:creationId xmlns:a16="http://schemas.microsoft.com/office/drawing/2014/main" id="{EA169775-41C1-4ACF-378E-8ABF1A321ECD}"/>
               </a:ext>
             </a:extLst>
           </p:cNvPr>
@@ -8895,7 +8901,7 @@
           <p:cNvPr id="12" name="Hình chữ nhật: Góc Tròn 11">
             <a:extLst>
               <a:ext uri="{FF2B5EF4-FFF2-40B4-BE49-F238E27FC236}">
-                <a16:creationId xmlns:a16="http://schemas.microsoft.com/office/drawing/2014/main" id="{2E0304B2-1D5E-452E-6111-81547F4E3381}"/>
+                <a16:creationId xmlns:a16="http://schemas.microsoft.com/office/drawing/2014/main" id="{3A1DCA13-8A81-C68E-2BEC-E256E3E04FDC}"/>
               </a:ext>
             </a:extLst>
           </p:cNvPr>
@@ -8963,7 +8969,7 @@
           <p:cNvPr id="13" name="Hình chữ nhật 12">
             <a:extLst>
               <a:ext uri="{FF2B5EF4-FFF2-40B4-BE49-F238E27FC236}">
-                <a16:creationId xmlns:a16="http://schemas.microsoft.com/office/drawing/2014/main" id="{A07DB99E-2768-B135-3712-A9327DD9B83F}"/>
+                <a16:creationId xmlns:a16="http://schemas.microsoft.com/office/drawing/2014/main" id="{8EBB74EA-59A1-22D3-F7F8-DC530940EA94}"/>
               </a:ext>
             </a:extLst>
           </p:cNvPr>
@@ -9031,7 +9037,7 @@
           <p:cNvPr id="14" name="Hộp Văn bản 13">
             <a:extLst>
               <a:ext uri="{FF2B5EF4-FFF2-40B4-BE49-F238E27FC236}">
-                <a16:creationId xmlns:a16="http://schemas.microsoft.com/office/drawing/2014/main" id="{672D2861-C9C1-9E22-85FE-6CB076251FC8}"/>
+                <a16:creationId xmlns:a16="http://schemas.microsoft.com/office/drawing/2014/main" id="{7D667916-7813-93A9-B271-F896ED1516E9}"/>
               </a:ext>
             </a:extLst>
           </p:cNvPr>
@@ -9076,7 +9082,7 @@
           <p:cNvPr id="15" name="Hộp Văn bản 14">
             <a:extLst>
               <a:ext uri="{FF2B5EF4-FFF2-40B4-BE49-F238E27FC236}">
-                <a16:creationId xmlns:a16="http://schemas.microsoft.com/office/drawing/2014/main" id="{AEBECF6B-0217-6A76-61CB-131B2DF4C375}"/>
+                <a16:creationId xmlns:a16="http://schemas.microsoft.com/office/drawing/2014/main" id="{3ED6183D-8FB3-045B-500F-B490D77CE984}"/>
               </a:ext>
             </a:extLst>
           </p:cNvPr>
@@ -9121,7 +9127,7 @@
           <p:cNvPr id="16" name="Hình chữ nhật: Góc Tròn 15">
             <a:extLst>
               <a:ext uri="{FF2B5EF4-FFF2-40B4-BE49-F238E27FC236}">
-                <a16:creationId xmlns:a16="http://schemas.microsoft.com/office/drawing/2014/main" id="{A4FECE51-EA23-1E24-EAA4-47F9DAB4E768}"/>
+                <a16:creationId xmlns:a16="http://schemas.microsoft.com/office/drawing/2014/main" id="{7AA86AB3-D848-2AB9-230B-3D74F953F424}"/>
               </a:ext>
             </a:extLst>
           </p:cNvPr>
@@ -9189,7 +9195,7 @@
           <p:cNvPr id="17" name="Hình chữ nhật 16">
             <a:extLst>
               <a:ext uri="{FF2B5EF4-FFF2-40B4-BE49-F238E27FC236}">
-                <a16:creationId xmlns:a16="http://schemas.microsoft.com/office/drawing/2014/main" id="{45520FB9-F7A0-952F-0496-E271EBCF0409}"/>
+                <a16:creationId xmlns:a16="http://schemas.microsoft.com/office/drawing/2014/main" id="{6CF058C7-E580-769F-86AF-E434BC6C2B29}"/>
               </a:ext>
             </a:extLst>
           </p:cNvPr>
@@ -9257,7 +9263,7 @@
           <p:cNvPr id="18" name="Hộp Văn bản 17">
             <a:extLst>
               <a:ext uri="{FF2B5EF4-FFF2-40B4-BE49-F238E27FC236}">
-                <a16:creationId xmlns:a16="http://schemas.microsoft.com/office/drawing/2014/main" id="{3B819F44-C5CA-3F52-BAB4-8043CD3A365C}"/>
+                <a16:creationId xmlns:a16="http://schemas.microsoft.com/office/drawing/2014/main" id="{D4DB8DAE-85A0-4783-E6EF-B01F4159FB5E}"/>
               </a:ext>
             </a:extLst>
           </p:cNvPr>
@@ -9302,7 +9308,7 @@
           <p:cNvPr id="19" name="Hộp Văn bản 18">
             <a:extLst>
               <a:ext uri="{FF2B5EF4-FFF2-40B4-BE49-F238E27FC236}">
-                <a16:creationId xmlns:a16="http://schemas.microsoft.com/office/drawing/2014/main" id="{DA5FD19B-9434-8982-6965-20ECD91D2047}"/>
+                <a16:creationId xmlns:a16="http://schemas.microsoft.com/office/drawing/2014/main" id="{25F9A628-AF6D-8980-3B71-272F4609260C}"/>
               </a:ext>
             </a:extLst>
           </p:cNvPr>
@@ -9347,7 +9353,7 @@
           <p:cNvPr id="20" name="Hộp Văn bản 19">
             <a:extLst>
               <a:ext uri="{FF2B5EF4-FFF2-40B4-BE49-F238E27FC236}">
-                <a16:creationId xmlns:a16="http://schemas.microsoft.com/office/drawing/2014/main" id="{B25122A1-55FE-2A0E-A61A-48C28A969C45}"/>
+                <a16:creationId xmlns:a16="http://schemas.microsoft.com/office/drawing/2014/main" id="{F8C2629B-C9AC-38C3-4C78-BD8013D8A552}"/>
               </a:ext>
             </a:extLst>
           </p:cNvPr>
@@ -9392,7 +9398,7 @@
           <p:cNvPr id="21" name="Hộp Văn bản 20">
             <a:extLst>
               <a:ext uri="{FF2B5EF4-FFF2-40B4-BE49-F238E27FC236}">
-                <a16:creationId xmlns:a16="http://schemas.microsoft.com/office/drawing/2014/main" id="{E3142730-A9EE-A049-AE81-3565D5478949}"/>
+                <a16:creationId xmlns:a16="http://schemas.microsoft.com/office/drawing/2014/main" id="{E06BBE36-4306-7591-EB00-E5A2A67230CD}"/>
               </a:ext>
             </a:extLst>
           </p:cNvPr>
@@ -9501,7 +9507,7 @@
           <p:cNvPr id="22" name="Hình chữ nhật: Góc Tròn 21">
             <a:extLst>
               <a:ext uri="{FF2B5EF4-FFF2-40B4-BE49-F238E27FC236}">
-                <a16:creationId xmlns:a16="http://schemas.microsoft.com/office/drawing/2014/main" id="{25FCC992-6B1F-E9F7-7E40-2F2C4E536627}"/>
+                <a16:creationId xmlns:a16="http://schemas.microsoft.com/office/drawing/2014/main" id="{2A003D90-04C8-D49C-57F6-5ECC786C8DEE}"/>
               </a:ext>
             </a:extLst>
           </p:cNvPr>
@@ -9569,7 +9575,7 @@
           <p:cNvPr id="23" name="Hộp Văn bản 22">
             <a:extLst>
               <a:ext uri="{FF2B5EF4-FFF2-40B4-BE49-F238E27FC236}">
-                <a16:creationId xmlns:a16="http://schemas.microsoft.com/office/drawing/2014/main" id="{A5429DB9-70AA-DE0F-0CEA-E181FC571E94}"/>
+                <a16:creationId xmlns:a16="http://schemas.microsoft.com/office/drawing/2014/main" id="{9C6C5B6B-B30B-91E1-E582-2F3413FCF780}"/>
               </a:ext>
             </a:extLst>
           </p:cNvPr>
@@ -9604,7 +9610,7 @@
                 </a:solidFill>
                 <a:latin typeface="Aptos" panose="020B0004020202020204" pitchFamily="34" charset="0"/>
               </a:rPr>
-              <a:t>Hiện trạng và đề xuất</a:t>
+              <a:t>Hiện trạng và tích hợp tùy chọn</a:t>
             </a:r>
           </a:p>
         </p:txBody>
@@ -9614,7 +9620,7 @@
           <p:cNvPr id="24" name="Hộp Văn bản 23">
             <a:extLst>
               <a:ext uri="{FF2B5EF4-FFF2-40B4-BE49-F238E27FC236}">
-                <a16:creationId xmlns:a16="http://schemas.microsoft.com/office/drawing/2014/main" id="{D610F5A8-B2D2-7606-B3C0-8ACD6F385992}"/>
+                <a16:creationId xmlns:a16="http://schemas.microsoft.com/office/drawing/2014/main" id="{AEB7A17B-50D3-23B3-F468-A36BEA9628F3}"/>
               </a:ext>
             </a:extLst>
           </p:cNvPr>
@@ -9649,7 +9655,7 @@
                 </a:solidFill>
                 <a:latin typeface="Aptos" panose="020B0004020202020204" pitchFamily="34" charset="0"/>
               </a:rPr>
-              <a:t>Chatbot hiện tra cứu theo quy tắc và dữ liệu hệ thống. Tóm tắt EMR, nhắc tái khám bằng AI chưa được triển khai.</a:t>
+              <a:t>Chatbot tra cứu theo quy tắc. Tóm tắt EMR và nhắc tái khám đã có trong source; cần consent, cấu hình Gemini/Twilio và lịch gửi.</a:t>
             </a:r>
           </a:p>
         </p:txBody>
@@ -9657,7 +9663,7 @@
     </p:spTree>
     <p:extLst>
       <p:ext uri="{BB962C8B-B14F-4D97-AF65-F5344CB8AC3E}">
-        <p14:creationId xmlns:p14="http://schemas.microsoft.com/office/powerpoint/2010/main" val="1334713447"/>
+        <p14:creationId xmlns:p14="http://schemas.microsoft.com/office/powerpoint/2010/main" val="2104000056"/>
       </p:ext>
     </p:extLst>
   </p:cSld>
@@ -9689,7 +9695,7 @@
           <p:cNvPr id="2" name="Hộp Văn bản 1">
             <a:extLst>
               <a:ext uri="{FF2B5EF4-FFF2-40B4-BE49-F238E27FC236}">
-                <a16:creationId xmlns:a16="http://schemas.microsoft.com/office/drawing/2014/main" id="{63B09823-3B35-404F-9E3C-6C21340CFFF7}"/>
+                <a16:creationId xmlns:a16="http://schemas.microsoft.com/office/drawing/2014/main" id="{344B9FC7-140F-01CA-579B-FDD4B6112F4F}"/>
               </a:ext>
             </a:extLst>
           </p:cNvPr>
@@ -9734,7 +9740,7 @@
           <p:cNvPr id="3" name="Hộp Văn bản 2">
             <a:extLst>
               <a:ext uri="{FF2B5EF4-FFF2-40B4-BE49-F238E27FC236}">
-                <a16:creationId xmlns:a16="http://schemas.microsoft.com/office/drawing/2014/main" id="{419CB675-1BBA-9A67-3DCA-C5988EF2BDC2}"/>
+                <a16:creationId xmlns:a16="http://schemas.microsoft.com/office/drawing/2014/main" id="{FE902368-D209-5E8A-8243-D87B2F7828FD}"/>
               </a:ext>
             </a:extLst>
           </p:cNvPr>
@@ -9779,7 +9785,7 @@
           <p:cNvPr id="4" name="Hộp Văn bản 3">
             <a:extLst>
               <a:ext uri="{FF2B5EF4-FFF2-40B4-BE49-F238E27FC236}">
-                <a16:creationId xmlns:a16="http://schemas.microsoft.com/office/drawing/2014/main" id="{DAEF7DEF-F7ED-4361-4481-A7F55CF5B087}"/>
+                <a16:creationId xmlns:a16="http://schemas.microsoft.com/office/drawing/2014/main" id="{1A7F1A8E-E438-BE9E-93FC-0750CF25D239}"/>
               </a:ext>
             </a:extLst>
           </p:cNvPr>
@@ -9824,7 +9830,7 @@
           <p:cNvPr id="5" name="Hình chữ nhật 4">
             <a:extLst>
               <a:ext uri="{FF2B5EF4-FFF2-40B4-BE49-F238E27FC236}">
-                <a16:creationId xmlns:a16="http://schemas.microsoft.com/office/drawing/2014/main" id="{BA40CFCF-2815-E3F9-6199-BAB180F45ABD}"/>
+                <a16:creationId xmlns:a16="http://schemas.microsoft.com/office/drawing/2014/main" id="{EB6A4D68-D0DB-2AC1-3B6E-2A1668534232}"/>
               </a:ext>
             </a:extLst>
           </p:cNvPr>
@@ -9892,7 +9898,7 @@
           <p:cNvPr id="6" name="Hộp Văn bản 5">
             <a:extLst>
               <a:ext uri="{FF2B5EF4-FFF2-40B4-BE49-F238E27FC236}">
-                <a16:creationId xmlns:a16="http://schemas.microsoft.com/office/drawing/2014/main" id="{73940047-1B9B-FECE-B0A7-3623FDA1F38A}"/>
+                <a16:creationId xmlns:a16="http://schemas.microsoft.com/office/drawing/2014/main" id="{FB1BC25D-FCD6-AF48-2080-85F790F5CF8D}"/>
               </a:ext>
             </a:extLst>
           </p:cNvPr>
@@ -9937,7 +9943,7 @@
           <p:cNvPr id="7" name="Hộp Văn bản 6">
             <a:extLst>
               <a:ext uri="{FF2B5EF4-FFF2-40B4-BE49-F238E27FC236}">
-                <a16:creationId xmlns:a16="http://schemas.microsoft.com/office/drawing/2014/main" id="{E4FD79B5-190F-4B40-95C1-320337E155D9}"/>
+                <a16:creationId xmlns:a16="http://schemas.microsoft.com/office/drawing/2014/main" id="{C70CD58D-38D3-F7D9-BDFA-A1F41A28635B}"/>
               </a:ext>
             </a:extLst>
           </p:cNvPr>
@@ -9982,7 +9988,7 @@
           <p:cNvPr id="8" name="Hình chữ nhật: Góc Tròn 7">
             <a:extLst>
               <a:ext uri="{FF2B5EF4-FFF2-40B4-BE49-F238E27FC236}">
-                <a16:creationId xmlns:a16="http://schemas.microsoft.com/office/drawing/2014/main" id="{042DA968-DB7B-7127-EE3D-FE6CC7E0136D}"/>
+                <a16:creationId xmlns:a16="http://schemas.microsoft.com/office/drawing/2014/main" id="{64911AEF-A719-4AFB-A06B-FF1D4BC63DBB}"/>
               </a:ext>
             </a:extLst>
           </p:cNvPr>
@@ -10050,7 +10056,7 @@
           <p:cNvPr id="9" name="Hình chữ nhật: Góc Tròn 8">
             <a:extLst>
               <a:ext uri="{FF2B5EF4-FFF2-40B4-BE49-F238E27FC236}">
-                <a16:creationId xmlns:a16="http://schemas.microsoft.com/office/drawing/2014/main" id="{9DA12BB6-FA5C-366C-375B-B4E78BF4A58A}"/>
+                <a16:creationId xmlns:a16="http://schemas.microsoft.com/office/drawing/2014/main" id="{7D2473C1-A61B-32EE-D8CF-D409BD64B238}"/>
               </a:ext>
             </a:extLst>
           </p:cNvPr>
@@ -10118,7 +10124,7 @@
           <p:cNvPr id="10" name="Hộp Văn bản 9">
             <a:extLst>
               <a:ext uri="{FF2B5EF4-FFF2-40B4-BE49-F238E27FC236}">
-                <a16:creationId xmlns:a16="http://schemas.microsoft.com/office/drawing/2014/main" id="{B1236A46-8A2D-97D3-872C-72F4C54B588F}"/>
+                <a16:creationId xmlns:a16="http://schemas.microsoft.com/office/drawing/2014/main" id="{9908751C-AA57-5A11-1DFC-1B0A99A88A8B}"/>
               </a:ext>
             </a:extLst>
           </p:cNvPr>
@@ -10163,7 +10169,7 @@
           <p:cNvPr id="11" name="Hộp Văn bản 10">
             <a:extLst>
               <a:ext uri="{FF2B5EF4-FFF2-40B4-BE49-F238E27FC236}">
-                <a16:creationId xmlns:a16="http://schemas.microsoft.com/office/drawing/2014/main" id="{FEABA842-4BB8-8F7E-14B2-45F193025529}"/>
+                <a16:creationId xmlns:a16="http://schemas.microsoft.com/office/drawing/2014/main" id="{A694CAAD-4C7E-2DE6-2F30-80EC9E8B5C32}"/>
               </a:ext>
             </a:extLst>
           </p:cNvPr>
@@ -10208,7 +10214,7 @@
           <p:cNvPr id="12" name="Hình chữ nhật 11">
             <a:extLst>
               <a:ext uri="{FF2B5EF4-FFF2-40B4-BE49-F238E27FC236}">
-                <a16:creationId xmlns:a16="http://schemas.microsoft.com/office/drawing/2014/main" id="{31BBA103-36B1-E432-B8E8-37420D0B16B3}"/>
+                <a16:creationId xmlns:a16="http://schemas.microsoft.com/office/drawing/2014/main" id="{88BDB216-68B7-D6A5-0092-45EF5BCA066F}"/>
               </a:ext>
             </a:extLst>
           </p:cNvPr>
@@ -10276,7 +10282,7 @@
           <p:cNvPr id="13" name="Hình chữ nhật: Góc Tròn 12">
             <a:extLst>
               <a:ext uri="{FF2B5EF4-FFF2-40B4-BE49-F238E27FC236}">
-                <a16:creationId xmlns:a16="http://schemas.microsoft.com/office/drawing/2014/main" id="{02C72959-E530-4CE8-2162-0871BA1A1C81}"/>
+                <a16:creationId xmlns:a16="http://schemas.microsoft.com/office/drawing/2014/main" id="{55070CD1-BA74-25D6-6FF9-D0B7246B46CF}"/>
               </a:ext>
             </a:extLst>
           </p:cNvPr>
@@ -10344,7 +10350,7 @@
           <p:cNvPr id="14" name="Hình chữ nhật: Góc Tròn 13">
             <a:extLst>
               <a:ext uri="{FF2B5EF4-FFF2-40B4-BE49-F238E27FC236}">
-                <a16:creationId xmlns:a16="http://schemas.microsoft.com/office/drawing/2014/main" id="{D85756A2-F58D-65AF-1624-A84A29E9083B}"/>
+                <a16:creationId xmlns:a16="http://schemas.microsoft.com/office/drawing/2014/main" id="{315C01A5-D811-D0C4-2952-C37BB4641129}"/>
               </a:ext>
             </a:extLst>
           </p:cNvPr>
@@ -10412,7 +10418,7 @@
           <p:cNvPr id="15" name="Hộp Văn bản 14">
             <a:extLst>
               <a:ext uri="{FF2B5EF4-FFF2-40B4-BE49-F238E27FC236}">
-                <a16:creationId xmlns:a16="http://schemas.microsoft.com/office/drawing/2014/main" id="{6B61C3DD-A9D3-1599-6E0D-793294D67503}"/>
+                <a16:creationId xmlns:a16="http://schemas.microsoft.com/office/drawing/2014/main" id="{7914E27F-286E-1980-B395-815CFB600452}"/>
               </a:ext>
             </a:extLst>
           </p:cNvPr>
@@ -10457,7 +10463,7 @@
           <p:cNvPr id="16" name="Hộp Văn bản 15">
             <a:extLst>
               <a:ext uri="{FF2B5EF4-FFF2-40B4-BE49-F238E27FC236}">
-                <a16:creationId xmlns:a16="http://schemas.microsoft.com/office/drawing/2014/main" id="{E972EFC3-77B0-FF16-6157-AAD75253EA2D}"/>
+                <a16:creationId xmlns:a16="http://schemas.microsoft.com/office/drawing/2014/main" id="{4E3EEC88-5E9B-006C-054A-B5AB21AA97B0}"/>
               </a:ext>
             </a:extLst>
           </p:cNvPr>
@@ -10502,7 +10508,7 @@
           <p:cNvPr id="17" name="Hình chữ nhật 16">
             <a:extLst>
               <a:ext uri="{FF2B5EF4-FFF2-40B4-BE49-F238E27FC236}">
-                <a16:creationId xmlns:a16="http://schemas.microsoft.com/office/drawing/2014/main" id="{3AA86FCA-CE3D-2CDD-AE14-4983E448D2D6}"/>
+                <a16:creationId xmlns:a16="http://schemas.microsoft.com/office/drawing/2014/main" id="{0015EC4C-8616-8C2E-05F1-8D72F813F93E}"/>
               </a:ext>
             </a:extLst>
           </p:cNvPr>
@@ -10570,7 +10576,7 @@
           <p:cNvPr id="18" name="Hình chữ nhật: Góc Tròn 17">
             <a:extLst>
               <a:ext uri="{FF2B5EF4-FFF2-40B4-BE49-F238E27FC236}">
-                <a16:creationId xmlns:a16="http://schemas.microsoft.com/office/drawing/2014/main" id="{F4624AD4-3216-D6F1-31E9-27C2B64B91CA}"/>
+                <a16:creationId xmlns:a16="http://schemas.microsoft.com/office/drawing/2014/main" id="{95E7D419-AF2D-B2C9-5B9D-5A1B3C8EEDC9}"/>
               </a:ext>
             </a:extLst>
           </p:cNvPr>
@@ -10638,7 +10644,7 @@
           <p:cNvPr id="19" name="Hình chữ nhật: Góc Tròn 18">
             <a:extLst>
               <a:ext uri="{FF2B5EF4-FFF2-40B4-BE49-F238E27FC236}">
-                <a16:creationId xmlns:a16="http://schemas.microsoft.com/office/drawing/2014/main" id="{A066517F-FEB9-10A2-0DF6-44EE8A5A15A9}"/>
+                <a16:creationId xmlns:a16="http://schemas.microsoft.com/office/drawing/2014/main" id="{1C7AF97D-19B2-583D-5795-13C0C012680D}"/>
               </a:ext>
             </a:extLst>
           </p:cNvPr>
@@ -10706,7 +10712,7 @@
           <p:cNvPr id="20" name="Hộp Văn bản 19">
             <a:extLst>
               <a:ext uri="{FF2B5EF4-FFF2-40B4-BE49-F238E27FC236}">
-                <a16:creationId xmlns:a16="http://schemas.microsoft.com/office/drawing/2014/main" id="{1E5E365A-64FE-B8DD-259D-98456AA06961}"/>
+                <a16:creationId xmlns:a16="http://schemas.microsoft.com/office/drawing/2014/main" id="{16E9C3F6-54F4-BF91-932D-72023098B700}"/>
               </a:ext>
             </a:extLst>
           </p:cNvPr>
@@ -10751,7 +10757,7 @@
           <p:cNvPr id="21" name="Hộp Văn bản 20">
             <a:extLst>
               <a:ext uri="{FF2B5EF4-FFF2-40B4-BE49-F238E27FC236}">
-                <a16:creationId xmlns:a16="http://schemas.microsoft.com/office/drawing/2014/main" id="{238D5C38-9FF5-E6AF-5E90-11C2523EEB57}"/>
+                <a16:creationId xmlns:a16="http://schemas.microsoft.com/office/drawing/2014/main" id="{0F276444-D19A-3B4A-3B1C-5073B56CA3AC}"/>
               </a:ext>
             </a:extLst>
           </p:cNvPr>
@@ -10796,7 +10802,7 @@
           <p:cNvPr id="22" name="Hình chữ nhật 21">
             <a:extLst>
               <a:ext uri="{FF2B5EF4-FFF2-40B4-BE49-F238E27FC236}">
-                <a16:creationId xmlns:a16="http://schemas.microsoft.com/office/drawing/2014/main" id="{5B52927E-4490-A58A-C0A6-9858E43A68FE}"/>
+                <a16:creationId xmlns:a16="http://schemas.microsoft.com/office/drawing/2014/main" id="{132AF42B-9040-87C8-4442-DD9196D572AB}"/>
               </a:ext>
             </a:extLst>
           </p:cNvPr>
@@ -10864,7 +10870,7 @@
           <p:cNvPr id="23" name="Hình chữ nhật: Góc Tròn 22">
             <a:extLst>
               <a:ext uri="{FF2B5EF4-FFF2-40B4-BE49-F238E27FC236}">
-                <a16:creationId xmlns:a16="http://schemas.microsoft.com/office/drawing/2014/main" id="{9407B38B-3DAF-5B68-A048-D15220FA2614}"/>
+                <a16:creationId xmlns:a16="http://schemas.microsoft.com/office/drawing/2014/main" id="{D66F8E61-7CC1-4C58-6E0D-D3B4805A831F}"/>
               </a:ext>
             </a:extLst>
           </p:cNvPr>
@@ -10932,7 +10938,7 @@
           <p:cNvPr id="24" name="Hình chữ nhật: Góc Tròn 23">
             <a:extLst>
               <a:ext uri="{FF2B5EF4-FFF2-40B4-BE49-F238E27FC236}">
-                <a16:creationId xmlns:a16="http://schemas.microsoft.com/office/drawing/2014/main" id="{9753EFE8-8398-53C2-E08F-C0BF88C9519D}"/>
+                <a16:creationId xmlns:a16="http://schemas.microsoft.com/office/drawing/2014/main" id="{AA2EC251-3C18-C37B-FD7C-F126001D28BC}"/>
               </a:ext>
             </a:extLst>
           </p:cNvPr>
@@ -11000,7 +11006,7 @@
           <p:cNvPr id="25" name="Hộp Văn bản 24">
             <a:extLst>
               <a:ext uri="{FF2B5EF4-FFF2-40B4-BE49-F238E27FC236}">
-                <a16:creationId xmlns:a16="http://schemas.microsoft.com/office/drawing/2014/main" id="{8C3DE32C-6F6E-2145-A9C7-D4722AA81367}"/>
+                <a16:creationId xmlns:a16="http://schemas.microsoft.com/office/drawing/2014/main" id="{DB6CA56F-F40C-7E26-13AF-305612103C3A}"/>
               </a:ext>
             </a:extLst>
           </p:cNvPr>
@@ -11045,7 +11051,7 @@
           <p:cNvPr id="26" name="Hộp Văn bản 25">
             <a:extLst>
               <a:ext uri="{FF2B5EF4-FFF2-40B4-BE49-F238E27FC236}">
-                <a16:creationId xmlns:a16="http://schemas.microsoft.com/office/drawing/2014/main" id="{44638B24-2782-BDF5-F880-09DB93B8AEE6}"/>
+                <a16:creationId xmlns:a16="http://schemas.microsoft.com/office/drawing/2014/main" id="{5D4E59C0-63BC-C40B-1BD4-5C657DFD99DF}"/>
               </a:ext>
             </a:extLst>
           </p:cNvPr>
@@ -11090,7 +11096,7 @@
           <p:cNvPr id="27" name="Hình chữ nhật: Góc Tròn 26">
             <a:extLst>
               <a:ext uri="{FF2B5EF4-FFF2-40B4-BE49-F238E27FC236}">
-                <a16:creationId xmlns:a16="http://schemas.microsoft.com/office/drawing/2014/main" id="{9AAC405A-EE72-3D9F-D65A-6BD523B70554}"/>
+                <a16:creationId xmlns:a16="http://schemas.microsoft.com/office/drawing/2014/main" id="{27B7B76D-F22C-1B32-E3CD-51498D06D3E0}"/>
               </a:ext>
             </a:extLst>
           </p:cNvPr>
@@ -11158,7 +11164,7 @@
           <p:cNvPr id="28" name="Hộp Văn bản 27">
             <a:extLst>
               <a:ext uri="{FF2B5EF4-FFF2-40B4-BE49-F238E27FC236}">
-                <a16:creationId xmlns:a16="http://schemas.microsoft.com/office/drawing/2014/main" id="{DE92A836-DE30-2E44-EC04-00619AF1B795}"/>
+                <a16:creationId xmlns:a16="http://schemas.microsoft.com/office/drawing/2014/main" id="{85973A08-7338-9775-C153-EAE728D1C71D}"/>
               </a:ext>
             </a:extLst>
           </p:cNvPr>
@@ -11201,7 +11207,7 @@
     </p:spTree>
     <p:extLst>
       <p:ext uri="{BB962C8B-B14F-4D97-AF65-F5344CB8AC3E}">
-        <p14:creationId xmlns:p14="http://schemas.microsoft.com/office/powerpoint/2010/main" val="504525561"/>
+        <p14:creationId xmlns:p14="http://schemas.microsoft.com/office/powerpoint/2010/main" val="3011604297"/>
       </p:ext>
     </p:extLst>
   </p:cSld>
@@ -11233,7 +11239,7 @@
           <p:cNvPr id="2" name="Hộp Văn bản 1">
             <a:extLst>
               <a:ext uri="{FF2B5EF4-FFF2-40B4-BE49-F238E27FC236}">
-                <a16:creationId xmlns:a16="http://schemas.microsoft.com/office/drawing/2014/main" id="{99E9CDA8-C22A-B052-5D66-82293EE29A1F}"/>
+                <a16:creationId xmlns:a16="http://schemas.microsoft.com/office/drawing/2014/main" id="{B0C2518D-F384-A648-0B5C-6703E2396641}"/>
               </a:ext>
             </a:extLst>
           </p:cNvPr>
@@ -11278,7 +11284,7 @@
           <p:cNvPr id="3" name="Hộp Văn bản 2">
             <a:extLst>
               <a:ext uri="{FF2B5EF4-FFF2-40B4-BE49-F238E27FC236}">
-                <a16:creationId xmlns:a16="http://schemas.microsoft.com/office/drawing/2014/main" id="{7BE67E87-EC2E-AF2C-7332-FB406E4B5303}"/>
+                <a16:creationId xmlns:a16="http://schemas.microsoft.com/office/drawing/2014/main" id="{A8A0FE64-9D31-DEB8-64D7-EDE3359B9D54}"/>
               </a:ext>
             </a:extLst>
           </p:cNvPr>
@@ -11323,7 +11329,7 @@
           <p:cNvPr id="4" name="Hộp Văn bản 3">
             <a:extLst>
               <a:ext uri="{FF2B5EF4-FFF2-40B4-BE49-F238E27FC236}">
-                <a16:creationId xmlns:a16="http://schemas.microsoft.com/office/drawing/2014/main" id="{2E9215C9-416C-EC41-3A8A-9A65E6DF873E}"/>
+                <a16:creationId xmlns:a16="http://schemas.microsoft.com/office/drawing/2014/main" id="{04041161-32DE-BB44-589B-7AF62AC7ACC1}"/>
               </a:ext>
             </a:extLst>
           </p:cNvPr>
@@ -11368,7 +11374,7 @@
           <p:cNvPr id="5" name="Hình chữ nhật 4">
             <a:extLst>
               <a:ext uri="{FF2B5EF4-FFF2-40B4-BE49-F238E27FC236}">
-                <a16:creationId xmlns:a16="http://schemas.microsoft.com/office/drawing/2014/main" id="{5B427087-2183-8DAA-096D-DDEDC4F0ECFB}"/>
+                <a16:creationId xmlns:a16="http://schemas.microsoft.com/office/drawing/2014/main" id="{955C9739-91C0-205C-6EF4-13890CE44D9F}"/>
               </a:ext>
             </a:extLst>
           </p:cNvPr>
@@ -11436,7 +11442,7 @@
           <p:cNvPr id="6" name="Hộp Văn bản 5">
             <a:extLst>
               <a:ext uri="{FF2B5EF4-FFF2-40B4-BE49-F238E27FC236}">
-                <a16:creationId xmlns:a16="http://schemas.microsoft.com/office/drawing/2014/main" id="{271B8F75-7A1A-7043-D5E8-0CEEBF94BB5F}"/>
+                <a16:creationId xmlns:a16="http://schemas.microsoft.com/office/drawing/2014/main" id="{64CE3EEC-C38C-E0C0-05D1-2E601289F396}"/>
               </a:ext>
             </a:extLst>
           </p:cNvPr>
@@ -11481,7 +11487,7 @@
           <p:cNvPr id="7" name="Hộp Văn bản 6">
             <a:extLst>
               <a:ext uri="{FF2B5EF4-FFF2-40B4-BE49-F238E27FC236}">
-                <a16:creationId xmlns:a16="http://schemas.microsoft.com/office/drawing/2014/main" id="{C5E2B8A5-425D-0767-06F2-C231C7958240}"/>
+                <a16:creationId xmlns:a16="http://schemas.microsoft.com/office/drawing/2014/main" id="{6A3B005A-AD32-F87B-4086-A9D56D96C030}"/>
               </a:ext>
             </a:extLst>
           </p:cNvPr>
@@ -11526,7 +11532,7 @@
           <p:cNvPr id="8" name="Hình chữ nhật: Góc Tròn 7">
             <a:extLst>
               <a:ext uri="{FF2B5EF4-FFF2-40B4-BE49-F238E27FC236}">
-                <a16:creationId xmlns:a16="http://schemas.microsoft.com/office/drawing/2014/main" id="{C0C6570D-4E4D-499D-EB17-7BE9F333C09B}"/>
+                <a16:creationId xmlns:a16="http://schemas.microsoft.com/office/drawing/2014/main" id="{85821BD9-4752-4C6F-8898-7C2481A87448}"/>
               </a:ext>
             </a:extLst>
           </p:cNvPr>
@@ -11594,7 +11600,7 @@
           <p:cNvPr id="9" name="Hộp Văn bản 8">
             <a:extLst>
               <a:ext uri="{FF2B5EF4-FFF2-40B4-BE49-F238E27FC236}">
-                <a16:creationId xmlns:a16="http://schemas.microsoft.com/office/drawing/2014/main" id="{CB115422-73EC-7D7D-1DA2-204FB23643AE}"/>
+                <a16:creationId xmlns:a16="http://schemas.microsoft.com/office/drawing/2014/main" id="{9865EDE7-6624-6DEA-D3B4-D85DE9F2C584}"/>
               </a:ext>
             </a:extLst>
           </p:cNvPr>
@@ -11639,7 +11645,7 @@
           <p:cNvPr id="10" name="Hộp Văn bản 9">
             <a:extLst>
               <a:ext uri="{FF2B5EF4-FFF2-40B4-BE49-F238E27FC236}">
-                <a16:creationId xmlns:a16="http://schemas.microsoft.com/office/drawing/2014/main" id="{1C14E47F-B3EC-E228-F516-F665A90563CC}"/>
+                <a16:creationId xmlns:a16="http://schemas.microsoft.com/office/drawing/2014/main" id="{F33B4669-006E-3D07-AE11-5E5DFB738599}"/>
               </a:ext>
             </a:extLst>
           </p:cNvPr>
@@ -11700,7 +11706,7 @@
           <p:cNvPr id="11" name="Hình chữ nhật: Góc Tròn 10">
             <a:extLst>
               <a:ext uri="{FF2B5EF4-FFF2-40B4-BE49-F238E27FC236}">
-                <a16:creationId xmlns:a16="http://schemas.microsoft.com/office/drawing/2014/main" id="{D8B4E697-C587-3CEB-62A5-7C6E0CC9FED4}"/>
+                <a16:creationId xmlns:a16="http://schemas.microsoft.com/office/drawing/2014/main" id="{9CD4BA17-2DE5-CBED-EC87-2024D9248A82}"/>
               </a:ext>
             </a:extLst>
           </p:cNvPr>
@@ -11768,7 +11774,7 @@
           <p:cNvPr id="12" name="Hộp Văn bản 11">
             <a:extLst>
               <a:ext uri="{FF2B5EF4-FFF2-40B4-BE49-F238E27FC236}">
-                <a16:creationId xmlns:a16="http://schemas.microsoft.com/office/drawing/2014/main" id="{4C1A21F8-E7E9-5439-AF32-27791F2B856F}"/>
+                <a16:creationId xmlns:a16="http://schemas.microsoft.com/office/drawing/2014/main" id="{8E741078-24CE-5D39-EB5C-546FF1E29797}"/>
               </a:ext>
             </a:extLst>
           </p:cNvPr>
@@ -11813,7 +11819,7 @@
           <p:cNvPr id="13" name="Hộp Văn bản 12">
             <a:extLst>
               <a:ext uri="{FF2B5EF4-FFF2-40B4-BE49-F238E27FC236}">
-                <a16:creationId xmlns:a16="http://schemas.microsoft.com/office/drawing/2014/main" id="{30521D7A-9E7F-9DCB-590E-6B3C064EA098}"/>
+                <a16:creationId xmlns:a16="http://schemas.microsoft.com/office/drawing/2014/main" id="{47309369-9DA9-EB16-7844-3E6735DB6983}"/>
               </a:ext>
             </a:extLst>
           </p:cNvPr>
@@ -11880,7 +11886,7 @@
           <p:cNvPr id="14" name="Hình chữ nhật: Góc Tròn 13">
             <a:extLst>
               <a:ext uri="{FF2B5EF4-FFF2-40B4-BE49-F238E27FC236}">
-                <a16:creationId xmlns:a16="http://schemas.microsoft.com/office/drawing/2014/main" id="{AD9B3B59-A27D-EE63-79DB-09F38DCE3398}"/>
+                <a16:creationId xmlns:a16="http://schemas.microsoft.com/office/drawing/2014/main" id="{3F3AF5AF-D6CA-F308-14FD-DB40B9636CB0}"/>
               </a:ext>
             </a:extLst>
           </p:cNvPr>
@@ -11948,7 +11954,7 @@
           <p:cNvPr id="15" name="Hộp Văn bản 14">
             <a:extLst>
               <a:ext uri="{FF2B5EF4-FFF2-40B4-BE49-F238E27FC236}">
-                <a16:creationId xmlns:a16="http://schemas.microsoft.com/office/drawing/2014/main" id="{030D6FCF-9965-9D17-4168-17E051B19C2F}"/>
+                <a16:creationId xmlns:a16="http://schemas.microsoft.com/office/drawing/2014/main" id="{26A90DC8-0E83-8FB8-8956-83948FB125AE}"/>
               </a:ext>
             </a:extLst>
           </p:cNvPr>
@@ -11993,7 +11999,7 @@
           <p:cNvPr id="16" name="Hộp Văn bản 15">
             <a:extLst>
               <a:ext uri="{FF2B5EF4-FFF2-40B4-BE49-F238E27FC236}">
-                <a16:creationId xmlns:a16="http://schemas.microsoft.com/office/drawing/2014/main" id="{ED6A26CE-A89F-8CDD-9202-E756BCBB043B}"/>
+                <a16:creationId xmlns:a16="http://schemas.microsoft.com/office/drawing/2014/main" id="{6A362511-B3AD-6339-60EB-D44FFC4B1AEB}"/>
               </a:ext>
             </a:extLst>
           </p:cNvPr>
@@ -12054,7 +12060,7 @@
           <p:cNvPr id="17" name="Hình chữ nhật 16">
             <a:extLst>
               <a:ext uri="{FF2B5EF4-FFF2-40B4-BE49-F238E27FC236}">
-                <a16:creationId xmlns:a16="http://schemas.microsoft.com/office/drawing/2014/main" id="{627D183C-79B9-CCF3-ED7D-80E05B4F5E6B}"/>
+                <a16:creationId xmlns:a16="http://schemas.microsoft.com/office/drawing/2014/main" id="{4E4B6440-0E4C-D584-48E6-213A167A2BCF}"/>
               </a:ext>
             </a:extLst>
           </p:cNvPr>
@@ -12122,7 +12128,7 @@
           <p:cNvPr id="18" name="Hình chữ nhật 17">
             <a:extLst>
               <a:ext uri="{FF2B5EF4-FFF2-40B4-BE49-F238E27FC236}">
-                <a16:creationId xmlns:a16="http://schemas.microsoft.com/office/drawing/2014/main" id="{8A5E7D04-8AF1-3830-82B6-F05347997304}"/>
+                <a16:creationId xmlns:a16="http://schemas.microsoft.com/office/drawing/2014/main" id="{940F5202-62BF-B584-248F-FB8DEC398A89}"/>
               </a:ext>
             </a:extLst>
           </p:cNvPr>
@@ -12190,7 +12196,7 @@
           <p:cNvPr id="19" name="Hình chữ nhật: Góc Tròn 18">
             <a:extLst>
               <a:ext uri="{FF2B5EF4-FFF2-40B4-BE49-F238E27FC236}">
-                <a16:creationId xmlns:a16="http://schemas.microsoft.com/office/drawing/2014/main" id="{B62AAA80-7DE1-62AF-DA55-B2C7DAF3B698}"/>
+                <a16:creationId xmlns:a16="http://schemas.microsoft.com/office/drawing/2014/main" id="{FCDA23FC-2C20-B4AE-CFB3-36CB44396DC5}"/>
               </a:ext>
             </a:extLst>
           </p:cNvPr>
@@ -12258,7 +12264,7 @@
           <p:cNvPr id="20" name="Hình chữ nhật 19">
             <a:extLst>
               <a:ext uri="{FF2B5EF4-FFF2-40B4-BE49-F238E27FC236}">
-                <a16:creationId xmlns:a16="http://schemas.microsoft.com/office/drawing/2014/main" id="{5D89165F-1067-506F-FD08-2DA9E6F710A5}"/>
+                <a16:creationId xmlns:a16="http://schemas.microsoft.com/office/drawing/2014/main" id="{3A923739-6F07-19D5-53A8-9ACF90E48A3E}"/>
               </a:ext>
             </a:extLst>
           </p:cNvPr>
@@ -12326,7 +12332,7 @@
           <p:cNvPr id="21" name="Hộp Văn bản 20">
             <a:extLst>
               <a:ext uri="{FF2B5EF4-FFF2-40B4-BE49-F238E27FC236}">
-                <a16:creationId xmlns:a16="http://schemas.microsoft.com/office/drawing/2014/main" id="{C9611732-08C8-0BFE-DF2C-05D67D586624}"/>
+                <a16:creationId xmlns:a16="http://schemas.microsoft.com/office/drawing/2014/main" id="{2EE4A54B-130A-8396-FC9E-06F6C8E18C96}"/>
               </a:ext>
             </a:extLst>
           </p:cNvPr>
@@ -12371,7 +12377,7 @@
           <p:cNvPr id="22" name="Hộp Văn bản 21">
             <a:extLst>
               <a:ext uri="{FF2B5EF4-FFF2-40B4-BE49-F238E27FC236}">
-                <a16:creationId xmlns:a16="http://schemas.microsoft.com/office/drawing/2014/main" id="{8933FE95-0516-BE33-FBEE-CE99235298DE}"/>
+                <a16:creationId xmlns:a16="http://schemas.microsoft.com/office/drawing/2014/main" id="{8407C79D-BCD0-9B4E-D001-4276CA0C35FA}"/>
               </a:ext>
             </a:extLst>
           </p:cNvPr>
@@ -12416,7 +12422,7 @@
           <p:cNvPr id="23" name="Hình chữ nhật: Góc Tròn 22">
             <a:extLst>
               <a:ext uri="{FF2B5EF4-FFF2-40B4-BE49-F238E27FC236}">
-                <a16:creationId xmlns:a16="http://schemas.microsoft.com/office/drawing/2014/main" id="{460086F0-9F32-1F8E-2C1B-716C8FEA32C9}"/>
+                <a16:creationId xmlns:a16="http://schemas.microsoft.com/office/drawing/2014/main" id="{79ABB6E6-73F1-5F14-CD07-61192375DB07}"/>
               </a:ext>
             </a:extLst>
           </p:cNvPr>
@@ -12484,7 +12490,7 @@
           <p:cNvPr id="24" name="Hình chữ nhật 23">
             <a:extLst>
               <a:ext uri="{FF2B5EF4-FFF2-40B4-BE49-F238E27FC236}">
-                <a16:creationId xmlns:a16="http://schemas.microsoft.com/office/drawing/2014/main" id="{F03EF6EA-EFAB-A0DC-EC13-1649A888BA7C}"/>
+                <a16:creationId xmlns:a16="http://schemas.microsoft.com/office/drawing/2014/main" id="{5877B74F-0A6B-E0EA-B213-CAB9CDBCC655}"/>
               </a:ext>
             </a:extLst>
           </p:cNvPr>
@@ -12552,7 +12558,7 @@
           <p:cNvPr id="25" name="Hộp Văn bản 24">
             <a:extLst>
               <a:ext uri="{FF2B5EF4-FFF2-40B4-BE49-F238E27FC236}">
-                <a16:creationId xmlns:a16="http://schemas.microsoft.com/office/drawing/2014/main" id="{1240977B-37C2-DED8-A1FA-BD7391FC8086}"/>
+                <a16:creationId xmlns:a16="http://schemas.microsoft.com/office/drawing/2014/main" id="{1645C8A5-2A33-725F-2BC4-9BF3E523DCBF}"/>
               </a:ext>
             </a:extLst>
           </p:cNvPr>
@@ -12597,7 +12603,7 @@
           <p:cNvPr id="26" name="Hộp Văn bản 25">
             <a:extLst>
               <a:ext uri="{FF2B5EF4-FFF2-40B4-BE49-F238E27FC236}">
-                <a16:creationId xmlns:a16="http://schemas.microsoft.com/office/drawing/2014/main" id="{F6E4FB1F-C8B7-D533-C7E8-CAD682FE9525}"/>
+                <a16:creationId xmlns:a16="http://schemas.microsoft.com/office/drawing/2014/main" id="{156A474C-CBC3-11C7-9D1A-8B0D2C41A06D}"/>
               </a:ext>
             </a:extLst>
           </p:cNvPr>
@@ -12642,7 +12648,7 @@
           <p:cNvPr id="27" name="Hình chữ nhật: Góc Tròn 26">
             <a:extLst>
               <a:ext uri="{FF2B5EF4-FFF2-40B4-BE49-F238E27FC236}">
-                <a16:creationId xmlns:a16="http://schemas.microsoft.com/office/drawing/2014/main" id="{84C69380-7FC8-E471-DDDA-A8A6FE049233}"/>
+                <a16:creationId xmlns:a16="http://schemas.microsoft.com/office/drawing/2014/main" id="{AB2E5F9C-337F-65BE-FAAD-62C53B87CAFA}"/>
               </a:ext>
             </a:extLst>
           </p:cNvPr>
@@ -12710,7 +12716,7 @@
           <p:cNvPr id="28" name="Hình chữ nhật 27">
             <a:extLst>
               <a:ext uri="{FF2B5EF4-FFF2-40B4-BE49-F238E27FC236}">
-                <a16:creationId xmlns:a16="http://schemas.microsoft.com/office/drawing/2014/main" id="{49E07904-7234-C8D6-E1C6-768EAE06883B}"/>
+                <a16:creationId xmlns:a16="http://schemas.microsoft.com/office/drawing/2014/main" id="{F03847C2-9D2C-81B8-93C8-0C0E7CE9C7FF}"/>
               </a:ext>
             </a:extLst>
           </p:cNvPr>
@@ -12778,7 +12784,7 @@
           <p:cNvPr id="29" name="Hộp Văn bản 28">
             <a:extLst>
               <a:ext uri="{FF2B5EF4-FFF2-40B4-BE49-F238E27FC236}">
-                <a16:creationId xmlns:a16="http://schemas.microsoft.com/office/drawing/2014/main" id="{B5D94AF8-E6F2-7D5A-EEAB-70C969AD1F4C}"/>
+                <a16:creationId xmlns:a16="http://schemas.microsoft.com/office/drawing/2014/main" id="{CDC9F63F-B6FD-8861-0F9C-5F202BBDBF3C}"/>
               </a:ext>
             </a:extLst>
           </p:cNvPr>
@@ -12813,7 +12819,7 @@
                 </a:solidFill>
                 <a:latin typeface="Aptos" panose="020B0004020202020204" pitchFamily="34" charset="0"/>
               </a:rPr>
-              <a:t>AI tương lai</a:t>
+              <a:t>AI / SMS tùy chọn</a:t>
             </a:r>
           </a:p>
         </p:txBody>
@@ -12823,7 +12829,7 @@
           <p:cNvPr id="30" name="Hộp Văn bản 29">
             <a:extLst>
               <a:ext uri="{FF2B5EF4-FFF2-40B4-BE49-F238E27FC236}">
-                <a16:creationId xmlns:a16="http://schemas.microsoft.com/office/drawing/2014/main" id="{2A63A123-7661-5765-67D4-DF2B031E1A3E}"/>
+                <a16:creationId xmlns:a16="http://schemas.microsoft.com/office/drawing/2014/main" id="{FEEC45E3-9124-DE5B-A045-384CFE9E55C6}"/>
               </a:ext>
             </a:extLst>
           </p:cNvPr>
@@ -12858,7 +12864,7 @@
                 </a:solidFill>
                 <a:latin typeface="Aptos" panose="020B0004020202020204" pitchFamily="34" charset="0"/>
               </a:rPr>
-              <a:t>Chưa kết nối dịch vụ AI, API tóm tắt EMR hoặc job nhắc tái khám.</a:t>
+              <a:t>Gemini tạo bản nháp EMR/lời nhắc chung; Twilio gửi SMS. Cần consent, credentials và Task Scheduler.</a:t>
             </a:r>
           </a:p>
         </p:txBody>
@@ -12866,7 +12872,7 @@
     </p:spTree>
     <p:extLst>
       <p:ext uri="{BB962C8B-B14F-4D97-AF65-F5344CB8AC3E}">
-        <p14:creationId xmlns:p14="http://schemas.microsoft.com/office/powerpoint/2010/main" val="3446255067"/>
+        <p14:creationId xmlns:p14="http://schemas.microsoft.com/office/powerpoint/2010/main" val="2862947079"/>
       </p:ext>
     </p:extLst>
   </p:cSld>
@@ -12898,7 +12904,7 @@
           <p:cNvPr id="2" name="Hộp Văn bản 1">
             <a:extLst>
               <a:ext uri="{FF2B5EF4-FFF2-40B4-BE49-F238E27FC236}">
-                <a16:creationId xmlns:a16="http://schemas.microsoft.com/office/drawing/2014/main" id="{04184E04-6490-B61B-EF35-8666F9AD1965}"/>
+                <a16:creationId xmlns:a16="http://schemas.microsoft.com/office/drawing/2014/main" id="{2DE5EB80-3D1D-C01A-89D9-8B7DEC572EA2}"/>
               </a:ext>
             </a:extLst>
           </p:cNvPr>
@@ -12943,7 +12949,7 @@
           <p:cNvPr id="3" name="Hộp Văn bản 2">
             <a:extLst>
               <a:ext uri="{FF2B5EF4-FFF2-40B4-BE49-F238E27FC236}">
-                <a16:creationId xmlns:a16="http://schemas.microsoft.com/office/drawing/2014/main" id="{612D0E09-4506-0843-B742-C46F58C75453}"/>
+                <a16:creationId xmlns:a16="http://schemas.microsoft.com/office/drawing/2014/main" id="{12C30E22-B787-DA4B-E23F-BEEFD7D9CBEB}"/>
               </a:ext>
             </a:extLst>
           </p:cNvPr>
@@ -12988,7 +12994,7 @@
           <p:cNvPr id="4" name="Hộp Văn bản 3">
             <a:extLst>
               <a:ext uri="{FF2B5EF4-FFF2-40B4-BE49-F238E27FC236}">
-                <a16:creationId xmlns:a16="http://schemas.microsoft.com/office/drawing/2014/main" id="{66CC0F1E-DC24-1CE3-C50B-09FBE53845E5}"/>
+                <a16:creationId xmlns:a16="http://schemas.microsoft.com/office/drawing/2014/main" id="{CD7647F3-65A9-6907-F005-2A3A2F171A00}"/>
               </a:ext>
             </a:extLst>
           </p:cNvPr>
@@ -13033,7 +13039,7 @@
           <p:cNvPr id="5" name="Hình chữ nhật 4">
             <a:extLst>
               <a:ext uri="{FF2B5EF4-FFF2-40B4-BE49-F238E27FC236}">
-                <a16:creationId xmlns:a16="http://schemas.microsoft.com/office/drawing/2014/main" id="{F93EFA4D-7EE4-CF93-A86B-5D3336CF84B2}"/>
+                <a16:creationId xmlns:a16="http://schemas.microsoft.com/office/drawing/2014/main" id="{ABCC6146-4DAE-FE4E-F08B-898BBB5D115C}"/>
               </a:ext>
             </a:extLst>
           </p:cNvPr>
@@ -13101,7 +13107,7 @@
           <p:cNvPr id="6" name="Hộp Văn bản 5">
             <a:extLst>
               <a:ext uri="{FF2B5EF4-FFF2-40B4-BE49-F238E27FC236}">
-                <a16:creationId xmlns:a16="http://schemas.microsoft.com/office/drawing/2014/main" id="{2E85D7D2-E08C-3AD1-9EA1-63FC6E55F993}"/>
+                <a16:creationId xmlns:a16="http://schemas.microsoft.com/office/drawing/2014/main" id="{0497B27B-4918-0C34-74A7-A3742ED3EB71}"/>
               </a:ext>
             </a:extLst>
           </p:cNvPr>
@@ -13146,7 +13152,7 @@
           <p:cNvPr id="7" name="Hộp Văn bản 6">
             <a:extLst>
               <a:ext uri="{FF2B5EF4-FFF2-40B4-BE49-F238E27FC236}">
-                <a16:creationId xmlns:a16="http://schemas.microsoft.com/office/drawing/2014/main" id="{93671D46-DE48-B4BA-F08B-9F678ACB5FEC}"/>
+                <a16:creationId xmlns:a16="http://schemas.microsoft.com/office/drawing/2014/main" id="{BE74110E-6A47-2DD5-C3D7-DB013C7223F7}"/>
               </a:ext>
             </a:extLst>
           </p:cNvPr>
@@ -13191,7 +13197,7 @@
           <p:cNvPr id="8" name="Hình chữ nhật: Góc Tròn 7">
             <a:extLst>
               <a:ext uri="{FF2B5EF4-FFF2-40B4-BE49-F238E27FC236}">
-                <a16:creationId xmlns:a16="http://schemas.microsoft.com/office/drawing/2014/main" id="{1537DF70-D26B-7015-FC8A-0D9D4CB655D8}"/>
+                <a16:creationId xmlns:a16="http://schemas.microsoft.com/office/drawing/2014/main" id="{5B897797-324F-6D50-704A-A7F5A4329B69}"/>
               </a:ext>
             </a:extLst>
           </p:cNvPr>
@@ -13259,7 +13265,7 @@
           <p:cNvPr id="9" name="Hình chữ nhật 8">
             <a:extLst>
               <a:ext uri="{FF2B5EF4-FFF2-40B4-BE49-F238E27FC236}">
-                <a16:creationId xmlns:a16="http://schemas.microsoft.com/office/drawing/2014/main" id="{A7306AAF-47A6-A8ED-AD53-B4EFC6FBA31B}"/>
+                <a16:creationId xmlns:a16="http://schemas.microsoft.com/office/drawing/2014/main" id="{886E548B-97F1-D11C-9D8E-A1E1C60FF65C}"/>
               </a:ext>
             </a:extLst>
           </p:cNvPr>
@@ -13327,7 +13333,7 @@
           <p:cNvPr id="10" name="Hộp Văn bản 9">
             <a:extLst>
               <a:ext uri="{FF2B5EF4-FFF2-40B4-BE49-F238E27FC236}">
-                <a16:creationId xmlns:a16="http://schemas.microsoft.com/office/drawing/2014/main" id="{6439BB5B-952F-AFC7-84E9-77960B1D76D0}"/>
+                <a16:creationId xmlns:a16="http://schemas.microsoft.com/office/drawing/2014/main" id="{3A5326B6-BC6A-59AB-AFBD-2F53978A5D4A}"/>
               </a:ext>
             </a:extLst>
           </p:cNvPr>
@@ -13372,7 +13378,7 @@
           <p:cNvPr id="11" name="Hộp Văn bản 10">
             <a:extLst>
               <a:ext uri="{FF2B5EF4-FFF2-40B4-BE49-F238E27FC236}">
-                <a16:creationId xmlns:a16="http://schemas.microsoft.com/office/drawing/2014/main" id="{81F7036E-3C7B-BB43-032E-B4372A40C811}"/>
+                <a16:creationId xmlns:a16="http://schemas.microsoft.com/office/drawing/2014/main" id="{CF447CD6-FC6E-F5AD-79F4-3FD4174CDE46}"/>
               </a:ext>
             </a:extLst>
           </p:cNvPr>
@@ -13401,20 +13407,14 @@
               </a:spcAft>
             </a:pPr>
             <a:r>
-              <a:rPr lang="en-US" sz="1100">
+              <a:rPr lang="vi-VN" sz="1100">
                 <a:solidFill>
                   <a:srgbClr val="657875"/>
                 </a:solidFill>
                 <a:latin typeface="Aptos" panose="020B0004020202020204" pitchFamily="34" charset="0"/>
               </a:rPr>
-              <a:t>patient_code · full_name · phone</a:t>
-            </a:r>
-            <a:endParaRPr lang="vi-VN" sz="1100">
-              <a:solidFill>
-                <a:srgbClr val="657875"/>
-              </a:solidFill>
-              <a:latin typeface="Aptos" panose="020B0004020202020204" pitchFamily="34" charset="0"/>
-            </a:endParaRPr>
+              <a:t>code · name · phone · AI/SMS consent</a:t>
+            </a:r>
           </a:p>
         </p:txBody>
       </p:sp>
@@ -13423,7 +13423,7 @@
           <p:cNvPr id="12" name="Hình chữ nhật: Góc Tròn 11">
             <a:extLst>
               <a:ext uri="{FF2B5EF4-FFF2-40B4-BE49-F238E27FC236}">
-                <a16:creationId xmlns:a16="http://schemas.microsoft.com/office/drawing/2014/main" id="{867F6774-4290-17A0-5CE2-D0C6E5427CAF}"/>
+                <a16:creationId xmlns:a16="http://schemas.microsoft.com/office/drawing/2014/main" id="{0AE1EE43-96F9-4BD2-CD29-D050F8FE1AD3}"/>
               </a:ext>
             </a:extLst>
           </p:cNvPr>
@@ -13491,7 +13491,7 @@
           <p:cNvPr id="13" name="Hình chữ nhật 12">
             <a:extLst>
               <a:ext uri="{FF2B5EF4-FFF2-40B4-BE49-F238E27FC236}">
-                <a16:creationId xmlns:a16="http://schemas.microsoft.com/office/drawing/2014/main" id="{17C00BE5-40A8-0E85-AF4B-4B316C027219}"/>
+                <a16:creationId xmlns:a16="http://schemas.microsoft.com/office/drawing/2014/main" id="{C4A1A113-F655-7EA3-9A4B-631413336F26}"/>
               </a:ext>
             </a:extLst>
           </p:cNvPr>
@@ -13559,7 +13559,7 @@
           <p:cNvPr id="14" name="Hộp Văn bản 13">
             <a:extLst>
               <a:ext uri="{FF2B5EF4-FFF2-40B4-BE49-F238E27FC236}">
-                <a16:creationId xmlns:a16="http://schemas.microsoft.com/office/drawing/2014/main" id="{2AEB779B-990A-15E3-D1F9-9CDCB0566523}"/>
+                <a16:creationId xmlns:a16="http://schemas.microsoft.com/office/drawing/2014/main" id="{6AC622A1-4F34-8D42-F9BC-060D7D74F607}"/>
               </a:ext>
             </a:extLst>
           </p:cNvPr>
@@ -13604,7 +13604,7 @@
           <p:cNvPr id="15" name="Hộp Văn bản 14">
             <a:extLst>
               <a:ext uri="{FF2B5EF4-FFF2-40B4-BE49-F238E27FC236}">
-                <a16:creationId xmlns:a16="http://schemas.microsoft.com/office/drawing/2014/main" id="{C0323D67-B8C3-A54F-DAAD-B805A01DA2A9}"/>
+                <a16:creationId xmlns:a16="http://schemas.microsoft.com/office/drawing/2014/main" id="{A8A2E601-135A-5E57-3785-93615632FD15}"/>
               </a:ext>
             </a:extLst>
           </p:cNvPr>
@@ -13649,7 +13649,7 @@
           <p:cNvPr id="16" name="Hình chữ nhật: Góc Tròn 15">
             <a:extLst>
               <a:ext uri="{FF2B5EF4-FFF2-40B4-BE49-F238E27FC236}">
-                <a16:creationId xmlns:a16="http://schemas.microsoft.com/office/drawing/2014/main" id="{623C733D-E8D0-6962-B853-5467C97D35A7}"/>
+                <a16:creationId xmlns:a16="http://schemas.microsoft.com/office/drawing/2014/main" id="{9A27290A-1DA8-3B52-D02F-301EE2D1D0DE}"/>
               </a:ext>
             </a:extLst>
           </p:cNvPr>
@@ -13717,7 +13717,7 @@
           <p:cNvPr id="17" name="Hình chữ nhật 16">
             <a:extLst>
               <a:ext uri="{FF2B5EF4-FFF2-40B4-BE49-F238E27FC236}">
-                <a16:creationId xmlns:a16="http://schemas.microsoft.com/office/drawing/2014/main" id="{21F1AB38-30BD-54BD-585D-52F937D0B3E6}"/>
+                <a16:creationId xmlns:a16="http://schemas.microsoft.com/office/drawing/2014/main" id="{549055C7-9681-8EED-99DE-CB2A01C286A8}"/>
               </a:ext>
             </a:extLst>
           </p:cNvPr>
@@ -13785,7 +13785,7 @@
           <p:cNvPr id="18" name="Hộp Văn bản 17">
             <a:extLst>
               <a:ext uri="{FF2B5EF4-FFF2-40B4-BE49-F238E27FC236}">
-                <a16:creationId xmlns:a16="http://schemas.microsoft.com/office/drawing/2014/main" id="{3C5E14C0-C1B1-D851-673D-EF4FE5CFA879}"/>
+                <a16:creationId xmlns:a16="http://schemas.microsoft.com/office/drawing/2014/main" id="{A3DE9BC1-1063-DE74-B09C-491D6F1C05D1}"/>
               </a:ext>
             </a:extLst>
           </p:cNvPr>
@@ -13830,7 +13830,7 @@
           <p:cNvPr id="19" name="Hộp Văn bản 18">
             <a:extLst>
               <a:ext uri="{FF2B5EF4-FFF2-40B4-BE49-F238E27FC236}">
-                <a16:creationId xmlns:a16="http://schemas.microsoft.com/office/drawing/2014/main" id="{D2AEC049-3A77-F528-1644-EE1B672C5BC3}"/>
+                <a16:creationId xmlns:a16="http://schemas.microsoft.com/office/drawing/2014/main" id="{8BC7F43B-87B3-19A3-8C61-DE77AEA8171D}"/>
               </a:ext>
             </a:extLst>
           </p:cNvPr>
@@ -13859,14 +13859,20 @@
               </a:spcAft>
             </a:pPr>
             <a:r>
-              <a:rPr lang="vi-VN" sz="1100">
+              <a:rPr lang="en-US" sz="1100">
                 <a:solidFill>
                   <a:srgbClr val="657875"/>
                 </a:solidFill>
                 <a:latin typeface="Aptos" panose="020B0004020202020204" pitchFamily="34" charset="0"/>
               </a:rPr>
-              <a:t>appointment · diagnosis · plan</a:t>
-            </a:r>
+              <a:t>appointment · diagnosis · plan · follow-up date</a:t>
+            </a:r>
+            <a:endParaRPr lang="vi-VN" sz="1100">
+              <a:solidFill>
+                <a:srgbClr val="657875"/>
+              </a:solidFill>
+              <a:latin typeface="Aptos" panose="020B0004020202020204" pitchFamily="34" charset="0"/>
+            </a:endParaRPr>
           </a:p>
         </p:txBody>
       </p:sp>
@@ -13875,7 +13881,7 @@
           <p:cNvPr id="20" name="Hình chữ nhật: Góc Tròn 19">
             <a:extLst>
               <a:ext uri="{FF2B5EF4-FFF2-40B4-BE49-F238E27FC236}">
-                <a16:creationId xmlns:a16="http://schemas.microsoft.com/office/drawing/2014/main" id="{566146DE-0B51-2A66-FD61-882C5FE2D5AB}"/>
+                <a16:creationId xmlns:a16="http://schemas.microsoft.com/office/drawing/2014/main" id="{0F19D517-9173-3E5E-9FEC-8B6BEBD61895}"/>
               </a:ext>
             </a:extLst>
           </p:cNvPr>
@@ -13943,7 +13949,7 @@
           <p:cNvPr id="21" name="Hình chữ nhật 20">
             <a:extLst>
               <a:ext uri="{FF2B5EF4-FFF2-40B4-BE49-F238E27FC236}">
-                <a16:creationId xmlns:a16="http://schemas.microsoft.com/office/drawing/2014/main" id="{CAF70D1C-0694-B905-3DD0-D58217BF90C9}"/>
+                <a16:creationId xmlns:a16="http://schemas.microsoft.com/office/drawing/2014/main" id="{7E93A1C3-AE7A-380B-707F-0362A633303C}"/>
               </a:ext>
             </a:extLst>
           </p:cNvPr>
@@ -14011,7 +14017,7 @@
           <p:cNvPr id="22" name="Hộp Văn bản 21">
             <a:extLst>
               <a:ext uri="{FF2B5EF4-FFF2-40B4-BE49-F238E27FC236}">
-                <a16:creationId xmlns:a16="http://schemas.microsoft.com/office/drawing/2014/main" id="{74A83101-7B74-D016-3818-F1B1D44C15AF}"/>
+                <a16:creationId xmlns:a16="http://schemas.microsoft.com/office/drawing/2014/main" id="{DDE00ACE-03AB-4A05-B963-A49C8699C393}"/>
               </a:ext>
             </a:extLst>
           </p:cNvPr>
@@ -14056,7 +14062,7 @@
           <p:cNvPr id="23" name="Hộp Văn bản 22">
             <a:extLst>
               <a:ext uri="{FF2B5EF4-FFF2-40B4-BE49-F238E27FC236}">
-                <a16:creationId xmlns:a16="http://schemas.microsoft.com/office/drawing/2014/main" id="{F37EDEF6-B2F3-2707-3340-45B18CFE46DB}"/>
+                <a16:creationId xmlns:a16="http://schemas.microsoft.com/office/drawing/2014/main" id="{632A4485-39B0-D024-3EAA-8180E42537F0}"/>
               </a:ext>
             </a:extLst>
           </p:cNvPr>
@@ -14107,7 +14113,7 @@
           <p:cNvPr id="24" name="Hình chữ nhật 23">
             <a:extLst>
               <a:ext uri="{FF2B5EF4-FFF2-40B4-BE49-F238E27FC236}">
-                <a16:creationId xmlns:a16="http://schemas.microsoft.com/office/drawing/2014/main" id="{AE5B7F98-4780-EB44-E5F4-25150CED1B78}"/>
+                <a16:creationId xmlns:a16="http://schemas.microsoft.com/office/drawing/2014/main" id="{FD635AE9-2A64-8110-338B-AA0C3359D06A}"/>
               </a:ext>
             </a:extLst>
           </p:cNvPr>
@@ -14175,7 +14181,7 @@
           <p:cNvPr id="25" name="Hình chữ nhật 24">
             <a:extLst>
               <a:ext uri="{FF2B5EF4-FFF2-40B4-BE49-F238E27FC236}">
-                <a16:creationId xmlns:a16="http://schemas.microsoft.com/office/drawing/2014/main" id="{2D43E1FC-C388-89AD-B91D-7529AAA20E06}"/>
+                <a16:creationId xmlns:a16="http://schemas.microsoft.com/office/drawing/2014/main" id="{E9FC35F2-3F4D-0BB1-49B1-D94B7D4B4A0B}"/>
               </a:ext>
             </a:extLst>
           </p:cNvPr>
@@ -14243,7 +14249,7 @@
           <p:cNvPr id="26" name="Hình chữ nhật 25">
             <a:extLst>
               <a:ext uri="{FF2B5EF4-FFF2-40B4-BE49-F238E27FC236}">
-                <a16:creationId xmlns:a16="http://schemas.microsoft.com/office/drawing/2014/main" id="{B38A86B5-746A-1C3C-DFAC-25271A2FABEF}"/>
+                <a16:creationId xmlns:a16="http://schemas.microsoft.com/office/drawing/2014/main" id="{DDAEE7B2-6958-6FE0-6CE6-B83CB592664D}"/>
               </a:ext>
             </a:extLst>
           </p:cNvPr>
@@ -14311,7 +14317,7 @@
           <p:cNvPr id="27" name="Hộp Văn bản 26">
             <a:extLst>
               <a:ext uri="{FF2B5EF4-FFF2-40B4-BE49-F238E27FC236}">
-                <a16:creationId xmlns:a16="http://schemas.microsoft.com/office/drawing/2014/main" id="{687F34E9-8D64-9588-3E15-56927020C304}"/>
+                <a16:creationId xmlns:a16="http://schemas.microsoft.com/office/drawing/2014/main" id="{F9D0EB04-16C0-57A1-55E4-061A21D899F7}"/>
               </a:ext>
             </a:extLst>
           </p:cNvPr>
@@ -14356,7 +14362,7 @@
           <p:cNvPr id="28" name="Hộp Văn bản 27">
             <a:extLst>
               <a:ext uri="{FF2B5EF4-FFF2-40B4-BE49-F238E27FC236}">
-                <a16:creationId xmlns:a16="http://schemas.microsoft.com/office/drawing/2014/main" id="{85BDC3B2-14E1-624D-E5E0-A65C4BB5D3C7}"/>
+                <a16:creationId xmlns:a16="http://schemas.microsoft.com/office/drawing/2014/main" id="{3CEE4C5A-4D04-20A6-3F6A-FA2B250EBA97}"/>
               </a:ext>
             </a:extLst>
           </p:cNvPr>
@@ -14401,7 +14407,7 @@
           <p:cNvPr id="29" name="Hộp Văn bản 28">
             <a:extLst>
               <a:ext uri="{FF2B5EF4-FFF2-40B4-BE49-F238E27FC236}">
-                <a16:creationId xmlns:a16="http://schemas.microsoft.com/office/drawing/2014/main" id="{98CFBDD7-6A49-8ED7-A52B-802EF50962D4}"/>
+                <a16:creationId xmlns:a16="http://schemas.microsoft.com/office/drawing/2014/main" id="{979A5232-D02C-DE53-D93C-AE11218761F9}"/>
               </a:ext>
             </a:extLst>
           </p:cNvPr>
@@ -14446,7 +14452,7 @@
           <p:cNvPr id="30" name="Hình chữ nhật 29">
             <a:extLst>
               <a:ext uri="{FF2B5EF4-FFF2-40B4-BE49-F238E27FC236}">
-                <a16:creationId xmlns:a16="http://schemas.microsoft.com/office/drawing/2014/main" id="{0823BAA6-07D1-37E2-08CE-9BC9181A0098}"/>
+                <a16:creationId xmlns:a16="http://schemas.microsoft.com/office/drawing/2014/main" id="{FA1950A9-AB2C-30BF-2239-BC0F31501C38}"/>
               </a:ext>
             </a:extLst>
           </p:cNvPr>
@@ -14514,7 +14520,7 @@
           <p:cNvPr id="31" name="Hình chữ nhật 30">
             <a:extLst>
               <a:ext uri="{FF2B5EF4-FFF2-40B4-BE49-F238E27FC236}">
-                <a16:creationId xmlns:a16="http://schemas.microsoft.com/office/drawing/2014/main" id="{CD2C9B85-494F-326E-6929-652284DAF880}"/>
+                <a16:creationId xmlns:a16="http://schemas.microsoft.com/office/drawing/2014/main" id="{04268D2C-60A9-3FC2-ADC2-4CD07DAF179D}"/>
               </a:ext>
             </a:extLst>
           </p:cNvPr>
@@ -14582,7 +14588,7 @@
           <p:cNvPr id="32" name="Hình chữ nhật 31">
             <a:extLst>
               <a:ext uri="{FF2B5EF4-FFF2-40B4-BE49-F238E27FC236}">
-                <a16:creationId xmlns:a16="http://schemas.microsoft.com/office/drawing/2014/main" id="{32CF4C81-A701-D8E6-8628-D0E224FA6A0C}"/>
+                <a16:creationId xmlns:a16="http://schemas.microsoft.com/office/drawing/2014/main" id="{98EEF36E-B446-B453-0755-C641DE4E0CFD}"/>
               </a:ext>
             </a:extLst>
           </p:cNvPr>
@@ -14650,7 +14656,7 @@
           <p:cNvPr id="33" name="Hình chữ nhật 32">
             <a:extLst>
               <a:ext uri="{FF2B5EF4-FFF2-40B4-BE49-F238E27FC236}">
-                <a16:creationId xmlns:a16="http://schemas.microsoft.com/office/drawing/2014/main" id="{75D9C24B-99E8-81EA-722D-30F8922A4203}"/>
+                <a16:creationId xmlns:a16="http://schemas.microsoft.com/office/drawing/2014/main" id="{B9DB70FE-5FCD-4FD0-7EC5-4743A8715862}"/>
               </a:ext>
             </a:extLst>
           </p:cNvPr>
@@ -14718,7 +14724,7 @@
           <p:cNvPr id="34" name="Hình chữ nhật: Góc Tròn 33">
             <a:extLst>
               <a:ext uri="{FF2B5EF4-FFF2-40B4-BE49-F238E27FC236}">
-                <a16:creationId xmlns:a16="http://schemas.microsoft.com/office/drawing/2014/main" id="{13F39B8E-B0A9-2836-7CC9-AC943A27A416}"/>
+                <a16:creationId xmlns:a16="http://schemas.microsoft.com/office/drawing/2014/main" id="{490D2D13-8DE5-D17C-101D-70249077A8DD}"/>
               </a:ext>
             </a:extLst>
           </p:cNvPr>
@@ -14786,7 +14792,7 @@
           <p:cNvPr id="35" name="Hình chữ nhật 34">
             <a:extLst>
               <a:ext uri="{FF2B5EF4-FFF2-40B4-BE49-F238E27FC236}">
-                <a16:creationId xmlns:a16="http://schemas.microsoft.com/office/drawing/2014/main" id="{A049DD10-809D-8550-52B3-9C7F81EBE505}"/>
+                <a16:creationId xmlns:a16="http://schemas.microsoft.com/office/drawing/2014/main" id="{0C772AEE-D1F4-B5D9-2DE7-088CB1BC006B}"/>
               </a:ext>
             </a:extLst>
           </p:cNvPr>
@@ -14854,7 +14860,7 @@
           <p:cNvPr id="36" name="Hộp Văn bản 35">
             <a:extLst>
               <a:ext uri="{FF2B5EF4-FFF2-40B4-BE49-F238E27FC236}">
-                <a16:creationId xmlns:a16="http://schemas.microsoft.com/office/drawing/2014/main" id="{A7520CA8-3AE8-8DE5-EF08-2876D91B4362}"/>
+                <a16:creationId xmlns:a16="http://schemas.microsoft.com/office/drawing/2014/main" id="{2162DFA3-37CD-5487-28B8-931FDF47F308}"/>
               </a:ext>
             </a:extLst>
           </p:cNvPr>
@@ -14899,7 +14905,7 @@
           <p:cNvPr id="37" name="Hộp Văn bản 36">
             <a:extLst>
               <a:ext uri="{FF2B5EF4-FFF2-40B4-BE49-F238E27FC236}">
-                <a16:creationId xmlns:a16="http://schemas.microsoft.com/office/drawing/2014/main" id="{1CF23891-D678-9DB7-E277-0147AEC690B6}"/>
+                <a16:creationId xmlns:a16="http://schemas.microsoft.com/office/drawing/2014/main" id="{888DFA41-97B4-72C4-9A41-39D5863C257A}"/>
               </a:ext>
             </a:extLst>
           </p:cNvPr>
@@ -14950,7 +14956,7 @@
           <p:cNvPr id="38" name="Hình chữ nhật: Góc Tròn 37">
             <a:extLst>
               <a:ext uri="{FF2B5EF4-FFF2-40B4-BE49-F238E27FC236}">
-                <a16:creationId xmlns:a16="http://schemas.microsoft.com/office/drawing/2014/main" id="{80C2E70F-E219-0CC8-0034-D1769A531009}"/>
+                <a16:creationId xmlns:a16="http://schemas.microsoft.com/office/drawing/2014/main" id="{86142200-A352-C36A-E897-B95F468F47D5}"/>
               </a:ext>
             </a:extLst>
           </p:cNvPr>
@@ -15018,7 +15024,7 @@
           <p:cNvPr id="39" name="Hình chữ nhật 38">
             <a:extLst>
               <a:ext uri="{FF2B5EF4-FFF2-40B4-BE49-F238E27FC236}">
-                <a16:creationId xmlns:a16="http://schemas.microsoft.com/office/drawing/2014/main" id="{E9718E0E-E22F-56DC-FF75-5CB3A2031CAE}"/>
+                <a16:creationId xmlns:a16="http://schemas.microsoft.com/office/drawing/2014/main" id="{63E5CE62-8B29-3538-BEFD-ADFBB4A6CDBC}"/>
               </a:ext>
             </a:extLst>
           </p:cNvPr>
@@ -15086,7 +15092,7 @@
           <p:cNvPr id="40" name="Hộp Văn bản 39">
             <a:extLst>
               <a:ext uri="{FF2B5EF4-FFF2-40B4-BE49-F238E27FC236}">
-                <a16:creationId xmlns:a16="http://schemas.microsoft.com/office/drawing/2014/main" id="{27ECE8F5-6805-B34F-2844-804384A1CD86}"/>
+                <a16:creationId xmlns:a16="http://schemas.microsoft.com/office/drawing/2014/main" id="{30EF0FC2-F939-7B0C-8FED-095BD3FA25F6}"/>
               </a:ext>
             </a:extLst>
           </p:cNvPr>
@@ -15131,7 +15137,7 @@
           <p:cNvPr id="41" name="Hộp Văn bản 40">
             <a:extLst>
               <a:ext uri="{FF2B5EF4-FFF2-40B4-BE49-F238E27FC236}">
-                <a16:creationId xmlns:a16="http://schemas.microsoft.com/office/drawing/2014/main" id="{37FE7B69-CE49-1F11-3A72-FC7ED2E3E71E}"/>
+                <a16:creationId xmlns:a16="http://schemas.microsoft.com/office/drawing/2014/main" id="{E55F5371-9423-8939-11A5-ED5CC7D250C1}"/>
               </a:ext>
             </a:extLst>
           </p:cNvPr>
@@ -15176,7 +15182,7 @@
           <p:cNvPr id="42" name="Hộp Văn bản 41">
             <a:extLst>
               <a:ext uri="{FF2B5EF4-FFF2-40B4-BE49-F238E27FC236}">
-                <a16:creationId xmlns:a16="http://schemas.microsoft.com/office/drawing/2014/main" id="{9DF04C54-908C-EA15-D24F-83D0E695257D}"/>
+                <a16:creationId xmlns:a16="http://schemas.microsoft.com/office/drawing/2014/main" id="{7069D877-0C90-CD35-F6FE-2EE2C52251FE}"/>
               </a:ext>
             </a:extLst>
           </p:cNvPr>
@@ -15221,7 +15227,7 @@
           <p:cNvPr id="43" name="Hộp Văn bản 42">
             <a:extLst>
               <a:ext uri="{FF2B5EF4-FFF2-40B4-BE49-F238E27FC236}">
-                <a16:creationId xmlns:a16="http://schemas.microsoft.com/office/drawing/2014/main" id="{0F224D8D-E4B1-3665-D89E-B06DE553020A}"/>
+                <a16:creationId xmlns:a16="http://schemas.microsoft.com/office/drawing/2014/main" id="{E425E361-834D-F9D6-69E6-18430D146790}"/>
               </a:ext>
             </a:extLst>
           </p:cNvPr>
@@ -15266,7 +15272,7 @@
           <p:cNvPr id="44" name="Hình chữ nhật: Góc Tròn 43">
             <a:extLst>
               <a:ext uri="{FF2B5EF4-FFF2-40B4-BE49-F238E27FC236}">
-                <a16:creationId xmlns:a16="http://schemas.microsoft.com/office/drawing/2014/main" id="{304B4F31-C968-6EFA-3325-8406D4818351}"/>
+                <a16:creationId xmlns:a16="http://schemas.microsoft.com/office/drawing/2014/main" id="{F96195A1-5447-8313-C886-59A12C730396}"/>
               </a:ext>
             </a:extLst>
           </p:cNvPr>
@@ -15334,7 +15340,7 @@
           <p:cNvPr id="45" name="Hộp Văn bản 44">
             <a:extLst>
               <a:ext uri="{FF2B5EF4-FFF2-40B4-BE49-F238E27FC236}">
-                <a16:creationId xmlns:a16="http://schemas.microsoft.com/office/drawing/2014/main" id="{32DD7E08-97A5-E4E4-58FF-9259C2039040}"/>
+                <a16:creationId xmlns:a16="http://schemas.microsoft.com/office/drawing/2014/main" id="{F0D3A7C6-8FAA-1927-96E1-AA205AA4C7AA}"/>
               </a:ext>
             </a:extLst>
           </p:cNvPr>
@@ -15379,7 +15385,7 @@
           <p:cNvPr id="46" name="Hộp Văn bản 45">
             <a:extLst>
               <a:ext uri="{FF2B5EF4-FFF2-40B4-BE49-F238E27FC236}">
-                <a16:creationId xmlns:a16="http://schemas.microsoft.com/office/drawing/2014/main" id="{36305F1D-7C38-E1A6-1469-56FF34D19910}"/>
+                <a16:creationId xmlns:a16="http://schemas.microsoft.com/office/drawing/2014/main" id="{7D2E83AD-6F9C-3448-A439-78B5C40BCED8}"/>
               </a:ext>
             </a:extLst>
           </p:cNvPr>
@@ -15414,7 +15420,7 @@
                 </a:solidFill>
                 <a:latin typeface="Aptos" panose="020B0004020202020204" pitchFamily="34" charset="0"/>
               </a:rPr>
-              <a:t>Invoice liên kết bệnh nhân; InvoiceItem lưu đơn giá/số lượng lúc lập.</a:t>
+              <a:t>FollowUpReminder theo dõi trạng thái gửi duy nhất theo EMR/ngày.</a:t>
             </a:r>
           </a:p>
         </p:txBody>
@@ -15422,7 +15428,7 @@
     </p:spTree>
     <p:extLst>
       <p:ext uri="{BB962C8B-B14F-4D97-AF65-F5344CB8AC3E}">
-        <p14:creationId xmlns:p14="http://schemas.microsoft.com/office/powerpoint/2010/main" val="3966193289"/>
+        <p14:creationId xmlns:p14="http://schemas.microsoft.com/office/powerpoint/2010/main" val="509967064"/>
       </p:ext>
     </p:extLst>
   </p:cSld>
@@ -15454,7 +15460,7 @@
           <p:cNvPr id="2" name="Hộp Văn bản 1">
             <a:extLst>
               <a:ext uri="{FF2B5EF4-FFF2-40B4-BE49-F238E27FC236}">
-                <a16:creationId xmlns:a16="http://schemas.microsoft.com/office/drawing/2014/main" id="{4C7731E2-13CF-C300-0363-62AA30AEA378}"/>
+                <a16:creationId xmlns:a16="http://schemas.microsoft.com/office/drawing/2014/main" id="{6F548BCB-99F1-E046-CC9C-156FE0060E8A}"/>
               </a:ext>
             </a:extLst>
           </p:cNvPr>
@@ -15499,7 +15505,7 @@
           <p:cNvPr id="3" name="Hộp Văn bản 2">
             <a:extLst>
               <a:ext uri="{FF2B5EF4-FFF2-40B4-BE49-F238E27FC236}">
-                <a16:creationId xmlns:a16="http://schemas.microsoft.com/office/drawing/2014/main" id="{42859D64-C891-6FCD-2227-883B1692946F}"/>
+                <a16:creationId xmlns:a16="http://schemas.microsoft.com/office/drawing/2014/main" id="{6E06112C-BB84-8549-0B8F-483086236312}"/>
               </a:ext>
             </a:extLst>
           </p:cNvPr>
@@ -15544,7 +15550,7 @@
           <p:cNvPr id="4" name="Hộp Văn bản 3">
             <a:extLst>
               <a:ext uri="{FF2B5EF4-FFF2-40B4-BE49-F238E27FC236}">
-                <a16:creationId xmlns:a16="http://schemas.microsoft.com/office/drawing/2014/main" id="{BAD7A1AD-0FAF-F9AD-AF5C-F80F6362E295}"/>
+                <a16:creationId xmlns:a16="http://schemas.microsoft.com/office/drawing/2014/main" id="{D7924E69-7B6E-A8BA-1155-9CCC804A4677}"/>
               </a:ext>
             </a:extLst>
           </p:cNvPr>
@@ -15589,7 +15595,7 @@
           <p:cNvPr id="5" name="Hình chữ nhật 4">
             <a:extLst>
               <a:ext uri="{FF2B5EF4-FFF2-40B4-BE49-F238E27FC236}">
-                <a16:creationId xmlns:a16="http://schemas.microsoft.com/office/drawing/2014/main" id="{3C8D904C-FC4E-F876-9729-4BD6DC92AF89}"/>
+                <a16:creationId xmlns:a16="http://schemas.microsoft.com/office/drawing/2014/main" id="{85495AA4-46E3-41C9-6E90-55D470B24357}"/>
               </a:ext>
             </a:extLst>
           </p:cNvPr>
@@ -15657,7 +15663,7 @@
           <p:cNvPr id="6" name="Hộp Văn bản 5">
             <a:extLst>
               <a:ext uri="{FF2B5EF4-FFF2-40B4-BE49-F238E27FC236}">
-                <a16:creationId xmlns:a16="http://schemas.microsoft.com/office/drawing/2014/main" id="{137AA187-0374-977B-C68D-484AC2792481}"/>
+                <a16:creationId xmlns:a16="http://schemas.microsoft.com/office/drawing/2014/main" id="{59D9C428-0FF1-664A-9015-B5CAB3FB5E4D}"/>
               </a:ext>
             </a:extLst>
           </p:cNvPr>
@@ -15702,7 +15708,7 @@
           <p:cNvPr id="7" name="Hộp Văn bản 6">
             <a:extLst>
               <a:ext uri="{FF2B5EF4-FFF2-40B4-BE49-F238E27FC236}">
-                <a16:creationId xmlns:a16="http://schemas.microsoft.com/office/drawing/2014/main" id="{164AE5D8-8E1D-A13F-99F2-F98F8EEEF65C}"/>
+                <a16:creationId xmlns:a16="http://schemas.microsoft.com/office/drawing/2014/main" id="{19388347-4ADC-BC3A-5FAC-A8DA46518B05}"/>
               </a:ext>
             </a:extLst>
           </p:cNvPr>
@@ -15747,7 +15753,7 @@
           <p:cNvPr id="8" name="Hình chữ nhật: Góc Tròn 7">
             <a:extLst>
               <a:ext uri="{FF2B5EF4-FFF2-40B4-BE49-F238E27FC236}">
-                <a16:creationId xmlns:a16="http://schemas.microsoft.com/office/drawing/2014/main" id="{C0F2E1AB-EE60-CC3A-5456-0A312DF074FF}"/>
+                <a16:creationId xmlns:a16="http://schemas.microsoft.com/office/drawing/2014/main" id="{9718E137-2241-899F-F0DC-949AF3153242}"/>
               </a:ext>
             </a:extLst>
           </p:cNvPr>
@@ -15815,7 +15821,7 @@
           <p:cNvPr id="10" name="Hình ảnh 9">
             <a:extLst>
               <a:ext uri="{FF2B5EF4-FFF2-40B4-BE49-F238E27FC236}">
-                <a16:creationId xmlns:a16="http://schemas.microsoft.com/office/drawing/2014/main" id="{1B8B3AB0-33FA-5227-860C-AC2CE1F84419}"/>
+                <a16:creationId xmlns:a16="http://schemas.microsoft.com/office/drawing/2014/main" id="{2D91CBED-335C-927A-114B-47DBC2370CC1}"/>
               </a:ext>
             </a:extLst>
           </p:cNvPr>
@@ -15851,7 +15857,7 @@
           <p:cNvPr id="11" name="Hộp Văn bản 10">
             <a:extLst>
               <a:ext uri="{FF2B5EF4-FFF2-40B4-BE49-F238E27FC236}">
-                <a16:creationId xmlns:a16="http://schemas.microsoft.com/office/drawing/2014/main" id="{25B346CE-4EAD-F4A7-669F-23C37409ABAD}"/>
+                <a16:creationId xmlns:a16="http://schemas.microsoft.com/office/drawing/2014/main" id="{AC47543E-A4C7-2591-0A53-720A20496D0B}"/>
               </a:ext>
             </a:extLst>
           </p:cNvPr>
@@ -15896,7 +15902,7 @@
           <p:cNvPr id="12" name="Hình chữ nhật: Góc Tròn 11">
             <a:extLst>
               <a:ext uri="{FF2B5EF4-FFF2-40B4-BE49-F238E27FC236}">
-                <a16:creationId xmlns:a16="http://schemas.microsoft.com/office/drawing/2014/main" id="{53179412-5416-D105-FD6E-03394793A30F}"/>
+                <a16:creationId xmlns:a16="http://schemas.microsoft.com/office/drawing/2014/main" id="{34DA7A1C-35AA-5810-B413-9B602E73BBB8}"/>
               </a:ext>
             </a:extLst>
           </p:cNvPr>
@@ -15964,7 +15970,7 @@
           <p:cNvPr id="13" name="Hình chữ nhật 12">
             <a:extLst>
               <a:ext uri="{FF2B5EF4-FFF2-40B4-BE49-F238E27FC236}">
-                <a16:creationId xmlns:a16="http://schemas.microsoft.com/office/drawing/2014/main" id="{EE1D2394-C3BE-5F88-3B9E-82739C95191C}"/>
+                <a16:creationId xmlns:a16="http://schemas.microsoft.com/office/drawing/2014/main" id="{F306985D-DFA7-1698-28A1-7CE77074D431}"/>
               </a:ext>
             </a:extLst>
           </p:cNvPr>
@@ -16032,7 +16038,7 @@
           <p:cNvPr id="14" name="Hộp Văn bản 13">
             <a:extLst>
               <a:ext uri="{FF2B5EF4-FFF2-40B4-BE49-F238E27FC236}">
-                <a16:creationId xmlns:a16="http://schemas.microsoft.com/office/drawing/2014/main" id="{5C597A7C-0B4B-4C63-3C72-45EBB606CEB4}"/>
+                <a16:creationId xmlns:a16="http://schemas.microsoft.com/office/drawing/2014/main" id="{8EF7110D-AFFE-4C37-C7A1-B170160AD609}"/>
               </a:ext>
             </a:extLst>
           </p:cNvPr>
@@ -16077,7 +16083,7 @@
           <p:cNvPr id="15" name="Hộp Văn bản 14">
             <a:extLst>
               <a:ext uri="{FF2B5EF4-FFF2-40B4-BE49-F238E27FC236}">
-                <a16:creationId xmlns:a16="http://schemas.microsoft.com/office/drawing/2014/main" id="{617311A0-AC5E-8691-1AA2-D58EB9D2AAC5}"/>
+                <a16:creationId xmlns:a16="http://schemas.microsoft.com/office/drawing/2014/main" id="{9D97AA83-3DBA-9BAA-7DBA-466B3E3E72B4}"/>
               </a:ext>
             </a:extLst>
           </p:cNvPr>
@@ -16122,7 +16128,7 @@
           <p:cNvPr id="16" name="Hình chữ nhật: Góc Tròn 15">
             <a:extLst>
               <a:ext uri="{FF2B5EF4-FFF2-40B4-BE49-F238E27FC236}">
-                <a16:creationId xmlns:a16="http://schemas.microsoft.com/office/drawing/2014/main" id="{BA04FD4C-CD51-B31D-4CCB-E398B43AD0C8}"/>
+                <a16:creationId xmlns:a16="http://schemas.microsoft.com/office/drawing/2014/main" id="{E6AECA7A-0E2C-CE4C-930E-63DAC2AE8C6F}"/>
               </a:ext>
             </a:extLst>
           </p:cNvPr>
@@ -16190,7 +16196,7 @@
           <p:cNvPr id="17" name="Hình chữ nhật 16">
             <a:extLst>
               <a:ext uri="{FF2B5EF4-FFF2-40B4-BE49-F238E27FC236}">
-                <a16:creationId xmlns:a16="http://schemas.microsoft.com/office/drawing/2014/main" id="{E22F2431-894F-C88B-F778-44E5F37C18AD}"/>
+                <a16:creationId xmlns:a16="http://schemas.microsoft.com/office/drawing/2014/main" id="{62EBB501-8F6D-0FCF-0AEC-3514E8FB4240}"/>
               </a:ext>
             </a:extLst>
           </p:cNvPr>
@@ -16258,7 +16264,7 @@
           <p:cNvPr id="18" name="Hộp Văn bản 17">
             <a:extLst>
               <a:ext uri="{FF2B5EF4-FFF2-40B4-BE49-F238E27FC236}">
-                <a16:creationId xmlns:a16="http://schemas.microsoft.com/office/drawing/2014/main" id="{84522387-4A14-3011-D59D-9E68A0BA0869}"/>
+                <a16:creationId xmlns:a16="http://schemas.microsoft.com/office/drawing/2014/main" id="{62D82A7F-6873-E325-543A-62E230CA9670}"/>
               </a:ext>
             </a:extLst>
           </p:cNvPr>
@@ -16303,7 +16309,7 @@
           <p:cNvPr id="19" name="Hộp Văn bản 18">
             <a:extLst>
               <a:ext uri="{FF2B5EF4-FFF2-40B4-BE49-F238E27FC236}">
-                <a16:creationId xmlns:a16="http://schemas.microsoft.com/office/drawing/2014/main" id="{FBC197F1-E86D-0A34-1466-F3E2D4A37C91}"/>
+                <a16:creationId xmlns:a16="http://schemas.microsoft.com/office/drawing/2014/main" id="{50C72E03-8127-85B7-D2ED-CE4D6E8A6E86}"/>
               </a:ext>
             </a:extLst>
           </p:cNvPr>
@@ -16348,7 +16354,7 @@
           <p:cNvPr id="20" name="Hình chữ nhật: Góc Tròn 19">
             <a:extLst>
               <a:ext uri="{FF2B5EF4-FFF2-40B4-BE49-F238E27FC236}">
-                <a16:creationId xmlns:a16="http://schemas.microsoft.com/office/drawing/2014/main" id="{3C33E9FC-38EA-E907-A0D0-9B803F8A74C8}"/>
+                <a16:creationId xmlns:a16="http://schemas.microsoft.com/office/drawing/2014/main" id="{83EC7245-4F9A-1BDA-8B80-9A45D21E3E36}"/>
               </a:ext>
             </a:extLst>
           </p:cNvPr>
@@ -16416,7 +16422,7 @@
           <p:cNvPr id="21" name="Hình chữ nhật 20">
             <a:extLst>
               <a:ext uri="{FF2B5EF4-FFF2-40B4-BE49-F238E27FC236}">
-                <a16:creationId xmlns:a16="http://schemas.microsoft.com/office/drawing/2014/main" id="{8516B570-7033-25E4-409F-E292927A1358}"/>
+                <a16:creationId xmlns:a16="http://schemas.microsoft.com/office/drawing/2014/main" id="{F6BFBC7D-BB97-7486-E271-09ED575DE4F2}"/>
               </a:ext>
             </a:extLst>
           </p:cNvPr>
@@ -16484,7 +16490,7 @@
           <p:cNvPr id="22" name="Hộp Văn bản 21">
             <a:extLst>
               <a:ext uri="{FF2B5EF4-FFF2-40B4-BE49-F238E27FC236}">
-                <a16:creationId xmlns:a16="http://schemas.microsoft.com/office/drawing/2014/main" id="{8B3DA0E6-6C53-D6F3-9B28-7425E6EFD3B8}"/>
+                <a16:creationId xmlns:a16="http://schemas.microsoft.com/office/drawing/2014/main" id="{5ED31E5F-7413-25F1-B3BD-BEBF49B4CFAA}"/>
               </a:ext>
             </a:extLst>
           </p:cNvPr>
@@ -16529,7 +16535,7 @@
           <p:cNvPr id="23" name="Hộp Văn bản 22">
             <a:extLst>
               <a:ext uri="{FF2B5EF4-FFF2-40B4-BE49-F238E27FC236}">
-                <a16:creationId xmlns:a16="http://schemas.microsoft.com/office/drawing/2014/main" id="{B56BBA3E-288B-7AE9-0374-2E5DEDF66600}"/>
+                <a16:creationId xmlns:a16="http://schemas.microsoft.com/office/drawing/2014/main" id="{CAFCAAA4-C9A9-AD22-CD4B-29F6EFE699A1}"/>
               </a:ext>
             </a:extLst>
           </p:cNvPr>
@@ -16572,7 +16578,7 @@
     </p:spTree>
     <p:extLst>
       <p:ext uri="{BB962C8B-B14F-4D97-AF65-F5344CB8AC3E}">
-        <p14:creationId xmlns:p14="http://schemas.microsoft.com/office/powerpoint/2010/main" val="3509672645"/>
+        <p14:creationId xmlns:p14="http://schemas.microsoft.com/office/powerpoint/2010/main" val="1937393795"/>
       </p:ext>
     </p:extLst>
   </p:cSld>
@@ -16604,7 +16610,7 @@
           <p:cNvPr id="2" name="Hộp Văn bản 1">
             <a:extLst>
               <a:ext uri="{FF2B5EF4-FFF2-40B4-BE49-F238E27FC236}">
-                <a16:creationId xmlns:a16="http://schemas.microsoft.com/office/drawing/2014/main" id="{1B3D578F-2FA2-A9EE-190F-7F0EAC37DDA7}"/>
+                <a16:creationId xmlns:a16="http://schemas.microsoft.com/office/drawing/2014/main" id="{4B68E8AB-D443-225D-2723-9C090B210746}"/>
               </a:ext>
             </a:extLst>
           </p:cNvPr>
@@ -16649,7 +16655,7 @@
           <p:cNvPr id="3" name="Hộp Văn bản 2">
             <a:extLst>
               <a:ext uri="{FF2B5EF4-FFF2-40B4-BE49-F238E27FC236}">
-                <a16:creationId xmlns:a16="http://schemas.microsoft.com/office/drawing/2014/main" id="{0D0BCEF5-A933-98EB-971C-D91715BDF565}"/>
+                <a16:creationId xmlns:a16="http://schemas.microsoft.com/office/drawing/2014/main" id="{0A25DFC0-0269-CB79-D72E-3FBDF24683A1}"/>
               </a:ext>
             </a:extLst>
           </p:cNvPr>
@@ -16694,7 +16700,7 @@
           <p:cNvPr id="4" name="Hộp Văn bản 3">
             <a:extLst>
               <a:ext uri="{FF2B5EF4-FFF2-40B4-BE49-F238E27FC236}">
-                <a16:creationId xmlns:a16="http://schemas.microsoft.com/office/drawing/2014/main" id="{C1397A1B-0BED-BDB3-28D3-43AC5656CEDD}"/>
+                <a16:creationId xmlns:a16="http://schemas.microsoft.com/office/drawing/2014/main" id="{0BB1F813-66D9-5F1B-4822-103B4E113935}"/>
               </a:ext>
             </a:extLst>
           </p:cNvPr>
@@ -16739,7 +16745,7 @@
           <p:cNvPr id="5" name="Hình chữ nhật 4">
             <a:extLst>
               <a:ext uri="{FF2B5EF4-FFF2-40B4-BE49-F238E27FC236}">
-                <a16:creationId xmlns:a16="http://schemas.microsoft.com/office/drawing/2014/main" id="{66B47A2E-D3D0-2633-9DAE-75F14EF2B99C}"/>
+                <a16:creationId xmlns:a16="http://schemas.microsoft.com/office/drawing/2014/main" id="{C05FE8FA-2ACF-0587-8818-E521B77D63AF}"/>
               </a:ext>
             </a:extLst>
           </p:cNvPr>
@@ -16807,7 +16813,7 @@
           <p:cNvPr id="6" name="Hộp Văn bản 5">
             <a:extLst>
               <a:ext uri="{FF2B5EF4-FFF2-40B4-BE49-F238E27FC236}">
-                <a16:creationId xmlns:a16="http://schemas.microsoft.com/office/drawing/2014/main" id="{C026B753-DFC8-460E-1471-F7A5DCAB7AA6}"/>
+                <a16:creationId xmlns:a16="http://schemas.microsoft.com/office/drawing/2014/main" id="{B8F5CEE9-80F2-4F67-715D-920C1F363D12}"/>
               </a:ext>
             </a:extLst>
           </p:cNvPr>
@@ -16852,7 +16858,7 @@
           <p:cNvPr id="7" name="Hộp Văn bản 6">
             <a:extLst>
               <a:ext uri="{FF2B5EF4-FFF2-40B4-BE49-F238E27FC236}">
-                <a16:creationId xmlns:a16="http://schemas.microsoft.com/office/drawing/2014/main" id="{BD3755B5-5DF0-315E-A8C8-0987C13E9036}"/>
+                <a16:creationId xmlns:a16="http://schemas.microsoft.com/office/drawing/2014/main" id="{BDB9C57D-FECC-0ACE-9051-FDEFC8C2E37E}"/>
               </a:ext>
             </a:extLst>
           </p:cNvPr>
@@ -16897,7 +16903,7 @@
           <p:cNvPr id="8" name="Hình chữ nhật: Góc Tròn 7">
             <a:extLst>
               <a:ext uri="{FF2B5EF4-FFF2-40B4-BE49-F238E27FC236}">
-                <a16:creationId xmlns:a16="http://schemas.microsoft.com/office/drawing/2014/main" id="{ECD957EC-E704-2A9D-8AEE-A06C1291EE18}"/>
+                <a16:creationId xmlns:a16="http://schemas.microsoft.com/office/drawing/2014/main" id="{B85A8391-AA18-8EEE-0E67-4BFB7D0AEC1C}"/>
               </a:ext>
             </a:extLst>
           </p:cNvPr>
@@ -16965,7 +16971,7 @@
           <p:cNvPr id="10" name="Hình ảnh 9">
             <a:extLst>
               <a:ext uri="{FF2B5EF4-FFF2-40B4-BE49-F238E27FC236}">
-                <a16:creationId xmlns:a16="http://schemas.microsoft.com/office/drawing/2014/main" id="{B0729897-B6EC-D62D-F2AA-5F471E0AD4BD}"/>
+                <a16:creationId xmlns:a16="http://schemas.microsoft.com/office/drawing/2014/main" id="{4F729F05-9FC4-31A8-4157-2950BFDBEB54}"/>
               </a:ext>
             </a:extLst>
           </p:cNvPr>
@@ -17001,7 +17007,7 @@
           <p:cNvPr id="11" name="Hộp Văn bản 10">
             <a:extLst>
               <a:ext uri="{FF2B5EF4-FFF2-40B4-BE49-F238E27FC236}">
-                <a16:creationId xmlns:a16="http://schemas.microsoft.com/office/drawing/2014/main" id="{5952620B-9BB1-EDF4-FDB9-5643915B7386}"/>
+                <a16:creationId xmlns:a16="http://schemas.microsoft.com/office/drawing/2014/main" id="{9BCFAEFC-902F-9A56-EE0F-D8CC6B6318A9}"/>
               </a:ext>
             </a:extLst>
           </p:cNvPr>
@@ -17046,7 +17052,7 @@
           <p:cNvPr id="12" name="Hình chữ nhật: Góc Tròn 11">
             <a:extLst>
               <a:ext uri="{FF2B5EF4-FFF2-40B4-BE49-F238E27FC236}">
-                <a16:creationId xmlns:a16="http://schemas.microsoft.com/office/drawing/2014/main" id="{E35DE13B-A9EE-A29A-D548-106B641C6E7A}"/>
+                <a16:creationId xmlns:a16="http://schemas.microsoft.com/office/drawing/2014/main" id="{AE825BF4-3E35-E980-20EB-4D123FEBD3AA}"/>
               </a:ext>
             </a:extLst>
           </p:cNvPr>
@@ -17114,7 +17120,7 @@
           <p:cNvPr id="13" name="Hình chữ nhật 12">
             <a:extLst>
               <a:ext uri="{FF2B5EF4-FFF2-40B4-BE49-F238E27FC236}">
-                <a16:creationId xmlns:a16="http://schemas.microsoft.com/office/drawing/2014/main" id="{17951E16-1097-8F9D-2CA4-5E7823AABD87}"/>
+                <a16:creationId xmlns:a16="http://schemas.microsoft.com/office/drawing/2014/main" id="{9BA48238-823D-3C61-B834-43B76E163DCA}"/>
               </a:ext>
             </a:extLst>
           </p:cNvPr>
@@ -17182,7 +17188,7 @@
           <p:cNvPr id="14" name="Hộp Văn bản 13">
             <a:extLst>
               <a:ext uri="{FF2B5EF4-FFF2-40B4-BE49-F238E27FC236}">
-                <a16:creationId xmlns:a16="http://schemas.microsoft.com/office/drawing/2014/main" id="{7CF9305A-BA46-10AA-10CF-6028AAF916E6}"/>
+                <a16:creationId xmlns:a16="http://schemas.microsoft.com/office/drawing/2014/main" id="{66DD68D3-FAB5-4994-57D1-587A0E829560}"/>
               </a:ext>
             </a:extLst>
           </p:cNvPr>
@@ -17227,7 +17233,7 @@
           <p:cNvPr id="15" name="Hộp Văn bản 14">
             <a:extLst>
               <a:ext uri="{FF2B5EF4-FFF2-40B4-BE49-F238E27FC236}">
-                <a16:creationId xmlns:a16="http://schemas.microsoft.com/office/drawing/2014/main" id="{62DD0774-A182-B8E1-2F43-692701EE9C04}"/>
+                <a16:creationId xmlns:a16="http://schemas.microsoft.com/office/drawing/2014/main" id="{900A8F44-3D2F-E95A-364A-1734146A168B}"/>
               </a:ext>
             </a:extLst>
           </p:cNvPr>
@@ -17272,7 +17278,7 @@
           <p:cNvPr id="16" name="Hình chữ nhật: Góc Tròn 15">
             <a:extLst>
               <a:ext uri="{FF2B5EF4-FFF2-40B4-BE49-F238E27FC236}">
-                <a16:creationId xmlns:a16="http://schemas.microsoft.com/office/drawing/2014/main" id="{54DF16BF-85B5-3F28-869D-931B2E7F3BCA}"/>
+                <a16:creationId xmlns:a16="http://schemas.microsoft.com/office/drawing/2014/main" id="{377C7367-F671-A263-4216-B5ED89A85021}"/>
               </a:ext>
             </a:extLst>
           </p:cNvPr>
@@ -17340,7 +17346,7 @@
           <p:cNvPr id="17" name="Hình chữ nhật 16">
             <a:extLst>
               <a:ext uri="{FF2B5EF4-FFF2-40B4-BE49-F238E27FC236}">
-                <a16:creationId xmlns:a16="http://schemas.microsoft.com/office/drawing/2014/main" id="{53268D31-4B4F-FE4A-E647-802B9711DC28}"/>
+                <a16:creationId xmlns:a16="http://schemas.microsoft.com/office/drawing/2014/main" id="{7E0BAC59-FC55-B285-7934-0DB6B8A6E087}"/>
               </a:ext>
             </a:extLst>
           </p:cNvPr>
@@ -17408,7 +17414,7 @@
           <p:cNvPr id="18" name="Hộp Văn bản 17">
             <a:extLst>
               <a:ext uri="{FF2B5EF4-FFF2-40B4-BE49-F238E27FC236}">
-                <a16:creationId xmlns:a16="http://schemas.microsoft.com/office/drawing/2014/main" id="{D7F25055-2CBE-460B-92EB-45B887D0640C}"/>
+                <a16:creationId xmlns:a16="http://schemas.microsoft.com/office/drawing/2014/main" id="{6570D003-1F83-B1BC-ABED-C7C67AB93A57}"/>
               </a:ext>
             </a:extLst>
           </p:cNvPr>
@@ -17453,7 +17459,7 @@
           <p:cNvPr id="19" name="Hộp Văn bản 18">
             <a:extLst>
               <a:ext uri="{FF2B5EF4-FFF2-40B4-BE49-F238E27FC236}">
-                <a16:creationId xmlns:a16="http://schemas.microsoft.com/office/drawing/2014/main" id="{48B190E6-2843-DDBA-F54E-87E28E7FCEB7}"/>
+                <a16:creationId xmlns:a16="http://schemas.microsoft.com/office/drawing/2014/main" id="{51C3E0F9-50F4-6B76-5919-8E2D4E86725E}"/>
               </a:ext>
             </a:extLst>
           </p:cNvPr>
@@ -17498,7 +17504,7 @@
           <p:cNvPr id="20" name="Hình chữ nhật: Góc Tròn 19">
             <a:extLst>
               <a:ext uri="{FF2B5EF4-FFF2-40B4-BE49-F238E27FC236}">
-                <a16:creationId xmlns:a16="http://schemas.microsoft.com/office/drawing/2014/main" id="{B2CE45FA-0A00-D549-E1BE-0CB699B24202}"/>
+                <a16:creationId xmlns:a16="http://schemas.microsoft.com/office/drawing/2014/main" id="{ABB5344C-2A08-08AA-C2FC-9559F793D831}"/>
               </a:ext>
             </a:extLst>
           </p:cNvPr>
@@ -17566,7 +17572,7 @@
           <p:cNvPr id="21" name="Hình chữ nhật: Góc Tròn 20">
             <a:extLst>
               <a:ext uri="{FF2B5EF4-FFF2-40B4-BE49-F238E27FC236}">
-                <a16:creationId xmlns:a16="http://schemas.microsoft.com/office/drawing/2014/main" id="{F4FA9A3F-4739-786F-9BC0-F6ACB4802973}"/>
+                <a16:creationId xmlns:a16="http://schemas.microsoft.com/office/drawing/2014/main" id="{D569B4F1-C703-B606-EDB4-29B81BA7E951}"/>
               </a:ext>
             </a:extLst>
           </p:cNvPr>
@@ -17576,7 +17582,7 @@
         <p:spPr>
           <a:xfrm>
             <a:off x="8255000" y="4851400"/>
-            <a:ext cx="2044700" cy="279400"/>
+            <a:ext cx="2603500" cy="279400"/>
           </a:xfrm>
           <a:prstGeom prst="roundRect">
             <a:avLst/>
@@ -17634,7 +17640,7 @@
           <p:cNvPr id="22" name="Hộp Văn bản 21">
             <a:extLst>
               <a:ext uri="{FF2B5EF4-FFF2-40B4-BE49-F238E27FC236}">
-                <a16:creationId xmlns:a16="http://schemas.microsoft.com/office/drawing/2014/main" id="{F925ED6C-D852-F04C-6036-92FB71194CE2}"/>
+                <a16:creationId xmlns:a16="http://schemas.microsoft.com/office/drawing/2014/main" id="{7E387749-4CAA-33C4-9888-E42526CEA893}"/>
               </a:ext>
             </a:extLst>
           </p:cNvPr>
@@ -17644,7 +17650,7 @@
         <p:spPr>
           <a:xfrm>
             <a:off x="8331200" y="4889500"/>
-            <a:ext cx="1892300" cy="216085"/>
+            <a:ext cx="2451100" cy="216085"/>
           </a:xfrm>
           <a:prstGeom prst="rect">
             <a:avLst/>
@@ -17669,7 +17675,7 @@
                 </a:solidFill>
                 <a:latin typeface="Aptos" panose="020B0004020202020204" pitchFamily="34" charset="0"/>
               </a:rPr>
-              <a:t>AI SUMMARY · ĐỀ XUẤT</a:t>
+              <a:t>AI SUMMARY · TÙY CHỌN</a:t>
             </a:r>
           </a:p>
         </p:txBody>
@@ -17679,7 +17685,7 @@
           <p:cNvPr id="23" name="Hộp Văn bản 22">
             <a:extLst>
               <a:ext uri="{FF2B5EF4-FFF2-40B4-BE49-F238E27FC236}">
-                <a16:creationId xmlns:a16="http://schemas.microsoft.com/office/drawing/2014/main" id="{1FCCAA1B-23F5-CA9F-703F-7CF3EBD4E3FA}"/>
+                <a16:creationId xmlns:a16="http://schemas.microsoft.com/office/drawing/2014/main" id="{87CDC2DE-0492-5790-9FA5-68AB1176DA48}"/>
               </a:ext>
             </a:extLst>
           </p:cNvPr>
@@ -17714,7 +17720,7 @@
                 </a:solidFill>
                 <a:latin typeface="Aptos" panose="020B0004020202020204" pitchFamily="34" charset="0"/>
               </a:rPr>
-              <a:t>AI tóm tắt EMR chưa được triển khai.</a:t>
+              <a:t>Cần consent + Gemini key; bác sĩ rà soát bản nháp.</a:t>
             </a:r>
           </a:p>
         </p:txBody>
@@ -17722,7 +17728,7 @@
     </p:spTree>
     <p:extLst>
       <p:ext uri="{BB962C8B-B14F-4D97-AF65-F5344CB8AC3E}">
-        <p14:creationId xmlns:p14="http://schemas.microsoft.com/office/powerpoint/2010/main" val="3977480324"/>
+        <p14:creationId xmlns:p14="http://schemas.microsoft.com/office/powerpoint/2010/main" val="524272033"/>
       </p:ext>
     </p:extLst>
   </p:cSld>
@@ -17754,7 +17760,7 @@
           <p:cNvPr id="2" name="Hộp Văn bản 1">
             <a:extLst>
               <a:ext uri="{FF2B5EF4-FFF2-40B4-BE49-F238E27FC236}">
-                <a16:creationId xmlns:a16="http://schemas.microsoft.com/office/drawing/2014/main" id="{2D41698B-F7CF-A3FE-0260-B0D650D99581}"/>
+                <a16:creationId xmlns:a16="http://schemas.microsoft.com/office/drawing/2014/main" id="{378226E7-D9A5-E50B-F806-81C782E33FF2}"/>
               </a:ext>
             </a:extLst>
           </p:cNvPr>
@@ -17799,7 +17805,7 @@
           <p:cNvPr id="3" name="Hộp Văn bản 2">
             <a:extLst>
               <a:ext uri="{FF2B5EF4-FFF2-40B4-BE49-F238E27FC236}">
-                <a16:creationId xmlns:a16="http://schemas.microsoft.com/office/drawing/2014/main" id="{71E33443-D0FD-E4B1-600E-E5A0E2289F62}"/>
+                <a16:creationId xmlns:a16="http://schemas.microsoft.com/office/drawing/2014/main" id="{1D48468E-A9B5-BF4F-4DA8-7EE156BCEAE9}"/>
               </a:ext>
             </a:extLst>
           </p:cNvPr>
@@ -17844,7 +17850,7 @@
           <p:cNvPr id="4" name="Hộp Văn bản 3">
             <a:extLst>
               <a:ext uri="{FF2B5EF4-FFF2-40B4-BE49-F238E27FC236}">
-                <a16:creationId xmlns:a16="http://schemas.microsoft.com/office/drawing/2014/main" id="{F83C88C1-874F-7C56-307E-00E4EF397CDA}"/>
+                <a16:creationId xmlns:a16="http://schemas.microsoft.com/office/drawing/2014/main" id="{D4FD3178-8FBF-9EF8-8BA8-C22C63714E52}"/>
               </a:ext>
             </a:extLst>
           </p:cNvPr>
@@ -17889,7 +17895,7 @@
           <p:cNvPr id="5" name="Hình chữ nhật 4">
             <a:extLst>
               <a:ext uri="{FF2B5EF4-FFF2-40B4-BE49-F238E27FC236}">
-                <a16:creationId xmlns:a16="http://schemas.microsoft.com/office/drawing/2014/main" id="{76E96A41-32C7-A8AA-E327-B15FDC9A24E1}"/>
+                <a16:creationId xmlns:a16="http://schemas.microsoft.com/office/drawing/2014/main" id="{4B8BCEC2-6603-72EB-A635-DFEDDFB44573}"/>
               </a:ext>
             </a:extLst>
           </p:cNvPr>
@@ -17957,7 +17963,7 @@
           <p:cNvPr id="6" name="Hộp Văn bản 5">
             <a:extLst>
               <a:ext uri="{FF2B5EF4-FFF2-40B4-BE49-F238E27FC236}">
-                <a16:creationId xmlns:a16="http://schemas.microsoft.com/office/drawing/2014/main" id="{7C76D6C4-6300-48E0-4E57-1134941B1198}"/>
+                <a16:creationId xmlns:a16="http://schemas.microsoft.com/office/drawing/2014/main" id="{D3A59C49-B4B7-2720-CD7F-B620CD0FDD34}"/>
               </a:ext>
             </a:extLst>
           </p:cNvPr>
@@ -18002,7 +18008,7 @@
           <p:cNvPr id="7" name="Hộp Văn bản 6">
             <a:extLst>
               <a:ext uri="{FF2B5EF4-FFF2-40B4-BE49-F238E27FC236}">
-                <a16:creationId xmlns:a16="http://schemas.microsoft.com/office/drawing/2014/main" id="{EBD872A6-734E-8D7C-960B-AD94D77B2107}"/>
+                <a16:creationId xmlns:a16="http://schemas.microsoft.com/office/drawing/2014/main" id="{8C907A99-E24C-E6E6-2CB9-D433FADDD046}"/>
               </a:ext>
             </a:extLst>
           </p:cNvPr>
@@ -18047,7 +18053,7 @@
           <p:cNvPr id="8" name="Hình chữ nhật: Góc Tròn 7">
             <a:extLst>
               <a:ext uri="{FF2B5EF4-FFF2-40B4-BE49-F238E27FC236}">
-                <a16:creationId xmlns:a16="http://schemas.microsoft.com/office/drawing/2014/main" id="{C0D47504-3DD3-9811-9988-F5316546960E}"/>
+                <a16:creationId xmlns:a16="http://schemas.microsoft.com/office/drawing/2014/main" id="{289C9A54-C829-CEBF-E7BF-BF333280A62D}"/>
               </a:ext>
             </a:extLst>
           </p:cNvPr>
@@ -18115,7 +18121,7 @@
           <p:cNvPr id="10" name="Hình ảnh 9">
             <a:extLst>
               <a:ext uri="{FF2B5EF4-FFF2-40B4-BE49-F238E27FC236}">
-                <a16:creationId xmlns:a16="http://schemas.microsoft.com/office/drawing/2014/main" id="{31A5E2CB-345A-7F35-E8FE-3DF969DCAB3D}"/>
+                <a16:creationId xmlns:a16="http://schemas.microsoft.com/office/drawing/2014/main" id="{911FF853-216E-0F44-A84C-2665A12C400B}"/>
               </a:ext>
             </a:extLst>
           </p:cNvPr>
@@ -18151,7 +18157,7 @@
           <p:cNvPr id="11" name="Hộp Văn bản 10">
             <a:extLst>
               <a:ext uri="{FF2B5EF4-FFF2-40B4-BE49-F238E27FC236}">
-                <a16:creationId xmlns:a16="http://schemas.microsoft.com/office/drawing/2014/main" id="{5ECE1BC7-4E20-F7B0-8A33-68DA70FCE396}"/>
+                <a16:creationId xmlns:a16="http://schemas.microsoft.com/office/drawing/2014/main" id="{48C53B19-5286-7268-4109-E537153FBE13}"/>
               </a:ext>
             </a:extLst>
           </p:cNvPr>
@@ -18196,7 +18202,7 @@
           <p:cNvPr id="12" name="Hình chữ nhật: Góc Tròn 11">
             <a:extLst>
               <a:ext uri="{FF2B5EF4-FFF2-40B4-BE49-F238E27FC236}">
-                <a16:creationId xmlns:a16="http://schemas.microsoft.com/office/drawing/2014/main" id="{88F54A71-1742-5644-3FBB-4341665CBC4A}"/>
+                <a16:creationId xmlns:a16="http://schemas.microsoft.com/office/drawing/2014/main" id="{A51B5285-D030-456F-F5F7-D30CF20A1952}"/>
               </a:ext>
             </a:extLst>
           </p:cNvPr>
@@ -18264,7 +18270,7 @@
           <p:cNvPr id="13" name="Hình chữ nhật 12">
             <a:extLst>
               <a:ext uri="{FF2B5EF4-FFF2-40B4-BE49-F238E27FC236}">
-                <a16:creationId xmlns:a16="http://schemas.microsoft.com/office/drawing/2014/main" id="{021C9FD4-E75B-4F51-BE7E-32A4F36AF295}"/>
+                <a16:creationId xmlns:a16="http://schemas.microsoft.com/office/drawing/2014/main" id="{58E21AB0-9C02-6F83-7DB1-E21E08FC724B}"/>
               </a:ext>
             </a:extLst>
           </p:cNvPr>
@@ -18332,7 +18338,7 @@
           <p:cNvPr id="14" name="Hộp Văn bản 13">
             <a:extLst>
               <a:ext uri="{FF2B5EF4-FFF2-40B4-BE49-F238E27FC236}">
-                <a16:creationId xmlns:a16="http://schemas.microsoft.com/office/drawing/2014/main" id="{F72352EE-A760-61A0-1777-7E7E32874A95}"/>
+                <a16:creationId xmlns:a16="http://schemas.microsoft.com/office/drawing/2014/main" id="{43032CCE-592C-136D-E493-C9F2B2CB4D4C}"/>
               </a:ext>
             </a:extLst>
           </p:cNvPr>
@@ -18377,7 +18383,7 @@
           <p:cNvPr id="15" name="Hộp Văn bản 14">
             <a:extLst>
               <a:ext uri="{FF2B5EF4-FFF2-40B4-BE49-F238E27FC236}">
-                <a16:creationId xmlns:a16="http://schemas.microsoft.com/office/drawing/2014/main" id="{0D2505CA-2590-474B-36F5-41DEAA74ACE6}"/>
+                <a16:creationId xmlns:a16="http://schemas.microsoft.com/office/drawing/2014/main" id="{4C4530AA-EFD2-57C6-1C4D-0FCED727E757}"/>
               </a:ext>
             </a:extLst>
           </p:cNvPr>
@@ -18422,7 +18428,7 @@
           <p:cNvPr id="16" name="Hình chữ nhật: Góc Tròn 15">
             <a:extLst>
               <a:ext uri="{FF2B5EF4-FFF2-40B4-BE49-F238E27FC236}">
-                <a16:creationId xmlns:a16="http://schemas.microsoft.com/office/drawing/2014/main" id="{733D7440-F55E-6285-4627-9CA89F4FB2D6}"/>
+                <a16:creationId xmlns:a16="http://schemas.microsoft.com/office/drawing/2014/main" id="{7B39C9FB-2366-0D67-D535-0BDACD5858BC}"/>
               </a:ext>
             </a:extLst>
           </p:cNvPr>
@@ -18490,7 +18496,7 @@
           <p:cNvPr id="17" name="Hình chữ nhật 16">
             <a:extLst>
               <a:ext uri="{FF2B5EF4-FFF2-40B4-BE49-F238E27FC236}">
-                <a16:creationId xmlns:a16="http://schemas.microsoft.com/office/drawing/2014/main" id="{7A900ACB-E4CE-0418-1F7B-211DEE776633}"/>
+                <a16:creationId xmlns:a16="http://schemas.microsoft.com/office/drawing/2014/main" id="{DA609024-CA41-F164-95AB-34364564F645}"/>
               </a:ext>
             </a:extLst>
           </p:cNvPr>
@@ -18558,7 +18564,7 @@
           <p:cNvPr id="18" name="Hộp Văn bản 17">
             <a:extLst>
               <a:ext uri="{FF2B5EF4-FFF2-40B4-BE49-F238E27FC236}">
-                <a16:creationId xmlns:a16="http://schemas.microsoft.com/office/drawing/2014/main" id="{BF9558C5-2168-91F1-4C5E-4E381D6E548D}"/>
+                <a16:creationId xmlns:a16="http://schemas.microsoft.com/office/drawing/2014/main" id="{842B1EC0-3EAD-8CBC-4EBC-453B985286FA}"/>
               </a:ext>
             </a:extLst>
           </p:cNvPr>
@@ -18603,7 +18609,7 @@
           <p:cNvPr id="19" name="Hộp Văn bản 18">
             <a:extLst>
               <a:ext uri="{FF2B5EF4-FFF2-40B4-BE49-F238E27FC236}">
-                <a16:creationId xmlns:a16="http://schemas.microsoft.com/office/drawing/2014/main" id="{3F41AF81-F894-38A5-172C-D8CB5039A841}"/>
+                <a16:creationId xmlns:a16="http://schemas.microsoft.com/office/drawing/2014/main" id="{22107760-D0EE-AD7B-B0B2-D24DEC885903}"/>
               </a:ext>
             </a:extLst>
           </p:cNvPr>
@@ -18648,7 +18654,7 @@
           <p:cNvPr id="20" name="Hình chữ nhật: Góc Tròn 19">
             <a:extLst>
               <a:ext uri="{FF2B5EF4-FFF2-40B4-BE49-F238E27FC236}">
-                <a16:creationId xmlns:a16="http://schemas.microsoft.com/office/drawing/2014/main" id="{8E4B9BAE-D16A-8207-EF62-4EA0A5DBE7E5}"/>
+                <a16:creationId xmlns:a16="http://schemas.microsoft.com/office/drawing/2014/main" id="{6AEB1E31-DA96-8074-DDF0-A1F728200614}"/>
               </a:ext>
             </a:extLst>
           </p:cNvPr>
@@ -18716,7 +18722,7 @@
           <p:cNvPr id="21" name="Hình chữ nhật 20">
             <a:extLst>
               <a:ext uri="{FF2B5EF4-FFF2-40B4-BE49-F238E27FC236}">
-                <a16:creationId xmlns:a16="http://schemas.microsoft.com/office/drawing/2014/main" id="{6946E099-A9EA-6EDF-8C8E-A8BA21B8D0BB}"/>
+                <a16:creationId xmlns:a16="http://schemas.microsoft.com/office/drawing/2014/main" id="{968FBADE-2AA1-C52A-9C24-8280FC5631D7}"/>
               </a:ext>
             </a:extLst>
           </p:cNvPr>
@@ -18784,7 +18790,7 @@
           <p:cNvPr id="22" name="Hộp Văn bản 21">
             <a:extLst>
               <a:ext uri="{FF2B5EF4-FFF2-40B4-BE49-F238E27FC236}">
-                <a16:creationId xmlns:a16="http://schemas.microsoft.com/office/drawing/2014/main" id="{3DB009F6-550B-54D8-17E2-1621EEE318D2}"/>
+                <a16:creationId xmlns:a16="http://schemas.microsoft.com/office/drawing/2014/main" id="{40D42B57-70C0-1D26-A515-8444D6F3000E}"/>
               </a:ext>
             </a:extLst>
           </p:cNvPr>
@@ -18829,7 +18835,7 @@
           <p:cNvPr id="23" name="Hộp Văn bản 22">
             <a:extLst>
               <a:ext uri="{FF2B5EF4-FFF2-40B4-BE49-F238E27FC236}">
-                <a16:creationId xmlns:a16="http://schemas.microsoft.com/office/drawing/2014/main" id="{9BC63721-DFE5-6B70-36CA-23C1A3B20C7C}"/>
+                <a16:creationId xmlns:a16="http://schemas.microsoft.com/office/drawing/2014/main" id="{56CB24CB-BAB3-FC5E-0515-95F1EACF9BB3}"/>
               </a:ext>
             </a:extLst>
           </p:cNvPr>
@@ -18872,7 +18878,7 @@
     </p:spTree>
     <p:extLst>
       <p:ext uri="{BB962C8B-B14F-4D97-AF65-F5344CB8AC3E}">
-        <p14:creationId xmlns:p14="http://schemas.microsoft.com/office/powerpoint/2010/main" val="428520192"/>
+        <p14:creationId xmlns:p14="http://schemas.microsoft.com/office/powerpoint/2010/main" val="1533614823"/>
       </p:ext>
     </p:extLst>
   </p:cSld>
@@ -18904,7 +18910,7 @@
           <p:cNvPr id="2" name="Hộp Văn bản 1">
             <a:extLst>
               <a:ext uri="{FF2B5EF4-FFF2-40B4-BE49-F238E27FC236}">
-                <a16:creationId xmlns:a16="http://schemas.microsoft.com/office/drawing/2014/main" id="{E84A4EBF-B637-9D7A-E623-52BF43892BA5}"/>
+                <a16:creationId xmlns:a16="http://schemas.microsoft.com/office/drawing/2014/main" id="{C617FF31-040F-33FD-5BAB-F042542FFF9C}"/>
               </a:ext>
             </a:extLst>
           </p:cNvPr>
@@ -18949,7 +18955,7 @@
           <p:cNvPr id="3" name="Hộp Văn bản 2">
             <a:extLst>
               <a:ext uri="{FF2B5EF4-FFF2-40B4-BE49-F238E27FC236}">
-                <a16:creationId xmlns:a16="http://schemas.microsoft.com/office/drawing/2014/main" id="{ECDB070A-901D-B885-0007-176B41DE10A9}"/>
+                <a16:creationId xmlns:a16="http://schemas.microsoft.com/office/drawing/2014/main" id="{2BB02636-8CC6-E6CA-FCEA-02E53AA65B35}"/>
               </a:ext>
             </a:extLst>
           </p:cNvPr>
@@ -18994,7 +19000,7 @@
           <p:cNvPr id="4" name="Hộp Văn bản 3">
             <a:extLst>
               <a:ext uri="{FF2B5EF4-FFF2-40B4-BE49-F238E27FC236}">
-                <a16:creationId xmlns:a16="http://schemas.microsoft.com/office/drawing/2014/main" id="{6DF4695D-95C9-E1D6-DE46-B2FED282D7EA}"/>
+                <a16:creationId xmlns:a16="http://schemas.microsoft.com/office/drawing/2014/main" id="{CDEB1B97-B949-ADF2-0024-5AAEB1BE7562}"/>
               </a:ext>
             </a:extLst>
           </p:cNvPr>
@@ -19039,7 +19045,7 @@
           <p:cNvPr id="5" name="Hình chữ nhật 4">
             <a:extLst>
               <a:ext uri="{FF2B5EF4-FFF2-40B4-BE49-F238E27FC236}">
-                <a16:creationId xmlns:a16="http://schemas.microsoft.com/office/drawing/2014/main" id="{56FA4DF5-0304-7F74-0C86-24A53C1B5F60}"/>
+                <a16:creationId xmlns:a16="http://schemas.microsoft.com/office/drawing/2014/main" id="{B11405FA-3BF9-F431-85B2-AC55E3FF6230}"/>
               </a:ext>
             </a:extLst>
           </p:cNvPr>
@@ -19107,7 +19113,7 @@
           <p:cNvPr id="6" name="Hộp Văn bản 5">
             <a:extLst>
               <a:ext uri="{FF2B5EF4-FFF2-40B4-BE49-F238E27FC236}">
-                <a16:creationId xmlns:a16="http://schemas.microsoft.com/office/drawing/2014/main" id="{EF8A7F45-7A8F-A927-34BD-8568207E0B83}"/>
+                <a16:creationId xmlns:a16="http://schemas.microsoft.com/office/drawing/2014/main" id="{A258E1AB-EEE5-8437-C591-C63577451A0E}"/>
               </a:ext>
             </a:extLst>
           </p:cNvPr>
@@ -19152,7 +19158,7 @@
           <p:cNvPr id="7" name="Hộp Văn bản 6">
             <a:extLst>
               <a:ext uri="{FF2B5EF4-FFF2-40B4-BE49-F238E27FC236}">
-                <a16:creationId xmlns:a16="http://schemas.microsoft.com/office/drawing/2014/main" id="{CE306D04-709C-E0C9-8207-56C9375533A2}"/>
+                <a16:creationId xmlns:a16="http://schemas.microsoft.com/office/drawing/2014/main" id="{E2ADC6ED-C6A0-11AC-BBE0-3D2BE54D3658}"/>
               </a:ext>
             </a:extLst>
           </p:cNvPr>
@@ -19197,7 +19203,7 @@
           <p:cNvPr id="8" name="Hình chữ nhật: Góc Tròn 7">
             <a:extLst>
               <a:ext uri="{FF2B5EF4-FFF2-40B4-BE49-F238E27FC236}">
-                <a16:creationId xmlns:a16="http://schemas.microsoft.com/office/drawing/2014/main" id="{3CCEEB19-2FFB-6D4E-8991-AC8717F262B0}"/>
+                <a16:creationId xmlns:a16="http://schemas.microsoft.com/office/drawing/2014/main" id="{92B3D505-6640-5E61-966D-DCD846ACD219}"/>
               </a:ext>
             </a:extLst>
           </p:cNvPr>
@@ -19265,7 +19271,7 @@
           <p:cNvPr id="10" name="Hình ảnh 9">
             <a:extLst>
               <a:ext uri="{FF2B5EF4-FFF2-40B4-BE49-F238E27FC236}">
-                <a16:creationId xmlns:a16="http://schemas.microsoft.com/office/drawing/2014/main" id="{27E5F4AE-505F-18AA-692B-5565E35C885D}"/>
+                <a16:creationId xmlns:a16="http://schemas.microsoft.com/office/drawing/2014/main" id="{5CF27686-C095-59B4-CD1D-206D311C0C75}"/>
               </a:ext>
             </a:extLst>
           </p:cNvPr>
@@ -19301,7 +19307,7 @@
           <p:cNvPr id="11" name="Hộp Văn bản 10">
             <a:extLst>
               <a:ext uri="{FF2B5EF4-FFF2-40B4-BE49-F238E27FC236}">
-                <a16:creationId xmlns:a16="http://schemas.microsoft.com/office/drawing/2014/main" id="{071639B1-6A9F-C339-DEE8-186DAB4EA687}"/>
+                <a16:creationId xmlns:a16="http://schemas.microsoft.com/office/drawing/2014/main" id="{83E9CC5C-CEAD-E84B-E647-A4B4B25514FA}"/>
               </a:ext>
             </a:extLst>
           </p:cNvPr>
@@ -19346,7 +19352,7 @@
           <p:cNvPr id="12" name="Hình chữ nhật: Góc Tròn 11">
             <a:extLst>
               <a:ext uri="{FF2B5EF4-FFF2-40B4-BE49-F238E27FC236}">
-                <a16:creationId xmlns:a16="http://schemas.microsoft.com/office/drawing/2014/main" id="{2BF01F75-8228-BF8E-44AC-6CD143EE44EE}"/>
+                <a16:creationId xmlns:a16="http://schemas.microsoft.com/office/drawing/2014/main" id="{E00BAE3F-2849-5863-E983-BA537A84ED57}"/>
               </a:ext>
             </a:extLst>
           </p:cNvPr>
@@ -19414,7 +19420,7 @@
           <p:cNvPr id="13" name="Hình chữ nhật: Góc Tròn 12">
             <a:extLst>
               <a:ext uri="{FF2B5EF4-FFF2-40B4-BE49-F238E27FC236}">
-                <a16:creationId xmlns:a16="http://schemas.microsoft.com/office/drawing/2014/main" id="{3A589773-5D63-8C0F-9DDE-3713D67BEF2A}"/>
+                <a16:creationId xmlns:a16="http://schemas.microsoft.com/office/drawing/2014/main" id="{A74D608E-8C12-53A8-9585-D58AC0EAB404}"/>
               </a:ext>
             </a:extLst>
           </p:cNvPr>
@@ -19482,7 +19488,7 @@
           <p:cNvPr id="14" name="Hộp Văn bản 13">
             <a:extLst>
               <a:ext uri="{FF2B5EF4-FFF2-40B4-BE49-F238E27FC236}">
-                <a16:creationId xmlns:a16="http://schemas.microsoft.com/office/drawing/2014/main" id="{E1A14288-56F2-2897-39BC-CF8BA4F3960F}"/>
+                <a16:creationId xmlns:a16="http://schemas.microsoft.com/office/drawing/2014/main" id="{ABBB02AF-C8DC-71AB-DD12-C9C75AADEDB3}"/>
               </a:ext>
             </a:extLst>
           </p:cNvPr>
@@ -19527,7 +19533,7 @@
           <p:cNvPr id="15" name="Hộp Văn bản 14">
             <a:extLst>
               <a:ext uri="{FF2B5EF4-FFF2-40B4-BE49-F238E27FC236}">
-                <a16:creationId xmlns:a16="http://schemas.microsoft.com/office/drawing/2014/main" id="{F9FC9C40-CF96-4CE7-5006-EFE5D6D56EF6}"/>
+                <a16:creationId xmlns:a16="http://schemas.microsoft.com/office/drawing/2014/main" id="{0B7DFBC7-B8C1-BFA7-A4EB-3484A9D9F8E9}"/>
               </a:ext>
             </a:extLst>
           </p:cNvPr>
@@ -19679,7 +19685,7 @@
     </p:spTree>
     <p:extLst>
       <p:ext uri="{BB962C8B-B14F-4D97-AF65-F5344CB8AC3E}">
-        <p14:creationId xmlns:p14="http://schemas.microsoft.com/office/powerpoint/2010/main" val="1744631951"/>
+        <p14:creationId xmlns:p14="http://schemas.microsoft.com/office/powerpoint/2010/main" val="463461378"/>
       </p:ext>
     </p:extLst>
   </p:cSld>

</xml_diff>

<commit_message>
future: prepare demo script and synthetic data
Co-authored-by: Copilot <223556219+Copilot@users.noreply.github.com>
</commit_message>
<xml_diff>
--- a/docs/project-presentation.pptx
+++ b/docs/project-presentation.pptx
@@ -141,7 +141,7 @@
           <p:cNvPr id="2" name="Tiêu đề 1">
             <a:extLst>
               <a:ext uri="{FF2B5EF4-FFF2-40B4-BE49-F238E27FC236}">
-                <a16:creationId xmlns:a16="http://schemas.microsoft.com/office/drawing/2014/main" id="{047B60B9-1780-EFAD-CC0C-76B3EF1EEF16}"/>
+                <a16:creationId xmlns:a16="http://schemas.microsoft.com/office/drawing/2014/main" id="{1FA7C713-C1F2-ABB4-1F3E-83070A23580F}"/>
               </a:ext>
             </a:extLst>
           </p:cNvPr>
@@ -178,7 +178,7 @@
           <p:cNvPr id="3" name="Tiêu đề phụ 2">
             <a:extLst>
               <a:ext uri="{FF2B5EF4-FFF2-40B4-BE49-F238E27FC236}">
-                <a16:creationId xmlns:a16="http://schemas.microsoft.com/office/drawing/2014/main" id="{0B2840CE-26AA-289D-6E7A-BEDE590572AB}"/>
+                <a16:creationId xmlns:a16="http://schemas.microsoft.com/office/drawing/2014/main" id="{FCF5296D-6572-3AD0-D294-0519F829DA39}"/>
               </a:ext>
             </a:extLst>
           </p:cNvPr>
@@ -248,7 +248,7 @@
           <p:cNvPr id="4" name="Chỗ dành sẵn cho Ngày tháng 3">
             <a:extLst>
               <a:ext uri="{FF2B5EF4-FFF2-40B4-BE49-F238E27FC236}">
-                <a16:creationId xmlns:a16="http://schemas.microsoft.com/office/drawing/2014/main" id="{05C90F22-CF3D-9EF8-A64F-DE878F6CDCC3}"/>
+                <a16:creationId xmlns:a16="http://schemas.microsoft.com/office/drawing/2014/main" id="{50D61E88-0583-FD0E-826C-092CFA03D3A7}"/>
               </a:ext>
             </a:extLst>
           </p:cNvPr>
@@ -264,7 +264,7 @@
           <a:bodyPr/>
           <a:lstStyle/>
           <a:p>
-            <a:fld id="{88986470-4349-47FE-9583-3F8A6EA241D7}" type="datetimeFigureOut">
+            <a:fld id="{B7BA3C22-A09D-46D6-8583-2EECF8DDC3D3}" type="datetimeFigureOut">
               <a:rPr lang="vi-VN" smtClean="0"/>
               <a:t>18/10/2026</a:t>
             </a:fld>
@@ -277,7 +277,7 @@
           <p:cNvPr id="5" name="Chỗ dành sẵn cho Chân trang 4">
             <a:extLst>
               <a:ext uri="{FF2B5EF4-FFF2-40B4-BE49-F238E27FC236}">
-                <a16:creationId xmlns:a16="http://schemas.microsoft.com/office/drawing/2014/main" id="{69272B15-48A6-EE84-3493-4419C9687153}"/>
+                <a16:creationId xmlns:a16="http://schemas.microsoft.com/office/drawing/2014/main" id="{44BC5692-429E-CCDB-A8F5-3AC69953D9B2}"/>
               </a:ext>
             </a:extLst>
           </p:cNvPr>
@@ -302,7 +302,7 @@
           <p:cNvPr id="6" name="Chỗ dành sẵn cho Số hiệu Bản chiếu 5">
             <a:extLst>
               <a:ext uri="{FF2B5EF4-FFF2-40B4-BE49-F238E27FC236}">
-                <a16:creationId xmlns:a16="http://schemas.microsoft.com/office/drawing/2014/main" id="{C2D1BDA4-B6FE-1DE2-F99B-A438E6649533}"/>
+                <a16:creationId xmlns:a16="http://schemas.microsoft.com/office/drawing/2014/main" id="{AD60A1F5-EF19-E7A9-80C7-8F41EEB677F7}"/>
               </a:ext>
             </a:extLst>
           </p:cNvPr>
@@ -318,7 +318,7 @@
           <a:bodyPr/>
           <a:lstStyle/>
           <a:p>
-            <a:fld id="{01D1AEF7-2044-4839-8C56-918BADCD9CB9}" type="slidenum">
+            <a:fld id="{4A67C82E-B2F4-43B9-B7CF-06EA92A9BBC3}" type="slidenum">
               <a:rPr lang="vi-VN" smtClean="0"/>
               <a:t>‹#›</a:t>
             </a:fld>
@@ -329,7 +329,7 @@
     </p:spTree>
     <p:extLst>
       <p:ext uri="{BB962C8B-B14F-4D97-AF65-F5344CB8AC3E}">
-        <p14:creationId xmlns:p14="http://schemas.microsoft.com/office/powerpoint/2010/main" val="1056873217"/>
+        <p14:creationId xmlns:p14="http://schemas.microsoft.com/office/powerpoint/2010/main" val="140328842"/>
       </p:ext>
     </p:extLst>
   </p:cSld>
@@ -361,7 +361,7 @@
           <p:cNvPr id="2" name="Tiêu đề 1">
             <a:extLst>
               <a:ext uri="{FF2B5EF4-FFF2-40B4-BE49-F238E27FC236}">
-                <a16:creationId xmlns:a16="http://schemas.microsoft.com/office/drawing/2014/main" id="{ACE9BF3E-1005-CBA6-1F8B-25A6A8D1FE26}"/>
+                <a16:creationId xmlns:a16="http://schemas.microsoft.com/office/drawing/2014/main" id="{79D4FE63-427C-624F-AC07-832E9A20F97F}"/>
               </a:ext>
             </a:extLst>
           </p:cNvPr>
@@ -389,7 +389,7 @@
           <p:cNvPr id="3" name="Chỗ dành sẵn cho Văn bản Dọc 2">
             <a:extLst>
               <a:ext uri="{FF2B5EF4-FFF2-40B4-BE49-F238E27FC236}">
-                <a16:creationId xmlns:a16="http://schemas.microsoft.com/office/drawing/2014/main" id="{8246C1E6-A1B2-D655-84C2-615BD02BF374}"/>
+                <a16:creationId xmlns:a16="http://schemas.microsoft.com/office/drawing/2014/main" id="{9E23D139-9A93-5491-E401-8A06A48862FF}"/>
               </a:ext>
             </a:extLst>
           </p:cNvPr>
@@ -446,7 +446,7 @@
           <p:cNvPr id="4" name="Chỗ dành sẵn cho Ngày tháng 3">
             <a:extLst>
               <a:ext uri="{FF2B5EF4-FFF2-40B4-BE49-F238E27FC236}">
-                <a16:creationId xmlns:a16="http://schemas.microsoft.com/office/drawing/2014/main" id="{3D1C91B2-7FBD-C7F4-3A1A-E1B48B34CB51}"/>
+                <a16:creationId xmlns:a16="http://schemas.microsoft.com/office/drawing/2014/main" id="{8F0F2D4B-264B-762F-EEFF-46B6F22816B3}"/>
               </a:ext>
             </a:extLst>
           </p:cNvPr>
@@ -462,7 +462,7 @@
           <a:bodyPr/>
           <a:lstStyle/>
           <a:p>
-            <a:fld id="{88986470-4349-47FE-9583-3F8A6EA241D7}" type="datetimeFigureOut">
+            <a:fld id="{B7BA3C22-A09D-46D6-8583-2EECF8DDC3D3}" type="datetimeFigureOut">
               <a:rPr lang="vi-VN" smtClean="0"/>
               <a:t>18/10/2026</a:t>
             </a:fld>
@@ -475,7 +475,7 @@
           <p:cNvPr id="5" name="Chỗ dành sẵn cho Chân trang 4">
             <a:extLst>
               <a:ext uri="{FF2B5EF4-FFF2-40B4-BE49-F238E27FC236}">
-                <a16:creationId xmlns:a16="http://schemas.microsoft.com/office/drawing/2014/main" id="{A92368BA-CBC0-F6E9-9002-83D11859E4B1}"/>
+                <a16:creationId xmlns:a16="http://schemas.microsoft.com/office/drawing/2014/main" id="{9A3CDEFE-8E7F-2F4D-71EB-574112FC19CA}"/>
               </a:ext>
             </a:extLst>
           </p:cNvPr>
@@ -500,7 +500,7 @@
           <p:cNvPr id="6" name="Chỗ dành sẵn cho Số hiệu Bản chiếu 5">
             <a:extLst>
               <a:ext uri="{FF2B5EF4-FFF2-40B4-BE49-F238E27FC236}">
-                <a16:creationId xmlns:a16="http://schemas.microsoft.com/office/drawing/2014/main" id="{E006AF5B-DCFE-C57A-C810-4620AE60A349}"/>
+                <a16:creationId xmlns:a16="http://schemas.microsoft.com/office/drawing/2014/main" id="{AF6E6F90-1F3A-DA73-3E8D-2A7A9531BAB1}"/>
               </a:ext>
             </a:extLst>
           </p:cNvPr>
@@ -516,7 +516,7 @@
           <a:bodyPr/>
           <a:lstStyle/>
           <a:p>
-            <a:fld id="{01D1AEF7-2044-4839-8C56-918BADCD9CB9}" type="slidenum">
+            <a:fld id="{4A67C82E-B2F4-43B9-B7CF-06EA92A9BBC3}" type="slidenum">
               <a:rPr lang="vi-VN" smtClean="0"/>
               <a:t>‹#›</a:t>
             </a:fld>
@@ -527,7 +527,7 @@
     </p:spTree>
     <p:extLst>
       <p:ext uri="{BB962C8B-B14F-4D97-AF65-F5344CB8AC3E}">
-        <p14:creationId xmlns:p14="http://schemas.microsoft.com/office/powerpoint/2010/main" val="406333280"/>
+        <p14:creationId xmlns:p14="http://schemas.microsoft.com/office/powerpoint/2010/main" val="1603285130"/>
       </p:ext>
     </p:extLst>
   </p:cSld>
@@ -559,7 +559,7 @@
           <p:cNvPr id="2" name="Tiêu đề Dọc 1">
             <a:extLst>
               <a:ext uri="{FF2B5EF4-FFF2-40B4-BE49-F238E27FC236}">
-                <a16:creationId xmlns:a16="http://schemas.microsoft.com/office/drawing/2014/main" id="{14B92B92-A3D6-9694-49C7-3747E7CB4E3C}"/>
+                <a16:creationId xmlns:a16="http://schemas.microsoft.com/office/drawing/2014/main" id="{6F3133B9-2B5D-407D-4ABA-DBB2F628DFA4}"/>
               </a:ext>
             </a:extLst>
           </p:cNvPr>
@@ -592,7 +592,7 @@
           <p:cNvPr id="3" name="Chỗ dành sẵn cho Văn bản Dọc 2">
             <a:extLst>
               <a:ext uri="{FF2B5EF4-FFF2-40B4-BE49-F238E27FC236}">
-                <a16:creationId xmlns:a16="http://schemas.microsoft.com/office/drawing/2014/main" id="{F8E03225-D89F-41FD-78E7-F8617DB65DC8}"/>
+                <a16:creationId xmlns:a16="http://schemas.microsoft.com/office/drawing/2014/main" id="{BB2DAA2A-8791-9B47-99A6-5B40ECB2C205}"/>
               </a:ext>
             </a:extLst>
           </p:cNvPr>
@@ -654,7 +654,7 @@
           <p:cNvPr id="4" name="Chỗ dành sẵn cho Ngày tháng 3">
             <a:extLst>
               <a:ext uri="{FF2B5EF4-FFF2-40B4-BE49-F238E27FC236}">
-                <a16:creationId xmlns:a16="http://schemas.microsoft.com/office/drawing/2014/main" id="{2C961FC3-9C13-4146-4FC1-4E218EADEADB}"/>
+                <a16:creationId xmlns:a16="http://schemas.microsoft.com/office/drawing/2014/main" id="{EBCF1CE6-212E-9A30-6E04-B01819D1AED4}"/>
               </a:ext>
             </a:extLst>
           </p:cNvPr>
@@ -670,7 +670,7 @@
           <a:bodyPr/>
           <a:lstStyle/>
           <a:p>
-            <a:fld id="{88986470-4349-47FE-9583-3F8A6EA241D7}" type="datetimeFigureOut">
+            <a:fld id="{B7BA3C22-A09D-46D6-8583-2EECF8DDC3D3}" type="datetimeFigureOut">
               <a:rPr lang="vi-VN" smtClean="0"/>
               <a:t>18/10/2026</a:t>
             </a:fld>
@@ -683,7 +683,7 @@
           <p:cNvPr id="5" name="Chỗ dành sẵn cho Chân trang 4">
             <a:extLst>
               <a:ext uri="{FF2B5EF4-FFF2-40B4-BE49-F238E27FC236}">
-                <a16:creationId xmlns:a16="http://schemas.microsoft.com/office/drawing/2014/main" id="{1CDA6838-6544-C5DC-B6B3-FDACDD63E1E9}"/>
+                <a16:creationId xmlns:a16="http://schemas.microsoft.com/office/drawing/2014/main" id="{A3903377-7B91-7DAC-C40F-B78EF818CDBC}"/>
               </a:ext>
             </a:extLst>
           </p:cNvPr>
@@ -708,7 +708,7 @@
           <p:cNvPr id="6" name="Chỗ dành sẵn cho Số hiệu Bản chiếu 5">
             <a:extLst>
               <a:ext uri="{FF2B5EF4-FFF2-40B4-BE49-F238E27FC236}">
-                <a16:creationId xmlns:a16="http://schemas.microsoft.com/office/drawing/2014/main" id="{47E35A9C-713A-F6D1-23E2-D401293FDCF7}"/>
+                <a16:creationId xmlns:a16="http://schemas.microsoft.com/office/drawing/2014/main" id="{6E09A3E1-9A61-D47E-7D37-43C6226F7050}"/>
               </a:ext>
             </a:extLst>
           </p:cNvPr>
@@ -724,7 +724,7 @@
           <a:bodyPr/>
           <a:lstStyle/>
           <a:p>
-            <a:fld id="{01D1AEF7-2044-4839-8C56-918BADCD9CB9}" type="slidenum">
+            <a:fld id="{4A67C82E-B2F4-43B9-B7CF-06EA92A9BBC3}" type="slidenum">
               <a:rPr lang="vi-VN" smtClean="0"/>
               <a:t>‹#›</a:t>
             </a:fld>
@@ -735,7 +735,7 @@
     </p:spTree>
     <p:extLst>
       <p:ext uri="{BB962C8B-B14F-4D97-AF65-F5344CB8AC3E}">
-        <p14:creationId xmlns:p14="http://schemas.microsoft.com/office/powerpoint/2010/main" val="1160184589"/>
+        <p14:creationId xmlns:p14="http://schemas.microsoft.com/office/powerpoint/2010/main" val="87578526"/>
       </p:ext>
     </p:extLst>
   </p:cSld>
@@ -767,7 +767,7 @@
           <p:cNvPr id="2" name="Tiêu đề 1">
             <a:extLst>
               <a:ext uri="{FF2B5EF4-FFF2-40B4-BE49-F238E27FC236}">
-                <a16:creationId xmlns:a16="http://schemas.microsoft.com/office/drawing/2014/main" id="{325C4ACD-20D9-F63A-C501-D1DFABB8CAF4}"/>
+                <a16:creationId xmlns:a16="http://schemas.microsoft.com/office/drawing/2014/main" id="{721210BC-7160-73E9-3881-82D99F8032FF}"/>
               </a:ext>
             </a:extLst>
           </p:cNvPr>
@@ -795,7 +795,7 @@
           <p:cNvPr id="3" name="Chỗ dành sẵn cho Nội dung 2">
             <a:extLst>
               <a:ext uri="{FF2B5EF4-FFF2-40B4-BE49-F238E27FC236}">
-                <a16:creationId xmlns:a16="http://schemas.microsoft.com/office/drawing/2014/main" id="{9B36183D-FB56-99AB-F3A9-32B11293A963}"/>
+                <a16:creationId xmlns:a16="http://schemas.microsoft.com/office/drawing/2014/main" id="{7F9BC7CF-F4AE-29F7-3534-38C491F2723C}"/>
               </a:ext>
             </a:extLst>
           </p:cNvPr>
@@ -852,7 +852,7 @@
           <p:cNvPr id="4" name="Chỗ dành sẵn cho Ngày tháng 3">
             <a:extLst>
               <a:ext uri="{FF2B5EF4-FFF2-40B4-BE49-F238E27FC236}">
-                <a16:creationId xmlns:a16="http://schemas.microsoft.com/office/drawing/2014/main" id="{1CE1EBF3-D0E3-0584-F8B2-38BDA5E3353F}"/>
+                <a16:creationId xmlns:a16="http://schemas.microsoft.com/office/drawing/2014/main" id="{F5645FE2-6A85-4BC0-A715-04E40740DBEF}"/>
               </a:ext>
             </a:extLst>
           </p:cNvPr>
@@ -868,7 +868,7 @@
           <a:bodyPr/>
           <a:lstStyle/>
           <a:p>
-            <a:fld id="{88986470-4349-47FE-9583-3F8A6EA241D7}" type="datetimeFigureOut">
+            <a:fld id="{B7BA3C22-A09D-46D6-8583-2EECF8DDC3D3}" type="datetimeFigureOut">
               <a:rPr lang="vi-VN" smtClean="0"/>
               <a:t>18/10/2026</a:t>
             </a:fld>
@@ -881,7 +881,7 @@
           <p:cNvPr id="5" name="Chỗ dành sẵn cho Chân trang 4">
             <a:extLst>
               <a:ext uri="{FF2B5EF4-FFF2-40B4-BE49-F238E27FC236}">
-                <a16:creationId xmlns:a16="http://schemas.microsoft.com/office/drawing/2014/main" id="{9AF76373-ECEB-6529-AF7A-A6ADF8212162}"/>
+                <a16:creationId xmlns:a16="http://schemas.microsoft.com/office/drawing/2014/main" id="{57471A71-B296-80AB-F29B-3D6BAD4F6D86}"/>
               </a:ext>
             </a:extLst>
           </p:cNvPr>
@@ -906,7 +906,7 @@
           <p:cNvPr id="6" name="Chỗ dành sẵn cho Số hiệu Bản chiếu 5">
             <a:extLst>
               <a:ext uri="{FF2B5EF4-FFF2-40B4-BE49-F238E27FC236}">
-                <a16:creationId xmlns:a16="http://schemas.microsoft.com/office/drawing/2014/main" id="{933DB131-04BD-2B62-38F5-35F6BD385C9E}"/>
+                <a16:creationId xmlns:a16="http://schemas.microsoft.com/office/drawing/2014/main" id="{722872DD-D104-B2E3-9C17-041394A8F8AE}"/>
               </a:ext>
             </a:extLst>
           </p:cNvPr>
@@ -922,7 +922,7 @@
           <a:bodyPr/>
           <a:lstStyle/>
           <a:p>
-            <a:fld id="{01D1AEF7-2044-4839-8C56-918BADCD9CB9}" type="slidenum">
+            <a:fld id="{4A67C82E-B2F4-43B9-B7CF-06EA92A9BBC3}" type="slidenum">
               <a:rPr lang="vi-VN" smtClean="0"/>
               <a:t>‹#›</a:t>
             </a:fld>
@@ -933,7 +933,7 @@
     </p:spTree>
     <p:extLst>
       <p:ext uri="{BB962C8B-B14F-4D97-AF65-F5344CB8AC3E}">
-        <p14:creationId xmlns:p14="http://schemas.microsoft.com/office/powerpoint/2010/main" val="3619412692"/>
+        <p14:creationId xmlns:p14="http://schemas.microsoft.com/office/powerpoint/2010/main" val="1137760202"/>
       </p:ext>
     </p:extLst>
   </p:cSld>
@@ -965,7 +965,7 @@
           <p:cNvPr id="2" name="Tiêu đề 1">
             <a:extLst>
               <a:ext uri="{FF2B5EF4-FFF2-40B4-BE49-F238E27FC236}">
-                <a16:creationId xmlns:a16="http://schemas.microsoft.com/office/drawing/2014/main" id="{AF002784-8C25-FE3F-BA40-2A5705758374}"/>
+                <a16:creationId xmlns:a16="http://schemas.microsoft.com/office/drawing/2014/main" id="{BA7DA5CD-0030-C7AD-42E6-4EE76CD56041}"/>
               </a:ext>
             </a:extLst>
           </p:cNvPr>
@@ -1002,7 +1002,7 @@
           <p:cNvPr id="3" name="Chỗ dành sẵn cho Văn bản 2">
             <a:extLst>
               <a:ext uri="{FF2B5EF4-FFF2-40B4-BE49-F238E27FC236}">
-                <a16:creationId xmlns:a16="http://schemas.microsoft.com/office/drawing/2014/main" id="{AEB6BF32-26D1-BD27-12E4-4D14A3547F1F}"/>
+                <a16:creationId xmlns:a16="http://schemas.microsoft.com/office/drawing/2014/main" id="{409B0800-2FCC-9954-4FC8-DBA00FEF4C85}"/>
               </a:ext>
             </a:extLst>
           </p:cNvPr>
@@ -1127,7 +1127,7 @@
           <p:cNvPr id="4" name="Chỗ dành sẵn cho Ngày tháng 3">
             <a:extLst>
               <a:ext uri="{FF2B5EF4-FFF2-40B4-BE49-F238E27FC236}">
-                <a16:creationId xmlns:a16="http://schemas.microsoft.com/office/drawing/2014/main" id="{90C06895-752E-FD72-44B1-795B3326A6FB}"/>
+                <a16:creationId xmlns:a16="http://schemas.microsoft.com/office/drawing/2014/main" id="{F8446FA2-DFE1-E407-66AC-CB829A46D208}"/>
               </a:ext>
             </a:extLst>
           </p:cNvPr>
@@ -1143,7 +1143,7 @@
           <a:bodyPr/>
           <a:lstStyle/>
           <a:p>
-            <a:fld id="{88986470-4349-47FE-9583-3F8A6EA241D7}" type="datetimeFigureOut">
+            <a:fld id="{B7BA3C22-A09D-46D6-8583-2EECF8DDC3D3}" type="datetimeFigureOut">
               <a:rPr lang="vi-VN" smtClean="0"/>
               <a:t>18/10/2026</a:t>
             </a:fld>
@@ -1156,7 +1156,7 @@
           <p:cNvPr id="5" name="Chỗ dành sẵn cho Chân trang 4">
             <a:extLst>
               <a:ext uri="{FF2B5EF4-FFF2-40B4-BE49-F238E27FC236}">
-                <a16:creationId xmlns:a16="http://schemas.microsoft.com/office/drawing/2014/main" id="{6CE77149-5284-A5E4-79A1-288246AE54EF}"/>
+                <a16:creationId xmlns:a16="http://schemas.microsoft.com/office/drawing/2014/main" id="{3A73D923-61E9-4A0C-7BBA-A056437CA635}"/>
               </a:ext>
             </a:extLst>
           </p:cNvPr>
@@ -1181,7 +1181,7 @@
           <p:cNvPr id="6" name="Chỗ dành sẵn cho Số hiệu Bản chiếu 5">
             <a:extLst>
               <a:ext uri="{FF2B5EF4-FFF2-40B4-BE49-F238E27FC236}">
-                <a16:creationId xmlns:a16="http://schemas.microsoft.com/office/drawing/2014/main" id="{8972522D-F68B-6526-3C0D-4FC04009DEA1}"/>
+                <a16:creationId xmlns:a16="http://schemas.microsoft.com/office/drawing/2014/main" id="{F712EB3D-2C8D-DB0B-117C-A9B10BA76767}"/>
               </a:ext>
             </a:extLst>
           </p:cNvPr>
@@ -1197,7 +1197,7 @@
           <a:bodyPr/>
           <a:lstStyle/>
           <a:p>
-            <a:fld id="{01D1AEF7-2044-4839-8C56-918BADCD9CB9}" type="slidenum">
+            <a:fld id="{4A67C82E-B2F4-43B9-B7CF-06EA92A9BBC3}" type="slidenum">
               <a:rPr lang="vi-VN" smtClean="0"/>
               <a:t>‹#›</a:t>
             </a:fld>
@@ -1208,7 +1208,7 @@
     </p:spTree>
     <p:extLst>
       <p:ext uri="{BB962C8B-B14F-4D97-AF65-F5344CB8AC3E}">
-        <p14:creationId xmlns:p14="http://schemas.microsoft.com/office/powerpoint/2010/main" val="1671780771"/>
+        <p14:creationId xmlns:p14="http://schemas.microsoft.com/office/powerpoint/2010/main" val="37054475"/>
       </p:ext>
     </p:extLst>
   </p:cSld>
@@ -1240,7 +1240,7 @@
           <p:cNvPr id="2" name="Tiêu đề 1">
             <a:extLst>
               <a:ext uri="{FF2B5EF4-FFF2-40B4-BE49-F238E27FC236}">
-                <a16:creationId xmlns:a16="http://schemas.microsoft.com/office/drawing/2014/main" id="{7E02C192-6E14-CEC4-4E3B-E7328908A4B6}"/>
+                <a16:creationId xmlns:a16="http://schemas.microsoft.com/office/drawing/2014/main" id="{260213E3-1BA8-9709-1EDF-2B0422587972}"/>
               </a:ext>
             </a:extLst>
           </p:cNvPr>
@@ -1268,7 +1268,7 @@
           <p:cNvPr id="3" name="Chỗ dành sẵn cho Nội dung 2">
             <a:extLst>
               <a:ext uri="{FF2B5EF4-FFF2-40B4-BE49-F238E27FC236}">
-                <a16:creationId xmlns:a16="http://schemas.microsoft.com/office/drawing/2014/main" id="{E2729160-1C22-4A03-3A4B-0F253A8B972A}"/>
+                <a16:creationId xmlns:a16="http://schemas.microsoft.com/office/drawing/2014/main" id="{8863D497-85F6-FFF5-EFF7-3D57302D1A22}"/>
               </a:ext>
             </a:extLst>
           </p:cNvPr>
@@ -1330,7 +1330,7 @@
           <p:cNvPr id="4" name="Chỗ dành sẵn cho Nội dung 3">
             <a:extLst>
               <a:ext uri="{FF2B5EF4-FFF2-40B4-BE49-F238E27FC236}">
-                <a16:creationId xmlns:a16="http://schemas.microsoft.com/office/drawing/2014/main" id="{6A12CCBA-B2D9-0F51-B98D-B186F4656DB8}"/>
+                <a16:creationId xmlns:a16="http://schemas.microsoft.com/office/drawing/2014/main" id="{AFDED034-474B-345D-F274-A9751C5A0484}"/>
               </a:ext>
             </a:extLst>
           </p:cNvPr>
@@ -1392,7 +1392,7 @@
           <p:cNvPr id="5" name="Chỗ dành sẵn cho Ngày tháng 4">
             <a:extLst>
               <a:ext uri="{FF2B5EF4-FFF2-40B4-BE49-F238E27FC236}">
-                <a16:creationId xmlns:a16="http://schemas.microsoft.com/office/drawing/2014/main" id="{273CA9D0-622C-057C-AE88-960728A33F0D}"/>
+                <a16:creationId xmlns:a16="http://schemas.microsoft.com/office/drawing/2014/main" id="{CEB530FE-C3E7-3495-07EF-0A35E69AFC0A}"/>
               </a:ext>
             </a:extLst>
           </p:cNvPr>
@@ -1408,7 +1408,7 @@
           <a:bodyPr/>
           <a:lstStyle/>
           <a:p>
-            <a:fld id="{88986470-4349-47FE-9583-3F8A6EA241D7}" type="datetimeFigureOut">
+            <a:fld id="{B7BA3C22-A09D-46D6-8583-2EECF8DDC3D3}" type="datetimeFigureOut">
               <a:rPr lang="vi-VN" smtClean="0"/>
               <a:t>18/10/2026</a:t>
             </a:fld>
@@ -1421,7 +1421,7 @@
           <p:cNvPr id="6" name="Chỗ dành sẵn cho Chân trang 5">
             <a:extLst>
               <a:ext uri="{FF2B5EF4-FFF2-40B4-BE49-F238E27FC236}">
-                <a16:creationId xmlns:a16="http://schemas.microsoft.com/office/drawing/2014/main" id="{A571B3F3-31ED-51D8-85FE-689383DB5A83}"/>
+                <a16:creationId xmlns:a16="http://schemas.microsoft.com/office/drawing/2014/main" id="{C5BDBFFA-90D9-63FB-4521-4BCEC68B69E3}"/>
               </a:ext>
             </a:extLst>
           </p:cNvPr>
@@ -1446,7 +1446,7 @@
           <p:cNvPr id="7" name="Chỗ dành sẵn cho Số hiệu Bản chiếu 6">
             <a:extLst>
               <a:ext uri="{FF2B5EF4-FFF2-40B4-BE49-F238E27FC236}">
-                <a16:creationId xmlns:a16="http://schemas.microsoft.com/office/drawing/2014/main" id="{4F17399C-1FAD-41E3-898A-DD4E756C8666}"/>
+                <a16:creationId xmlns:a16="http://schemas.microsoft.com/office/drawing/2014/main" id="{49096DBC-BDD8-44ED-18CC-57DD72D8D5D3}"/>
               </a:ext>
             </a:extLst>
           </p:cNvPr>
@@ -1462,7 +1462,7 @@
           <a:bodyPr/>
           <a:lstStyle/>
           <a:p>
-            <a:fld id="{01D1AEF7-2044-4839-8C56-918BADCD9CB9}" type="slidenum">
+            <a:fld id="{4A67C82E-B2F4-43B9-B7CF-06EA92A9BBC3}" type="slidenum">
               <a:rPr lang="vi-VN" smtClean="0"/>
               <a:t>‹#›</a:t>
             </a:fld>
@@ -1473,7 +1473,7 @@
     </p:spTree>
     <p:extLst>
       <p:ext uri="{BB962C8B-B14F-4D97-AF65-F5344CB8AC3E}">
-        <p14:creationId xmlns:p14="http://schemas.microsoft.com/office/powerpoint/2010/main" val="576490803"/>
+        <p14:creationId xmlns:p14="http://schemas.microsoft.com/office/powerpoint/2010/main" val="737891725"/>
       </p:ext>
     </p:extLst>
   </p:cSld>
@@ -1505,7 +1505,7 @@
           <p:cNvPr id="2" name="Tiêu đề 1">
             <a:extLst>
               <a:ext uri="{FF2B5EF4-FFF2-40B4-BE49-F238E27FC236}">
-                <a16:creationId xmlns:a16="http://schemas.microsoft.com/office/drawing/2014/main" id="{43D59D18-8ADE-0565-33F0-3520958226BA}"/>
+                <a16:creationId xmlns:a16="http://schemas.microsoft.com/office/drawing/2014/main" id="{4E2A85A4-C0D1-1B2A-0B60-C049E504A288}"/>
               </a:ext>
             </a:extLst>
           </p:cNvPr>
@@ -1538,7 +1538,7 @@
           <p:cNvPr id="3" name="Chỗ dành sẵn cho Văn bản 2">
             <a:extLst>
               <a:ext uri="{FF2B5EF4-FFF2-40B4-BE49-F238E27FC236}">
-                <a16:creationId xmlns:a16="http://schemas.microsoft.com/office/drawing/2014/main" id="{C93B0984-F3DE-4481-FDCF-BCDC2F88D53C}"/>
+                <a16:creationId xmlns:a16="http://schemas.microsoft.com/office/drawing/2014/main" id="{0CD9EA2C-C24C-3112-6C06-45F3346F8369}"/>
               </a:ext>
             </a:extLst>
           </p:cNvPr>
@@ -1609,7 +1609,7 @@
           <p:cNvPr id="4" name="Chỗ dành sẵn cho Nội dung 3">
             <a:extLst>
               <a:ext uri="{FF2B5EF4-FFF2-40B4-BE49-F238E27FC236}">
-                <a16:creationId xmlns:a16="http://schemas.microsoft.com/office/drawing/2014/main" id="{73D867AE-9BF9-6CC2-07B7-E4238671585A}"/>
+                <a16:creationId xmlns:a16="http://schemas.microsoft.com/office/drawing/2014/main" id="{9786022A-CF97-07AB-A145-C55F1B5A2CF1}"/>
               </a:ext>
             </a:extLst>
           </p:cNvPr>
@@ -1671,7 +1671,7 @@
           <p:cNvPr id="5" name="Chỗ dành sẵn cho Văn bản 4">
             <a:extLst>
               <a:ext uri="{FF2B5EF4-FFF2-40B4-BE49-F238E27FC236}">
-                <a16:creationId xmlns:a16="http://schemas.microsoft.com/office/drawing/2014/main" id="{EF75A8A5-BD24-A88F-7663-A3002785FCA5}"/>
+                <a16:creationId xmlns:a16="http://schemas.microsoft.com/office/drawing/2014/main" id="{EB58E978-C46E-7F80-975A-F1B7FFCC9935}"/>
               </a:ext>
             </a:extLst>
           </p:cNvPr>
@@ -1742,7 +1742,7 @@
           <p:cNvPr id="6" name="Chỗ dành sẵn cho Nội dung 5">
             <a:extLst>
               <a:ext uri="{FF2B5EF4-FFF2-40B4-BE49-F238E27FC236}">
-                <a16:creationId xmlns:a16="http://schemas.microsoft.com/office/drawing/2014/main" id="{5E64F6E4-01E5-2499-CE65-87C1C3016868}"/>
+                <a16:creationId xmlns:a16="http://schemas.microsoft.com/office/drawing/2014/main" id="{EF4AC524-7458-2221-A709-4A3B25D52732}"/>
               </a:ext>
             </a:extLst>
           </p:cNvPr>
@@ -1804,7 +1804,7 @@
           <p:cNvPr id="7" name="Chỗ dành sẵn cho Ngày tháng 6">
             <a:extLst>
               <a:ext uri="{FF2B5EF4-FFF2-40B4-BE49-F238E27FC236}">
-                <a16:creationId xmlns:a16="http://schemas.microsoft.com/office/drawing/2014/main" id="{F85BFA5A-A9A3-3F26-DCDD-FC8096C7149C}"/>
+                <a16:creationId xmlns:a16="http://schemas.microsoft.com/office/drawing/2014/main" id="{85ADDC31-D475-0B5B-D266-5515D411F549}"/>
               </a:ext>
             </a:extLst>
           </p:cNvPr>
@@ -1820,7 +1820,7 @@
           <a:bodyPr/>
           <a:lstStyle/>
           <a:p>
-            <a:fld id="{88986470-4349-47FE-9583-3F8A6EA241D7}" type="datetimeFigureOut">
+            <a:fld id="{B7BA3C22-A09D-46D6-8583-2EECF8DDC3D3}" type="datetimeFigureOut">
               <a:rPr lang="vi-VN" smtClean="0"/>
               <a:t>18/10/2026</a:t>
             </a:fld>
@@ -1833,7 +1833,7 @@
           <p:cNvPr id="8" name="Chỗ dành sẵn cho Chân trang 7">
             <a:extLst>
               <a:ext uri="{FF2B5EF4-FFF2-40B4-BE49-F238E27FC236}">
-                <a16:creationId xmlns:a16="http://schemas.microsoft.com/office/drawing/2014/main" id="{79B7E381-DEF3-D5A2-1B8A-4198A49AD3BC}"/>
+                <a16:creationId xmlns:a16="http://schemas.microsoft.com/office/drawing/2014/main" id="{6907D94D-0A58-B7AE-1FA9-281FA23B77BC}"/>
               </a:ext>
             </a:extLst>
           </p:cNvPr>
@@ -1858,7 +1858,7 @@
           <p:cNvPr id="9" name="Chỗ dành sẵn cho Số hiệu Bản chiếu 8">
             <a:extLst>
               <a:ext uri="{FF2B5EF4-FFF2-40B4-BE49-F238E27FC236}">
-                <a16:creationId xmlns:a16="http://schemas.microsoft.com/office/drawing/2014/main" id="{FD84674E-EDAF-AAE9-562C-4C8A7274C8B5}"/>
+                <a16:creationId xmlns:a16="http://schemas.microsoft.com/office/drawing/2014/main" id="{983577D2-921B-CACC-9C46-2589150BDFB4}"/>
               </a:ext>
             </a:extLst>
           </p:cNvPr>
@@ -1874,7 +1874,7 @@
           <a:bodyPr/>
           <a:lstStyle/>
           <a:p>
-            <a:fld id="{01D1AEF7-2044-4839-8C56-918BADCD9CB9}" type="slidenum">
+            <a:fld id="{4A67C82E-B2F4-43B9-B7CF-06EA92A9BBC3}" type="slidenum">
               <a:rPr lang="vi-VN" smtClean="0"/>
               <a:t>‹#›</a:t>
             </a:fld>
@@ -1885,7 +1885,7 @@
     </p:spTree>
     <p:extLst>
       <p:ext uri="{BB962C8B-B14F-4D97-AF65-F5344CB8AC3E}">
-        <p14:creationId xmlns:p14="http://schemas.microsoft.com/office/powerpoint/2010/main" val="3964253664"/>
+        <p14:creationId xmlns:p14="http://schemas.microsoft.com/office/powerpoint/2010/main" val="1187474253"/>
       </p:ext>
     </p:extLst>
   </p:cSld>
@@ -1917,7 +1917,7 @@
           <p:cNvPr id="2" name="Tiêu đề 1">
             <a:extLst>
               <a:ext uri="{FF2B5EF4-FFF2-40B4-BE49-F238E27FC236}">
-                <a16:creationId xmlns:a16="http://schemas.microsoft.com/office/drawing/2014/main" id="{E9D4150D-CB0E-3AE1-3AF4-E314B8F34AD4}"/>
+                <a16:creationId xmlns:a16="http://schemas.microsoft.com/office/drawing/2014/main" id="{F49868E8-5CC4-A26C-3000-68425317919B}"/>
               </a:ext>
             </a:extLst>
           </p:cNvPr>
@@ -1945,7 +1945,7 @@
           <p:cNvPr id="3" name="Chỗ dành sẵn cho Ngày tháng 2">
             <a:extLst>
               <a:ext uri="{FF2B5EF4-FFF2-40B4-BE49-F238E27FC236}">
-                <a16:creationId xmlns:a16="http://schemas.microsoft.com/office/drawing/2014/main" id="{685D4C9E-DE78-27CF-5561-657DA0142DD8}"/>
+                <a16:creationId xmlns:a16="http://schemas.microsoft.com/office/drawing/2014/main" id="{3D07AFBF-82EC-91DB-2ECD-69C123D148A5}"/>
               </a:ext>
             </a:extLst>
           </p:cNvPr>
@@ -1961,7 +1961,7 @@
           <a:bodyPr/>
           <a:lstStyle/>
           <a:p>
-            <a:fld id="{88986470-4349-47FE-9583-3F8A6EA241D7}" type="datetimeFigureOut">
+            <a:fld id="{B7BA3C22-A09D-46D6-8583-2EECF8DDC3D3}" type="datetimeFigureOut">
               <a:rPr lang="vi-VN" smtClean="0"/>
               <a:t>18/10/2026</a:t>
             </a:fld>
@@ -1974,7 +1974,7 @@
           <p:cNvPr id="4" name="Chỗ dành sẵn cho Chân trang 3">
             <a:extLst>
               <a:ext uri="{FF2B5EF4-FFF2-40B4-BE49-F238E27FC236}">
-                <a16:creationId xmlns:a16="http://schemas.microsoft.com/office/drawing/2014/main" id="{09C58AC0-F038-9373-82E3-938FD721A706}"/>
+                <a16:creationId xmlns:a16="http://schemas.microsoft.com/office/drawing/2014/main" id="{3F633F15-2F42-9AD7-E9C4-88ACC48DEB55}"/>
               </a:ext>
             </a:extLst>
           </p:cNvPr>
@@ -1999,7 +1999,7 @@
           <p:cNvPr id="5" name="Chỗ dành sẵn cho Số hiệu Bản chiếu 4">
             <a:extLst>
               <a:ext uri="{FF2B5EF4-FFF2-40B4-BE49-F238E27FC236}">
-                <a16:creationId xmlns:a16="http://schemas.microsoft.com/office/drawing/2014/main" id="{BB61D831-E51F-2764-1F3A-7C27E71F69D4}"/>
+                <a16:creationId xmlns:a16="http://schemas.microsoft.com/office/drawing/2014/main" id="{E52811B0-1BE8-A27C-1EE2-AD5623002BBB}"/>
               </a:ext>
             </a:extLst>
           </p:cNvPr>
@@ -2015,7 +2015,7 @@
           <a:bodyPr/>
           <a:lstStyle/>
           <a:p>
-            <a:fld id="{01D1AEF7-2044-4839-8C56-918BADCD9CB9}" type="slidenum">
+            <a:fld id="{4A67C82E-B2F4-43B9-B7CF-06EA92A9BBC3}" type="slidenum">
               <a:rPr lang="vi-VN" smtClean="0"/>
               <a:t>‹#›</a:t>
             </a:fld>
@@ -2026,7 +2026,7 @@
     </p:spTree>
     <p:extLst>
       <p:ext uri="{BB962C8B-B14F-4D97-AF65-F5344CB8AC3E}">
-        <p14:creationId xmlns:p14="http://schemas.microsoft.com/office/powerpoint/2010/main" val="923588217"/>
+        <p14:creationId xmlns:p14="http://schemas.microsoft.com/office/powerpoint/2010/main" val="3624340549"/>
       </p:ext>
     </p:extLst>
   </p:cSld>
@@ -2058,7 +2058,7 @@
           <p:cNvPr id="2" name="Chỗ dành sẵn cho Ngày tháng 1">
             <a:extLst>
               <a:ext uri="{FF2B5EF4-FFF2-40B4-BE49-F238E27FC236}">
-                <a16:creationId xmlns:a16="http://schemas.microsoft.com/office/drawing/2014/main" id="{CF988EB6-F185-421B-F2EA-F795B570103C}"/>
+                <a16:creationId xmlns:a16="http://schemas.microsoft.com/office/drawing/2014/main" id="{D8238681-AAB6-6BE9-7F89-242090C351E3}"/>
               </a:ext>
             </a:extLst>
           </p:cNvPr>
@@ -2074,7 +2074,7 @@
           <a:bodyPr/>
           <a:lstStyle/>
           <a:p>
-            <a:fld id="{88986470-4349-47FE-9583-3F8A6EA241D7}" type="datetimeFigureOut">
+            <a:fld id="{B7BA3C22-A09D-46D6-8583-2EECF8DDC3D3}" type="datetimeFigureOut">
               <a:rPr lang="vi-VN" smtClean="0"/>
               <a:t>18/10/2026</a:t>
             </a:fld>
@@ -2087,7 +2087,7 @@
           <p:cNvPr id="3" name="Chỗ dành sẵn cho Chân trang 2">
             <a:extLst>
               <a:ext uri="{FF2B5EF4-FFF2-40B4-BE49-F238E27FC236}">
-                <a16:creationId xmlns:a16="http://schemas.microsoft.com/office/drawing/2014/main" id="{E1AF201E-E6AF-87B0-E4B4-523381386E2F}"/>
+                <a16:creationId xmlns:a16="http://schemas.microsoft.com/office/drawing/2014/main" id="{9E1D3D22-A6E6-D35B-ED9F-902E3F098C76}"/>
               </a:ext>
             </a:extLst>
           </p:cNvPr>
@@ -2112,7 +2112,7 @@
           <p:cNvPr id="4" name="Chỗ dành sẵn cho Số hiệu Bản chiếu 3">
             <a:extLst>
               <a:ext uri="{FF2B5EF4-FFF2-40B4-BE49-F238E27FC236}">
-                <a16:creationId xmlns:a16="http://schemas.microsoft.com/office/drawing/2014/main" id="{3F38D755-1DCC-1373-F7C0-22BD5F93B049}"/>
+                <a16:creationId xmlns:a16="http://schemas.microsoft.com/office/drawing/2014/main" id="{174BD4F6-DEFA-F615-3C71-7B6143C8CB3A}"/>
               </a:ext>
             </a:extLst>
           </p:cNvPr>
@@ -2128,7 +2128,7 @@
           <a:bodyPr/>
           <a:lstStyle/>
           <a:p>
-            <a:fld id="{01D1AEF7-2044-4839-8C56-918BADCD9CB9}" type="slidenum">
+            <a:fld id="{4A67C82E-B2F4-43B9-B7CF-06EA92A9BBC3}" type="slidenum">
               <a:rPr lang="vi-VN" smtClean="0"/>
               <a:t>‹#›</a:t>
             </a:fld>
@@ -2139,7 +2139,7 @@
     </p:spTree>
     <p:extLst>
       <p:ext uri="{BB962C8B-B14F-4D97-AF65-F5344CB8AC3E}">
-        <p14:creationId xmlns:p14="http://schemas.microsoft.com/office/powerpoint/2010/main" val="1813543002"/>
+        <p14:creationId xmlns:p14="http://schemas.microsoft.com/office/powerpoint/2010/main" val="2684384088"/>
       </p:ext>
     </p:extLst>
   </p:cSld>
@@ -2171,7 +2171,7 @@
           <p:cNvPr id="2" name="Tiêu đề 1">
             <a:extLst>
               <a:ext uri="{FF2B5EF4-FFF2-40B4-BE49-F238E27FC236}">
-                <a16:creationId xmlns:a16="http://schemas.microsoft.com/office/drawing/2014/main" id="{F961A397-83C0-33A0-3A2A-91B6523CDEB9}"/>
+                <a16:creationId xmlns:a16="http://schemas.microsoft.com/office/drawing/2014/main" id="{677664BC-A52A-6F26-E075-EA8024FEA5D0}"/>
               </a:ext>
             </a:extLst>
           </p:cNvPr>
@@ -2208,7 +2208,7 @@
           <p:cNvPr id="3" name="Chỗ dành sẵn cho Nội dung 2">
             <a:extLst>
               <a:ext uri="{FF2B5EF4-FFF2-40B4-BE49-F238E27FC236}">
-                <a16:creationId xmlns:a16="http://schemas.microsoft.com/office/drawing/2014/main" id="{36487D19-3AE0-AC54-6BEA-E56CE4088061}"/>
+                <a16:creationId xmlns:a16="http://schemas.microsoft.com/office/drawing/2014/main" id="{4ED7930F-CB58-32D3-48AE-5EF4AD9C55B9}"/>
               </a:ext>
             </a:extLst>
           </p:cNvPr>
@@ -2298,7 +2298,7 @@
           <p:cNvPr id="4" name="Chỗ dành sẵn cho Văn bản 3">
             <a:extLst>
               <a:ext uri="{FF2B5EF4-FFF2-40B4-BE49-F238E27FC236}">
-                <a16:creationId xmlns:a16="http://schemas.microsoft.com/office/drawing/2014/main" id="{738345E5-1939-CC40-456B-9CAB9FEBEDF0}"/>
+                <a16:creationId xmlns:a16="http://schemas.microsoft.com/office/drawing/2014/main" id="{C6F118A8-C985-622B-0287-8D1CFD7B5A69}"/>
               </a:ext>
             </a:extLst>
           </p:cNvPr>
@@ -2369,7 +2369,7 @@
           <p:cNvPr id="5" name="Chỗ dành sẵn cho Ngày tháng 4">
             <a:extLst>
               <a:ext uri="{FF2B5EF4-FFF2-40B4-BE49-F238E27FC236}">
-                <a16:creationId xmlns:a16="http://schemas.microsoft.com/office/drawing/2014/main" id="{C34CA9A1-0E0A-8D4E-06CB-BA66461C75AB}"/>
+                <a16:creationId xmlns:a16="http://schemas.microsoft.com/office/drawing/2014/main" id="{0A28CC18-D747-5639-01DE-9E1CB057B368}"/>
               </a:ext>
             </a:extLst>
           </p:cNvPr>
@@ -2385,7 +2385,7 @@
           <a:bodyPr/>
           <a:lstStyle/>
           <a:p>
-            <a:fld id="{88986470-4349-47FE-9583-3F8A6EA241D7}" type="datetimeFigureOut">
+            <a:fld id="{B7BA3C22-A09D-46D6-8583-2EECF8DDC3D3}" type="datetimeFigureOut">
               <a:rPr lang="vi-VN" smtClean="0"/>
               <a:t>18/10/2026</a:t>
             </a:fld>
@@ -2398,7 +2398,7 @@
           <p:cNvPr id="6" name="Chỗ dành sẵn cho Chân trang 5">
             <a:extLst>
               <a:ext uri="{FF2B5EF4-FFF2-40B4-BE49-F238E27FC236}">
-                <a16:creationId xmlns:a16="http://schemas.microsoft.com/office/drawing/2014/main" id="{75B98C8C-E64F-16D7-8D14-B81CE7DE6A86}"/>
+                <a16:creationId xmlns:a16="http://schemas.microsoft.com/office/drawing/2014/main" id="{F8EF0766-65F8-47D6-0537-A60F69C60A27}"/>
               </a:ext>
             </a:extLst>
           </p:cNvPr>
@@ -2423,7 +2423,7 @@
           <p:cNvPr id="7" name="Chỗ dành sẵn cho Số hiệu Bản chiếu 6">
             <a:extLst>
               <a:ext uri="{FF2B5EF4-FFF2-40B4-BE49-F238E27FC236}">
-                <a16:creationId xmlns:a16="http://schemas.microsoft.com/office/drawing/2014/main" id="{E6FEFDC4-2FE7-010D-D409-ED226D1B6F80}"/>
+                <a16:creationId xmlns:a16="http://schemas.microsoft.com/office/drawing/2014/main" id="{7AC5FC1A-946E-86E9-4E10-5B724BE1EEFC}"/>
               </a:ext>
             </a:extLst>
           </p:cNvPr>
@@ -2439,7 +2439,7 @@
           <a:bodyPr/>
           <a:lstStyle/>
           <a:p>
-            <a:fld id="{01D1AEF7-2044-4839-8C56-918BADCD9CB9}" type="slidenum">
+            <a:fld id="{4A67C82E-B2F4-43B9-B7CF-06EA92A9BBC3}" type="slidenum">
               <a:rPr lang="vi-VN" smtClean="0"/>
               <a:t>‹#›</a:t>
             </a:fld>
@@ -2450,7 +2450,7 @@
     </p:spTree>
     <p:extLst>
       <p:ext uri="{BB962C8B-B14F-4D97-AF65-F5344CB8AC3E}">
-        <p14:creationId xmlns:p14="http://schemas.microsoft.com/office/powerpoint/2010/main" val="1741840010"/>
+        <p14:creationId xmlns:p14="http://schemas.microsoft.com/office/powerpoint/2010/main" val="4115734761"/>
       </p:ext>
     </p:extLst>
   </p:cSld>
@@ -2482,7 +2482,7 @@
           <p:cNvPr id="2" name="Tiêu đề 1">
             <a:extLst>
               <a:ext uri="{FF2B5EF4-FFF2-40B4-BE49-F238E27FC236}">
-                <a16:creationId xmlns:a16="http://schemas.microsoft.com/office/drawing/2014/main" id="{C4E27209-009B-4A77-F5E8-5A59FF164533}"/>
+                <a16:creationId xmlns:a16="http://schemas.microsoft.com/office/drawing/2014/main" id="{50EDB953-83F0-7F4B-FE38-83BB0952079B}"/>
               </a:ext>
             </a:extLst>
           </p:cNvPr>
@@ -2519,7 +2519,7 @@
           <p:cNvPr id="3" name="Chỗ dành sẵn cho Hình ảnh 2">
             <a:extLst>
               <a:ext uri="{FF2B5EF4-FFF2-40B4-BE49-F238E27FC236}">
-                <a16:creationId xmlns:a16="http://schemas.microsoft.com/office/drawing/2014/main" id="{5349951D-3C33-A8F5-1DA4-F97D30BF4C72}"/>
+                <a16:creationId xmlns:a16="http://schemas.microsoft.com/office/drawing/2014/main" id="{EEEB799C-3FC1-90FA-E62D-77E548A14C9C}"/>
               </a:ext>
             </a:extLst>
           </p:cNvPr>
@@ -2586,7 +2586,7 @@
           <p:cNvPr id="4" name="Chỗ dành sẵn cho Văn bản 3">
             <a:extLst>
               <a:ext uri="{FF2B5EF4-FFF2-40B4-BE49-F238E27FC236}">
-                <a16:creationId xmlns:a16="http://schemas.microsoft.com/office/drawing/2014/main" id="{E2401BA7-5B99-9C36-4A7D-8B0898D6074A}"/>
+                <a16:creationId xmlns:a16="http://schemas.microsoft.com/office/drawing/2014/main" id="{7FC690B3-FCEE-313C-D6DB-597AC05A2FAD}"/>
               </a:ext>
             </a:extLst>
           </p:cNvPr>
@@ -2657,7 +2657,7 @@
           <p:cNvPr id="5" name="Chỗ dành sẵn cho Ngày tháng 4">
             <a:extLst>
               <a:ext uri="{FF2B5EF4-FFF2-40B4-BE49-F238E27FC236}">
-                <a16:creationId xmlns:a16="http://schemas.microsoft.com/office/drawing/2014/main" id="{6F4E8CB3-806D-E4B3-D19E-36119C17F62B}"/>
+                <a16:creationId xmlns:a16="http://schemas.microsoft.com/office/drawing/2014/main" id="{EFD354C2-847A-3FFB-DEF9-E1E6349612E4}"/>
               </a:ext>
             </a:extLst>
           </p:cNvPr>
@@ -2673,7 +2673,7 @@
           <a:bodyPr/>
           <a:lstStyle/>
           <a:p>
-            <a:fld id="{88986470-4349-47FE-9583-3F8A6EA241D7}" type="datetimeFigureOut">
+            <a:fld id="{B7BA3C22-A09D-46D6-8583-2EECF8DDC3D3}" type="datetimeFigureOut">
               <a:rPr lang="vi-VN" smtClean="0"/>
               <a:t>18/10/2026</a:t>
             </a:fld>
@@ -2686,7 +2686,7 @@
           <p:cNvPr id="6" name="Chỗ dành sẵn cho Chân trang 5">
             <a:extLst>
               <a:ext uri="{FF2B5EF4-FFF2-40B4-BE49-F238E27FC236}">
-                <a16:creationId xmlns:a16="http://schemas.microsoft.com/office/drawing/2014/main" id="{1FD99099-37C0-F920-AE59-A5F05D7445EB}"/>
+                <a16:creationId xmlns:a16="http://schemas.microsoft.com/office/drawing/2014/main" id="{94CB9219-F528-A19C-57E9-5A653D39ADE2}"/>
               </a:ext>
             </a:extLst>
           </p:cNvPr>
@@ -2711,7 +2711,7 @@
           <p:cNvPr id="7" name="Chỗ dành sẵn cho Số hiệu Bản chiếu 6">
             <a:extLst>
               <a:ext uri="{FF2B5EF4-FFF2-40B4-BE49-F238E27FC236}">
-                <a16:creationId xmlns:a16="http://schemas.microsoft.com/office/drawing/2014/main" id="{F099ABA9-7E6F-48AF-C486-04D280858546}"/>
+                <a16:creationId xmlns:a16="http://schemas.microsoft.com/office/drawing/2014/main" id="{1F3D6BCA-8E8F-7F28-0206-BC049A2C50C7}"/>
               </a:ext>
             </a:extLst>
           </p:cNvPr>
@@ -2727,7 +2727,7 @@
           <a:bodyPr/>
           <a:lstStyle/>
           <a:p>
-            <a:fld id="{01D1AEF7-2044-4839-8C56-918BADCD9CB9}" type="slidenum">
+            <a:fld id="{4A67C82E-B2F4-43B9-B7CF-06EA92A9BBC3}" type="slidenum">
               <a:rPr lang="vi-VN" smtClean="0"/>
               <a:t>‹#›</a:t>
             </a:fld>
@@ -2738,7 +2738,7 @@
     </p:spTree>
     <p:extLst>
       <p:ext uri="{BB962C8B-B14F-4D97-AF65-F5344CB8AC3E}">
-        <p14:creationId xmlns:p14="http://schemas.microsoft.com/office/powerpoint/2010/main" val="1014553500"/>
+        <p14:creationId xmlns:p14="http://schemas.microsoft.com/office/powerpoint/2010/main" val="185636304"/>
       </p:ext>
     </p:extLst>
   </p:cSld>
@@ -2775,7 +2775,7 @@
           <p:cNvPr id="2" name="Chỗ dành sẵn cho Tiêu đề 1">
             <a:extLst>
               <a:ext uri="{FF2B5EF4-FFF2-40B4-BE49-F238E27FC236}">
-                <a16:creationId xmlns:a16="http://schemas.microsoft.com/office/drawing/2014/main" id="{7946D0F9-8BB9-724B-4CD7-4609F54D5D33}"/>
+                <a16:creationId xmlns:a16="http://schemas.microsoft.com/office/drawing/2014/main" id="{76AB787A-31D3-C71E-81F3-5B49F6BD90B6}"/>
               </a:ext>
             </a:extLst>
           </p:cNvPr>
@@ -2813,7 +2813,7 @@
           <p:cNvPr id="3" name="Chỗ dành sẵn cho Văn bản 2">
             <a:extLst>
               <a:ext uri="{FF2B5EF4-FFF2-40B4-BE49-F238E27FC236}">
-                <a16:creationId xmlns:a16="http://schemas.microsoft.com/office/drawing/2014/main" id="{BBF22DDF-FABF-84F4-DC70-7042F552C876}"/>
+                <a16:creationId xmlns:a16="http://schemas.microsoft.com/office/drawing/2014/main" id="{D9B221F5-F42E-D638-FAA5-C76D93FC2CFC}"/>
               </a:ext>
             </a:extLst>
           </p:cNvPr>
@@ -2880,7 +2880,7 @@
           <p:cNvPr id="4" name="Chỗ dành sẵn cho Ngày tháng 3">
             <a:extLst>
               <a:ext uri="{FF2B5EF4-FFF2-40B4-BE49-F238E27FC236}">
-                <a16:creationId xmlns:a16="http://schemas.microsoft.com/office/drawing/2014/main" id="{01E2253B-92D2-555C-DCD7-4F27B210D6CA}"/>
+                <a16:creationId xmlns:a16="http://schemas.microsoft.com/office/drawing/2014/main" id="{9718E4DE-C5CB-1600-DE55-1C7FE5138614}"/>
               </a:ext>
             </a:extLst>
           </p:cNvPr>
@@ -2914,7 +2914,7 @@
             </a:lvl1pPr>
           </a:lstStyle>
           <a:p>
-            <a:fld id="{88986470-4349-47FE-9583-3F8A6EA241D7}" type="datetimeFigureOut">
+            <a:fld id="{B7BA3C22-A09D-46D6-8583-2EECF8DDC3D3}" type="datetimeFigureOut">
               <a:rPr lang="vi-VN" smtClean="0"/>
               <a:t>18/10/2026</a:t>
             </a:fld>
@@ -2927,7 +2927,7 @@
           <p:cNvPr id="5" name="Chỗ dành sẵn cho Chân trang 4">
             <a:extLst>
               <a:ext uri="{FF2B5EF4-FFF2-40B4-BE49-F238E27FC236}">
-                <a16:creationId xmlns:a16="http://schemas.microsoft.com/office/drawing/2014/main" id="{CB05AE87-C5C1-6B75-F212-2C78F5919FB3}"/>
+                <a16:creationId xmlns:a16="http://schemas.microsoft.com/office/drawing/2014/main" id="{F44C33CE-E94D-4BD5-0D7B-4EF1E257E195}"/>
               </a:ext>
             </a:extLst>
           </p:cNvPr>
@@ -2970,7 +2970,7 @@
           <p:cNvPr id="6" name="Chỗ dành sẵn cho Số hiệu Bản chiếu 5">
             <a:extLst>
               <a:ext uri="{FF2B5EF4-FFF2-40B4-BE49-F238E27FC236}">
-                <a16:creationId xmlns:a16="http://schemas.microsoft.com/office/drawing/2014/main" id="{5DA9DDCB-8937-4564-2B39-8EEA6285CD5A}"/>
+                <a16:creationId xmlns:a16="http://schemas.microsoft.com/office/drawing/2014/main" id="{4159DEA6-2CBA-9399-B2D3-432995D3FB6D}"/>
               </a:ext>
             </a:extLst>
           </p:cNvPr>
@@ -3004,7 +3004,7 @@
             </a:lvl1pPr>
           </a:lstStyle>
           <a:p>
-            <a:fld id="{01D1AEF7-2044-4839-8C56-918BADCD9CB9}" type="slidenum">
+            <a:fld id="{4A67C82E-B2F4-43B9-B7CF-06EA92A9BBC3}" type="slidenum">
               <a:rPr lang="vi-VN" smtClean="0"/>
               <a:t>‹#›</a:t>
             </a:fld>
@@ -3015,7 +3015,7 @@
     </p:spTree>
     <p:extLst>
       <p:ext uri="{BB962C8B-B14F-4D97-AF65-F5344CB8AC3E}">
-        <p14:creationId xmlns:p14="http://schemas.microsoft.com/office/powerpoint/2010/main" val="4059987004"/>
+        <p14:creationId xmlns:p14="http://schemas.microsoft.com/office/powerpoint/2010/main" val="2021721786"/>
       </p:ext>
     </p:extLst>
   </p:cSld>
@@ -3338,7 +3338,7 @@
           <p:cNvPr id="2" name="Hình chữ nhật 1">
             <a:extLst>
               <a:ext uri="{FF2B5EF4-FFF2-40B4-BE49-F238E27FC236}">
-                <a16:creationId xmlns:a16="http://schemas.microsoft.com/office/drawing/2014/main" id="{2683630D-F01A-BFE2-5A89-0D254335E0BC}"/>
+                <a16:creationId xmlns:a16="http://schemas.microsoft.com/office/drawing/2014/main" id="{7A7E9BDC-7D17-6938-5B08-4F5FBBB0C6D3}"/>
               </a:ext>
             </a:extLst>
           </p:cNvPr>
@@ -3406,7 +3406,7 @@
           <p:cNvPr id="3" name="Hình chữ nhật: Góc Tròn 2">
             <a:extLst>
               <a:ext uri="{FF2B5EF4-FFF2-40B4-BE49-F238E27FC236}">
-                <a16:creationId xmlns:a16="http://schemas.microsoft.com/office/drawing/2014/main" id="{400C46C1-164E-E8E4-33C9-E62C94D8AF2A}"/>
+                <a16:creationId xmlns:a16="http://schemas.microsoft.com/office/drawing/2014/main" id="{ED3F428B-76CB-6416-91A7-3806C4594BAE}"/>
               </a:ext>
             </a:extLst>
           </p:cNvPr>
@@ -3474,7 +3474,7 @@
           <p:cNvPr id="4" name="Hộp Văn bản 3">
             <a:extLst>
               <a:ext uri="{FF2B5EF4-FFF2-40B4-BE49-F238E27FC236}">
-                <a16:creationId xmlns:a16="http://schemas.microsoft.com/office/drawing/2014/main" id="{5777D749-FB92-B3BF-DFFB-85522E614460}"/>
+                <a16:creationId xmlns:a16="http://schemas.microsoft.com/office/drawing/2014/main" id="{8CF2202D-C635-76F7-4775-3ECE28089425}"/>
               </a:ext>
             </a:extLst>
           </p:cNvPr>
@@ -3519,7 +3519,7 @@
           <p:cNvPr id="5" name="Hộp Văn bản 4">
             <a:extLst>
               <a:ext uri="{FF2B5EF4-FFF2-40B4-BE49-F238E27FC236}">
-                <a16:creationId xmlns:a16="http://schemas.microsoft.com/office/drawing/2014/main" id="{750B6C1F-1724-F390-81F4-2EDAABB4CCC3}"/>
+                <a16:creationId xmlns:a16="http://schemas.microsoft.com/office/drawing/2014/main" id="{A688F41A-58CE-B07B-790C-6620181FFD30}"/>
               </a:ext>
             </a:extLst>
           </p:cNvPr>
@@ -3580,7 +3580,7 @@
           <p:cNvPr id="6" name="Hộp Văn bản 5">
             <a:extLst>
               <a:ext uri="{FF2B5EF4-FFF2-40B4-BE49-F238E27FC236}">
-                <a16:creationId xmlns:a16="http://schemas.microsoft.com/office/drawing/2014/main" id="{AC76B986-2162-9299-2E9E-6D1D114C6EFE}"/>
+                <a16:creationId xmlns:a16="http://schemas.microsoft.com/office/drawing/2014/main" id="{627B0155-3DC4-D687-A0AD-CE4CA9F4E1E5}"/>
               </a:ext>
             </a:extLst>
           </p:cNvPr>
@@ -3625,7 +3625,7 @@
           <p:cNvPr id="7" name="Hộp Văn bản 6">
             <a:extLst>
               <a:ext uri="{FF2B5EF4-FFF2-40B4-BE49-F238E27FC236}">
-                <a16:creationId xmlns:a16="http://schemas.microsoft.com/office/drawing/2014/main" id="{E9ACC1FE-EE1B-32C2-F1D5-0D970CC4B327}"/>
+                <a16:creationId xmlns:a16="http://schemas.microsoft.com/office/drawing/2014/main" id="{76E76D7F-1794-50D3-F603-9758DEE6069D}"/>
               </a:ext>
             </a:extLst>
           </p:cNvPr>
@@ -3670,7 +3670,7 @@
           <p:cNvPr id="8" name="Hình chữ nhật: Góc Tròn 7">
             <a:extLst>
               <a:ext uri="{FF2B5EF4-FFF2-40B4-BE49-F238E27FC236}">
-                <a16:creationId xmlns:a16="http://schemas.microsoft.com/office/drawing/2014/main" id="{1A4E9048-6C04-C0A5-E371-A8FAE9C69272}"/>
+                <a16:creationId xmlns:a16="http://schemas.microsoft.com/office/drawing/2014/main" id="{F81FED54-B4A9-A766-45D0-EE7608AAD4F6}"/>
               </a:ext>
             </a:extLst>
           </p:cNvPr>
@@ -3738,7 +3738,7 @@
           <p:cNvPr id="9" name="Hộp Văn bản 8">
             <a:extLst>
               <a:ext uri="{FF2B5EF4-FFF2-40B4-BE49-F238E27FC236}">
-                <a16:creationId xmlns:a16="http://schemas.microsoft.com/office/drawing/2014/main" id="{0E6B2657-86EF-6DEE-EDE3-B3ECF80CD8A9}"/>
+                <a16:creationId xmlns:a16="http://schemas.microsoft.com/office/drawing/2014/main" id="{9A4EEEB6-6B10-A502-C88D-A415C814C3F9}"/>
               </a:ext>
             </a:extLst>
           </p:cNvPr>
@@ -3783,7 +3783,7 @@
           <p:cNvPr id="10" name="Hình chữ nhật: Góc Tròn 9">
             <a:extLst>
               <a:ext uri="{FF2B5EF4-FFF2-40B4-BE49-F238E27FC236}">
-                <a16:creationId xmlns:a16="http://schemas.microsoft.com/office/drawing/2014/main" id="{164C50CC-C142-9421-6B6D-DA65AC6CB208}"/>
+                <a16:creationId xmlns:a16="http://schemas.microsoft.com/office/drawing/2014/main" id="{9AA9DD76-09E5-B7C0-D56E-EC4154A88C7A}"/>
               </a:ext>
             </a:extLst>
           </p:cNvPr>
@@ -3851,7 +3851,7 @@
           <p:cNvPr id="12" name="Hình ảnh 11">
             <a:extLst>
               <a:ext uri="{FF2B5EF4-FFF2-40B4-BE49-F238E27FC236}">
-                <a16:creationId xmlns:a16="http://schemas.microsoft.com/office/drawing/2014/main" id="{C4C34D72-961F-00EC-7A5F-11B7A8C1960C}"/>
+                <a16:creationId xmlns:a16="http://schemas.microsoft.com/office/drawing/2014/main" id="{5A819AD8-DD15-722F-BD24-4DCD5F3835A6}"/>
               </a:ext>
             </a:extLst>
           </p:cNvPr>
@@ -3887,7 +3887,7 @@
           <p:cNvPr id="13" name="Hộp Văn bản 12">
             <a:extLst>
               <a:ext uri="{FF2B5EF4-FFF2-40B4-BE49-F238E27FC236}">
-                <a16:creationId xmlns:a16="http://schemas.microsoft.com/office/drawing/2014/main" id="{26281422-5484-47CC-2952-41D630AC1CA3}"/>
+                <a16:creationId xmlns:a16="http://schemas.microsoft.com/office/drawing/2014/main" id="{E1B17751-38F4-82C5-DE89-484AF5172FBB}"/>
               </a:ext>
             </a:extLst>
           </p:cNvPr>
@@ -3932,7 +3932,7 @@
           <p:cNvPr id="14" name="Hình chữ nhật 13">
             <a:extLst>
               <a:ext uri="{FF2B5EF4-FFF2-40B4-BE49-F238E27FC236}">
-                <a16:creationId xmlns:a16="http://schemas.microsoft.com/office/drawing/2014/main" id="{CEB7F7CB-E482-8304-3EFA-492904AB82C2}"/>
+                <a16:creationId xmlns:a16="http://schemas.microsoft.com/office/drawing/2014/main" id="{A150AB7A-D27A-608D-AA75-6215242B5C4B}"/>
               </a:ext>
             </a:extLst>
           </p:cNvPr>
@@ -4000,7 +4000,7 @@
           <p:cNvPr id="15" name="Hộp Văn bản 14">
             <a:extLst>
               <a:ext uri="{FF2B5EF4-FFF2-40B4-BE49-F238E27FC236}">
-                <a16:creationId xmlns:a16="http://schemas.microsoft.com/office/drawing/2014/main" id="{023077F4-210B-5A4A-5461-23E1022E4B32}"/>
+                <a16:creationId xmlns:a16="http://schemas.microsoft.com/office/drawing/2014/main" id="{5DEAD169-D06F-66B6-9A7C-3F573C7A90C4}"/>
               </a:ext>
             </a:extLst>
           </p:cNvPr>
@@ -4045,7 +4045,7 @@
           <p:cNvPr id="16" name="Hộp Văn bản 15">
             <a:extLst>
               <a:ext uri="{FF2B5EF4-FFF2-40B4-BE49-F238E27FC236}">
-                <a16:creationId xmlns:a16="http://schemas.microsoft.com/office/drawing/2014/main" id="{CE23F9D3-0A12-F03D-59FE-46DC185CCC17}"/>
+                <a16:creationId xmlns:a16="http://schemas.microsoft.com/office/drawing/2014/main" id="{5251C473-EF2F-64A1-C1AC-7C4097DB71A4}"/>
               </a:ext>
             </a:extLst>
           </p:cNvPr>
@@ -4088,7 +4088,7 @@
     </p:spTree>
     <p:extLst>
       <p:ext uri="{BB962C8B-B14F-4D97-AF65-F5344CB8AC3E}">
-        <p14:creationId xmlns:p14="http://schemas.microsoft.com/office/powerpoint/2010/main" val="2466369297"/>
+        <p14:creationId xmlns:p14="http://schemas.microsoft.com/office/powerpoint/2010/main" val="2963858678"/>
       </p:ext>
     </p:extLst>
   </p:cSld>
@@ -4120,7 +4120,7 @@
           <p:cNvPr id="2" name="Hộp Văn bản 1">
             <a:extLst>
               <a:ext uri="{FF2B5EF4-FFF2-40B4-BE49-F238E27FC236}">
-                <a16:creationId xmlns:a16="http://schemas.microsoft.com/office/drawing/2014/main" id="{E99C391E-96A1-60BD-47E9-D8FE16B9497A}"/>
+                <a16:creationId xmlns:a16="http://schemas.microsoft.com/office/drawing/2014/main" id="{0C425909-B05B-9988-FDBC-E304DA1C0471}"/>
               </a:ext>
             </a:extLst>
           </p:cNvPr>
@@ -4165,7 +4165,7 @@
           <p:cNvPr id="3" name="Hộp Văn bản 2">
             <a:extLst>
               <a:ext uri="{FF2B5EF4-FFF2-40B4-BE49-F238E27FC236}">
-                <a16:creationId xmlns:a16="http://schemas.microsoft.com/office/drawing/2014/main" id="{0C3F82A2-AC11-2FBE-B7BD-33653E686DB4}"/>
+                <a16:creationId xmlns:a16="http://schemas.microsoft.com/office/drawing/2014/main" id="{4E143326-DFDE-FE0B-23A5-E49F8B5EBC44}"/>
               </a:ext>
             </a:extLst>
           </p:cNvPr>
@@ -4210,7 +4210,7 @@
           <p:cNvPr id="4" name="Hộp Văn bản 3">
             <a:extLst>
               <a:ext uri="{FF2B5EF4-FFF2-40B4-BE49-F238E27FC236}">
-                <a16:creationId xmlns:a16="http://schemas.microsoft.com/office/drawing/2014/main" id="{CE734F9C-FA6F-E89B-7AC8-BB2E82C64D14}"/>
+                <a16:creationId xmlns:a16="http://schemas.microsoft.com/office/drawing/2014/main" id="{61C2FF05-7CA8-120E-FFF0-7EB4A39391C4}"/>
               </a:ext>
             </a:extLst>
           </p:cNvPr>
@@ -4255,7 +4255,7 @@
           <p:cNvPr id="5" name="Hình chữ nhật 4">
             <a:extLst>
               <a:ext uri="{FF2B5EF4-FFF2-40B4-BE49-F238E27FC236}">
-                <a16:creationId xmlns:a16="http://schemas.microsoft.com/office/drawing/2014/main" id="{36058E55-79A8-E025-DCD9-5B0B253F47F7}"/>
+                <a16:creationId xmlns:a16="http://schemas.microsoft.com/office/drawing/2014/main" id="{D66734EF-1B19-8B70-6377-2001150A0DF6}"/>
               </a:ext>
             </a:extLst>
           </p:cNvPr>
@@ -4323,7 +4323,7 @@
           <p:cNvPr id="6" name="Hộp Văn bản 5">
             <a:extLst>
               <a:ext uri="{FF2B5EF4-FFF2-40B4-BE49-F238E27FC236}">
-                <a16:creationId xmlns:a16="http://schemas.microsoft.com/office/drawing/2014/main" id="{772E06FE-3501-EC14-D205-DE47AA496794}"/>
+                <a16:creationId xmlns:a16="http://schemas.microsoft.com/office/drawing/2014/main" id="{EEB0DFA6-D5C6-457A-70B9-3DA1627ABD1A}"/>
               </a:ext>
             </a:extLst>
           </p:cNvPr>
@@ -4368,7 +4368,7 @@
           <p:cNvPr id="7" name="Hộp Văn bản 6">
             <a:extLst>
               <a:ext uri="{FF2B5EF4-FFF2-40B4-BE49-F238E27FC236}">
-                <a16:creationId xmlns:a16="http://schemas.microsoft.com/office/drawing/2014/main" id="{DE5AF7A4-6DAE-30B8-2BC7-216E3FB89C2F}"/>
+                <a16:creationId xmlns:a16="http://schemas.microsoft.com/office/drawing/2014/main" id="{8A1899BD-7517-6FC2-F166-22AA057D51E4}"/>
               </a:ext>
             </a:extLst>
           </p:cNvPr>
@@ -4413,7 +4413,7 @@
           <p:cNvPr id="8" name="Hình chữ nhật: Góc Tròn 7">
             <a:extLst>
               <a:ext uri="{FF2B5EF4-FFF2-40B4-BE49-F238E27FC236}">
-                <a16:creationId xmlns:a16="http://schemas.microsoft.com/office/drawing/2014/main" id="{9A16AD5D-AE90-4B2A-FD2F-7FABC217D289}"/>
+                <a16:creationId xmlns:a16="http://schemas.microsoft.com/office/drawing/2014/main" id="{EEC38C16-4FBB-4598-14C8-C6DED21ACEBE}"/>
               </a:ext>
             </a:extLst>
           </p:cNvPr>
@@ -4481,7 +4481,7 @@
           <p:cNvPr id="9" name="Hình chữ nhật: Góc Tròn 8">
             <a:extLst>
               <a:ext uri="{FF2B5EF4-FFF2-40B4-BE49-F238E27FC236}">
-                <a16:creationId xmlns:a16="http://schemas.microsoft.com/office/drawing/2014/main" id="{F1E574E0-9E44-6398-3D14-9084A53C592B}"/>
+                <a16:creationId xmlns:a16="http://schemas.microsoft.com/office/drawing/2014/main" id="{B06ECCD7-BBBE-8E3E-9AD8-2159AE7DC860}"/>
               </a:ext>
             </a:extLst>
           </p:cNvPr>
@@ -4549,7 +4549,7 @@
           <p:cNvPr id="10" name="Hộp Văn bản 9">
             <a:extLst>
               <a:ext uri="{FF2B5EF4-FFF2-40B4-BE49-F238E27FC236}">
-                <a16:creationId xmlns:a16="http://schemas.microsoft.com/office/drawing/2014/main" id="{D745B973-347B-76B5-9412-4BE5966BB624}"/>
+                <a16:creationId xmlns:a16="http://schemas.microsoft.com/office/drawing/2014/main" id="{4F95D0E1-6836-7150-C8BE-E69E6E5CE931}"/>
               </a:ext>
             </a:extLst>
           </p:cNvPr>
@@ -4594,7 +4594,7 @@
           <p:cNvPr id="11" name="Hộp Văn bản 10">
             <a:extLst>
               <a:ext uri="{FF2B5EF4-FFF2-40B4-BE49-F238E27FC236}">
-                <a16:creationId xmlns:a16="http://schemas.microsoft.com/office/drawing/2014/main" id="{A8FA7458-85E2-C1A8-14B2-0D873A63E6AA}"/>
+                <a16:creationId xmlns:a16="http://schemas.microsoft.com/office/drawing/2014/main" id="{BB40C271-033E-DCC0-B4F7-504C82CCA202}"/>
               </a:ext>
             </a:extLst>
           </p:cNvPr>
@@ -4767,7 +4767,7 @@
           <p:cNvPr id="12" name="Hình chữ nhật: Góc Tròn 11">
             <a:extLst>
               <a:ext uri="{FF2B5EF4-FFF2-40B4-BE49-F238E27FC236}">
-                <a16:creationId xmlns:a16="http://schemas.microsoft.com/office/drawing/2014/main" id="{9B088D06-B878-DFFF-FD5A-B62BD92F6770}"/>
+                <a16:creationId xmlns:a16="http://schemas.microsoft.com/office/drawing/2014/main" id="{5E4D8CC3-6042-2007-3006-2BD49436004A}"/>
               </a:ext>
             </a:extLst>
           </p:cNvPr>
@@ -4835,7 +4835,7 @@
           <p:cNvPr id="13" name="Hình chữ nhật: Góc Tròn 12">
             <a:extLst>
               <a:ext uri="{FF2B5EF4-FFF2-40B4-BE49-F238E27FC236}">
-                <a16:creationId xmlns:a16="http://schemas.microsoft.com/office/drawing/2014/main" id="{5459D595-7C47-BD07-2AC2-B4CFDA90C7A0}"/>
+                <a16:creationId xmlns:a16="http://schemas.microsoft.com/office/drawing/2014/main" id="{9990BB37-B9F9-BF54-975B-77D6E0EAA246}"/>
               </a:ext>
             </a:extLst>
           </p:cNvPr>
@@ -4903,7 +4903,7 @@
           <p:cNvPr id="14" name="Hộp Văn bản 13">
             <a:extLst>
               <a:ext uri="{FF2B5EF4-FFF2-40B4-BE49-F238E27FC236}">
-                <a16:creationId xmlns:a16="http://schemas.microsoft.com/office/drawing/2014/main" id="{EBD96928-3E63-F674-8C43-2CB08B5F38E0}"/>
+                <a16:creationId xmlns:a16="http://schemas.microsoft.com/office/drawing/2014/main" id="{0976B052-BF8F-BC4D-2572-A1178086DEF9}"/>
               </a:ext>
             </a:extLst>
           </p:cNvPr>
@@ -4948,7 +4948,7 @@
           <p:cNvPr id="15" name="Hộp Văn bản 14">
             <a:extLst>
               <a:ext uri="{FF2B5EF4-FFF2-40B4-BE49-F238E27FC236}">
-                <a16:creationId xmlns:a16="http://schemas.microsoft.com/office/drawing/2014/main" id="{8DAA31A0-3CC7-0697-19B7-5D095720EE19}"/>
+                <a16:creationId xmlns:a16="http://schemas.microsoft.com/office/drawing/2014/main" id="{8ED3CB72-BAE1-5CE2-794D-3BDFCB39F780}"/>
               </a:ext>
             </a:extLst>
           </p:cNvPr>
@@ -5015,6 +5015,38 @@
                 </a:solidFill>
                 <a:latin typeface="Aptos" panose="020B0004020202020204" pitchFamily="34" charset="0"/>
               </a:rPr>
+              <a:t>Lễ tân xem preview, chưa gửi tin</a:t>
+            </a:r>
+          </a:p>
+          <a:p>
+            <a:pPr>
+              <a:spcAft>
+                <a:spcPts val="400"/>
+              </a:spcAft>
+            </a:pPr>
+            <a:r>
+              <a:rPr lang="vi-VN" sz="1200">
+                <a:solidFill>
+                  <a:srgbClr val="153F3A"/>
+                </a:solidFill>
+                <a:latin typeface="Aptos" panose="020B0004020202020204" pitchFamily="34" charset="0"/>
+              </a:rPr>
+              <a:t>↓</a:t>
+            </a:r>
+          </a:p>
+          <a:p>
+            <a:pPr>
+              <a:spcAft>
+                <a:spcPts val="400"/>
+              </a:spcAft>
+            </a:pPr>
+            <a:r>
+              <a:rPr lang="vi-VN" sz="1200">
+                <a:solidFill>
+                  <a:srgbClr val="153F3A"/>
+                </a:solidFill>
+                <a:latin typeface="Aptos" panose="020B0004020202020204" pitchFamily="34" charset="0"/>
+              </a:rPr>
               <a:t>Task Scheduler gọi lệnh hằng ngày</a:t>
             </a:r>
           </a:p>
@@ -5047,7 +5079,7 @@
                 </a:solidFill>
                 <a:latin typeface="Aptos" panose="020B0004020202020204" pitchFamily="34" charset="0"/>
               </a:rPr>
-              <a:t>Gemini soạn lời mời chung</a:t>
+              <a:t>Gemini + Twilio gửi lời mời chung</a:t>
             </a:r>
           </a:p>
           <a:p>
@@ -5079,38 +5111,6 @@
                 </a:solidFill>
                 <a:latin typeface="Aptos" panose="020B0004020202020204" pitchFamily="34" charset="0"/>
               </a:rPr>
-              <a:t>Twilio gửi SMS + lưu trạng thái</a:t>
-            </a:r>
-          </a:p>
-          <a:p>
-            <a:pPr>
-              <a:spcAft>
-                <a:spcPts val="400"/>
-              </a:spcAft>
-            </a:pPr>
-            <a:r>
-              <a:rPr lang="vi-VN" sz="1200">
-                <a:solidFill>
-                  <a:srgbClr val="153F3A"/>
-                </a:solidFill>
-                <a:latin typeface="Aptos" panose="020B0004020202020204" pitchFamily="34" charset="0"/>
-              </a:rPr>
-              <a:t>↓</a:t>
-            </a:r>
-          </a:p>
-          <a:p>
-            <a:pPr>
-              <a:spcAft>
-                <a:spcPts val="400"/>
-              </a:spcAft>
-            </a:pPr>
-            <a:r>
-              <a:rPr lang="vi-VN" sz="1200">
-                <a:solidFill>
-                  <a:srgbClr val="153F3A"/>
-                </a:solidFill>
-                <a:latin typeface="Aptos" panose="020B0004020202020204" pitchFamily="34" charset="0"/>
-              </a:rPr>
               <a:t>Không gửi bệnh án; UNKNOWN không retry</a:t>
             </a:r>
           </a:p>
@@ -5121,7 +5121,7 @@
           <p:cNvPr id="16" name="Hình chữ nhật: Góc Tròn 15">
             <a:extLst>
               <a:ext uri="{FF2B5EF4-FFF2-40B4-BE49-F238E27FC236}">
-                <a16:creationId xmlns:a16="http://schemas.microsoft.com/office/drawing/2014/main" id="{67CF0161-43C5-79B0-D0BC-52778ED4A23E}"/>
+                <a16:creationId xmlns:a16="http://schemas.microsoft.com/office/drawing/2014/main" id="{68211423-35F2-D96E-CE80-8943517D5F57}"/>
               </a:ext>
             </a:extLst>
           </p:cNvPr>
@@ -5189,7 +5189,7 @@
           <p:cNvPr id="17" name="Hộp Văn bản 16">
             <a:extLst>
               <a:ext uri="{FF2B5EF4-FFF2-40B4-BE49-F238E27FC236}">
-                <a16:creationId xmlns:a16="http://schemas.microsoft.com/office/drawing/2014/main" id="{87EABF06-9F58-DD91-7DC7-929FF71E9AE8}"/>
+                <a16:creationId xmlns:a16="http://schemas.microsoft.com/office/drawing/2014/main" id="{F332CD71-EEE0-3783-2A49-B6F20364ADDF}"/>
               </a:ext>
             </a:extLst>
           </p:cNvPr>
@@ -5238,7 +5238,7 @@
     </p:spTree>
     <p:extLst>
       <p:ext uri="{BB962C8B-B14F-4D97-AF65-F5344CB8AC3E}">
-        <p14:creationId xmlns:p14="http://schemas.microsoft.com/office/powerpoint/2010/main" val="825656413"/>
+        <p14:creationId xmlns:p14="http://schemas.microsoft.com/office/powerpoint/2010/main" val="1638505250"/>
       </p:ext>
     </p:extLst>
   </p:cSld>
@@ -5270,7 +5270,7 @@
           <p:cNvPr id="2" name="Hộp Văn bản 1">
             <a:extLst>
               <a:ext uri="{FF2B5EF4-FFF2-40B4-BE49-F238E27FC236}">
-                <a16:creationId xmlns:a16="http://schemas.microsoft.com/office/drawing/2014/main" id="{7258574D-1F66-C536-0D64-CC7DBA4C0C3F}"/>
+                <a16:creationId xmlns:a16="http://schemas.microsoft.com/office/drawing/2014/main" id="{2A31BE93-F404-D5FB-3F31-A589AC78AFD1}"/>
               </a:ext>
             </a:extLst>
           </p:cNvPr>
@@ -5315,7 +5315,7 @@
           <p:cNvPr id="3" name="Hộp Văn bản 2">
             <a:extLst>
               <a:ext uri="{FF2B5EF4-FFF2-40B4-BE49-F238E27FC236}">
-                <a16:creationId xmlns:a16="http://schemas.microsoft.com/office/drawing/2014/main" id="{B0BF9A6A-B8FD-04EB-143C-0B760F799A44}"/>
+                <a16:creationId xmlns:a16="http://schemas.microsoft.com/office/drawing/2014/main" id="{28889F1F-7382-126A-0CA6-5723358E7A04}"/>
               </a:ext>
             </a:extLst>
           </p:cNvPr>
@@ -5360,7 +5360,7 @@
           <p:cNvPr id="4" name="Hộp Văn bản 3">
             <a:extLst>
               <a:ext uri="{FF2B5EF4-FFF2-40B4-BE49-F238E27FC236}">
-                <a16:creationId xmlns:a16="http://schemas.microsoft.com/office/drawing/2014/main" id="{A5EE9EAE-1478-03C7-DD6F-A9597E244EC3}"/>
+                <a16:creationId xmlns:a16="http://schemas.microsoft.com/office/drawing/2014/main" id="{7612AF83-06BC-2413-F71A-0A76C899FEA4}"/>
               </a:ext>
             </a:extLst>
           </p:cNvPr>
@@ -5405,7 +5405,7 @@
           <p:cNvPr id="5" name="Hình chữ nhật 4">
             <a:extLst>
               <a:ext uri="{FF2B5EF4-FFF2-40B4-BE49-F238E27FC236}">
-                <a16:creationId xmlns:a16="http://schemas.microsoft.com/office/drawing/2014/main" id="{7DD99FE3-5004-CB4A-EA52-0FE4CCD95670}"/>
+                <a16:creationId xmlns:a16="http://schemas.microsoft.com/office/drawing/2014/main" id="{5842E227-6AF8-BD67-3149-D19F8EA49E47}"/>
               </a:ext>
             </a:extLst>
           </p:cNvPr>
@@ -5473,7 +5473,7 @@
           <p:cNvPr id="6" name="Hộp Văn bản 5">
             <a:extLst>
               <a:ext uri="{FF2B5EF4-FFF2-40B4-BE49-F238E27FC236}">
-                <a16:creationId xmlns:a16="http://schemas.microsoft.com/office/drawing/2014/main" id="{F1BCAEB6-CE18-CFB4-89FF-886981EF8423}"/>
+                <a16:creationId xmlns:a16="http://schemas.microsoft.com/office/drawing/2014/main" id="{965C33FC-B954-2CB9-35F8-B87308E80ED4}"/>
               </a:ext>
             </a:extLst>
           </p:cNvPr>
@@ -5518,7 +5518,7 @@
           <p:cNvPr id="7" name="Hộp Văn bản 6">
             <a:extLst>
               <a:ext uri="{FF2B5EF4-FFF2-40B4-BE49-F238E27FC236}">
-                <a16:creationId xmlns:a16="http://schemas.microsoft.com/office/drawing/2014/main" id="{7303BA07-0173-C085-150C-0CF37727735E}"/>
+                <a16:creationId xmlns:a16="http://schemas.microsoft.com/office/drawing/2014/main" id="{DE756025-BF77-8DEC-FBE1-C02C7D89351D}"/>
               </a:ext>
             </a:extLst>
           </p:cNvPr>
@@ -5563,7 +5563,7 @@
           <p:cNvPr id="8" name="Hình chữ nhật: Góc Tròn 7">
             <a:extLst>
               <a:ext uri="{FF2B5EF4-FFF2-40B4-BE49-F238E27FC236}">
-                <a16:creationId xmlns:a16="http://schemas.microsoft.com/office/drawing/2014/main" id="{92420AAD-C7F5-F6E5-A379-4E93268F3E8C}"/>
+                <a16:creationId xmlns:a16="http://schemas.microsoft.com/office/drawing/2014/main" id="{DCA98CE5-F1B7-40E6-DF2D-9ED63C714A12}"/>
               </a:ext>
             </a:extLst>
           </p:cNvPr>
@@ -5631,7 +5631,7 @@
           <p:cNvPr id="9" name="Hộp Văn bản 8">
             <a:extLst>
               <a:ext uri="{FF2B5EF4-FFF2-40B4-BE49-F238E27FC236}">
-                <a16:creationId xmlns:a16="http://schemas.microsoft.com/office/drawing/2014/main" id="{1552EA90-69E0-D345-B113-F3B81F875B72}"/>
+                <a16:creationId xmlns:a16="http://schemas.microsoft.com/office/drawing/2014/main" id="{E787C974-0684-975E-48F4-28C0589D5075}"/>
               </a:ext>
             </a:extLst>
           </p:cNvPr>
@@ -5676,7 +5676,7 @@
           <p:cNvPr id="10" name="Hộp Văn bản 9">
             <a:extLst>
               <a:ext uri="{FF2B5EF4-FFF2-40B4-BE49-F238E27FC236}">
-                <a16:creationId xmlns:a16="http://schemas.microsoft.com/office/drawing/2014/main" id="{9BDAFFEC-A662-CFB6-D7D2-140E938D49EB}"/>
+                <a16:creationId xmlns:a16="http://schemas.microsoft.com/office/drawing/2014/main" id="{3B06F857-011A-7C8D-975A-490F883C3DFF}"/>
               </a:ext>
             </a:extLst>
           </p:cNvPr>
@@ -5785,7 +5785,7 @@
           <p:cNvPr id="11" name="Hình chữ nhật: Góc Tròn 10">
             <a:extLst>
               <a:ext uri="{FF2B5EF4-FFF2-40B4-BE49-F238E27FC236}">
-                <a16:creationId xmlns:a16="http://schemas.microsoft.com/office/drawing/2014/main" id="{1524C78E-B7B5-535C-B208-D9C6EDDC9C7D}"/>
+                <a16:creationId xmlns:a16="http://schemas.microsoft.com/office/drawing/2014/main" id="{AE08899C-9905-4134-DA8C-FD31CFE3BE85}"/>
               </a:ext>
             </a:extLst>
           </p:cNvPr>
@@ -5853,7 +5853,7 @@
           <p:cNvPr id="12" name="Hộp Văn bản 11">
             <a:extLst>
               <a:ext uri="{FF2B5EF4-FFF2-40B4-BE49-F238E27FC236}">
-                <a16:creationId xmlns:a16="http://schemas.microsoft.com/office/drawing/2014/main" id="{6543B2BF-07A1-1EE3-A1B6-63CC0337C472}"/>
+                <a16:creationId xmlns:a16="http://schemas.microsoft.com/office/drawing/2014/main" id="{382854EF-6DFF-36D3-CBF3-23FE0B7F190B}"/>
               </a:ext>
             </a:extLst>
           </p:cNvPr>
@@ -5898,7 +5898,7 @@
           <p:cNvPr id="13" name="Hộp Văn bản 12">
             <a:extLst>
               <a:ext uri="{FF2B5EF4-FFF2-40B4-BE49-F238E27FC236}">
-                <a16:creationId xmlns:a16="http://schemas.microsoft.com/office/drawing/2014/main" id="{49C28B94-9C66-65B2-A047-737B0C088C16}"/>
+                <a16:creationId xmlns:a16="http://schemas.microsoft.com/office/drawing/2014/main" id="{8BB44045-9B75-93B4-5A3B-DF050224055D}"/>
               </a:ext>
             </a:extLst>
           </p:cNvPr>
@@ -6007,7 +6007,7 @@
           <p:cNvPr id="14" name="Hộp Văn bản 13">
             <a:extLst>
               <a:ext uri="{FF2B5EF4-FFF2-40B4-BE49-F238E27FC236}">
-                <a16:creationId xmlns:a16="http://schemas.microsoft.com/office/drawing/2014/main" id="{4E1705C8-51DB-C4A8-CBD2-394C80023500}"/>
+                <a16:creationId xmlns:a16="http://schemas.microsoft.com/office/drawing/2014/main" id="{5B1EF957-07F1-CD5D-A2D4-4AC74B92EB6C}"/>
               </a:ext>
             </a:extLst>
           </p:cNvPr>
@@ -6050,7 +6050,7 @@
     </p:spTree>
     <p:extLst>
       <p:ext uri="{BB962C8B-B14F-4D97-AF65-F5344CB8AC3E}">
-        <p14:creationId xmlns:p14="http://schemas.microsoft.com/office/powerpoint/2010/main" val="899283255"/>
+        <p14:creationId xmlns:p14="http://schemas.microsoft.com/office/powerpoint/2010/main" val="1182723625"/>
       </p:ext>
     </p:extLst>
   </p:cSld>
@@ -6082,7 +6082,7 @@
           <p:cNvPr id="2" name="Hộp Văn bản 1">
             <a:extLst>
               <a:ext uri="{FF2B5EF4-FFF2-40B4-BE49-F238E27FC236}">
-                <a16:creationId xmlns:a16="http://schemas.microsoft.com/office/drawing/2014/main" id="{59EB209B-7BA7-092F-67E2-4C868B83AF7E}"/>
+                <a16:creationId xmlns:a16="http://schemas.microsoft.com/office/drawing/2014/main" id="{243B247C-A811-4EDB-3EC1-E0422D63358B}"/>
               </a:ext>
             </a:extLst>
           </p:cNvPr>
@@ -6127,7 +6127,7 @@
           <p:cNvPr id="3" name="Hộp Văn bản 2">
             <a:extLst>
               <a:ext uri="{FF2B5EF4-FFF2-40B4-BE49-F238E27FC236}">
-                <a16:creationId xmlns:a16="http://schemas.microsoft.com/office/drawing/2014/main" id="{18B083F2-EC43-809B-FFBE-C4F32B4A3903}"/>
+                <a16:creationId xmlns:a16="http://schemas.microsoft.com/office/drawing/2014/main" id="{16F32776-3E72-94C8-A7E6-5DF4B310BF89}"/>
               </a:ext>
             </a:extLst>
           </p:cNvPr>
@@ -6172,7 +6172,7 @@
           <p:cNvPr id="4" name="Hộp Văn bản 3">
             <a:extLst>
               <a:ext uri="{FF2B5EF4-FFF2-40B4-BE49-F238E27FC236}">
-                <a16:creationId xmlns:a16="http://schemas.microsoft.com/office/drawing/2014/main" id="{D23E3F3C-094F-8446-C15C-2F0F222C610B}"/>
+                <a16:creationId xmlns:a16="http://schemas.microsoft.com/office/drawing/2014/main" id="{E6C7E14A-1FCC-0E9A-9D48-07A95960213A}"/>
               </a:ext>
             </a:extLst>
           </p:cNvPr>
@@ -6217,7 +6217,7 @@
           <p:cNvPr id="5" name="Hình chữ nhật 4">
             <a:extLst>
               <a:ext uri="{FF2B5EF4-FFF2-40B4-BE49-F238E27FC236}">
-                <a16:creationId xmlns:a16="http://schemas.microsoft.com/office/drawing/2014/main" id="{FBCAAC6F-A348-4F7A-6373-E98552F8F7CD}"/>
+                <a16:creationId xmlns:a16="http://schemas.microsoft.com/office/drawing/2014/main" id="{AAD0FE2C-724D-B50D-7571-75EB24A913ED}"/>
               </a:ext>
             </a:extLst>
           </p:cNvPr>
@@ -6285,7 +6285,7 @@
           <p:cNvPr id="6" name="Hộp Văn bản 5">
             <a:extLst>
               <a:ext uri="{FF2B5EF4-FFF2-40B4-BE49-F238E27FC236}">
-                <a16:creationId xmlns:a16="http://schemas.microsoft.com/office/drawing/2014/main" id="{BE4CA1FF-6AB3-442F-982C-7DD96FAD22FA}"/>
+                <a16:creationId xmlns:a16="http://schemas.microsoft.com/office/drawing/2014/main" id="{9DD5D125-97DE-2BA8-8EF3-34E327BDC515}"/>
               </a:ext>
             </a:extLst>
           </p:cNvPr>
@@ -6330,7 +6330,7 @@
           <p:cNvPr id="7" name="Hộp Văn bản 6">
             <a:extLst>
               <a:ext uri="{FF2B5EF4-FFF2-40B4-BE49-F238E27FC236}">
-                <a16:creationId xmlns:a16="http://schemas.microsoft.com/office/drawing/2014/main" id="{518D9661-AEF3-AE6E-7040-D7A982CBA3FA}"/>
+                <a16:creationId xmlns:a16="http://schemas.microsoft.com/office/drawing/2014/main" id="{64626F8C-6010-E02C-0DDE-FFA0FF04554E}"/>
               </a:ext>
             </a:extLst>
           </p:cNvPr>
@@ -6375,7 +6375,7 @@
           <p:cNvPr id="8" name="Hình chữ nhật: Góc Tròn 7">
             <a:extLst>
               <a:ext uri="{FF2B5EF4-FFF2-40B4-BE49-F238E27FC236}">
-                <a16:creationId xmlns:a16="http://schemas.microsoft.com/office/drawing/2014/main" id="{50868ABD-5627-0FDA-5000-74FF672027E9}"/>
+                <a16:creationId xmlns:a16="http://schemas.microsoft.com/office/drawing/2014/main" id="{09779635-AB6E-6F34-9801-6ED4F1DA8687}"/>
               </a:ext>
             </a:extLst>
           </p:cNvPr>
@@ -6443,7 +6443,7 @@
           <p:cNvPr id="9" name="Hộp Văn bản 8">
             <a:extLst>
               <a:ext uri="{FF2B5EF4-FFF2-40B4-BE49-F238E27FC236}">
-                <a16:creationId xmlns:a16="http://schemas.microsoft.com/office/drawing/2014/main" id="{64EF1677-F4C0-041E-3A3F-3EEB3F20A12E}"/>
+                <a16:creationId xmlns:a16="http://schemas.microsoft.com/office/drawing/2014/main" id="{48F2B050-DFC1-80A5-4EA8-09F6164C5CC1}"/>
               </a:ext>
             </a:extLst>
           </p:cNvPr>
@@ -6488,7 +6488,7 @@
           <p:cNvPr id="10" name="Hộp Văn bản 9">
             <a:extLst>
               <a:ext uri="{FF2B5EF4-FFF2-40B4-BE49-F238E27FC236}">
-                <a16:creationId xmlns:a16="http://schemas.microsoft.com/office/drawing/2014/main" id="{81AFE059-950B-55AE-A5E5-9A77540123F1}"/>
+                <a16:creationId xmlns:a16="http://schemas.microsoft.com/office/drawing/2014/main" id="{0855ED46-E092-FE64-5DC2-0A7AB920B7E1}"/>
               </a:ext>
             </a:extLst>
           </p:cNvPr>
@@ -6533,7 +6533,7 @@
           <p:cNvPr id="11" name="Hộp Văn bản 10">
             <a:extLst>
               <a:ext uri="{FF2B5EF4-FFF2-40B4-BE49-F238E27FC236}">
-                <a16:creationId xmlns:a16="http://schemas.microsoft.com/office/drawing/2014/main" id="{0713CF42-AB2F-E5C0-8E9D-1D535AEF4FAC}"/>
+                <a16:creationId xmlns:a16="http://schemas.microsoft.com/office/drawing/2014/main" id="{A01B7489-63A1-AE8F-67DD-88E8F702A2DF}"/>
               </a:ext>
             </a:extLst>
           </p:cNvPr>
@@ -6578,7 +6578,7 @@
           <p:cNvPr id="12" name="Hình chữ nhật: Góc Tròn 11">
             <a:extLst>
               <a:ext uri="{FF2B5EF4-FFF2-40B4-BE49-F238E27FC236}">
-                <a16:creationId xmlns:a16="http://schemas.microsoft.com/office/drawing/2014/main" id="{187DCDA2-3842-132E-4FF2-E75C1ACB0606}"/>
+                <a16:creationId xmlns:a16="http://schemas.microsoft.com/office/drawing/2014/main" id="{F18E2108-8170-14F4-D722-09E0BBF6A273}"/>
               </a:ext>
             </a:extLst>
           </p:cNvPr>
@@ -6646,7 +6646,7 @@
           <p:cNvPr id="13" name="Hộp Văn bản 12">
             <a:extLst>
               <a:ext uri="{FF2B5EF4-FFF2-40B4-BE49-F238E27FC236}">
-                <a16:creationId xmlns:a16="http://schemas.microsoft.com/office/drawing/2014/main" id="{C6E19829-0B50-5165-A728-83E2AB13866E}"/>
+                <a16:creationId xmlns:a16="http://schemas.microsoft.com/office/drawing/2014/main" id="{A4E3C5DE-CABC-818A-B42F-D79EFCEB3FB0}"/>
               </a:ext>
             </a:extLst>
           </p:cNvPr>
@@ -6691,7 +6691,7 @@
           <p:cNvPr id="14" name="Hộp Văn bản 13">
             <a:extLst>
               <a:ext uri="{FF2B5EF4-FFF2-40B4-BE49-F238E27FC236}">
-                <a16:creationId xmlns:a16="http://schemas.microsoft.com/office/drawing/2014/main" id="{2CFE7A48-214A-C59D-EFE0-8BE259417003}"/>
+                <a16:creationId xmlns:a16="http://schemas.microsoft.com/office/drawing/2014/main" id="{2133E37A-1D25-9DDA-40AE-803403595247}"/>
               </a:ext>
             </a:extLst>
           </p:cNvPr>
@@ -6736,7 +6736,7 @@
           <p:cNvPr id="15" name="Hộp Văn bản 14">
             <a:extLst>
               <a:ext uri="{FF2B5EF4-FFF2-40B4-BE49-F238E27FC236}">
-                <a16:creationId xmlns:a16="http://schemas.microsoft.com/office/drawing/2014/main" id="{C34142C3-F289-CCF9-0CEA-8D848055E4DF}"/>
+                <a16:creationId xmlns:a16="http://schemas.microsoft.com/office/drawing/2014/main" id="{37ED7754-8742-BB02-A75C-0187D592F825}"/>
               </a:ext>
             </a:extLst>
           </p:cNvPr>
@@ -6781,7 +6781,7 @@
           <p:cNvPr id="16" name="Hình chữ nhật: Góc Tròn 15">
             <a:extLst>
               <a:ext uri="{FF2B5EF4-FFF2-40B4-BE49-F238E27FC236}">
-                <a16:creationId xmlns:a16="http://schemas.microsoft.com/office/drawing/2014/main" id="{3FAA3876-3FB6-A482-0CE4-FBA88E1963C3}"/>
+                <a16:creationId xmlns:a16="http://schemas.microsoft.com/office/drawing/2014/main" id="{25BAD39E-5C28-295B-325D-E6EF7C838666}"/>
               </a:ext>
             </a:extLst>
           </p:cNvPr>
@@ -6849,7 +6849,7 @@
           <p:cNvPr id="17" name="Hộp Văn bản 16">
             <a:extLst>
               <a:ext uri="{FF2B5EF4-FFF2-40B4-BE49-F238E27FC236}">
-                <a16:creationId xmlns:a16="http://schemas.microsoft.com/office/drawing/2014/main" id="{870C105D-D2F7-8B71-87EB-2FB91A6BC355}"/>
+                <a16:creationId xmlns:a16="http://schemas.microsoft.com/office/drawing/2014/main" id="{180FFB5B-4020-F698-28B9-26336032734A}"/>
               </a:ext>
             </a:extLst>
           </p:cNvPr>
@@ -6894,7 +6894,7 @@
           <p:cNvPr id="18" name="Hộp Văn bản 17">
             <a:extLst>
               <a:ext uri="{FF2B5EF4-FFF2-40B4-BE49-F238E27FC236}">
-                <a16:creationId xmlns:a16="http://schemas.microsoft.com/office/drawing/2014/main" id="{08843267-A75F-BA1F-C89A-8DCED89ECAD5}"/>
+                <a16:creationId xmlns:a16="http://schemas.microsoft.com/office/drawing/2014/main" id="{247DE8BB-2840-C219-3D6E-CB0A9E02DCD5}"/>
               </a:ext>
             </a:extLst>
           </p:cNvPr>
@@ -6939,7 +6939,7 @@
           <p:cNvPr id="19" name="Hộp Văn bản 18">
             <a:extLst>
               <a:ext uri="{FF2B5EF4-FFF2-40B4-BE49-F238E27FC236}">
-                <a16:creationId xmlns:a16="http://schemas.microsoft.com/office/drawing/2014/main" id="{496B3813-6BA2-E11A-DFAE-A2791F6B686B}"/>
+                <a16:creationId xmlns:a16="http://schemas.microsoft.com/office/drawing/2014/main" id="{1856EA62-DB3F-474C-98AB-A2F21F1A82AC}"/>
               </a:ext>
             </a:extLst>
           </p:cNvPr>
@@ -6984,7 +6984,7 @@
           <p:cNvPr id="20" name="Hình chữ nhật: Góc Tròn 19">
             <a:extLst>
               <a:ext uri="{FF2B5EF4-FFF2-40B4-BE49-F238E27FC236}">
-                <a16:creationId xmlns:a16="http://schemas.microsoft.com/office/drawing/2014/main" id="{08F024B2-F488-27FC-78C3-B882B442BC4F}"/>
+                <a16:creationId xmlns:a16="http://schemas.microsoft.com/office/drawing/2014/main" id="{FC23AFB6-36A1-A6AD-1F22-0776430CE59D}"/>
               </a:ext>
             </a:extLst>
           </p:cNvPr>
@@ -7052,7 +7052,7 @@
           <p:cNvPr id="21" name="Hộp Văn bản 20">
             <a:extLst>
               <a:ext uri="{FF2B5EF4-FFF2-40B4-BE49-F238E27FC236}">
-                <a16:creationId xmlns:a16="http://schemas.microsoft.com/office/drawing/2014/main" id="{EADA7973-23E9-E1F5-F727-EED6E987F1CC}"/>
+                <a16:creationId xmlns:a16="http://schemas.microsoft.com/office/drawing/2014/main" id="{FC7525D6-A001-D632-AE1C-B02A77EA06C6}"/>
               </a:ext>
             </a:extLst>
           </p:cNvPr>
@@ -7097,7 +7097,7 @@
           <p:cNvPr id="22" name="Hộp Văn bản 21">
             <a:extLst>
               <a:ext uri="{FF2B5EF4-FFF2-40B4-BE49-F238E27FC236}">
-                <a16:creationId xmlns:a16="http://schemas.microsoft.com/office/drawing/2014/main" id="{0B33C7CC-DA1D-BB3E-79E6-02FB8A551FF4}"/>
+                <a16:creationId xmlns:a16="http://schemas.microsoft.com/office/drawing/2014/main" id="{C226750E-D30F-C483-28E3-11C7CDCC51ED}"/>
               </a:ext>
             </a:extLst>
           </p:cNvPr>
@@ -7142,7 +7142,7 @@
           <p:cNvPr id="23" name="Hộp Văn bản 22">
             <a:extLst>
               <a:ext uri="{FF2B5EF4-FFF2-40B4-BE49-F238E27FC236}">
-                <a16:creationId xmlns:a16="http://schemas.microsoft.com/office/drawing/2014/main" id="{2343D1EE-3927-8663-2054-6C2B26F9C114}"/>
+                <a16:creationId xmlns:a16="http://schemas.microsoft.com/office/drawing/2014/main" id="{E14B8F11-63A9-E6D2-DEC8-97A94F459FF8}"/>
               </a:ext>
             </a:extLst>
           </p:cNvPr>
@@ -7187,7 +7187,7 @@
           <p:cNvPr id="24" name="Hộp Văn bản 23">
             <a:extLst>
               <a:ext uri="{FF2B5EF4-FFF2-40B4-BE49-F238E27FC236}">
-                <a16:creationId xmlns:a16="http://schemas.microsoft.com/office/drawing/2014/main" id="{5F3AE1FF-4785-D2FE-DB3E-BF820051DADC}"/>
+                <a16:creationId xmlns:a16="http://schemas.microsoft.com/office/drawing/2014/main" id="{A6DA3D3A-3AE1-6F13-F882-E8E8EEBD6CBB}"/>
               </a:ext>
             </a:extLst>
           </p:cNvPr>
@@ -7230,7 +7230,7 @@
     </p:spTree>
     <p:extLst>
       <p:ext uri="{BB962C8B-B14F-4D97-AF65-F5344CB8AC3E}">
-        <p14:creationId xmlns:p14="http://schemas.microsoft.com/office/powerpoint/2010/main" val="3310595391"/>
+        <p14:creationId xmlns:p14="http://schemas.microsoft.com/office/powerpoint/2010/main" val="398519923"/>
       </p:ext>
     </p:extLst>
   </p:cSld>
@@ -7262,7 +7262,7 @@
           <p:cNvPr id="2" name="Hộp Văn bản 1">
             <a:extLst>
               <a:ext uri="{FF2B5EF4-FFF2-40B4-BE49-F238E27FC236}">
-                <a16:creationId xmlns:a16="http://schemas.microsoft.com/office/drawing/2014/main" id="{D954A977-5143-8A50-D0B1-52E610F94482}"/>
+                <a16:creationId xmlns:a16="http://schemas.microsoft.com/office/drawing/2014/main" id="{06DB98D0-A589-7BC9-B63D-F62ACCEBCBCA}"/>
               </a:ext>
             </a:extLst>
           </p:cNvPr>
@@ -7307,7 +7307,7 @@
           <p:cNvPr id="3" name="Hộp Văn bản 2">
             <a:extLst>
               <a:ext uri="{FF2B5EF4-FFF2-40B4-BE49-F238E27FC236}">
-                <a16:creationId xmlns:a16="http://schemas.microsoft.com/office/drawing/2014/main" id="{E54E4A9E-EF5C-B699-A7BC-1EC93D66D968}"/>
+                <a16:creationId xmlns:a16="http://schemas.microsoft.com/office/drawing/2014/main" id="{FD0A0470-057D-4F49-5FDD-F621CE570F04}"/>
               </a:ext>
             </a:extLst>
           </p:cNvPr>
@@ -7352,7 +7352,7 @@
           <p:cNvPr id="4" name="Hộp Văn bản 3">
             <a:extLst>
               <a:ext uri="{FF2B5EF4-FFF2-40B4-BE49-F238E27FC236}">
-                <a16:creationId xmlns:a16="http://schemas.microsoft.com/office/drawing/2014/main" id="{D5A950DF-F770-AA89-C624-62FF8A985109}"/>
+                <a16:creationId xmlns:a16="http://schemas.microsoft.com/office/drawing/2014/main" id="{2A5D935A-EDFA-0269-45C3-A6F6F82B842B}"/>
               </a:ext>
             </a:extLst>
           </p:cNvPr>
@@ -7397,7 +7397,7 @@
           <p:cNvPr id="5" name="Hình chữ nhật 4">
             <a:extLst>
               <a:ext uri="{FF2B5EF4-FFF2-40B4-BE49-F238E27FC236}">
-                <a16:creationId xmlns:a16="http://schemas.microsoft.com/office/drawing/2014/main" id="{754B55E5-FC7C-1AAF-D993-68AC01F45453}"/>
+                <a16:creationId xmlns:a16="http://schemas.microsoft.com/office/drawing/2014/main" id="{5737F8FB-738D-CC59-52C3-8F9A7CE1FAF5}"/>
               </a:ext>
             </a:extLst>
           </p:cNvPr>
@@ -7465,7 +7465,7 @@
           <p:cNvPr id="6" name="Hộp Văn bản 5">
             <a:extLst>
               <a:ext uri="{FF2B5EF4-FFF2-40B4-BE49-F238E27FC236}">
-                <a16:creationId xmlns:a16="http://schemas.microsoft.com/office/drawing/2014/main" id="{0CB82D30-43B9-5339-AABE-6AE35567F966}"/>
+                <a16:creationId xmlns:a16="http://schemas.microsoft.com/office/drawing/2014/main" id="{06B78B97-01C9-F39C-EFBA-8746DB99F293}"/>
               </a:ext>
             </a:extLst>
           </p:cNvPr>
@@ -7510,7 +7510,7 @@
           <p:cNvPr id="7" name="Hộp Văn bản 6">
             <a:extLst>
               <a:ext uri="{FF2B5EF4-FFF2-40B4-BE49-F238E27FC236}">
-                <a16:creationId xmlns:a16="http://schemas.microsoft.com/office/drawing/2014/main" id="{6DB2AF16-F603-6AD7-20BD-B579A0A5AA6A}"/>
+                <a16:creationId xmlns:a16="http://schemas.microsoft.com/office/drawing/2014/main" id="{07730209-5740-0123-11DE-E6D561122FA2}"/>
               </a:ext>
             </a:extLst>
           </p:cNvPr>
@@ -7555,7 +7555,7 @@
           <p:cNvPr id="8" name="Hình chữ nhật: Góc Tròn 7">
             <a:extLst>
               <a:ext uri="{FF2B5EF4-FFF2-40B4-BE49-F238E27FC236}">
-                <a16:creationId xmlns:a16="http://schemas.microsoft.com/office/drawing/2014/main" id="{10A2FC4C-005F-EE57-8987-B2951F866121}"/>
+                <a16:creationId xmlns:a16="http://schemas.microsoft.com/office/drawing/2014/main" id="{B5683B63-DC97-03E8-88AA-27B5A03D19B2}"/>
               </a:ext>
             </a:extLst>
           </p:cNvPr>
@@ -7623,7 +7623,7 @@
           <p:cNvPr id="9" name="Hình chữ nhật 8">
             <a:extLst>
               <a:ext uri="{FF2B5EF4-FFF2-40B4-BE49-F238E27FC236}">
-                <a16:creationId xmlns:a16="http://schemas.microsoft.com/office/drawing/2014/main" id="{1986D320-17CA-2B1A-A58D-1759B10C7552}"/>
+                <a16:creationId xmlns:a16="http://schemas.microsoft.com/office/drawing/2014/main" id="{A26AD84B-8ADB-89E1-E77C-3EE97A78FA99}"/>
               </a:ext>
             </a:extLst>
           </p:cNvPr>
@@ -7691,7 +7691,7 @@
           <p:cNvPr id="10" name="Hộp Văn bản 9">
             <a:extLst>
               <a:ext uri="{FF2B5EF4-FFF2-40B4-BE49-F238E27FC236}">
-                <a16:creationId xmlns:a16="http://schemas.microsoft.com/office/drawing/2014/main" id="{776F82BD-FDDA-3CF1-A9A1-38F97D05A424}"/>
+                <a16:creationId xmlns:a16="http://schemas.microsoft.com/office/drawing/2014/main" id="{FA40CA8F-2D3C-60A9-19E9-05C7768E1A36}"/>
               </a:ext>
             </a:extLst>
           </p:cNvPr>
@@ -7742,7 +7742,7 @@
           <p:cNvPr id="11" name="Hộp Văn bản 10">
             <a:extLst>
               <a:ext uri="{FF2B5EF4-FFF2-40B4-BE49-F238E27FC236}">
-                <a16:creationId xmlns:a16="http://schemas.microsoft.com/office/drawing/2014/main" id="{D44D5597-F371-BA09-EF5A-5BDDCA540433}"/>
+                <a16:creationId xmlns:a16="http://schemas.microsoft.com/office/drawing/2014/main" id="{5B832DC3-A4FC-DB4C-64F9-0DAD66405CA6}"/>
               </a:ext>
             </a:extLst>
           </p:cNvPr>
@@ -7787,7 +7787,7 @@
           <p:cNvPr id="12" name="Hình chữ nhật: Góc Tròn 11">
             <a:extLst>
               <a:ext uri="{FF2B5EF4-FFF2-40B4-BE49-F238E27FC236}">
-                <a16:creationId xmlns:a16="http://schemas.microsoft.com/office/drawing/2014/main" id="{C5FF5C1E-018F-2F80-CE20-4F71524F3FC3}"/>
+                <a16:creationId xmlns:a16="http://schemas.microsoft.com/office/drawing/2014/main" id="{35FBC664-0E30-4339-C94E-29F27662FFDF}"/>
               </a:ext>
             </a:extLst>
           </p:cNvPr>
@@ -7855,7 +7855,7 @@
           <p:cNvPr id="13" name="Hình chữ nhật 12">
             <a:extLst>
               <a:ext uri="{FF2B5EF4-FFF2-40B4-BE49-F238E27FC236}">
-                <a16:creationId xmlns:a16="http://schemas.microsoft.com/office/drawing/2014/main" id="{975F05C2-F13D-B7E8-7B44-0FE88EF0BEE5}"/>
+                <a16:creationId xmlns:a16="http://schemas.microsoft.com/office/drawing/2014/main" id="{BA055361-B5BA-A0AA-6D5F-98D62D678AFF}"/>
               </a:ext>
             </a:extLst>
           </p:cNvPr>
@@ -7923,7 +7923,7 @@
           <p:cNvPr id="14" name="Hộp Văn bản 13">
             <a:extLst>
               <a:ext uri="{FF2B5EF4-FFF2-40B4-BE49-F238E27FC236}">
-                <a16:creationId xmlns:a16="http://schemas.microsoft.com/office/drawing/2014/main" id="{40457EAB-79BD-926B-C62B-B3AA6181483C}"/>
+                <a16:creationId xmlns:a16="http://schemas.microsoft.com/office/drawing/2014/main" id="{B87D3821-F0A9-C704-0911-CBB3E748B8FE}"/>
               </a:ext>
             </a:extLst>
           </p:cNvPr>
@@ -7968,7 +7968,7 @@
           <p:cNvPr id="15" name="Hộp Văn bản 14">
             <a:extLst>
               <a:ext uri="{FF2B5EF4-FFF2-40B4-BE49-F238E27FC236}">
-                <a16:creationId xmlns:a16="http://schemas.microsoft.com/office/drawing/2014/main" id="{0C3115BD-4F56-09EE-FCCD-747AE2A4BABB}"/>
+                <a16:creationId xmlns:a16="http://schemas.microsoft.com/office/drawing/2014/main" id="{EAF9CD2B-A7D3-36D8-E6D2-34FE5FE49E0A}"/>
               </a:ext>
             </a:extLst>
           </p:cNvPr>
@@ -8013,7 +8013,7 @@
           <p:cNvPr id="16" name="Hình chữ nhật: Góc Tròn 15">
             <a:extLst>
               <a:ext uri="{FF2B5EF4-FFF2-40B4-BE49-F238E27FC236}">
-                <a16:creationId xmlns:a16="http://schemas.microsoft.com/office/drawing/2014/main" id="{B34F900A-0261-AB17-39C8-5AEF6CDC6514}"/>
+                <a16:creationId xmlns:a16="http://schemas.microsoft.com/office/drawing/2014/main" id="{24607244-B788-E0FF-18CB-D7707F726D96}"/>
               </a:ext>
             </a:extLst>
           </p:cNvPr>
@@ -8081,7 +8081,7 @@
           <p:cNvPr id="17" name="Hình chữ nhật 16">
             <a:extLst>
               <a:ext uri="{FF2B5EF4-FFF2-40B4-BE49-F238E27FC236}">
-                <a16:creationId xmlns:a16="http://schemas.microsoft.com/office/drawing/2014/main" id="{24165E2F-28B8-AAD4-773D-3FF7AEC922C1}"/>
+                <a16:creationId xmlns:a16="http://schemas.microsoft.com/office/drawing/2014/main" id="{7E8323AB-ADA9-F53A-536B-604B85A0ECAB}"/>
               </a:ext>
             </a:extLst>
           </p:cNvPr>
@@ -8149,7 +8149,7 @@
           <p:cNvPr id="18" name="Hộp Văn bản 17">
             <a:extLst>
               <a:ext uri="{FF2B5EF4-FFF2-40B4-BE49-F238E27FC236}">
-                <a16:creationId xmlns:a16="http://schemas.microsoft.com/office/drawing/2014/main" id="{E0BD6D2B-9245-31DC-B626-0D7FBED4A521}"/>
+                <a16:creationId xmlns:a16="http://schemas.microsoft.com/office/drawing/2014/main" id="{14982EFF-7609-C8EA-F261-14BBF57A242E}"/>
               </a:ext>
             </a:extLst>
           </p:cNvPr>
@@ -8194,7 +8194,7 @@
           <p:cNvPr id="19" name="Hộp Văn bản 18">
             <a:extLst>
               <a:ext uri="{FF2B5EF4-FFF2-40B4-BE49-F238E27FC236}">
-                <a16:creationId xmlns:a16="http://schemas.microsoft.com/office/drawing/2014/main" id="{D1F7D142-6EF1-81BC-347B-2D7D4A55720D}"/>
+                <a16:creationId xmlns:a16="http://schemas.microsoft.com/office/drawing/2014/main" id="{1CD943E3-3631-4A86-7814-FA57E0A8A285}"/>
               </a:ext>
             </a:extLst>
           </p:cNvPr>
@@ -8239,7 +8239,7 @@
           <p:cNvPr id="20" name="Hình chữ nhật: Góc Tròn 19">
             <a:extLst>
               <a:ext uri="{FF2B5EF4-FFF2-40B4-BE49-F238E27FC236}">
-                <a16:creationId xmlns:a16="http://schemas.microsoft.com/office/drawing/2014/main" id="{18B4A9E5-1C16-2477-D181-EE177D21D2D9}"/>
+                <a16:creationId xmlns:a16="http://schemas.microsoft.com/office/drawing/2014/main" id="{A8B6E960-A16D-098F-387C-29FF3AE7792E}"/>
               </a:ext>
             </a:extLst>
           </p:cNvPr>
@@ -8307,7 +8307,7 @@
           <p:cNvPr id="21" name="Hộp Văn bản 20">
             <a:extLst>
               <a:ext uri="{FF2B5EF4-FFF2-40B4-BE49-F238E27FC236}">
-                <a16:creationId xmlns:a16="http://schemas.microsoft.com/office/drawing/2014/main" id="{23C37116-A4C0-8FF7-5583-1CE256751D1E}"/>
+                <a16:creationId xmlns:a16="http://schemas.microsoft.com/office/drawing/2014/main" id="{3FC6CCE3-6967-30C2-EC7C-7C694E97F728}"/>
               </a:ext>
             </a:extLst>
           </p:cNvPr>
@@ -8350,7 +8350,7 @@
     </p:spTree>
     <p:extLst>
       <p:ext uri="{BB962C8B-B14F-4D97-AF65-F5344CB8AC3E}">
-        <p14:creationId xmlns:p14="http://schemas.microsoft.com/office/powerpoint/2010/main" val="1627229475"/>
+        <p14:creationId xmlns:p14="http://schemas.microsoft.com/office/powerpoint/2010/main" val="3314326253"/>
       </p:ext>
     </p:extLst>
   </p:cSld>
@@ -8382,7 +8382,7 @@
           <p:cNvPr id="2" name="Hộp Văn bản 1">
             <a:extLst>
               <a:ext uri="{FF2B5EF4-FFF2-40B4-BE49-F238E27FC236}">
-                <a16:creationId xmlns:a16="http://schemas.microsoft.com/office/drawing/2014/main" id="{EC801E1C-5348-5DB4-BBF7-024DEBFE3613}"/>
+                <a16:creationId xmlns:a16="http://schemas.microsoft.com/office/drawing/2014/main" id="{DFF3D464-AE94-6600-D045-83912F509E6C}"/>
               </a:ext>
             </a:extLst>
           </p:cNvPr>
@@ -8427,7 +8427,7 @@
           <p:cNvPr id="3" name="Hộp Văn bản 2">
             <a:extLst>
               <a:ext uri="{FF2B5EF4-FFF2-40B4-BE49-F238E27FC236}">
-                <a16:creationId xmlns:a16="http://schemas.microsoft.com/office/drawing/2014/main" id="{A522F758-F571-6370-B1FE-CC940C1C5B8B}"/>
+                <a16:creationId xmlns:a16="http://schemas.microsoft.com/office/drawing/2014/main" id="{257CF96C-56E9-1994-3A9E-7B60AB6449EC}"/>
               </a:ext>
             </a:extLst>
           </p:cNvPr>
@@ -8472,7 +8472,7 @@
           <p:cNvPr id="4" name="Hộp Văn bản 3">
             <a:extLst>
               <a:ext uri="{FF2B5EF4-FFF2-40B4-BE49-F238E27FC236}">
-                <a16:creationId xmlns:a16="http://schemas.microsoft.com/office/drawing/2014/main" id="{C99FEBF7-5964-E335-2790-5448C5D4A19D}"/>
+                <a16:creationId xmlns:a16="http://schemas.microsoft.com/office/drawing/2014/main" id="{ADF74A20-5872-0344-AA20-4D64190A7A0A}"/>
               </a:ext>
             </a:extLst>
           </p:cNvPr>
@@ -8517,7 +8517,7 @@
           <p:cNvPr id="5" name="Hình chữ nhật 4">
             <a:extLst>
               <a:ext uri="{FF2B5EF4-FFF2-40B4-BE49-F238E27FC236}">
-                <a16:creationId xmlns:a16="http://schemas.microsoft.com/office/drawing/2014/main" id="{20E35455-1B3F-7F3C-79CE-4CB2927CD664}"/>
+                <a16:creationId xmlns:a16="http://schemas.microsoft.com/office/drawing/2014/main" id="{CCD291FE-59B6-F962-E267-56993A80B07C}"/>
               </a:ext>
             </a:extLst>
           </p:cNvPr>
@@ -8585,7 +8585,7 @@
           <p:cNvPr id="6" name="Hộp Văn bản 5">
             <a:extLst>
               <a:ext uri="{FF2B5EF4-FFF2-40B4-BE49-F238E27FC236}">
-                <a16:creationId xmlns:a16="http://schemas.microsoft.com/office/drawing/2014/main" id="{E7ACA612-597B-E92F-431F-1DC7DC5F5956}"/>
+                <a16:creationId xmlns:a16="http://schemas.microsoft.com/office/drawing/2014/main" id="{350369D0-C309-5DF9-00A8-A8EDDFFF8C79}"/>
               </a:ext>
             </a:extLst>
           </p:cNvPr>
@@ -8630,7 +8630,7 @@
           <p:cNvPr id="7" name="Hộp Văn bản 6">
             <a:extLst>
               <a:ext uri="{FF2B5EF4-FFF2-40B4-BE49-F238E27FC236}">
-                <a16:creationId xmlns:a16="http://schemas.microsoft.com/office/drawing/2014/main" id="{43245514-7455-1AAD-3806-559E03E100FA}"/>
+                <a16:creationId xmlns:a16="http://schemas.microsoft.com/office/drawing/2014/main" id="{30B2193C-BBA6-4050-3826-AF9CBD2DD9E7}"/>
               </a:ext>
             </a:extLst>
           </p:cNvPr>
@@ -8675,7 +8675,7 @@
           <p:cNvPr id="8" name="Hình chữ nhật: Góc Tròn 7">
             <a:extLst>
               <a:ext uri="{FF2B5EF4-FFF2-40B4-BE49-F238E27FC236}">
-                <a16:creationId xmlns:a16="http://schemas.microsoft.com/office/drawing/2014/main" id="{7D7413B0-EEEE-5B1C-EF60-6B2A81E10061}"/>
+                <a16:creationId xmlns:a16="http://schemas.microsoft.com/office/drawing/2014/main" id="{0C2DFD6D-F5EB-1D73-C125-87A9F844647A}"/>
               </a:ext>
             </a:extLst>
           </p:cNvPr>
@@ -8743,7 +8743,7 @@
           <p:cNvPr id="9" name="Hình chữ nhật 8">
             <a:extLst>
               <a:ext uri="{FF2B5EF4-FFF2-40B4-BE49-F238E27FC236}">
-                <a16:creationId xmlns:a16="http://schemas.microsoft.com/office/drawing/2014/main" id="{D60E516D-EF4D-6E44-8489-4D4BDAF2E5CC}"/>
+                <a16:creationId xmlns:a16="http://schemas.microsoft.com/office/drawing/2014/main" id="{A544BFB8-C18D-CA05-17D1-BE8F0FA5BA62}"/>
               </a:ext>
             </a:extLst>
           </p:cNvPr>
@@ -8811,7 +8811,7 @@
           <p:cNvPr id="10" name="Hộp Văn bản 9">
             <a:extLst>
               <a:ext uri="{FF2B5EF4-FFF2-40B4-BE49-F238E27FC236}">
-                <a16:creationId xmlns:a16="http://schemas.microsoft.com/office/drawing/2014/main" id="{49EA4315-F2F4-2901-5371-0743B25B54A3}"/>
+                <a16:creationId xmlns:a16="http://schemas.microsoft.com/office/drawing/2014/main" id="{6CF11054-2C27-D91E-4D2B-B79A7F6DC7D4}"/>
               </a:ext>
             </a:extLst>
           </p:cNvPr>
@@ -8856,7 +8856,7 @@
           <p:cNvPr id="11" name="Hộp Văn bản 10">
             <a:extLst>
               <a:ext uri="{FF2B5EF4-FFF2-40B4-BE49-F238E27FC236}">
-                <a16:creationId xmlns:a16="http://schemas.microsoft.com/office/drawing/2014/main" id="{EA169775-41C1-4ACF-378E-8ABF1A321ECD}"/>
+                <a16:creationId xmlns:a16="http://schemas.microsoft.com/office/drawing/2014/main" id="{D5876401-AB3A-BA26-810A-E7C8BEC53CDD}"/>
               </a:ext>
             </a:extLst>
           </p:cNvPr>
@@ -8901,7 +8901,7 @@
           <p:cNvPr id="12" name="Hình chữ nhật: Góc Tròn 11">
             <a:extLst>
               <a:ext uri="{FF2B5EF4-FFF2-40B4-BE49-F238E27FC236}">
-                <a16:creationId xmlns:a16="http://schemas.microsoft.com/office/drawing/2014/main" id="{3A1DCA13-8A81-C68E-2BEC-E256E3E04FDC}"/>
+                <a16:creationId xmlns:a16="http://schemas.microsoft.com/office/drawing/2014/main" id="{F7D3E7D4-215E-DAEB-9590-C32CFEAAA742}"/>
               </a:ext>
             </a:extLst>
           </p:cNvPr>
@@ -8969,7 +8969,7 @@
           <p:cNvPr id="13" name="Hình chữ nhật 12">
             <a:extLst>
               <a:ext uri="{FF2B5EF4-FFF2-40B4-BE49-F238E27FC236}">
-                <a16:creationId xmlns:a16="http://schemas.microsoft.com/office/drawing/2014/main" id="{8EBB74EA-59A1-22D3-F7F8-DC530940EA94}"/>
+                <a16:creationId xmlns:a16="http://schemas.microsoft.com/office/drawing/2014/main" id="{A9EA7B6C-6B04-C2B8-572A-39BD3C5A4EB7}"/>
               </a:ext>
             </a:extLst>
           </p:cNvPr>
@@ -9037,7 +9037,7 @@
           <p:cNvPr id="14" name="Hộp Văn bản 13">
             <a:extLst>
               <a:ext uri="{FF2B5EF4-FFF2-40B4-BE49-F238E27FC236}">
-                <a16:creationId xmlns:a16="http://schemas.microsoft.com/office/drawing/2014/main" id="{7D667916-7813-93A9-B271-F896ED1516E9}"/>
+                <a16:creationId xmlns:a16="http://schemas.microsoft.com/office/drawing/2014/main" id="{E2FA6C47-2426-86A6-F6BB-7982A0FB1921}"/>
               </a:ext>
             </a:extLst>
           </p:cNvPr>
@@ -9082,7 +9082,7 @@
           <p:cNvPr id="15" name="Hộp Văn bản 14">
             <a:extLst>
               <a:ext uri="{FF2B5EF4-FFF2-40B4-BE49-F238E27FC236}">
-                <a16:creationId xmlns:a16="http://schemas.microsoft.com/office/drawing/2014/main" id="{3ED6183D-8FB3-045B-500F-B490D77CE984}"/>
+                <a16:creationId xmlns:a16="http://schemas.microsoft.com/office/drawing/2014/main" id="{5055863B-2AD9-30E0-439E-F896D2A7D085}"/>
               </a:ext>
             </a:extLst>
           </p:cNvPr>
@@ -9127,7 +9127,7 @@
           <p:cNvPr id="16" name="Hình chữ nhật: Góc Tròn 15">
             <a:extLst>
               <a:ext uri="{FF2B5EF4-FFF2-40B4-BE49-F238E27FC236}">
-                <a16:creationId xmlns:a16="http://schemas.microsoft.com/office/drawing/2014/main" id="{7AA86AB3-D848-2AB9-230B-3D74F953F424}"/>
+                <a16:creationId xmlns:a16="http://schemas.microsoft.com/office/drawing/2014/main" id="{5600EB0E-7777-3222-46A2-FE976C176AE6}"/>
               </a:ext>
             </a:extLst>
           </p:cNvPr>
@@ -9195,7 +9195,7 @@
           <p:cNvPr id="17" name="Hình chữ nhật 16">
             <a:extLst>
               <a:ext uri="{FF2B5EF4-FFF2-40B4-BE49-F238E27FC236}">
-                <a16:creationId xmlns:a16="http://schemas.microsoft.com/office/drawing/2014/main" id="{6CF058C7-E580-769F-86AF-E434BC6C2B29}"/>
+                <a16:creationId xmlns:a16="http://schemas.microsoft.com/office/drawing/2014/main" id="{5C3C3BA8-6C45-4429-1F1E-179C954C9F17}"/>
               </a:ext>
             </a:extLst>
           </p:cNvPr>
@@ -9263,7 +9263,7 @@
           <p:cNvPr id="18" name="Hộp Văn bản 17">
             <a:extLst>
               <a:ext uri="{FF2B5EF4-FFF2-40B4-BE49-F238E27FC236}">
-                <a16:creationId xmlns:a16="http://schemas.microsoft.com/office/drawing/2014/main" id="{D4DB8DAE-85A0-4783-E6EF-B01F4159FB5E}"/>
+                <a16:creationId xmlns:a16="http://schemas.microsoft.com/office/drawing/2014/main" id="{8F143530-1550-0AF4-084B-2E66E1D7CB2D}"/>
               </a:ext>
             </a:extLst>
           </p:cNvPr>
@@ -9308,7 +9308,7 @@
           <p:cNvPr id="19" name="Hộp Văn bản 18">
             <a:extLst>
               <a:ext uri="{FF2B5EF4-FFF2-40B4-BE49-F238E27FC236}">
-                <a16:creationId xmlns:a16="http://schemas.microsoft.com/office/drawing/2014/main" id="{25F9A628-AF6D-8980-3B71-272F4609260C}"/>
+                <a16:creationId xmlns:a16="http://schemas.microsoft.com/office/drawing/2014/main" id="{236C5D1E-4F25-D654-0EBB-2FAAF104BF60}"/>
               </a:ext>
             </a:extLst>
           </p:cNvPr>
@@ -9353,7 +9353,7 @@
           <p:cNvPr id="20" name="Hộp Văn bản 19">
             <a:extLst>
               <a:ext uri="{FF2B5EF4-FFF2-40B4-BE49-F238E27FC236}">
-                <a16:creationId xmlns:a16="http://schemas.microsoft.com/office/drawing/2014/main" id="{F8C2629B-C9AC-38C3-4C78-BD8013D8A552}"/>
+                <a16:creationId xmlns:a16="http://schemas.microsoft.com/office/drawing/2014/main" id="{ECA439DB-0405-0A8A-04E5-5F674EF5BB13}"/>
               </a:ext>
             </a:extLst>
           </p:cNvPr>
@@ -9398,7 +9398,7 @@
           <p:cNvPr id="21" name="Hộp Văn bản 20">
             <a:extLst>
               <a:ext uri="{FF2B5EF4-FFF2-40B4-BE49-F238E27FC236}">
-                <a16:creationId xmlns:a16="http://schemas.microsoft.com/office/drawing/2014/main" id="{E06BBE36-4306-7591-EB00-E5A2A67230CD}"/>
+                <a16:creationId xmlns:a16="http://schemas.microsoft.com/office/drawing/2014/main" id="{38C46DD8-2A63-3A88-0456-4ABB78129CCB}"/>
               </a:ext>
             </a:extLst>
           </p:cNvPr>
@@ -9507,7 +9507,7 @@
           <p:cNvPr id="22" name="Hình chữ nhật: Góc Tròn 21">
             <a:extLst>
               <a:ext uri="{FF2B5EF4-FFF2-40B4-BE49-F238E27FC236}">
-                <a16:creationId xmlns:a16="http://schemas.microsoft.com/office/drawing/2014/main" id="{2A003D90-04C8-D49C-57F6-5ECC786C8DEE}"/>
+                <a16:creationId xmlns:a16="http://schemas.microsoft.com/office/drawing/2014/main" id="{0DA1E964-FA5F-A1A9-78F3-1941B3D17F6C}"/>
               </a:ext>
             </a:extLst>
           </p:cNvPr>
@@ -9575,7 +9575,7 @@
           <p:cNvPr id="23" name="Hộp Văn bản 22">
             <a:extLst>
               <a:ext uri="{FF2B5EF4-FFF2-40B4-BE49-F238E27FC236}">
-                <a16:creationId xmlns:a16="http://schemas.microsoft.com/office/drawing/2014/main" id="{9C6C5B6B-B30B-91E1-E582-2F3413FCF780}"/>
+                <a16:creationId xmlns:a16="http://schemas.microsoft.com/office/drawing/2014/main" id="{728E3250-0C7B-6D48-63BA-652DBAD18A38}"/>
               </a:ext>
             </a:extLst>
           </p:cNvPr>
@@ -9620,7 +9620,7 @@
           <p:cNvPr id="24" name="Hộp Văn bản 23">
             <a:extLst>
               <a:ext uri="{FF2B5EF4-FFF2-40B4-BE49-F238E27FC236}">
-                <a16:creationId xmlns:a16="http://schemas.microsoft.com/office/drawing/2014/main" id="{AEB7A17B-50D3-23B3-F468-A36BEA9628F3}"/>
+                <a16:creationId xmlns:a16="http://schemas.microsoft.com/office/drawing/2014/main" id="{9D5012B3-337F-3100-4DBC-9422F32A86FA}"/>
               </a:ext>
             </a:extLst>
           </p:cNvPr>
@@ -9663,7 +9663,7 @@
     </p:spTree>
     <p:extLst>
       <p:ext uri="{BB962C8B-B14F-4D97-AF65-F5344CB8AC3E}">
-        <p14:creationId xmlns:p14="http://schemas.microsoft.com/office/powerpoint/2010/main" val="2104000056"/>
+        <p14:creationId xmlns:p14="http://schemas.microsoft.com/office/powerpoint/2010/main" val="3632125080"/>
       </p:ext>
     </p:extLst>
   </p:cSld>
@@ -9695,7 +9695,7 @@
           <p:cNvPr id="2" name="Hộp Văn bản 1">
             <a:extLst>
               <a:ext uri="{FF2B5EF4-FFF2-40B4-BE49-F238E27FC236}">
-                <a16:creationId xmlns:a16="http://schemas.microsoft.com/office/drawing/2014/main" id="{344B9FC7-140F-01CA-579B-FDD4B6112F4F}"/>
+                <a16:creationId xmlns:a16="http://schemas.microsoft.com/office/drawing/2014/main" id="{38244CA0-D5F7-7CE8-3F93-5F95A53A9A39}"/>
               </a:ext>
             </a:extLst>
           </p:cNvPr>
@@ -9740,7 +9740,7 @@
           <p:cNvPr id="3" name="Hộp Văn bản 2">
             <a:extLst>
               <a:ext uri="{FF2B5EF4-FFF2-40B4-BE49-F238E27FC236}">
-                <a16:creationId xmlns:a16="http://schemas.microsoft.com/office/drawing/2014/main" id="{FE902368-D209-5E8A-8243-D87B2F7828FD}"/>
+                <a16:creationId xmlns:a16="http://schemas.microsoft.com/office/drawing/2014/main" id="{1BFF9BB0-FE99-9EB4-D86D-D02E1D1946E2}"/>
               </a:ext>
             </a:extLst>
           </p:cNvPr>
@@ -9785,7 +9785,7 @@
           <p:cNvPr id="4" name="Hộp Văn bản 3">
             <a:extLst>
               <a:ext uri="{FF2B5EF4-FFF2-40B4-BE49-F238E27FC236}">
-                <a16:creationId xmlns:a16="http://schemas.microsoft.com/office/drawing/2014/main" id="{1A7F1A8E-E438-BE9E-93FC-0750CF25D239}"/>
+                <a16:creationId xmlns:a16="http://schemas.microsoft.com/office/drawing/2014/main" id="{935359C5-578F-2C3D-8F12-3248D9034F4A}"/>
               </a:ext>
             </a:extLst>
           </p:cNvPr>
@@ -9830,7 +9830,7 @@
           <p:cNvPr id="5" name="Hình chữ nhật 4">
             <a:extLst>
               <a:ext uri="{FF2B5EF4-FFF2-40B4-BE49-F238E27FC236}">
-                <a16:creationId xmlns:a16="http://schemas.microsoft.com/office/drawing/2014/main" id="{EB6A4D68-D0DB-2AC1-3B6E-2A1668534232}"/>
+                <a16:creationId xmlns:a16="http://schemas.microsoft.com/office/drawing/2014/main" id="{BE64B8AD-8827-E516-7B7B-38DB94BB79D2}"/>
               </a:ext>
             </a:extLst>
           </p:cNvPr>
@@ -9898,7 +9898,7 @@
           <p:cNvPr id="6" name="Hộp Văn bản 5">
             <a:extLst>
               <a:ext uri="{FF2B5EF4-FFF2-40B4-BE49-F238E27FC236}">
-                <a16:creationId xmlns:a16="http://schemas.microsoft.com/office/drawing/2014/main" id="{FB1BC25D-FCD6-AF48-2080-85F790F5CF8D}"/>
+                <a16:creationId xmlns:a16="http://schemas.microsoft.com/office/drawing/2014/main" id="{A3CC8CF4-FCC1-0DA7-C42F-BFDC4C948D6C}"/>
               </a:ext>
             </a:extLst>
           </p:cNvPr>
@@ -9943,7 +9943,7 @@
           <p:cNvPr id="7" name="Hộp Văn bản 6">
             <a:extLst>
               <a:ext uri="{FF2B5EF4-FFF2-40B4-BE49-F238E27FC236}">
-                <a16:creationId xmlns:a16="http://schemas.microsoft.com/office/drawing/2014/main" id="{C70CD58D-38D3-F7D9-BDFA-A1F41A28635B}"/>
+                <a16:creationId xmlns:a16="http://schemas.microsoft.com/office/drawing/2014/main" id="{D8B3889A-062F-1B6B-8A95-4C1BEB76829D}"/>
               </a:ext>
             </a:extLst>
           </p:cNvPr>
@@ -9988,7 +9988,7 @@
           <p:cNvPr id="8" name="Hình chữ nhật: Góc Tròn 7">
             <a:extLst>
               <a:ext uri="{FF2B5EF4-FFF2-40B4-BE49-F238E27FC236}">
-                <a16:creationId xmlns:a16="http://schemas.microsoft.com/office/drawing/2014/main" id="{64911AEF-A719-4AFB-A06B-FF1D4BC63DBB}"/>
+                <a16:creationId xmlns:a16="http://schemas.microsoft.com/office/drawing/2014/main" id="{516F297C-2009-C864-8C7E-D6F416DE5697}"/>
               </a:ext>
             </a:extLst>
           </p:cNvPr>
@@ -10056,7 +10056,7 @@
           <p:cNvPr id="9" name="Hình chữ nhật: Góc Tròn 8">
             <a:extLst>
               <a:ext uri="{FF2B5EF4-FFF2-40B4-BE49-F238E27FC236}">
-                <a16:creationId xmlns:a16="http://schemas.microsoft.com/office/drawing/2014/main" id="{7D2473C1-A61B-32EE-D8CF-D409BD64B238}"/>
+                <a16:creationId xmlns:a16="http://schemas.microsoft.com/office/drawing/2014/main" id="{E1A95ABC-ED99-A375-2F1F-E5FDC922F34C}"/>
               </a:ext>
             </a:extLst>
           </p:cNvPr>
@@ -10124,7 +10124,7 @@
           <p:cNvPr id="10" name="Hộp Văn bản 9">
             <a:extLst>
               <a:ext uri="{FF2B5EF4-FFF2-40B4-BE49-F238E27FC236}">
-                <a16:creationId xmlns:a16="http://schemas.microsoft.com/office/drawing/2014/main" id="{9908751C-AA57-5A11-1DFC-1B0A99A88A8B}"/>
+                <a16:creationId xmlns:a16="http://schemas.microsoft.com/office/drawing/2014/main" id="{7FE796DB-13CF-04E9-E240-C3C3B0E155EE}"/>
               </a:ext>
             </a:extLst>
           </p:cNvPr>
@@ -10169,7 +10169,7 @@
           <p:cNvPr id="11" name="Hộp Văn bản 10">
             <a:extLst>
               <a:ext uri="{FF2B5EF4-FFF2-40B4-BE49-F238E27FC236}">
-                <a16:creationId xmlns:a16="http://schemas.microsoft.com/office/drawing/2014/main" id="{A694CAAD-4C7E-2DE6-2F30-80EC9E8B5C32}"/>
+                <a16:creationId xmlns:a16="http://schemas.microsoft.com/office/drawing/2014/main" id="{E532CBB6-123B-2366-EADA-1E464CFE394B}"/>
               </a:ext>
             </a:extLst>
           </p:cNvPr>
@@ -10214,7 +10214,7 @@
           <p:cNvPr id="12" name="Hình chữ nhật 11">
             <a:extLst>
               <a:ext uri="{FF2B5EF4-FFF2-40B4-BE49-F238E27FC236}">
-                <a16:creationId xmlns:a16="http://schemas.microsoft.com/office/drawing/2014/main" id="{88BDB216-68B7-D6A5-0092-45EF5BCA066F}"/>
+                <a16:creationId xmlns:a16="http://schemas.microsoft.com/office/drawing/2014/main" id="{7AA2EF4D-A9E6-82B4-618D-5EAF565C24AD}"/>
               </a:ext>
             </a:extLst>
           </p:cNvPr>
@@ -10282,7 +10282,7 @@
           <p:cNvPr id="13" name="Hình chữ nhật: Góc Tròn 12">
             <a:extLst>
               <a:ext uri="{FF2B5EF4-FFF2-40B4-BE49-F238E27FC236}">
-                <a16:creationId xmlns:a16="http://schemas.microsoft.com/office/drawing/2014/main" id="{55070CD1-BA74-25D6-6FF9-D0B7246B46CF}"/>
+                <a16:creationId xmlns:a16="http://schemas.microsoft.com/office/drawing/2014/main" id="{D0FAEC8A-5BB4-3229-3A3C-33EC889301A1}"/>
               </a:ext>
             </a:extLst>
           </p:cNvPr>
@@ -10350,7 +10350,7 @@
           <p:cNvPr id="14" name="Hình chữ nhật: Góc Tròn 13">
             <a:extLst>
               <a:ext uri="{FF2B5EF4-FFF2-40B4-BE49-F238E27FC236}">
-                <a16:creationId xmlns:a16="http://schemas.microsoft.com/office/drawing/2014/main" id="{315C01A5-D811-D0C4-2952-C37BB4641129}"/>
+                <a16:creationId xmlns:a16="http://schemas.microsoft.com/office/drawing/2014/main" id="{1C67D886-03CD-748D-4E4C-AFE8583FFDDD}"/>
               </a:ext>
             </a:extLst>
           </p:cNvPr>
@@ -10418,7 +10418,7 @@
           <p:cNvPr id="15" name="Hộp Văn bản 14">
             <a:extLst>
               <a:ext uri="{FF2B5EF4-FFF2-40B4-BE49-F238E27FC236}">
-                <a16:creationId xmlns:a16="http://schemas.microsoft.com/office/drawing/2014/main" id="{7914E27F-286E-1980-B395-815CFB600452}"/>
+                <a16:creationId xmlns:a16="http://schemas.microsoft.com/office/drawing/2014/main" id="{57B97442-4C6B-2E72-7B26-7FC58A67EAE5}"/>
               </a:ext>
             </a:extLst>
           </p:cNvPr>
@@ -10463,7 +10463,7 @@
           <p:cNvPr id="16" name="Hộp Văn bản 15">
             <a:extLst>
               <a:ext uri="{FF2B5EF4-FFF2-40B4-BE49-F238E27FC236}">
-                <a16:creationId xmlns:a16="http://schemas.microsoft.com/office/drawing/2014/main" id="{4E3EEC88-5E9B-006C-054A-B5AB21AA97B0}"/>
+                <a16:creationId xmlns:a16="http://schemas.microsoft.com/office/drawing/2014/main" id="{F16DFA7C-0192-9D75-ABFF-306495A074EE}"/>
               </a:ext>
             </a:extLst>
           </p:cNvPr>
@@ -10508,7 +10508,7 @@
           <p:cNvPr id="17" name="Hình chữ nhật 16">
             <a:extLst>
               <a:ext uri="{FF2B5EF4-FFF2-40B4-BE49-F238E27FC236}">
-                <a16:creationId xmlns:a16="http://schemas.microsoft.com/office/drawing/2014/main" id="{0015EC4C-8616-8C2E-05F1-8D72F813F93E}"/>
+                <a16:creationId xmlns:a16="http://schemas.microsoft.com/office/drawing/2014/main" id="{972201A7-497A-DEB8-5B17-70CBFE59838B}"/>
               </a:ext>
             </a:extLst>
           </p:cNvPr>
@@ -10576,7 +10576,7 @@
           <p:cNvPr id="18" name="Hình chữ nhật: Góc Tròn 17">
             <a:extLst>
               <a:ext uri="{FF2B5EF4-FFF2-40B4-BE49-F238E27FC236}">
-                <a16:creationId xmlns:a16="http://schemas.microsoft.com/office/drawing/2014/main" id="{95E7D419-AF2D-B2C9-5B9D-5A1B3C8EEDC9}"/>
+                <a16:creationId xmlns:a16="http://schemas.microsoft.com/office/drawing/2014/main" id="{032915D6-A3F4-2EDC-63CC-6B1358B85D78}"/>
               </a:ext>
             </a:extLst>
           </p:cNvPr>
@@ -10644,7 +10644,7 @@
           <p:cNvPr id="19" name="Hình chữ nhật: Góc Tròn 18">
             <a:extLst>
               <a:ext uri="{FF2B5EF4-FFF2-40B4-BE49-F238E27FC236}">
-                <a16:creationId xmlns:a16="http://schemas.microsoft.com/office/drawing/2014/main" id="{1C7AF97D-19B2-583D-5795-13C0C012680D}"/>
+                <a16:creationId xmlns:a16="http://schemas.microsoft.com/office/drawing/2014/main" id="{AEBA5B49-F20C-48B4-AB06-54FE825B8CED}"/>
               </a:ext>
             </a:extLst>
           </p:cNvPr>
@@ -10712,7 +10712,7 @@
           <p:cNvPr id="20" name="Hộp Văn bản 19">
             <a:extLst>
               <a:ext uri="{FF2B5EF4-FFF2-40B4-BE49-F238E27FC236}">
-                <a16:creationId xmlns:a16="http://schemas.microsoft.com/office/drawing/2014/main" id="{16E9C3F6-54F4-BF91-932D-72023098B700}"/>
+                <a16:creationId xmlns:a16="http://schemas.microsoft.com/office/drawing/2014/main" id="{1E589F57-C4E1-0AC5-A4D4-C3DFBB80B387}"/>
               </a:ext>
             </a:extLst>
           </p:cNvPr>
@@ -10757,7 +10757,7 @@
           <p:cNvPr id="21" name="Hộp Văn bản 20">
             <a:extLst>
               <a:ext uri="{FF2B5EF4-FFF2-40B4-BE49-F238E27FC236}">
-                <a16:creationId xmlns:a16="http://schemas.microsoft.com/office/drawing/2014/main" id="{0F276444-D19A-3B4A-3B1C-5073B56CA3AC}"/>
+                <a16:creationId xmlns:a16="http://schemas.microsoft.com/office/drawing/2014/main" id="{F2939DE5-CCB9-7BA6-7CE5-2B91D5533755}"/>
               </a:ext>
             </a:extLst>
           </p:cNvPr>
@@ -10802,7 +10802,7 @@
           <p:cNvPr id="22" name="Hình chữ nhật 21">
             <a:extLst>
               <a:ext uri="{FF2B5EF4-FFF2-40B4-BE49-F238E27FC236}">
-                <a16:creationId xmlns:a16="http://schemas.microsoft.com/office/drawing/2014/main" id="{132AF42B-9040-87C8-4442-DD9196D572AB}"/>
+                <a16:creationId xmlns:a16="http://schemas.microsoft.com/office/drawing/2014/main" id="{5AC1E15E-6669-73DE-DAA5-639A63EA9A86}"/>
               </a:ext>
             </a:extLst>
           </p:cNvPr>
@@ -10870,7 +10870,7 @@
           <p:cNvPr id="23" name="Hình chữ nhật: Góc Tròn 22">
             <a:extLst>
               <a:ext uri="{FF2B5EF4-FFF2-40B4-BE49-F238E27FC236}">
-                <a16:creationId xmlns:a16="http://schemas.microsoft.com/office/drawing/2014/main" id="{D66F8E61-7CC1-4C58-6E0D-D3B4805A831F}"/>
+                <a16:creationId xmlns:a16="http://schemas.microsoft.com/office/drawing/2014/main" id="{E0873CDF-D2B1-AFC5-2615-30A5BAA5F20B}"/>
               </a:ext>
             </a:extLst>
           </p:cNvPr>
@@ -10938,7 +10938,7 @@
           <p:cNvPr id="24" name="Hình chữ nhật: Góc Tròn 23">
             <a:extLst>
               <a:ext uri="{FF2B5EF4-FFF2-40B4-BE49-F238E27FC236}">
-                <a16:creationId xmlns:a16="http://schemas.microsoft.com/office/drawing/2014/main" id="{AA2EC251-3C18-C37B-FD7C-F126001D28BC}"/>
+                <a16:creationId xmlns:a16="http://schemas.microsoft.com/office/drawing/2014/main" id="{F12986C4-96B4-4DFE-6621-B1C836B6AFBC}"/>
               </a:ext>
             </a:extLst>
           </p:cNvPr>
@@ -11006,7 +11006,7 @@
           <p:cNvPr id="25" name="Hộp Văn bản 24">
             <a:extLst>
               <a:ext uri="{FF2B5EF4-FFF2-40B4-BE49-F238E27FC236}">
-                <a16:creationId xmlns:a16="http://schemas.microsoft.com/office/drawing/2014/main" id="{DB6CA56F-F40C-7E26-13AF-305612103C3A}"/>
+                <a16:creationId xmlns:a16="http://schemas.microsoft.com/office/drawing/2014/main" id="{40ED7439-87DE-3A51-4A53-03051E92714D}"/>
               </a:ext>
             </a:extLst>
           </p:cNvPr>
@@ -11051,7 +11051,7 @@
           <p:cNvPr id="26" name="Hộp Văn bản 25">
             <a:extLst>
               <a:ext uri="{FF2B5EF4-FFF2-40B4-BE49-F238E27FC236}">
-                <a16:creationId xmlns:a16="http://schemas.microsoft.com/office/drawing/2014/main" id="{5D4E59C0-63BC-C40B-1BD4-5C657DFD99DF}"/>
+                <a16:creationId xmlns:a16="http://schemas.microsoft.com/office/drawing/2014/main" id="{58F98B56-C135-3549-44E6-19D4208ABEAD}"/>
               </a:ext>
             </a:extLst>
           </p:cNvPr>
@@ -11096,7 +11096,7 @@
           <p:cNvPr id="27" name="Hình chữ nhật: Góc Tròn 26">
             <a:extLst>
               <a:ext uri="{FF2B5EF4-FFF2-40B4-BE49-F238E27FC236}">
-                <a16:creationId xmlns:a16="http://schemas.microsoft.com/office/drawing/2014/main" id="{27B7B76D-F22C-1B32-E3CD-51498D06D3E0}"/>
+                <a16:creationId xmlns:a16="http://schemas.microsoft.com/office/drawing/2014/main" id="{AF23C604-1C65-0B5D-504B-237CD0263CCC}"/>
               </a:ext>
             </a:extLst>
           </p:cNvPr>
@@ -11164,7 +11164,7 @@
           <p:cNvPr id="28" name="Hộp Văn bản 27">
             <a:extLst>
               <a:ext uri="{FF2B5EF4-FFF2-40B4-BE49-F238E27FC236}">
-                <a16:creationId xmlns:a16="http://schemas.microsoft.com/office/drawing/2014/main" id="{85973A08-7338-9775-C153-EAE728D1C71D}"/>
+                <a16:creationId xmlns:a16="http://schemas.microsoft.com/office/drawing/2014/main" id="{C0B8FCA0-8042-0DF4-398E-A830A403DF72}"/>
               </a:ext>
             </a:extLst>
           </p:cNvPr>
@@ -11207,7 +11207,7 @@
     </p:spTree>
     <p:extLst>
       <p:ext uri="{BB962C8B-B14F-4D97-AF65-F5344CB8AC3E}">
-        <p14:creationId xmlns:p14="http://schemas.microsoft.com/office/powerpoint/2010/main" val="3011604297"/>
+        <p14:creationId xmlns:p14="http://schemas.microsoft.com/office/powerpoint/2010/main" val="3359720705"/>
       </p:ext>
     </p:extLst>
   </p:cSld>
@@ -11239,7 +11239,7 @@
           <p:cNvPr id="2" name="Hộp Văn bản 1">
             <a:extLst>
               <a:ext uri="{FF2B5EF4-FFF2-40B4-BE49-F238E27FC236}">
-                <a16:creationId xmlns:a16="http://schemas.microsoft.com/office/drawing/2014/main" id="{B0C2518D-F384-A648-0B5C-6703E2396641}"/>
+                <a16:creationId xmlns:a16="http://schemas.microsoft.com/office/drawing/2014/main" id="{2390DD3D-9524-1EFF-9AA8-D27583A44290}"/>
               </a:ext>
             </a:extLst>
           </p:cNvPr>
@@ -11284,7 +11284,7 @@
           <p:cNvPr id="3" name="Hộp Văn bản 2">
             <a:extLst>
               <a:ext uri="{FF2B5EF4-FFF2-40B4-BE49-F238E27FC236}">
-                <a16:creationId xmlns:a16="http://schemas.microsoft.com/office/drawing/2014/main" id="{A8A0FE64-9D31-DEB8-64D7-EDE3359B9D54}"/>
+                <a16:creationId xmlns:a16="http://schemas.microsoft.com/office/drawing/2014/main" id="{D9820D2F-8653-865F-F6D2-8E1BD7DF52AD}"/>
               </a:ext>
             </a:extLst>
           </p:cNvPr>
@@ -11329,7 +11329,7 @@
           <p:cNvPr id="4" name="Hộp Văn bản 3">
             <a:extLst>
               <a:ext uri="{FF2B5EF4-FFF2-40B4-BE49-F238E27FC236}">
-                <a16:creationId xmlns:a16="http://schemas.microsoft.com/office/drawing/2014/main" id="{04041161-32DE-BB44-589B-7AF62AC7ACC1}"/>
+                <a16:creationId xmlns:a16="http://schemas.microsoft.com/office/drawing/2014/main" id="{173D6185-40E0-9632-CD78-21CAC7BB109B}"/>
               </a:ext>
             </a:extLst>
           </p:cNvPr>
@@ -11374,7 +11374,7 @@
           <p:cNvPr id="5" name="Hình chữ nhật 4">
             <a:extLst>
               <a:ext uri="{FF2B5EF4-FFF2-40B4-BE49-F238E27FC236}">
-                <a16:creationId xmlns:a16="http://schemas.microsoft.com/office/drawing/2014/main" id="{955C9739-91C0-205C-6EF4-13890CE44D9F}"/>
+                <a16:creationId xmlns:a16="http://schemas.microsoft.com/office/drawing/2014/main" id="{181C17CE-17C3-A79E-5ED8-6451DB017080}"/>
               </a:ext>
             </a:extLst>
           </p:cNvPr>
@@ -11442,7 +11442,7 @@
           <p:cNvPr id="6" name="Hộp Văn bản 5">
             <a:extLst>
               <a:ext uri="{FF2B5EF4-FFF2-40B4-BE49-F238E27FC236}">
-                <a16:creationId xmlns:a16="http://schemas.microsoft.com/office/drawing/2014/main" id="{64CE3EEC-C38C-E0C0-05D1-2E601289F396}"/>
+                <a16:creationId xmlns:a16="http://schemas.microsoft.com/office/drawing/2014/main" id="{4DB6B301-F13F-817F-9A17-2D5576C18A7F}"/>
               </a:ext>
             </a:extLst>
           </p:cNvPr>
@@ -11487,7 +11487,7 @@
           <p:cNvPr id="7" name="Hộp Văn bản 6">
             <a:extLst>
               <a:ext uri="{FF2B5EF4-FFF2-40B4-BE49-F238E27FC236}">
-                <a16:creationId xmlns:a16="http://schemas.microsoft.com/office/drawing/2014/main" id="{6A3B005A-AD32-F87B-4086-A9D56D96C030}"/>
+                <a16:creationId xmlns:a16="http://schemas.microsoft.com/office/drawing/2014/main" id="{0EE29240-6A5C-C476-C04F-80D7260A81D5}"/>
               </a:ext>
             </a:extLst>
           </p:cNvPr>
@@ -11532,7 +11532,7 @@
           <p:cNvPr id="8" name="Hình chữ nhật: Góc Tròn 7">
             <a:extLst>
               <a:ext uri="{FF2B5EF4-FFF2-40B4-BE49-F238E27FC236}">
-                <a16:creationId xmlns:a16="http://schemas.microsoft.com/office/drawing/2014/main" id="{85821BD9-4752-4C6F-8898-7C2481A87448}"/>
+                <a16:creationId xmlns:a16="http://schemas.microsoft.com/office/drawing/2014/main" id="{7D716F6E-45D2-D585-25FF-B909240D992D}"/>
               </a:ext>
             </a:extLst>
           </p:cNvPr>
@@ -11600,7 +11600,7 @@
           <p:cNvPr id="9" name="Hộp Văn bản 8">
             <a:extLst>
               <a:ext uri="{FF2B5EF4-FFF2-40B4-BE49-F238E27FC236}">
-                <a16:creationId xmlns:a16="http://schemas.microsoft.com/office/drawing/2014/main" id="{9865EDE7-6624-6DEA-D3B4-D85DE9F2C584}"/>
+                <a16:creationId xmlns:a16="http://schemas.microsoft.com/office/drawing/2014/main" id="{A3714D84-51C7-000E-9F67-4DFADBF75406}"/>
               </a:ext>
             </a:extLst>
           </p:cNvPr>
@@ -11645,7 +11645,7 @@
           <p:cNvPr id="10" name="Hộp Văn bản 9">
             <a:extLst>
               <a:ext uri="{FF2B5EF4-FFF2-40B4-BE49-F238E27FC236}">
-                <a16:creationId xmlns:a16="http://schemas.microsoft.com/office/drawing/2014/main" id="{F33B4669-006E-3D07-AE11-5E5DFB738599}"/>
+                <a16:creationId xmlns:a16="http://schemas.microsoft.com/office/drawing/2014/main" id="{5B7EB787-2EE4-CBC7-5A12-CA87CCD3AB50}"/>
               </a:ext>
             </a:extLst>
           </p:cNvPr>
@@ -11706,7 +11706,7 @@
           <p:cNvPr id="11" name="Hình chữ nhật: Góc Tròn 10">
             <a:extLst>
               <a:ext uri="{FF2B5EF4-FFF2-40B4-BE49-F238E27FC236}">
-                <a16:creationId xmlns:a16="http://schemas.microsoft.com/office/drawing/2014/main" id="{9CD4BA17-2DE5-CBED-EC87-2024D9248A82}"/>
+                <a16:creationId xmlns:a16="http://schemas.microsoft.com/office/drawing/2014/main" id="{A538FD32-F1FC-9786-6FD0-A38E2B5F3E3F}"/>
               </a:ext>
             </a:extLst>
           </p:cNvPr>
@@ -11774,7 +11774,7 @@
           <p:cNvPr id="12" name="Hộp Văn bản 11">
             <a:extLst>
               <a:ext uri="{FF2B5EF4-FFF2-40B4-BE49-F238E27FC236}">
-                <a16:creationId xmlns:a16="http://schemas.microsoft.com/office/drawing/2014/main" id="{8E741078-24CE-5D39-EB5C-546FF1E29797}"/>
+                <a16:creationId xmlns:a16="http://schemas.microsoft.com/office/drawing/2014/main" id="{8F037C5B-0AB6-A12B-FA07-69A0B240A57E}"/>
               </a:ext>
             </a:extLst>
           </p:cNvPr>
@@ -11819,7 +11819,7 @@
           <p:cNvPr id="13" name="Hộp Văn bản 12">
             <a:extLst>
               <a:ext uri="{FF2B5EF4-FFF2-40B4-BE49-F238E27FC236}">
-                <a16:creationId xmlns:a16="http://schemas.microsoft.com/office/drawing/2014/main" id="{47309369-9DA9-EB16-7844-3E6735DB6983}"/>
+                <a16:creationId xmlns:a16="http://schemas.microsoft.com/office/drawing/2014/main" id="{B1E37B54-8841-D340-9357-CFC7A14FF261}"/>
               </a:ext>
             </a:extLst>
           </p:cNvPr>
@@ -11886,7 +11886,7 @@
           <p:cNvPr id="14" name="Hình chữ nhật: Góc Tròn 13">
             <a:extLst>
               <a:ext uri="{FF2B5EF4-FFF2-40B4-BE49-F238E27FC236}">
-                <a16:creationId xmlns:a16="http://schemas.microsoft.com/office/drawing/2014/main" id="{3F3AF5AF-D6CA-F308-14FD-DB40B9636CB0}"/>
+                <a16:creationId xmlns:a16="http://schemas.microsoft.com/office/drawing/2014/main" id="{DBBF36DD-D8F7-ED7E-EAC1-7B4970B348AF}"/>
               </a:ext>
             </a:extLst>
           </p:cNvPr>
@@ -11954,7 +11954,7 @@
           <p:cNvPr id="15" name="Hộp Văn bản 14">
             <a:extLst>
               <a:ext uri="{FF2B5EF4-FFF2-40B4-BE49-F238E27FC236}">
-                <a16:creationId xmlns:a16="http://schemas.microsoft.com/office/drawing/2014/main" id="{26A90DC8-0E83-8FB8-8956-83948FB125AE}"/>
+                <a16:creationId xmlns:a16="http://schemas.microsoft.com/office/drawing/2014/main" id="{CEB009C8-1A96-427A-F4A2-EC8328C16AE8}"/>
               </a:ext>
             </a:extLst>
           </p:cNvPr>
@@ -11999,7 +11999,7 @@
           <p:cNvPr id="16" name="Hộp Văn bản 15">
             <a:extLst>
               <a:ext uri="{FF2B5EF4-FFF2-40B4-BE49-F238E27FC236}">
-                <a16:creationId xmlns:a16="http://schemas.microsoft.com/office/drawing/2014/main" id="{6A362511-B3AD-6339-60EB-D44FFC4B1AEB}"/>
+                <a16:creationId xmlns:a16="http://schemas.microsoft.com/office/drawing/2014/main" id="{0D35C39A-1E5B-76C2-967D-8800CF079180}"/>
               </a:ext>
             </a:extLst>
           </p:cNvPr>
@@ -12060,7 +12060,7 @@
           <p:cNvPr id="17" name="Hình chữ nhật 16">
             <a:extLst>
               <a:ext uri="{FF2B5EF4-FFF2-40B4-BE49-F238E27FC236}">
-                <a16:creationId xmlns:a16="http://schemas.microsoft.com/office/drawing/2014/main" id="{4E4B6440-0E4C-D584-48E6-213A167A2BCF}"/>
+                <a16:creationId xmlns:a16="http://schemas.microsoft.com/office/drawing/2014/main" id="{3FB3F9B3-B206-A2C3-DB08-115B83F4DA0C}"/>
               </a:ext>
             </a:extLst>
           </p:cNvPr>
@@ -12128,7 +12128,7 @@
           <p:cNvPr id="18" name="Hình chữ nhật 17">
             <a:extLst>
               <a:ext uri="{FF2B5EF4-FFF2-40B4-BE49-F238E27FC236}">
-                <a16:creationId xmlns:a16="http://schemas.microsoft.com/office/drawing/2014/main" id="{940F5202-62BF-B584-248F-FB8DEC398A89}"/>
+                <a16:creationId xmlns:a16="http://schemas.microsoft.com/office/drawing/2014/main" id="{4CB3F7CF-E76D-EF92-7227-5FAB2F065AB4}"/>
               </a:ext>
             </a:extLst>
           </p:cNvPr>
@@ -12196,7 +12196,7 @@
           <p:cNvPr id="19" name="Hình chữ nhật: Góc Tròn 18">
             <a:extLst>
               <a:ext uri="{FF2B5EF4-FFF2-40B4-BE49-F238E27FC236}">
-                <a16:creationId xmlns:a16="http://schemas.microsoft.com/office/drawing/2014/main" id="{FCDA23FC-2C20-B4AE-CFB3-36CB44396DC5}"/>
+                <a16:creationId xmlns:a16="http://schemas.microsoft.com/office/drawing/2014/main" id="{48B5BB92-F02B-04C4-7745-CDFD4A35BF50}"/>
               </a:ext>
             </a:extLst>
           </p:cNvPr>
@@ -12264,7 +12264,7 @@
           <p:cNvPr id="20" name="Hình chữ nhật 19">
             <a:extLst>
               <a:ext uri="{FF2B5EF4-FFF2-40B4-BE49-F238E27FC236}">
-                <a16:creationId xmlns:a16="http://schemas.microsoft.com/office/drawing/2014/main" id="{3A923739-6F07-19D5-53A8-9ACF90E48A3E}"/>
+                <a16:creationId xmlns:a16="http://schemas.microsoft.com/office/drawing/2014/main" id="{629B4117-BDE4-6D21-DEE3-D9F40F463976}"/>
               </a:ext>
             </a:extLst>
           </p:cNvPr>
@@ -12332,7 +12332,7 @@
           <p:cNvPr id="21" name="Hộp Văn bản 20">
             <a:extLst>
               <a:ext uri="{FF2B5EF4-FFF2-40B4-BE49-F238E27FC236}">
-                <a16:creationId xmlns:a16="http://schemas.microsoft.com/office/drawing/2014/main" id="{2EE4A54B-130A-8396-FC9E-06F6C8E18C96}"/>
+                <a16:creationId xmlns:a16="http://schemas.microsoft.com/office/drawing/2014/main" id="{9AAB1676-F653-2BCF-CDBA-E7D8D1D388CF}"/>
               </a:ext>
             </a:extLst>
           </p:cNvPr>
@@ -12377,7 +12377,7 @@
           <p:cNvPr id="22" name="Hộp Văn bản 21">
             <a:extLst>
               <a:ext uri="{FF2B5EF4-FFF2-40B4-BE49-F238E27FC236}">
-                <a16:creationId xmlns:a16="http://schemas.microsoft.com/office/drawing/2014/main" id="{8407C79D-BCD0-9B4E-D001-4276CA0C35FA}"/>
+                <a16:creationId xmlns:a16="http://schemas.microsoft.com/office/drawing/2014/main" id="{07F6FFB5-1A16-5BB0-C565-A2B1E9DA6549}"/>
               </a:ext>
             </a:extLst>
           </p:cNvPr>
@@ -12422,7 +12422,7 @@
           <p:cNvPr id="23" name="Hình chữ nhật: Góc Tròn 22">
             <a:extLst>
               <a:ext uri="{FF2B5EF4-FFF2-40B4-BE49-F238E27FC236}">
-                <a16:creationId xmlns:a16="http://schemas.microsoft.com/office/drawing/2014/main" id="{79ABB6E6-73F1-5F14-CD07-61192375DB07}"/>
+                <a16:creationId xmlns:a16="http://schemas.microsoft.com/office/drawing/2014/main" id="{B5FA6A7C-B724-0CC4-3B3C-931BB25165E6}"/>
               </a:ext>
             </a:extLst>
           </p:cNvPr>
@@ -12490,7 +12490,7 @@
           <p:cNvPr id="24" name="Hình chữ nhật 23">
             <a:extLst>
               <a:ext uri="{FF2B5EF4-FFF2-40B4-BE49-F238E27FC236}">
-                <a16:creationId xmlns:a16="http://schemas.microsoft.com/office/drawing/2014/main" id="{5877B74F-0A6B-E0EA-B213-CAB9CDBCC655}"/>
+                <a16:creationId xmlns:a16="http://schemas.microsoft.com/office/drawing/2014/main" id="{9C436879-3D9C-D482-596F-115BCDE9F727}"/>
               </a:ext>
             </a:extLst>
           </p:cNvPr>
@@ -12558,7 +12558,7 @@
           <p:cNvPr id="25" name="Hộp Văn bản 24">
             <a:extLst>
               <a:ext uri="{FF2B5EF4-FFF2-40B4-BE49-F238E27FC236}">
-                <a16:creationId xmlns:a16="http://schemas.microsoft.com/office/drawing/2014/main" id="{1645C8A5-2A33-725F-2BC4-9BF3E523DCBF}"/>
+                <a16:creationId xmlns:a16="http://schemas.microsoft.com/office/drawing/2014/main" id="{079D4953-E533-D213-3E2D-80477663392A}"/>
               </a:ext>
             </a:extLst>
           </p:cNvPr>
@@ -12603,7 +12603,7 @@
           <p:cNvPr id="26" name="Hộp Văn bản 25">
             <a:extLst>
               <a:ext uri="{FF2B5EF4-FFF2-40B4-BE49-F238E27FC236}">
-                <a16:creationId xmlns:a16="http://schemas.microsoft.com/office/drawing/2014/main" id="{156A474C-CBC3-11C7-9D1A-8B0D2C41A06D}"/>
+                <a16:creationId xmlns:a16="http://schemas.microsoft.com/office/drawing/2014/main" id="{2BF199A5-A54C-6B40-6415-0239F5890A1F}"/>
               </a:ext>
             </a:extLst>
           </p:cNvPr>
@@ -12648,7 +12648,7 @@
           <p:cNvPr id="27" name="Hình chữ nhật: Góc Tròn 26">
             <a:extLst>
               <a:ext uri="{FF2B5EF4-FFF2-40B4-BE49-F238E27FC236}">
-                <a16:creationId xmlns:a16="http://schemas.microsoft.com/office/drawing/2014/main" id="{AB2E5F9C-337F-65BE-FAAD-62C53B87CAFA}"/>
+                <a16:creationId xmlns:a16="http://schemas.microsoft.com/office/drawing/2014/main" id="{82F93438-EC9C-B87D-EC49-4ECC641CA5BB}"/>
               </a:ext>
             </a:extLst>
           </p:cNvPr>
@@ -12716,7 +12716,7 @@
           <p:cNvPr id="28" name="Hình chữ nhật 27">
             <a:extLst>
               <a:ext uri="{FF2B5EF4-FFF2-40B4-BE49-F238E27FC236}">
-                <a16:creationId xmlns:a16="http://schemas.microsoft.com/office/drawing/2014/main" id="{F03847C2-9D2C-81B8-93C8-0C0E7CE9C7FF}"/>
+                <a16:creationId xmlns:a16="http://schemas.microsoft.com/office/drawing/2014/main" id="{29727C1E-90E0-5223-2B71-127C78ADA073}"/>
               </a:ext>
             </a:extLst>
           </p:cNvPr>
@@ -12784,7 +12784,7 @@
           <p:cNvPr id="29" name="Hộp Văn bản 28">
             <a:extLst>
               <a:ext uri="{FF2B5EF4-FFF2-40B4-BE49-F238E27FC236}">
-                <a16:creationId xmlns:a16="http://schemas.microsoft.com/office/drawing/2014/main" id="{CDC9F63F-B6FD-8861-0F9C-5F202BBDBF3C}"/>
+                <a16:creationId xmlns:a16="http://schemas.microsoft.com/office/drawing/2014/main" id="{430D044D-9178-5A1B-5358-99A133EEA636}"/>
               </a:ext>
             </a:extLst>
           </p:cNvPr>
@@ -12829,7 +12829,7 @@
           <p:cNvPr id="30" name="Hộp Văn bản 29">
             <a:extLst>
               <a:ext uri="{FF2B5EF4-FFF2-40B4-BE49-F238E27FC236}">
-                <a16:creationId xmlns:a16="http://schemas.microsoft.com/office/drawing/2014/main" id="{FEEC45E3-9124-DE5B-A045-384CFE9E55C6}"/>
+                <a16:creationId xmlns:a16="http://schemas.microsoft.com/office/drawing/2014/main" id="{B6DB73E0-46BE-327D-EBAD-2B37AA8D21FF}"/>
               </a:ext>
             </a:extLst>
           </p:cNvPr>
@@ -12872,7 +12872,7 @@
     </p:spTree>
     <p:extLst>
       <p:ext uri="{BB962C8B-B14F-4D97-AF65-F5344CB8AC3E}">
-        <p14:creationId xmlns:p14="http://schemas.microsoft.com/office/powerpoint/2010/main" val="2862947079"/>
+        <p14:creationId xmlns:p14="http://schemas.microsoft.com/office/powerpoint/2010/main" val="1596897759"/>
       </p:ext>
     </p:extLst>
   </p:cSld>
@@ -12904,7 +12904,7 @@
           <p:cNvPr id="2" name="Hộp Văn bản 1">
             <a:extLst>
               <a:ext uri="{FF2B5EF4-FFF2-40B4-BE49-F238E27FC236}">
-                <a16:creationId xmlns:a16="http://schemas.microsoft.com/office/drawing/2014/main" id="{2DE5EB80-3D1D-C01A-89D9-8B7DEC572EA2}"/>
+                <a16:creationId xmlns:a16="http://schemas.microsoft.com/office/drawing/2014/main" id="{B42CDD61-1561-14F5-15F4-05F9ED174049}"/>
               </a:ext>
             </a:extLst>
           </p:cNvPr>
@@ -12949,7 +12949,7 @@
           <p:cNvPr id="3" name="Hộp Văn bản 2">
             <a:extLst>
               <a:ext uri="{FF2B5EF4-FFF2-40B4-BE49-F238E27FC236}">
-                <a16:creationId xmlns:a16="http://schemas.microsoft.com/office/drawing/2014/main" id="{12C30E22-B787-DA4B-E23F-BEEFD7D9CBEB}"/>
+                <a16:creationId xmlns:a16="http://schemas.microsoft.com/office/drawing/2014/main" id="{56CBA7C4-7E20-0958-F7BE-314AEDC3E27D}"/>
               </a:ext>
             </a:extLst>
           </p:cNvPr>
@@ -12994,7 +12994,7 @@
           <p:cNvPr id="4" name="Hộp Văn bản 3">
             <a:extLst>
               <a:ext uri="{FF2B5EF4-FFF2-40B4-BE49-F238E27FC236}">
-                <a16:creationId xmlns:a16="http://schemas.microsoft.com/office/drawing/2014/main" id="{CD7647F3-65A9-6907-F005-2A3A2F171A00}"/>
+                <a16:creationId xmlns:a16="http://schemas.microsoft.com/office/drawing/2014/main" id="{9FE61CE6-0A5C-740F-E122-E32A10249043}"/>
               </a:ext>
             </a:extLst>
           </p:cNvPr>
@@ -13039,7 +13039,7 @@
           <p:cNvPr id="5" name="Hình chữ nhật 4">
             <a:extLst>
               <a:ext uri="{FF2B5EF4-FFF2-40B4-BE49-F238E27FC236}">
-                <a16:creationId xmlns:a16="http://schemas.microsoft.com/office/drawing/2014/main" id="{ABCC6146-4DAE-FE4E-F08B-898BBB5D115C}"/>
+                <a16:creationId xmlns:a16="http://schemas.microsoft.com/office/drawing/2014/main" id="{36E865FA-28F5-C901-050E-D5A72509B9D1}"/>
               </a:ext>
             </a:extLst>
           </p:cNvPr>
@@ -13107,7 +13107,7 @@
           <p:cNvPr id="6" name="Hộp Văn bản 5">
             <a:extLst>
               <a:ext uri="{FF2B5EF4-FFF2-40B4-BE49-F238E27FC236}">
-                <a16:creationId xmlns:a16="http://schemas.microsoft.com/office/drawing/2014/main" id="{0497B27B-4918-0C34-74A7-A3742ED3EB71}"/>
+                <a16:creationId xmlns:a16="http://schemas.microsoft.com/office/drawing/2014/main" id="{00EE38E1-41D3-E19D-797E-6C97956757B3}"/>
               </a:ext>
             </a:extLst>
           </p:cNvPr>
@@ -13152,7 +13152,7 @@
           <p:cNvPr id="7" name="Hộp Văn bản 6">
             <a:extLst>
               <a:ext uri="{FF2B5EF4-FFF2-40B4-BE49-F238E27FC236}">
-                <a16:creationId xmlns:a16="http://schemas.microsoft.com/office/drawing/2014/main" id="{BE74110E-6A47-2DD5-C3D7-DB013C7223F7}"/>
+                <a16:creationId xmlns:a16="http://schemas.microsoft.com/office/drawing/2014/main" id="{D64DEE08-C593-FBCF-3D5F-023ABDD89DAE}"/>
               </a:ext>
             </a:extLst>
           </p:cNvPr>
@@ -13197,7 +13197,7 @@
           <p:cNvPr id="8" name="Hình chữ nhật: Góc Tròn 7">
             <a:extLst>
               <a:ext uri="{FF2B5EF4-FFF2-40B4-BE49-F238E27FC236}">
-                <a16:creationId xmlns:a16="http://schemas.microsoft.com/office/drawing/2014/main" id="{5B897797-324F-6D50-704A-A7F5A4329B69}"/>
+                <a16:creationId xmlns:a16="http://schemas.microsoft.com/office/drawing/2014/main" id="{E8123765-C7DB-23BD-45D6-FEAAFA309D55}"/>
               </a:ext>
             </a:extLst>
           </p:cNvPr>
@@ -13265,7 +13265,7 @@
           <p:cNvPr id="9" name="Hình chữ nhật 8">
             <a:extLst>
               <a:ext uri="{FF2B5EF4-FFF2-40B4-BE49-F238E27FC236}">
-                <a16:creationId xmlns:a16="http://schemas.microsoft.com/office/drawing/2014/main" id="{886E548B-97F1-D11C-9D8E-A1E1C60FF65C}"/>
+                <a16:creationId xmlns:a16="http://schemas.microsoft.com/office/drawing/2014/main" id="{7F8B8B17-46BE-7EC2-6CB7-A89430DF80DF}"/>
               </a:ext>
             </a:extLst>
           </p:cNvPr>
@@ -13333,7 +13333,7 @@
           <p:cNvPr id="10" name="Hộp Văn bản 9">
             <a:extLst>
               <a:ext uri="{FF2B5EF4-FFF2-40B4-BE49-F238E27FC236}">
-                <a16:creationId xmlns:a16="http://schemas.microsoft.com/office/drawing/2014/main" id="{3A5326B6-BC6A-59AB-AFBD-2F53978A5D4A}"/>
+                <a16:creationId xmlns:a16="http://schemas.microsoft.com/office/drawing/2014/main" id="{BEDED6F5-BD7D-D8E4-C46A-5B5838B20977}"/>
               </a:ext>
             </a:extLst>
           </p:cNvPr>
@@ -13378,7 +13378,7 @@
           <p:cNvPr id="11" name="Hộp Văn bản 10">
             <a:extLst>
               <a:ext uri="{FF2B5EF4-FFF2-40B4-BE49-F238E27FC236}">
-                <a16:creationId xmlns:a16="http://schemas.microsoft.com/office/drawing/2014/main" id="{CF447CD6-FC6E-F5AD-79F4-3FD4174CDE46}"/>
+                <a16:creationId xmlns:a16="http://schemas.microsoft.com/office/drawing/2014/main" id="{61E7768C-4614-2892-328B-746B5871636F}"/>
               </a:ext>
             </a:extLst>
           </p:cNvPr>
@@ -13423,7 +13423,7 @@
           <p:cNvPr id="12" name="Hình chữ nhật: Góc Tròn 11">
             <a:extLst>
               <a:ext uri="{FF2B5EF4-FFF2-40B4-BE49-F238E27FC236}">
-                <a16:creationId xmlns:a16="http://schemas.microsoft.com/office/drawing/2014/main" id="{0AE1EE43-96F9-4BD2-CD29-D050F8FE1AD3}"/>
+                <a16:creationId xmlns:a16="http://schemas.microsoft.com/office/drawing/2014/main" id="{FF3F7CA4-7E64-CC3F-C670-BB8F26CEF595}"/>
               </a:ext>
             </a:extLst>
           </p:cNvPr>
@@ -13491,7 +13491,7 @@
           <p:cNvPr id="13" name="Hình chữ nhật 12">
             <a:extLst>
               <a:ext uri="{FF2B5EF4-FFF2-40B4-BE49-F238E27FC236}">
-                <a16:creationId xmlns:a16="http://schemas.microsoft.com/office/drawing/2014/main" id="{C4A1A113-F655-7EA3-9A4B-631413336F26}"/>
+                <a16:creationId xmlns:a16="http://schemas.microsoft.com/office/drawing/2014/main" id="{E8F30FD6-C60A-692E-F9AC-25CEC8386F53}"/>
               </a:ext>
             </a:extLst>
           </p:cNvPr>
@@ -13559,7 +13559,7 @@
           <p:cNvPr id="14" name="Hộp Văn bản 13">
             <a:extLst>
               <a:ext uri="{FF2B5EF4-FFF2-40B4-BE49-F238E27FC236}">
-                <a16:creationId xmlns:a16="http://schemas.microsoft.com/office/drawing/2014/main" id="{6AC622A1-4F34-8D42-F9BC-060D7D74F607}"/>
+                <a16:creationId xmlns:a16="http://schemas.microsoft.com/office/drawing/2014/main" id="{DD1504E2-20EC-1E96-FB39-3E473355825E}"/>
               </a:ext>
             </a:extLst>
           </p:cNvPr>
@@ -13604,7 +13604,7 @@
           <p:cNvPr id="15" name="Hộp Văn bản 14">
             <a:extLst>
               <a:ext uri="{FF2B5EF4-FFF2-40B4-BE49-F238E27FC236}">
-                <a16:creationId xmlns:a16="http://schemas.microsoft.com/office/drawing/2014/main" id="{A8A2E601-135A-5E57-3785-93615632FD15}"/>
+                <a16:creationId xmlns:a16="http://schemas.microsoft.com/office/drawing/2014/main" id="{E639B04A-4D1A-764C-13D3-01F5174678FE}"/>
               </a:ext>
             </a:extLst>
           </p:cNvPr>
@@ -13649,7 +13649,7 @@
           <p:cNvPr id="16" name="Hình chữ nhật: Góc Tròn 15">
             <a:extLst>
               <a:ext uri="{FF2B5EF4-FFF2-40B4-BE49-F238E27FC236}">
-                <a16:creationId xmlns:a16="http://schemas.microsoft.com/office/drawing/2014/main" id="{9A27290A-1DA8-3B52-D02F-301EE2D1D0DE}"/>
+                <a16:creationId xmlns:a16="http://schemas.microsoft.com/office/drawing/2014/main" id="{4A92FA6A-A2FB-94BA-0EC5-59589E3D4AC7}"/>
               </a:ext>
             </a:extLst>
           </p:cNvPr>
@@ -13717,7 +13717,7 @@
           <p:cNvPr id="17" name="Hình chữ nhật 16">
             <a:extLst>
               <a:ext uri="{FF2B5EF4-FFF2-40B4-BE49-F238E27FC236}">
-                <a16:creationId xmlns:a16="http://schemas.microsoft.com/office/drawing/2014/main" id="{549055C7-9681-8EED-99DE-CB2A01C286A8}"/>
+                <a16:creationId xmlns:a16="http://schemas.microsoft.com/office/drawing/2014/main" id="{C81C8A2F-AF9A-6F39-C509-4A0D0A9E291A}"/>
               </a:ext>
             </a:extLst>
           </p:cNvPr>
@@ -13785,7 +13785,7 @@
           <p:cNvPr id="18" name="Hộp Văn bản 17">
             <a:extLst>
               <a:ext uri="{FF2B5EF4-FFF2-40B4-BE49-F238E27FC236}">
-                <a16:creationId xmlns:a16="http://schemas.microsoft.com/office/drawing/2014/main" id="{A3DE9BC1-1063-DE74-B09C-491D6F1C05D1}"/>
+                <a16:creationId xmlns:a16="http://schemas.microsoft.com/office/drawing/2014/main" id="{F66E0DA1-8357-4366-37AA-092CBECFF175}"/>
               </a:ext>
             </a:extLst>
           </p:cNvPr>
@@ -13830,7 +13830,7 @@
           <p:cNvPr id="19" name="Hộp Văn bản 18">
             <a:extLst>
               <a:ext uri="{FF2B5EF4-FFF2-40B4-BE49-F238E27FC236}">
-                <a16:creationId xmlns:a16="http://schemas.microsoft.com/office/drawing/2014/main" id="{8BC7F43B-87B3-19A3-8C61-DE77AEA8171D}"/>
+                <a16:creationId xmlns:a16="http://schemas.microsoft.com/office/drawing/2014/main" id="{2ED9F9E9-7DAD-8947-C9CD-F5398D90FC9E}"/>
               </a:ext>
             </a:extLst>
           </p:cNvPr>
@@ -13881,7 +13881,7 @@
           <p:cNvPr id="20" name="Hình chữ nhật: Góc Tròn 19">
             <a:extLst>
               <a:ext uri="{FF2B5EF4-FFF2-40B4-BE49-F238E27FC236}">
-                <a16:creationId xmlns:a16="http://schemas.microsoft.com/office/drawing/2014/main" id="{0F19D517-9173-3E5E-9FEC-8B6BEBD61895}"/>
+                <a16:creationId xmlns:a16="http://schemas.microsoft.com/office/drawing/2014/main" id="{D68DA2BA-6FBB-E98B-555B-5BF8C3F156D2}"/>
               </a:ext>
             </a:extLst>
           </p:cNvPr>
@@ -13949,7 +13949,7 @@
           <p:cNvPr id="21" name="Hình chữ nhật 20">
             <a:extLst>
               <a:ext uri="{FF2B5EF4-FFF2-40B4-BE49-F238E27FC236}">
-                <a16:creationId xmlns:a16="http://schemas.microsoft.com/office/drawing/2014/main" id="{7E93A1C3-AE7A-380B-707F-0362A633303C}"/>
+                <a16:creationId xmlns:a16="http://schemas.microsoft.com/office/drawing/2014/main" id="{35CC81F8-4D01-7037-73E8-7E7E73B78E64}"/>
               </a:ext>
             </a:extLst>
           </p:cNvPr>
@@ -14017,7 +14017,7 @@
           <p:cNvPr id="22" name="Hộp Văn bản 21">
             <a:extLst>
               <a:ext uri="{FF2B5EF4-FFF2-40B4-BE49-F238E27FC236}">
-                <a16:creationId xmlns:a16="http://schemas.microsoft.com/office/drawing/2014/main" id="{DDE00ACE-03AB-4A05-B963-A49C8699C393}"/>
+                <a16:creationId xmlns:a16="http://schemas.microsoft.com/office/drawing/2014/main" id="{1DFFCE52-D12A-DD37-297F-A2240F20F2AC}"/>
               </a:ext>
             </a:extLst>
           </p:cNvPr>
@@ -14062,7 +14062,7 @@
           <p:cNvPr id="23" name="Hộp Văn bản 22">
             <a:extLst>
               <a:ext uri="{FF2B5EF4-FFF2-40B4-BE49-F238E27FC236}">
-                <a16:creationId xmlns:a16="http://schemas.microsoft.com/office/drawing/2014/main" id="{632A4485-39B0-D024-3EAA-8180E42537F0}"/>
+                <a16:creationId xmlns:a16="http://schemas.microsoft.com/office/drawing/2014/main" id="{F1A34639-385E-05A8-D497-40725F462BEC}"/>
               </a:ext>
             </a:extLst>
           </p:cNvPr>
@@ -14113,7 +14113,7 @@
           <p:cNvPr id="24" name="Hình chữ nhật 23">
             <a:extLst>
               <a:ext uri="{FF2B5EF4-FFF2-40B4-BE49-F238E27FC236}">
-                <a16:creationId xmlns:a16="http://schemas.microsoft.com/office/drawing/2014/main" id="{FD635AE9-2A64-8110-338B-AA0C3359D06A}"/>
+                <a16:creationId xmlns:a16="http://schemas.microsoft.com/office/drawing/2014/main" id="{D60BE673-BF0D-4E09-CAF6-7E6A9413B450}"/>
               </a:ext>
             </a:extLst>
           </p:cNvPr>
@@ -14181,7 +14181,7 @@
           <p:cNvPr id="25" name="Hình chữ nhật 24">
             <a:extLst>
               <a:ext uri="{FF2B5EF4-FFF2-40B4-BE49-F238E27FC236}">
-                <a16:creationId xmlns:a16="http://schemas.microsoft.com/office/drawing/2014/main" id="{E9FC35F2-3F4D-0BB1-49B1-D94B7D4B4A0B}"/>
+                <a16:creationId xmlns:a16="http://schemas.microsoft.com/office/drawing/2014/main" id="{9B878C6C-C958-5DC0-6353-8B6F58EFC772}"/>
               </a:ext>
             </a:extLst>
           </p:cNvPr>
@@ -14249,7 +14249,7 @@
           <p:cNvPr id="26" name="Hình chữ nhật 25">
             <a:extLst>
               <a:ext uri="{FF2B5EF4-FFF2-40B4-BE49-F238E27FC236}">
-                <a16:creationId xmlns:a16="http://schemas.microsoft.com/office/drawing/2014/main" id="{DDAEE7B2-6958-6FE0-6CE6-B83CB592664D}"/>
+                <a16:creationId xmlns:a16="http://schemas.microsoft.com/office/drawing/2014/main" id="{16544E18-3A61-A0BF-14C2-70257AACE8FA}"/>
               </a:ext>
             </a:extLst>
           </p:cNvPr>
@@ -14317,7 +14317,7 @@
           <p:cNvPr id="27" name="Hộp Văn bản 26">
             <a:extLst>
               <a:ext uri="{FF2B5EF4-FFF2-40B4-BE49-F238E27FC236}">
-                <a16:creationId xmlns:a16="http://schemas.microsoft.com/office/drawing/2014/main" id="{F9D0EB04-16C0-57A1-55E4-061A21D899F7}"/>
+                <a16:creationId xmlns:a16="http://schemas.microsoft.com/office/drawing/2014/main" id="{46F4123E-4461-230C-4564-8380FE132B61}"/>
               </a:ext>
             </a:extLst>
           </p:cNvPr>
@@ -14362,7 +14362,7 @@
           <p:cNvPr id="28" name="Hộp Văn bản 27">
             <a:extLst>
               <a:ext uri="{FF2B5EF4-FFF2-40B4-BE49-F238E27FC236}">
-                <a16:creationId xmlns:a16="http://schemas.microsoft.com/office/drawing/2014/main" id="{3CEE4C5A-4D04-20A6-3F6A-FA2B250EBA97}"/>
+                <a16:creationId xmlns:a16="http://schemas.microsoft.com/office/drawing/2014/main" id="{46A0C73F-41D4-AEE8-E4E1-4BE15D9B036F}"/>
               </a:ext>
             </a:extLst>
           </p:cNvPr>
@@ -14407,7 +14407,7 @@
           <p:cNvPr id="29" name="Hộp Văn bản 28">
             <a:extLst>
               <a:ext uri="{FF2B5EF4-FFF2-40B4-BE49-F238E27FC236}">
-                <a16:creationId xmlns:a16="http://schemas.microsoft.com/office/drawing/2014/main" id="{979A5232-D02C-DE53-D93C-AE11218761F9}"/>
+                <a16:creationId xmlns:a16="http://schemas.microsoft.com/office/drawing/2014/main" id="{70864A8E-74F5-A088-E6A4-8CF3D69CAE82}"/>
               </a:ext>
             </a:extLst>
           </p:cNvPr>
@@ -14452,7 +14452,7 @@
           <p:cNvPr id="30" name="Hình chữ nhật 29">
             <a:extLst>
               <a:ext uri="{FF2B5EF4-FFF2-40B4-BE49-F238E27FC236}">
-                <a16:creationId xmlns:a16="http://schemas.microsoft.com/office/drawing/2014/main" id="{FA1950A9-AB2C-30BF-2239-BC0F31501C38}"/>
+                <a16:creationId xmlns:a16="http://schemas.microsoft.com/office/drawing/2014/main" id="{E5AE7FDA-93A0-BA87-2E20-D87B0FA108E8}"/>
               </a:ext>
             </a:extLst>
           </p:cNvPr>
@@ -14520,7 +14520,7 @@
           <p:cNvPr id="31" name="Hình chữ nhật 30">
             <a:extLst>
               <a:ext uri="{FF2B5EF4-FFF2-40B4-BE49-F238E27FC236}">
-                <a16:creationId xmlns:a16="http://schemas.microsoft.com/office/drawing/2014/main" id="{04268D2C-60A9-3FC2-ADC2-4CD07DAF179D}"/>
+                <a16:creationId xmlns:a16="http://schemas.microsoft.com/office/drawing/2014/main" id="{EEAD37E4-A53E-63CD-89A4-7C1949977E8A}"/>
               </a:ext>
             </a:extLst>
           </p:cNvPr>
@@ -14588,7 +14588,7 @@
           <p:cNvPr id="32" name="Hình chữ nhật 31">
             <a:extLst>
               <a:ext uri="{FF2B5EF4-FFF2-40B4-BE49-F238E27FC236}">
-                <a16:creationId xmlns:a16="http://schemas.microsoft.com/office/drawing/2014/main" id="{98EEF36E-B446-B453-0755-C641DE4E0CFD}"/>
+                <a16:creationId xmlns:a16="http://schemas.microsoft.com/office/drawing/2014/main" id="{CD74DCE6-A3C6-2141-4B2C-EE471E4B9079}"/>
               </a:ext>
             </a:extLst>
           </p:cNvPr>
@@ -14656,7 +14656,7 @@
           <p:cNvPr id="33" name="Hình chữ nhật 32">
             <a:extLst>
               <a:ext uri="{FF2B5EF4-FFF2-40B4-BE49-F238E27FC236}">
-                <a16:creationId xmlns:a16="http://schemas.microsoft.com/office/drawing/2014/main" id="{B9DB70FE-5FCD-4FD0-7EC5-4743A8715862}"/>
+                <a16:creationId xmlns:a16="http://schemas.microsoft.com/office/drawing/2014/main" id="{5CF8BE62-0151-B80E-5C05-F1A64BEAE9A5}"/>
               </a:ext>
             </a:extLst>
           </p:cNvPr>
@@ -14724,7 +14724,7 @@
           <p:cNvPr id="34" name="Hình chữ nhật: Góc Tròn 33">
             <a:extLst>
               <a:ext uri="{FF2B5EF4-FFF2-40B4-BE49-F238E27FC236}">
-                <a16:creationId xmlns:a16="http://schemas.microsoft.com/office/drawing/2014/main" id="{490D2D13-8DE5-D17C-101D-70249077A8DD}"/>
+                <a16:creationId xmlns:a16="http://schemas.microsoft.com/office/drawing/2014/main" id="{97A3BD84-9F72-540C-6150-C957BE7F4DA6}"/>
               </a:ext>
             </a:extLst>
           </p:cNvPr>
@@ -14792,7 +14792,7 @@
           <p:cNvPr id="35" name="Hình chữ nhật 34">
             <a:extLst>
               <a:ext uri="{FF2B5EF4-FFF2-40B4-BE49-F238E27FC236}">
-                <a16:creationId xmlns:a16="http://schemas.microsoft.com/office/drawing/2014/main" id="{0C772AEE-D1F4-B5D9-2DE7-088CB1BC006B}"/>
+                <a16:creationId xmlns:a16="http://schemas.microsoft.com/office/drawing/2014/main" id="{153A8615-FA52-62CF-10E6-3C22775380A2}"/>
               </a:ext>
             </a:extLst>
           </p:cNvPr>
@@ -14860,7 +14860,7 @@
           <p:cNvPr id="36" name="Hộp Văn bản 35">
             <a:extLst>
               <a:ext uri="{FF2B5EF4-FFF2-40B4-BE49-F238E27FC236}">
-                <a16:creationId xmlns:a16="http://schemas.microsoft.com/office/drawing/2014/main" id="{2162DFA3-37CD-5487-28B8-931FDF47F308}"/>
+                <a16:creationId xmlns:a16="http://schemas.microsoft.com/office/drawing/2014/main" id="{6370EAC9-E346-0326-36DB-F1B95A830C4D}"/>
               </a:ext>
             </a:extLst>
           </p:cNvPr>
@@ -14905,7 +14905,7 @@
           <p:cNvPr id="37" name="Hộp Văn bản 36">
             <a:extLst>
               <a:ext uri="{FF2B5EF4-FFF2-40B4-BE49-F238E27FC236}">
-                <a16:creationId xmlns:a16="http://schemas.microsoft.com/office/drawing/2014/main" id="{888DFA41-97B4-72C4-9A41-39D5863C257A}"/>
+                <a16:creationId xmlns:a16="http://schemas.microsoft.com/office/drawing/2014/main" id="{4DCF873D-A11A-54BD-5ACC-B8C99A9441DC}"/>
               </a:ext>
             </a:extLst>
           </p:cNvPr>
@@ -14956,7 +14956,7 @@
           <p:cNvPr id="38" name="Hình chữ nhật: Góc Tròn 37">
             <a:extLst>
               <a:ext uri="{FF2B5EF4-FFF2-40B4-BE49-F238E27FC236}">
-                <a16:creationId xmlns:a16="http://schemas.microsoft.com/office/drawing/2014/main" id="{86142200-A352-C36A-E897-B95F468F47D5}"/>
+                <a16:creationId xmlns:a16="http://schemas.microsoft.com/office/drawing/2014/main" id="{DF9EDA4A-89B6-28C3-9622-F4DA729C7440}"/>
               </a:ext>
             </a:extLst>
           </p:cNvPr>
@@ -15024,7 +15024,7 @@
           <p:cNvPr id="39" name="Hình chữ nhật 38">
             <a:extLst>
               <a:ext uri="{FF2B5EF4-FFF2-40B4-BE49-F238E27FC236}">
-                <a16:creationId xmlns:a16="http://schemas.microsoft.com/office/drawing/2014/main" id="{63E5CE62-8B29-3538-BEFD-ADFBB4A6CDBC}"/>
+                <a16:creationId xmlns:a16="http://schemas.microsoft.com/office/drawing/2014/main" id="{35DB23E4-05D6-544B-7D81-5505F7E9E22B}"/>
               </a:ext>
             </a:extLst>
           </p:cNvPr>
@@ -15092,7 +15092,7 @@
           <p:cNvPr id="40" name="Hộp Văn bản 39">
             <a:extLst>
               <a:ext uri="{FF2B5EF4-FFF2-40B4-BE49-F238E27FC236}">
-                <a16:creationId xmlns:a16="http://schemas.microsoft.com/office/drawing/2014/main" id="{30EF0FC2-F939-7B0C-8FED-095BD3FA25F6}"/>
+                <a16:creationId xmlns:a16="http://schemas.microsoft.com/office/drawing/2014/main" id="{4D5EE588-B24D-CB3A-52A3-3F508BB275BB}"/>
               </a:ext>
             </a:extLst>
           </p:cNvPr>
@@ -15137,7 +15137,7 @@
           <p:cNvPr id="41" name="Hộp Văn bản 40">
             <a:extLst>
               <a:ext uri="{FF2B5EF4-FFF2-40B4-BE49-F238E27FC236}">
-                <a16:creationId xmlns:a16="http://schemas.microsoft.com/office/drawing/2014/main" id="{E55F5371-9423-8939-11A5-ED5CC7D250C1}"/>
+                <a16:creationId xmlns:a16="http://schemas.microsoft.com/office/drawing/2014/main" id="{F7251CAD-8BD6-19BA-4062-E8121384B5DC}"/>
               </a:ext>
             </a:extLst>
           </p:cNvPr>
@@ -15182,7 +15182,7 @@
           <p:cNvPr id="42" name="Hộp Văn bản 41">
             <a:extLst>
               <a:ext uri="{FF2B5EF4-FFF2-40B4-BE49-F238E27FC236}">
-                <a16:creationId xmlns:a16="http://schemas.microsoft.com/office/drawing/2014/main" id="{7069D877-0C90-CD35-F6FE-2EE2C52251FE}"/>
+                <a16:creationId xmlns:a16="http://schemas.microsoft.com/office/drawing/2014/main" id="{67C2B4F5-7162-98AC-8AA6-E2A30E092C33}"/>
               </a:ext>
             </a:extLst>
           </p:cNvPr>
@@ -15227,7 +15227,7 @@
           <p:cNvPr id="43" name="Hộp Văn bản 42">
             <a:extLst>
               <a:ext uri="{FF2B5EF4-FFF2-40B4-BE49-F238E27FC236}">
-                <a16:creationId xmlns:a16="http://schemas.microsoft.com/office/drawing/2014/main" id="{E425E361-834D-F9D6-69E6-18430D146790}"/>
+                <a16:creationId xmlns:a16="http://schemas.microsoft.com/office/drawing/2014/main" id="{86F642BB-94FB-50F9-C62E-4837B0E6EA2F}"/>
               </a:ext>
             </a:extLst>
           </p:cNvPr>
@@ -15272,7 +15272,7 @@
           <p:cNvPr id="44" name="Hình chữ nhật: Góc Tròn 43">
             <a:extLst>
               <a:ext uri="{FF2B5EF4-FFF2-40B4-BE49-F238E27FC236}">
-                <a16:creationId xmlns:a16="http://schemas.microsoft.com/office/drawing/2014/main" id="{F96195A1-5447-8313-C886-59A12C730396}"/>
+                <a16:creationId xmlns:a16="http://schemas.microsoft.com/office/drawing/2014/main" id="{86802F37-F520-A0E7-CE22-7757B1CD7FD5}"/>
               </a:ext>
             </a:extLst>
           </p:cNvPr>
@@ -15340,7 +15340,7 @@
           <p:cNvPr id="45" name="Hộp Văn bản 44">
             <a:extLst>
               <a:ext uri="{FF2B5EF4-FFF2-40B4-BE49-F238E27FC236}">
-                <a16:creationId xmlns:a16="http://schemas.microsoft.com/office/drawing/2014/main" id="{F0D3A7C6-8FAA-1927-96E1-AA205AA4C7AA}"/>
+                <a16:creationId xmlns:a16="http://schemas.microsoft.com/office/drawing/2014/main" id="{5B0FC989-8981-A524-F95C-C410048A2374}"/>
               </a:ext>
             </a:extLst>
           </p:cNvPr>
@@ -15385,7 +15385,7 @@
           <p:cNvPr id="46" name="Hộp Văn bản 45">
             <a:extLst>
               <a:ext uri="{FF2B5EF4-FFF2-40B4-BE49-F238E27FC236}">
-                <a16:creationId xmlns:a16="http://schemas.microsoft.com/office/drawing/2014/main" id="{7D2E83AD-6F9C-3448-A439-78B5C40BCED8}"/>
+                <a16:creationId xmlns:a16="http://schemas.microsoft.com/office/drawing/2014/main" id="{EFF31BDA-3FFA-60D0-7D02-EA8D6B81615B}"/>
               </a:ext>
             </a:extLst>
           </p:cNvPr>
@@ -15428,7 +15428,7 @@
     </p:spTree>
     <p:extLst>
       <p:ext uri="{BB962C8B-B14F-4D97-AF65-F5344CB8AC3E}">
-        <p14:creationId xmlns:p14="http://schemas.microsoft.com/office/powerpoint/2010/main" val="509967064"/>
+        <p14:creationId xmlns:p14="http://schemas.microsoft.com/office/powerpoint/2010/main" val="1913941784"/>
       </p:ext>
     </p:extLst>
   </p:cSld>
@@ -15460,7 +15460,7 @@
           <p:cNvPr id="2" name="Hộp Văn bản 1">
             <a:extLst>
               <a:ext uri="{FF2B5EF4-FFF2-40B4-BE49-F238E27FC236}">
-                <a16:creationId xmlns:a16="http://schemas.microsoft.com/office/drawing/2014/main" id="{6F548BCB-99F1-E046-CC9C-156FE0060E8A}"/>
+                <a16:creationId xmlns:a16="http://schemas.microsoft.com/office/drawing/2014/main" id="{BB8CD58E-D166-66D6-5A0C-BC44A2F87364}"/>
               </a:ext>
             </a:extLst>
           </p:cNvPr>
@@ -15505,7 +15505,7 @@
           <p:cNvPr id="3" name="Hộp Văn bản 2">
             <a:extLst>
               <a:ext uri="{FF2B5EF4-FFF2-40B4-BE49-F238E27FC236}">
-                <a16:creationId xmlns:a16="http://schemas.microsoft.com/office/drawing/2014/main" id="{6E06112C-BB84-8549-0B8F-483086236312}"/>
+                <a16:creationId xmlns:a16="http://schemas.microsoft.com/office/drawing/2014/main" id="{95C89DEA-19D3-E571-4405-5F1C4EC69F1D}"/>
               </a:ext>
             </a:extLst>
           </p:cNvPr>
@@ -15550,7 +15550,7 @@
           <p:cNvPr id="4" name="Hộp Văn bản 3">
             <a:extLst>
               <a:ext uri="{FF2B5EF4-FFF2-40B4-BE49-F238E27FC236}">
-                <a16:creationId xmlns:a16="http://schemas.microsoft.com/office/drawing/2014/main" id="{D7924E69-7B6E-A8BA-1155-9CCC804A4677}"/>
+                <a16:creationId xmlns:a16="http://schemas.microsoft.com/office/drawing/2014/main" id="{A622D1CB-4D86-7652-CCFF-4057D6CD378F}"/>
               </a:ext>
             </a:extLst>
           </p:cNvPr>
@@ -15595,7 +15595,7 @@
           <p:cNvPr id="5" name="Hình chữ nhật 4">
             <a:extLst>
               <a:ext uri="{FF2B5EF4-FFF2-40B4-BE49-F238E27FC236}">
-                <a16:creationId xmlns:a16="http://schemas.microsoft.com/office/drawing/2014/main" id="{85495AA4-46E3-41C9-6E90-55D470B24357}"/>
+                <a16:creationId xmlns:a16="http://schemas.microsoft.com/office/drawing/2014/main" id="{3FE883DC-1CBC-E216-1F94-9933525CCDF8}"/>
               </a:ext>
             </a:extLst>
           </p:cNvPr>
@@ -15663,7 +15663,7 @@
           <p:cNvPr id="6" name="Hộp Văn bản 5">
             <a:extLst>
               <a:ext uri="{FF2B5EF4-FFF2-40B4-BE49-F238E27FC236}">
-                <a16:creationId xmlns:a16="http://schemas.microsoft.com/office/drawing/2014/main" id="{59D9C428-0FF1-664A-9015-B5CAB3FB5E4D}"/>
+                <a16:creationId xmlns:a16="http://schemas.microsoft.com/office/drawing/2014/main" id="{90272629-83B1-CFD4-1A86-2A9B34BB8037}"/>
               </a:ext>
             </a:extLst>
           </p:cNvPr>
@@ -15708,7 +15708,7 @@
           <p:cNvPr id="7" name="Hộp Văn bản 6">
             <a:extLst>
               <a:ext uri="{FF2B5EF4-FFF2-40B4-BE49-F238E27FC236}">
-                <a16:creationId xmlns:a16="http://schemas.microsoft.com/office/drawing/2014/main" id="{19388347-4ADC-BC3A-5FAC-A8DA46518B05}"/>
+                <a16:creationId xmlns:a16="http://schemas.microsoft.com/office/drawing/2014/main" id="{ECE41A68-9B02-C175-9424-5A194B27F62F}"/>
               </a:ext>
             </a:extLst>
           </p:cNvPr>
@@ -15753,7 +15753,7 @@
           <p:cNvPr id="8" name="Hình chữ nhật: Góc Tròn 7">
             <a:extLst>
               <a:ext uri="{FF2B5EF4-FFF2-40B4-BE49-F238E27FC236}">
-                <a16:creationId xmlns:a16="http://schemas.microsoft.com/office/drawing/2014/main" id="{9718E137-2241-899F-F0DC-949AF3153242}"/>
+                <a16:creationId xmlns:a16="http://schemas.microsoft.com/office/drawing/2014/main" id="{8B1607A4-AE91-B143-82A2-6CA506978A5C}"/>
               </a:ext>
             </a:extLst>
           </p:cNvPr>
@@ -15821,7 +15821,7 @@
           <p:cNvPr id="10" name="Hình ảnh 9">
             <a:extLst>
               <a:ext uri="{FF2B5EF4-FFF2-40B4-BE49-F238E27FC236}">
-                <a16:creationId xmlns:a16="http://schemas.microsoft.com/office/drawing/2014/main" id="{2D91CBED-335C-927A-114B-47DBC2370CC1}"/>
+                <a16:creationId xmlns:a16="http://schemas.microsoft.com/office/drawing/2014/main" id="{BB6719F6-8158-960B-D857-B51E620BFF10}"/>
               </a:ext>
             </a:extLst>
           </p:cNvPr>
@@ -15857,7 +15857,7 @@
           <p:cNvPr id="11" name="Hộp Văn bản 10">
             <a:extLst>
               <a:ext uri="{FF2B5EF4-FFF2-40B4-BE49-F238E27FC236}">
-                <a16:creationId xmlns:a16="http://schemas.microsoft.com/office/drawing/2014/main" id="{AC47543E-A4C7-2591-0A53-720A20496D0B}"/>
+                <a16:creationId xmlns:a16="http://schemas.microsoft.com/office/drawing/2014/main" id="{F6D22C7E-FCE3-6D9D-E195-0ECE679D1333}"/>
               </a:ext>
             </a:extLst>
           </p:cNvPr>
@@ -15902,7 +15902,7 @@
           <p:cNvPr id="12" name="Hình chữ nhật: Góc Tròn 11">
             <a:extLst>
               <a:ext uri="{FF2B5EF4-FFF2-40B4-BE49-F238E27FC236}">
-                <a16:creationId xmlns:a16="http://schemas.microsoft.com/office/drawing/2014/main" id="{34DA7A1C-35AA-5810-B413-9B602E73BBB8}"/>
+                <a16:creationId xmlns:a16="http://schemas.microsoft.com/office/drawing/2014/main" id="{B02A91D5-0B97-A5EC-D74D-664E1C5FFDF1}"/>
               </a:ext>
             </a:extLst>
           </p:cNvPr>
@@ -15970,7 +15970,7 @@
           <p:cNvPr id="13" name="Hình chữ nhật 12">
             <a:extLst>
               <a:ext uri="{FF2B5EF4-FFF2-40B4-BE49-F238E27FC236}">
-                <a16:creationId xmlns:a16="http://schemas.microsoft.com/office/drawing/2014/main" id="{F306985D-DFA7-1698-28A1-7CE77074D431}"/>
+                <a16:creationId xmlns:a16="http://schemas.microsoft.com/office/drawing/2014/main" id="{3E5989AB-6057-6EE2-A741-89981EBA0415}"/>
               </a:ext>
             </a:extLst>
           </p:cNvPr>
@@ -16038,7 +16038,7 @@
           <p:cNvPr id="14" name="Hộp Văn bản 13">
             <a:extLst>
               <a:ext uri="{FF2B5EF4-FFF2-40B4-BE49-F238E27FC236}">
-                <a16:creationId xmlns:a16="http://schemas.microsoft.com/office/drawing/2014/main" id="{8EF7110D-AFFE-4C37-C7A1-B170160AD609}"/>
+                <a16:creationId xmlns:a16="http://schemas.microsoft.com/office/drawing/2014/main" id="{6326C086-F65D-9B32-ED94-1AF9195A1890}"/>
               </a:ext>
             </a:extLst>
           </p:cNvPr>
@@ -16083,7 +16083,7 @@
           <p:cNvPr id="15" name="Hộp Văn bản 14">
             <a:extLst>
               <a:ext uri="{FF2B5EF4-FFF2-40B4-BE49-F238E27FC236}">
-                <a16:creationId xmlns:a16="http://schemas.microsoft.com/office/drawing/2014/main" id="{9D97AA83-3DBA-9BAA-7DBA-466B3E3E72B4}"/>
+                <a16:creationId xmlns:a16="http://schemas.microsoft.com/office/drawing/2014/main" id="{DB4C229B-7D0D-DE25-1411-3BF5205B3CB2}"/>
               </a:ext>
             </a:extLst>
           </p:cNvPr>
@@ -16128,7 +16128,7 @@
           <p:cNvPr id="16" name="Hình chữ nhật: Góc Tròn 15">
             <a:extLst>
               <a:ext uri="{FF2B5EF4-FFF2-40B4-BE49-F238E27FC236}">
-                <a16:creationId xmlns:a16="http://schemas.microsoft.com/office/drawing/2014/main" id="{E6AECA7A-0E2C-CE4C-930E-63DAC2AE8C6F}"/>
+                <a16:creationId xmlns:a16="http://schemas.microsoft.com/office/drawing/2014/main" id="{FED8309F-5CC0-95A6-9560-7671FFFFB030}"/>
               </a:ext>
             </a:extLst>
           </p:cNvPr>
@@ -16196,7 +16196,7 @@
           <p:cNvPr id="17" name="Hình chữ nhật 16">
             <a:extLst>
               <a:ext uri="{FF2B5EF4-FFF2-40B4-BE49-F238E27FC236}">
-                <a16:creationId xmlns:a16="http://schemas.microsoft.com/office/drawing/2014/main" id="{62EBB501-8F6D-0FCF-0AEC-3514E8FB4240}"/>
+                <a16:creationId xmlns:a16="http://schemas.microsoft.com/office/drawing/2014/main" id="{021093CA-C90A-B540-CF53-85C8D400B89A}"/>
               </a:ext>
             </a:extLst>
           </p:cNvPr>
@@ -16264,7 +16264,7 @@
           <p:cNvPr id="18" name="Hộp Văn bản 17">
             <a:extLst>
               <a:ext uri="{FF2B5EF4-FFF2-40B4-BE49-F238E27FC236}">
-                <a16:creationId xmlns:a16="http://schemas.microsoft.com/office/drawing/2014/main" id="{62D82A7F-6873-E325-543A-62E230CA9670}"/>
+                <a16:creationId xmlns:a16="http://schemas.microsoft.com/office/drawing/2014/main" id="{4179157A-816B-D370-DB1C-487909D23717}"/>
               </a:ext>
             </a:extLst>
           </p:cNvPr>
@@ -16309,7 +16309,7 @@
           <p:cNvPr id="19" name="Hộp Văn bản 18">
             <a:extLst>
               <a:ext uri="{FF2B5EF4-FFF2-40B4-BE49-F238E27FC236}">
-                <a16:creationId xmlns:a16="http://schemas.microsoft.com/office/drawing/2014/main" id="{50C72E03-8127-85B7-D2ED-CE4D6E8A6E86}"/>
+                <a16:creationId xmlns:a16="http://schemas.microsoft.com/office/drawing/2014/main" id="{F8DA9DEE-968D-F709-49EF-7DA52BDAF554}"/>
               </a:ext>
             </a:extLst>
           </p:cNvPr>
@@ -16354,7 +16354,7 @@
           <p:cNvPr id="20" name="Hình chữ nhật: Góc Tròn 19">
             <a:extLst>
               <a:ext uri="{FF2B5EF4-FFF2-40B4-BE49-F238E27FC236}">
-                <a16:creationId xmlns:a16="http://schemas.microsoft.com/office/drawing/2014/main" id="{83EC7245-4F9A-1BDA-8B80-9A45D21E3E36}"/>
+                <a16:creationId xmlns:a16="http://schemas.microsoft.com/office/drawing/2014/main" id="{31625AD4-E2DF-C7CA-65A9-26C041AA3C58}"/>
               </a:ext>
             </a:extLst>
           </p:cNvPr>
@@ -16422,7 +16422,7 @@
           <p:cNvPr id="21" name="Hình chữ nhật 20">
             <a:extLst>
               <a:ext uri="{FF2B5EF4-FFF2-40B4-BE49-F238E27FC236}">
-                <a16:creationId xmlns:a16="http://schemas.microsoft.com/office/drawing/2014/main" id="{F6BFBC7D-BB97-7486-E271-09ED575DE4F2}"/>
+                <a16:creationId xmlns:a16="http://schemas.microsoft.com/office/drawing/2014/main" id="{00571A1F-3B04-9BC8-542B-E1C5CBFDE054}"/>
               </a:ext>
             </a:extLst>
           </p:cNvPr>
@@ -16490,7 +16490,7 @@
           <p:cNvPr id="22" name="Hộp Văn bản 21">
             <a:extLst>
               <a:ext uri="{FF2B5EF4-FFF2-40B4-BE49-F238E27FC236}">
-                <a16:creationId xmlns:a16="http://schemas.microsoft.com/office/drawing/2014/main" id="{5ED31E5F-7413-25F1-B3BD-BEBF49B4CFAA}"/>
+                <a16:creationId xmlns:a16="http://schemas.microsoft.com/office/drawing/2014/main" id="{BDBC9DB2-7C88-CEFE-BD0B-7489DFF6B337}"/>
               </a:ext>
             </a:extLst>
           </p:cNvPr>
@@ -16535,7 +16535,7 @@
           <p:cNvPr id="23" name="Hộp Văn bản 22">
             <a:extLst>
               <a:ext uri="{FF2B5EF4-FFF2-40B4-BE49-F238E27FC236}">
-                <a16:creationId xmlns:a16="http://schemas.microsoft.com/office/drawing/2014/main" id="{CAFCAAA4-C9A9-AD22-CD4B-29F6EFE699A1}"/>
+                <a16:creationId xmlns:a16="http://schemas.microsoft.com/office/drawing/2014/main" id="{C9AD06C9-059A-7998-3F12-9D13B08AAC9F}"/>
               </a:ext>
             </a:extLst>
           </p:cNvPr>
@@ -16578,7 +16578,7 @@
     </p:spTree>
     <p:extLst>
       <p:ext uri="{BB962C8B-B14F-4D97-AF65-F5344CB8AC3E}">
-        <p14:creationId xmlns:p14="http://schemas.microsoft.com/office/powerpoint/2010/main" val="1937393795"/>
+        <p14:creationId xmlns:p14="http://schemas.microsoft.com/office/powerpoint/2010/main" val="4255718599"/>
       </p:ext>
     </p:extLst>
   </p:cSld>
@@ -16610,7 +16610,7 @@
           <p:cNvPr id="2" name="Hộp Văn bản 1">
             <a:extLst>
               <a:ext uri="{FF2B5EF4-FFF2-40B4-BE49-F238E27FC236}">
-                <a16:creationId xmlns:a16="http://schemas.microsoft.com/office/drawing/2014/main" id="{4B68E8AB-D443-225D-2723-9C090B210746}"/>
+                <a16:creationId xmlns:a16="http://schemas.microsoft.com/office/drawing/2014/main" id="{6AFC26D7-6BB0-95DA-E533-219849167B52}"/>
               </a:ext>
             </a:extLst>
           </p:cNvPr>
@@ -16655,7 +16655,7 @@
           <p:cNvPr id="3" name="Hộp Văn bản 2">
             <a:extLst>
               <a:ext uri="{FF2B5EF4-FFF2-40B4-BE49-F238E27FC236}">
-                <a16:creationId xmlns:a16="http://schemas.microsoft.com/office/drawing/2014/main" id="{0A25DFC0-0269-CB79-D72E-3FBDF24683A1}"/>
+                <a16:creationId xmlns:a16="http://schemas.microsoft.com/office/drawing/2014/main" id="{9E5648B1-C74A-FD02-97F5-B54839B002CF}"/>
               </a:ext>
             </a:extLst>
           </p:cNvPr>
@@ -16700,7 +16700,7 @@
           <p:cNvPr id="4" name="Hộp Văn bản 3">
             <a:extLst>
               <a:ext uri="{FF2B5EF4-FFF2-40B4-BE49-F238E27FC236}">
-                <a16:creationId xmlns:a16="http://schemas.microsoft.com/office/drawing/2014/main" id="{0BB1F813-66D9-5F1B-4822-103B4E113935}"/>
+                <a16:creationId xmlns:a16="http://schemas.microsoft.com/office/drawing/2014/main" id="{80432033-11A1-7A46-D6D3-073AADF1841B}"/>
               </a:ext>
             </a:extLst>
           </p:cNvPr>
@@ -16745,7 +16745,7 @@
           <p:cNvPr id="5" name="Hình chữ nhật 4">
             <a:extLst>
               <a:ext uri="{FF2B5EF4-FFF2-40B4-BE49-F238E27FC236}">
-                <a16:creationId xmlns:a16="http://schemas.microsoft.com/office/drawing/2014/main" id="{C05FE8FA-2ACF-0587-8818-E521B77D63AF}"/>
+                <a16:creationId xmlns:a16="http://schemas.microsoft.com/office/drawing/2014/main" id="{CEA3E1BC-C227-4127-20FF-5CC9AB7E163C}"/>
               </a:ext>
             </a:extLst>
           </p:cNvPr>
@@ -16813,7 +16813,7 @@
           <p:cNvPr id="6" name="Hộp Văn bản 5">
             <a:extLst>
               <a:ext uri="{FF2B5EF4-FFF2-40B4-BE49-F238E27FC236}">
-                <a16:creationId xmlns:a16="http://schemas.microsoft.com/office/drawing/2014/main" id="{B8F5CEE9-80F2-4F67-715D-920C1F363D12}"/>
+                <a16:creationId xmlns:a16="http://schemas.microsoft.com/office/drawing/2014/main" id="{BF3FC5BE-6046-095B-0179-A5BAD75B7C08}"/>
               </a:ext>
             </a:extLst>
           </p:cNvPr>
@@ -16858,7 +16858,7 @@
           <p:cNvPr id="7" name="Hộp Văn bản 6">
             <a:extLst>
               <a:ext uri="{FF2B5EF4-FFF2-40B4-BE49-F238E27FC236}">
-                <a16:creationId xmlns:a16="http://schemas.microsoft.com/office/drawing/2014/main" id="{BDB9C57D-FECC-0ACE-9051-FDEFC8C2E37E}"/>
+                <a16:creationId xmlns:a16="http://schemas.microsoft.com/office/drawing/2014/main" id="{8832CECA-99D2-3742-AF6A-43044118A41B}"/>
               </a:ext>
             </a:extLst>
           </p:cNvPr>
@@ -16903,7 +16903,7 @@
           <p:cNvPr id="8" name="Hình chữ nhật: Góc Tròn 7">
             <a:extLst>
               <a:ext uri="{FF2B5EF4-FFF2-40B4-BE49-F238E27FC236}">
-                <a16:creationId xmlns:a16="http://schemas.microsoft.com/office/drawing/2014/main" id="{B85A8391-AA18-8EEE-0E67-4BFB7D0AEC1C}"/>
+                <a16:creationId xmlns:a16="http://schemas.microsoft.com/office/drawing/2014/main" id="{744E19E0-B04F-9DFA-A6F1-9937145926AD}"/>
               </a:ext>
             </a:extLst>
           </p:cNvPr>
@@ -16971,7 +16971,7 @@
           <p:cNvPr id="10" name="Hình ảnh 9">
             <a:extLst>
               <a:ext uri="{FF2B5EF4-FFF2-40B4-BE49-F238E27FC236}">
-                <a16:creationId xmlns:a16="http://schemas.microsoft.com/office/drawing/2014/main" id="{4F729F05-9FC4-31A8-4157-2950BFDBEB54}"/>
+                <a16:creationId xmlns:a16="http://schemas.microsoft.com/office/drawing/2014/main" id="{901D6B6C-0060-D6E7-5AAE-2B06165583B0}"/>
               </a:ext>
             </a:extLst>
           </p:cNvPr>
@@ -17007,7 +17007,7 @@
           <p:cNvPr id="11" name="Hộp Văn bản 10">
             <a:extLst>
               <a:ext uri="{FF2B5EF4-FFF2-40B4-BE49-F238E27FC236}">
-                <a16:creationId xmlns:a16="http://schemas.microsoft.com/office/drawing/2014/main" id="{9BCFAEFC-902F-9A56-EE0F-D8CC6B6318A9}"/>
+                <a16:creationId xmlns:a16="http://schemas.microsoft.com/office/drawing/2014/main" id="{D8017C93-8BFD-4B0C-128D-D1D81E0D3324}"/>
               </a:ext>
             </a:extLst>
           </p:cNvPr>
@@ -17052,7 +17052,7 @@
           <p:cNvPr id="12" name="Hình chữ nhật: Góc Tròn 11">
             <a:extLst>
               <a:ext uri="{FF2B5EF4-FFF2-40B4-BE49-F238E27FC236}">
-                <a16:creationId xmlns:a16="http://schemas.microsoft.com/office/drawing/2014/main" id="{AE825BF4-3E35-E980-20EB-4D123FEBD3AA}"/>
+                <a16:creationId xmlns:a16="http://schemas.microsoft.com/office/drawing/2014/main" id="{F54CE83E-0B79-63B1-4305-F0C809CD11E3}"/>
               </a:ext>
             </a:extLst>
           </p:cNvPr>
@@ -17120,7 +17120,7 @@
           <p:cNvPr id="13" name="Hình chữ nhật 12">
             <a:extLst>
               <a:ext uri="{FF2B5EF4-FFF2-40B4-BE49-F238E27FC236}">
-                <a16:creationId xmlns:a16="http://schemas.microsoft.com/office/drawing/2014/main" id="{9BA48238-823D-3C61-B834-43B76E163DCA}"/>
+                <a16:creationId xmlns:a16="http://schemas.microsoft.com/office/drawing/2014/main" id="{80A70D68-F344-93DA-3536-786CAE481EDF}"/>
               </a:ext>
             </a:extLst>
           </p:cNvPr>
@@ -17188,7 +17188,7 @@
           <p:cNvPr id="14" name="Hộp Văn bản 13">
             <a:extLst>
               <a:ext uri="{FF2B5EF4-FFF2-40B4-BE49-F238E27FC236}">
-                <a16:creationId xmlns:a16="http://schemas.microsoft.com/office/drawing/2014/main" id="{66DD68D3-FAB5-4994-57D1-587A0E829560}"/>
+                <a16:creationId xmlns:a16="http://schemas.microsoft.com/office/drawing/2014/main" id="{824008CD-5A9D-019F-625D-F364BB59CD2A}"/>
               </a:ext>
             </a:extLst>
           </p:cNvPr>
@@ -17233,7 +17233,7 @@
           <p:cNvPr id="15" name="Hộp Văn bản 14">
             <a:extLst>
               <a:ext uri="{FF2B5EF4-FFF2-40B4-BE49-F238E27FC236}">
-                <a16:creationId xmlns:a16="http://schemas.microsoft.com/office/drawing/2014/main" id="{900A8F44-3D2F-E95A-364A-1734146A168B}"/>
+                <a16:creationId xmlns:a16="http://schemas.microsoft.com/office/drawing/2014/main" id="{D687E063-3464-1E38-0E25-81F90080461A}"/>
               </a:ext>
             </a:extLst>
           </p:cNvPr>
@@ -17278,7 +17278,7 @@
           <p:cNvPr id="16" name="Hình chữ nhật: Góc Tròn 15">
             <a:extLst>
               <a:ext uri="{FF2B5EF4-FFF2-40B4-BE49-F238E27FC236}">
-                <a16:creationId xmlns:a16="http://schemas.microsoft.com/office/drawing/2014/main" id="{377C7367-F671-A263-4216-B5ED89A85021}"/>
+                <a16:creationId xmlns:a16="http://schemas.microsoft.com/office/drawing/2014/main" id="{EF6D4C2F-D058-4D9A-CA9B-2D0F6396E08C}"/>
               </a:ext>
             </a:extLst>
           </p:cNvPr>
@@ -17346,7 +17346,7 @@
           <p:cNvPr id="17" name="Hình chữ nhật 16">
             <a:extLst>
               <a:ext uri="{FF2B5EF4-FFF2-40B4-BE49-F238E27FC236}">
-                <a16:creationId xmlns:a16="http://schemas.microsoft.com/office/drawing/2014/main" id="{7E0BAC59-FC55-B285-7934-0DB6B8A6E087}"/>
+                <a16:creationId xmlns:a16="http://schemas.microsoft.com/office/drawing/2014/main" id="{5A94E60E-45B1-84E5-9973-35CB9B82AB4B}"/>
               </a:ext>
             </a:extLst>
           </p:cNvPr>
@@ -17414,7 +17414,7 @@
           <p:cNvPr id="18" name="Hộp Văn bản 17">
             <a:extLst>
               <a:ext uri="{FF2B5EF4-FFF2-40B4-BE49-F238E27FC236}">
-                <a16:creationId xmlns:a16="http://schemas.microsoft.com/office/drawing/2014/main" id="{6570D003-1F83-B1BC-ABED-C7C67AB93A57}"/>
+                <a16:creationId xmlns:a16="http://schemas.microsoft.com/office/drawing/2014/main" id="{BA6C0864-FA6E-11C4-1EF6-D518D7FEA2FB}"/>
               </a:ext>
             </a:extLst>
           </p:cNvPr>
@@ -17459,7 +17459,7 @@
           <p:cNvPr id="19" name="Hộp Văn bản 18">
             <a:extLst>
               <a:ext uri="{FF2B5EF4-FFF2-40B4-BE49-F238E27FC236}">
-                <a16:creationId xmlns:a16="http://schemas.microsoft.com/office/drawing/2014/main" id="{51C3E0F9-50F4-6B76-5919-8E2D4E86725E}"/>
+                <a16:creationId xmlns:a16="http://schemas.microsoft.com/office/drawing/2014/main" id="{482E049F-6A5F-DFD7-AA09-86EECFD8CAD5}"/>
               </a:ext>
             </a:extLst>
           </p:cNvPr>
@@ -17504,7 +17504,7 @@
           <p:cNvPr id="20" name="Hình chữ nhật: Góc Tròn 19">
             <a:extLst>
               <a:ext uri="{FF2B5EF4-FFF2-40B4-BE49-F238E27FC236}">
-                <a16:creationId xmlns:a16="http://schemas.microsoft.com/office/drawing/2014/main" id="{ABB5344C-2A08-08AA-C2FC-9559F793D831}"/>
+                <a16:creationId xmlns:a16="http://schemas.microsoft.com/office/drawing/2014/main" id="{86BACB81-086A-431B-A992-3B9B9D6EDB27}"/>
               </a:ext>
             </a:extLst>
           </p:cNvPr>
@@ -17572,7 +17572,7 @@
           <p:cNvPr id="21" name="Hình chữ nhật: Góc Tròn 20">
             <a:extLst>
               <a:ext uri="{FF2B5EF4-FFF2-40B4-BE49-F238E27FC236}">
-                <a16:creationId xmlns:a16="http://schemas.microsoft.com/office/drawing/2014/main" id="{D569B4F1-C703-B606-EDB4-29B81BA7E951}"/>
+                <a16:creationId xmlns:a16="http://schemas.microsoft.com/office/drawing/2014/main" id="{E035064E-4C18-8D25-17F1-465E8355AFB5}"/>
               </a:ext>
             </a:extLst>
           </p:cNvPr>
@@ -17640,7 +17640,7 @@
           <p:cNvPr id="22" name="Hộp Văn bản 21">
             <a:extLst>
               <a:ext uri="{FF2B5EF4-FFF2-40B4-BE49-F238E27FC236}">
-                <a16:creationId xmlns:a16="http://schemas.microsoft.com/office/drawing/2014/main" id="{7E387749-4CAA-33C4-9888-E42526CEA893}"/>
+                <a16:creationId xmlns:a16="http://schemas.microsoft.com/office/drawing/2014/main" id="{095EF508-50CB-F493-BBF2-6A9D239649A9}"/>
               </a:ext>
             </a:extLst>
           </p:cNvPr>
@@ -17685,7 +17685,7 @@
           <p:cNvPr id="23" name="Hộp Văn bản 22">
             <a:extLst>
               <a:ext uri="{FF2B5EF4-FFF2-40B4-BE49-F238E27FC236}">
-                <a16:creationId xmlns:a16="http://schemas.microsoft.com/office/drawing/2014/main" id="{87CDC2DE-0492-5790-9FA5-68AB1176DA48}"/>
+                <a16:creationId xmlns:a16="http://schemas.microsoft.com/office/drawing/2014/main" id="{5845B78F-368B-E8B7-DFF4-0E3226F5A11B}"/>
               </a:ext>
             </a:extLst>
           </p:cNvPr>
@@ -17728,7 +17728,7 @@
     </p:spTree>
     <p:extLst>
       <p:ext uri="{BB962C8B-B14F-4D97-AF65-F5344CB8AC3E}">
-        <p14:creationId xmlns:p14="http://schemas.microsoft.com/office/powerpoint/2010/main" val="524272033"/>
+        <p14:creationId xmlns:p14="http://schemas.microsoft.com/office/powerpoint/2010/main" val="2795468300"/>
       </p:ext>
     </p:extLst>
   </p:cSld>
@@ -17760,7 +17760,7 @@
           <p:cNvPr id="2" name="Hộp Văn bản 1">
             <a:extLst>
               <a:ext uri="{FF2B5EF4-FFF2-40B4-BE49-F238E27FC236}">
-                <a16:creationId xmlns:a16="http://schemas.microsoft.com/office/drawing/2014/main" id="{378226E7-D9A5-E50B-F806-81C782E33FF2}"/>
+                <a16:creationId xmlns:a16="http://schemas.microsoft.com/office/drawing/2014/main" id="{B3B5298B-D216-056F-3B41-9E6B10E97D19}"/>
               </a:ext>
             </a:extLst>
           </p:cNvPr>
@@ -17805,7 +17805,7 @@
           <p:cNvPr id="3" name="Hộp Văn bản 2">
             <a:extLst>
               <a:ext uri="{FF2B5EF4-FFF2-40B4-BE49-F238E27FC236}">
-                <a16:creationId xmlns:a16="http://schemas.microsoft.com/office/drawing/2014/main" id="{1D48468E-A9B5-BF4F-4DA8-7EE156BCEAE9}"/>
+                <a16:creationId xmlns:a16="http://schemas.microsoft.com/office/drawing/2014/main" id="{8C326E4B-C3AF-AC21-5E52-361F739344E7}"/>
               </a:ext>
             </a:extLst>
           </p:cNvPr>
@@ -17850,7 +17850,7 @@
           <p:cNvPr id="4" name="Hộp Văn bản 3">
             <a:extLst>
               <a:ext uri="{FF2B5EF4-FFF2-40B4-BE49-F238E27FC236}">
-                <a16:creationId xmlns:a16="http://schemas.microsoft.com/office/drawing/2014/main" id="{D4FD3178-8FBF-9EF8-8BA8-C22C63714E52}"/>
+                <a16:creationId xmlns:a16="http://schemas.microsoft.com/office/drawing/2014/main" id="{B91C70C7-193C-DB53-F8D7-DE613D70ED30}"/>
               </a:ext>
             </a:extLst>
           </p:cNvPr>
@@ -17895,7 +17895,7 @@
           <p:cNvPr id="5" name="Hình chữ nhật 4">
             <a:extLst>
               <a:ext uri="{FF2B5EF4-FFF2-40B4-BE49-F238E27FC236}">
-                <a16:creationId xmlns:a16="http://schemas.microsoft.com/office/drawing/2014/main" id="{4B8BCEC2-6603-72EB-A635-DFEDDFB44573}"/>
+                <a16:creationId xmlns:a16="http://schemas.microsoft.com/office/drawing/2014/main" id="{FA4EBF72-3D64-2362-AD13-A45F323F582E}"/>
               </a:ext>
             </a:extLst>
           </p:cNvPr>
@@ -17963,7 +17963,7 @@
           <p:cNvPr id="6" name="Hộp Văn bản 5">
             <a:extLst>
               <a:ext uri="{FF2B5EF4-FFF2-40B4-BE49-F238E27FC236}">
-                <a16:creationId xmlns:a16="http://schemas.microsoft.com/office/drawing/2014/main" id="{D3A59C49-B4B7-2720-CD7F-B620CD0FDD34}"/>
+                <a16:creationId xmlns:a16="http://schemas.microsoft.com/office/drawing/2014/main" id="{36037CFF-9F05-B7D3-E63B-CD20F31F8484}"/>
               </a:ext>
             </a:extLst>
           </p:cNvPr>
@@ -18008,7 +18008,7 @@
           <p:cNvPr id="7" name="Hộp Văn bản 6">
             <a:extLst>
               <a:ext uri="{FF2B5EF4-FFF2-40B4-BE49-F238E27FC236}">
-                <a16:creationId xmlns:a16="http://schemas.microsoft.com/office/drawing/2014/main" id="{8C907A99-E24C-E6E6-2CB9-D433FADDD046}"/>
+                <a16:creationId xmlns:a16="http://schemas.microsoft.com/office/drawing/2014/main" id="{45B1A4C7-3109-8356-404B-F006E8CA1258}"/>
               </a:ext>
             </a:extLst>
           </p:cNvPr>
@@ -18053,7 +18053,7 @@
           <p:cNvPr id="8" name="Hình chữ nhật: Góc Tròn 7">
             <a:extLst>
               <a:ext uri="{FF2B5EF4-FFF2-40B4-BE49-F238E27FC236}">
-                <a16:creationId xmlns:a16="http://schemas.microsoft.com/office/drawing/2014/main" id="{289C9A54-C829-CEBF-E7BF-BF333280A62D}"/>
+                <a16:creationId xmlns:a16="http://schemas.microsoft.com/office/drawing/2014/main" id="{57DDEB02-48FA-EA7D-4473-C19EC149C27E}"/>
               </a:ext>
             </a:extLst>
           </p:cNvPr>
@@ -18121,7 +18121,7 @@
           <p:cNvPr id="10" name="Hình ảnh 9">
             <a:extLst>
               <a:ext uri="{FF2B5EF4-FFF2-40B4-BE49-F238E27FC236}">
-                <a16:creationId xmlns:a16="http://schemas.microsoft.com/office/drawing/2014/main" id="{911FF853-216E-0F44-A84C-2665A12C400B}"/>
+                <a16:creationId xmlns:a16="http://schemas.microsoft.com/office/drawing/2014/main" id="{2EBA9092-C722-F30C-E28E-5EEEA8C26BCE}"/>
               </a:ext>
             </a:extLst>
           </p:cNvPr>
@@ -18157,7 +18157,7 @@
           <p:cNvPr id="11" name="Hộp Văn bản 10">
             <a:extLst>
               <a:ext uri="{FF2B5EF4-FFF2-40B4-BE49-F238E27FC236}">
-                <a16:creationId xmlns:a16="http://schemas.microsoft.com/office/drawing/2014/main" id="{48C53B19-5286-7268-4109-E537153FBE13}"/>
+                <a16:creationId xmlns:a16="http://schemas.microsoft.com/office/drawing/2014/main" id="{C2FECBAC-A64F-647F-9FDD-2EC98A7A977B}"/>
               </a:ext>
             </a:extLst>
           </p:cNvPr>
@@ -18202,7 +18202,7 @@
           <p:cNvPr id="12" name="Hình chữ nhật: Góc Tròn 11">
             <a:extLst>
               <a:ext uri="{FF2B5EF4-FFF2-40B4-BE49-F238E27FC236}">
-                <a16:creationId xmlns:a16="http://schemas.microsoft.com/office/drawing/2014/main" id="{A51B5285-D030-456F-F5F7-D30CF20A1952}"/>
+                <a16:creationId xmlns:a16="http://schemas.microsoft.com/office/drawing/2014/main" id="{97403E1C-A778-939B-F636-68BF64F61266}"/>
               </a:ext>
             </a:extLst>
           </p:cNvPr>
@@ -18270,7 +18270,7 @@
           <p:cNvPr id="13" name="Hình chữ nhật 12">
             <a:extLst>
               <a:ext uri="{FF2B5EF4-FFF2-40B4-BE49-F238E27FC236}">
-                <a16:creationId xmlns:a16="http://schemas.microsoft.com/office/drawing/2014/main" id="{58E21AB0-9C02-6F83-7DB1-E21E08FC724B}"/>
+                <a16:creationId xmlns:a16="http://schemas.microsoft.com/office/drawing/2014/main" id="{7D9FCCD1-3473-0098-59ED-856EFDC9DEF0}"/>
               </a:ext>
             </a:extLst>
           </p:cNvPr>
@@ -18338,7 +18338,7 @@
           <p:cNvPr id="14" name="Hộp Văn bản 13">
             <a:extLst>
               <a:ext uri="{FF2B5EF4-FFF2-40B4-BE49-F238E27FC236}">
-                <a16:creationId xmlns:a16="http://schemas.microsoft.com/office/drawing/2014/main" id="{43032CCE-592C-136D-E493-C9F2B2CB4D4C}"/>
+                <a16:creationId xmlns:a16="http://schemas.microsoft.com/office/drawing/2014/main" id="{5E37DA90-6B8D-87EE-4F99-84E357F1B6B1}"/>
               </a:ext>
             </a:extLst>
           </p:cNvPr>
@@ -18383,7 +18383,7 @@
           <p:cNvPr id="15" name="Hộp Văn bản 14">
             <a:extLst>
               <a:ext uri="{FF2B5EF4-FFF2-40B4-BE49-F238E27FC236}">
-                <a16:creationId xmlns:a16="http://schemas.microsoft.com/office/drawing/2014/main" id="{4C4530AA-EFD2-57C6-1C4D-0FCED727E757}"/>
+                <a16:creationId xmlns:a16="http://schemas.microsoft.com/office/drawing/2014/main" id="{67CFB4BB-EBAD-ED6F-A2D3-7E505E30497A}"/>
               </a:ext>
             </a:extLst>
           </p:cNvPr>
@@ -18428,7 +18428,7 @@
           <p:cNvPr id="16" name="Hình chữ nhật: Góc Tròn 15">
             <a:extLst>
               <a:ext uri="{FF2B5EF4-FFF2-40B4-BE49-F238E27FC236}">
-                <a16:creationId xmlns:a16="http://schemas.microsoft.com/office/drawing/2014/main" id="{7B39C9FB-2366-0D67-D535-0BDACD5858BC}"/>
+                <a16:creationId xmlns:a16="http://schemas.microsoft.com/office/drawing/2014/main" id="{92185ECC-3A7E-A928-98CF-049A29FC4741}"/>
               </a:ext>
             </a:extLst>
           </p:cNvPr>
@@ -18496,7 +18496,7 @@
           <p:cNvPr id="17" name="Hình chữ nhật 16">
             <a:extLst>
               <a:ext uri="{FF2B5EF4-FFF2-40B4-BE49-F238E27FC236}">
-                <a16:creationId xmlns:a16="http://schemas.microsoft.com/office/drawing/2014/main" id="{DA609024-CA41-F164-95AB-34364564F645}"/>
+                <a16:creationId xmlns:a16="http://schemas.microsoft.com/office/drawing/2014/main" id="{F746949E-1B7D-C755-2C05-3A1F869E582C}"/>
               </a:ext>
             </a:extLst>
           </p:cNvPr>
@@ -18564,7 +18564,7 @@
           <p:cNvPr id="18" name="Hộp Văn bản 17">
             <a:extLst>
               <a:ext uri="{FF2B5EF4-FFF2-40B4-BE49-F238E27FC236}">
-                <a16:creationId xmlns:a16="http://schemas.microsoft.com/office/drawing/2014/main" id="{842B1EC0-3EAD-8CBC-4EBC-453B985286FA}"/>
+                <a16:creationId xmlns:a16="http://schemas.microsoft.com/office/drawing/2014/main" id="{33B9E50D-D442-E909-C641-B7041A723CF7}"/>
               </a:ext>
             </a:extLst>
           </p:cNvPr>
@@ -18609,7 +18609,7 @@
           <p:cNvPr id="19" name="Hộp Văn bản 18">
             <a:extLst>
               <a:ext uri="{FF2B5EF4-FFF2-40B4-BE49-F238E27FC236}">
-                <a16:creationId xmlns:a16="http://schemas.microsoft.com/office/drawing/2014/main" id="{22107760-D0EE-AD7B-B0B2-D24DEC885903}"/>
+                <a16:creationId xmlns:a16="http://schemas.microsoft.com/office/drawing/2014/main" id="{96168028-8062-415F-355E-953F0D397B1A}"/>
               </a:ext>
             </a:extLst>
           </p:cNvPr>
@@ -18654,7 +18654,7 @@
           <p:cNvPr id="20" name="Hình chữ nhật: Góc Tròn 19">
             <a:extLst>
               <a:ext uri="{FF2B5EF4-FFF2-40B4-BE49-F238E27FC236}">
-                <a16:creationId xmlns:a16="http://schemas.microsoft.com/office/drawing/2014/main" id="{6AEB1E31-DA96-8074-DDF0-A1F728200614}"/>
+                <a16:creationId xmlns:a16="http://schemas.microsoft.com/office/drawing/2014/main" id="{29F60DF5-B8A4-3E64-8FB5-74D3AC571AA4}"/>
               </a:ext>
             </a:extLst>
           </p:cNvPr>
@@ -18722,7 +18722,7 @@
           <p:cNvPr id="21" name="Hình chữ nhật 20">
             <a:extLst>
               <a:ext uri="{FF2B5EF4-FFF2-40B4-BE49-F238E27FC236}">
-                <a16:creationId xmlns:a16="http://schemas.microsoft.com/office/drawing/2014/main" id="{968FBADE-2AA1-C52A-9C24-8280FC5631D7}"/>
+                <a16:creationId xmlns:a16="http://schemas.microsoft.com/office/drawing/2014/main" id="{DD030190-AB64-DD45-9683-2DA4EAAB20E2}"/>
               </a:ext>
             </a:extLst>
           </p:cNvPr>
@@ -18790,7 +18790,7 @@
           <p:cNvPr id="22" name="Hộp Văn bản 21">
             <a:extLst>
               <a:ext uri="{FF2B5EF4-FFF2-40B4-BE49-F238E27FC236}">
-                <a16:creationId xmlns:a16="http://schemas.microsoft.com/office/drawing/2014/main" id="{40D42B57-70C0-1D26-A515-8444D6F3000E}"/>
+                <a16:creationId xmlns:a16="http://schemas.microsoft.com/office/drawing/2014/main" id="{11B7CF4B-A141-483B-F094-7D49DC257FEB}"/>
               </a:ext>
             </a:extLst>
           </p:cNvPr>
@@ -18835,7 +18835,7 @@
           <p:cNvPr id="23" name="Hộp Văn bản 22">
             <a:extLst>
               <a:ext uri="{FF2B5EF4-FFF2-40B4-BE49-F238E27FC236}">
-                <a16:creationId xmlns:a16="http://schemas.microsoft.com/office/drawing/2014/main" id="{56CB24CB-BAB3-FC5E-0515-95F1EACF9BB3}"/>
+                <a16:creationId xmlns:a16="http://schemas.microsoft.com/office/drawing/2014/main" id="{CE936B43-972F-419B-E674-9BC49A456C4E}"/>
               </a:ext>
             </a:extLst>
           </p:cNvPr>
@@ -18878,7 +18878,7 @@
     </p:spTree>
     <p:extLst>
       <p:ext uri="{BB962C8B-B14F-4D97-AF65-F5344CB8AC3E}">
-        <p14:creationId xmlns:p14="http://schemas.microsoft.com/office/powerpoint/2010/main" val="1533614823"/>
+        <p14:creationId xmlns:p14="http://schemas.microsoft.com/office/powerpoint/2010/main" val="158259325"/>
       </p:ext>
     </p:extLst>
   </p:cSld>
@@ -18910,7 +18910,7 @@
           <p:cNvPr id="2" name="Hộp Văn bản 1">
             <a:extLst>
               <a:ext uri="{FF2B5EF4-FFF2-40B4-BE49-F238E27FC236}">
-                <a16:creationId xmlns:a16="http://schemas.microsoft.com/office/drawing/2014/main" id="{C617FF31-040F-33FD-5BAB-F042542FFF9C}"/>
+                <a16:creationId xmlns:a16="http://schemas.microsoft.com/office/drawing/2014/main" id="{A1D398F9-5B55-9881-B7B8-A6227201C356}"/>
               </a:ext>
             </a:extLst>
           </p:cNvPr>
@@ -18955,7 +18955,7 @@
           <p:cNvPr id="3" name="Hộp Văn bản 2">
             <a:extLst>
               <a:ext uri="{FF2B5EF4-FFF2-40B4-BE49-F238E27FC236}">
-                <a16:creationId xmlns:a16="http://schemas.microsoft.com/office/drawing/2014/main" id="{2BB02636-8CC6-E6CA-FCEA-02E53AA65B35}"/>
+                <a16:creationId xmlns:a16="http://schemas.microsoft.com/office/drawing/2014/main" id="{FE5BACF7-F7F1-2BA1-AAC4-60A75792CA4F}"/>
               </a:ext>
             </a:extLst>
           </p:cNvPr>
@@ -19000,7 +19000,7 @@
           <p:cNvPr id="4" name="Hộp Văn bản 3">
             <a:extLst>
               <a:ext uri="{FF2B5EF4-FFF2-40B4-BE49-F238E27FC236}">
-                <a16:creationId xmlns:a16="http://schemas.microsoft.com/office/drawing/2014/main" id="{CDEB1B97-B949-ADF2-0024-5AAEB1BE7562}"/>
+                <a16:creationId xmlns:a16="http://schemas.microsoft.com/office/drawing/2014/main" id="{626A0551-D848-DCFB-BB24-7A5C779B214F}"/>
               </a:ext>
             </a:extLst>
           </p:cNvPr>
@@ -19045,7 +19045,7 @@
           <p:cNvPr id="5" name="Hình chữ nhật 4">
             <a:extLst>
               <a:ext uri="{FF2B5EF4-FFF2-40B4-BE49-F238E27FC236}">
-                <a16:creationId xmlns:a16="http://schemas.microsoft.com/office/drawing/2014/main" id="{B11405FA-3BF9-F431-85B2-AC55E3FF6230}"/>
+                <a16:creationId xmlns:a16="http://schemas.microsoft.com/office/drawing/2014/main" id="{747FF3B4-8B74-F442-BDD6-098A6D345A18}"/>
               </a:ext>
             </a:extLst>
           </p:cNvPr>
@@ -19113,7 +19113,7 @@
           <p:cNvPr id="6" name="Hộp Văn bản 5">
             <a:extLst>
               <a:ext uri="{FF2B5EF4-FFF2-40B4-BE49-F238E27FC236}">
-                <a16:creationId xmlns:a16="http://schemas.microsoft.com/office/drawing/2014/main" id="{A258E1AB-EEE5-8437-C591-C63577451A0E}"/>
+                <a16:creationId xmlns:a16="http://schemas.microsoft.com/office/drawing/2014/main" id="{DDE3107A-950E-5DF4-2F27-79DF88D43401}"/>
               </a:ext>
             </a:extLst>
           </p:cNvPr>
@@ -19158,7 +19158,7 @@
           <p:cNvPr id="7" name="Hộp Văn bản 6">
             <a:extLst>
               <a:ext uri="{FF2B5EF4-FFF2-40B4-BE49-F238E27FC236}">
-                <a16:creationId xmlns:a16="http://schemas.microsoft.com/office/drawing/2014/main" id="{E2ADC6ED-C6A0-11AC-BBE0-3D2BE54D3658}"/>
+                <a16:creationId xmlns:a16="http://schemas.microsoft.com/office/drawing/2014/main" id="{DCC84395-7A9E-F086-CE39-49FE089E0666}"/>
               </a:ext>
             </a:extLst>
           </p:cNvPr>
@@ -19203,7 +19203,7 @@
           <p:cNvPr id="8" name="Hình chữ nhật: Góc Tròn 7">
             <a:extLst>
               <a:ext uri="{FF2B5EF4-FFF2-40B4-BE49-F238E27FC236}">
-                <a16:creationId xmlns:a16="http://schemas.microsoft.com/office/drawing/2014/main" id="{92B3D505-6640-5E61-966D-DCD846ACD219}"/>
+                <a16:creationId xmlns:a16="http://schemas.microsoft.com/office/drawing/2014/main" id="{D7559A00-39BD-3810-F2ED-A6A844E217C3}"/>
               </a:ext>
             </a:extLst>
           </p:cNvPr>
@@ -19271,7 +19271,7 @@
           <p:cNvPr id="10" name="Hình ảnh 9">
             <a:extLst>
               <a:ext uri="{FF2B5EF4-FFF2-40B4-BE49-F238E27FC236}">
-                <a16:creationId xmlns:a16="http://schemas.microsoft.com/office/drawing/2014/main" id="{5CF27686-C095-59B4-CD1D-206D311C0C75}"/>
+                <a16:creationId xmlns:a16="http://schemas.microsoft.com/office/drawing/2014/main" id="{ABF20624-EDD5-094C-1472-A0DA9D50F048}"/>
               </a:ext>
             </a:extLst>
           </p:cNvPr>
@@ -19307,7 +19307,7 @@
           <p:cNvPr id="11" name="Hộp Văn bản 10">
             <a:extLst>
               <a:ext uri="{FF2B5EF4-FFF2-40B4-BE49-F238E27FC236}">
-                <a16:creationId xmlns:a16="http://schemas.microsoft.com/office/drawing/2014/main" id="{83E9CC5C-CEAD-E84B-E647-A4B4B25514FA}"/>
+                <a16:creationId xmlns:a16="http://schemas.microsoft.com/office/drawing/2014/main" id="{78FFD51C-612F-8D94-FFE7-B975F3DA9079}"/>
               </a:ext>
             </a:extLst>
           </p:cNvPr>
@@ -19352,7 +19352,7 @@
           <p:cNvPr id="12" name="Hình chữ nhật: Góc Tròn 11">
             <a:extLst>
               <a:ext uri="{FF2B5EF4-FFF2-40B4-BE49-F238E27FC236}">
-                <a16:creationId xmlns:a16="http://schemas.microsoft.com/office/drawing/2014/main" id="{E00BAE3F-2849-5863-E983-BA537A84ED57}"/>
+                <a16:creationId xmlns:a16="http://schemas.microsoft.com/office/drawing/2014/main" id="{C2F6C308-60C9-83F9-3642-76CEF8554767}"/>
               </a:ext>
             </a:extLst>
           </p:cNvPr>
@@ -19420,7 +19420,7 @@
           <p:cNvPr id="13" name="Hình chữ nhật: Góc Tròn 12">
             <a:extLst>
               <a:ext uri="{FF2B5EF4-FFF2-40B4-BE49-F238E27FC236}">
-                <a16:creationId xmlns:a16="http://schemas.microsoft.com/office/drawing/2014/main" id="{A74D608E-8C12-53A8-9585-D58AC0EAB404}"/>
+                <a16:creationId xmlns:a16="http://schemas.microsoft.com/office/drawing/2014/main" id="{86728072-987E-343A-CC47-7FF236941891}"/>
               </a:ext>
             </a:extLst>
           </p:cNvPr>
@@ -19488,7 +19488,7 @@
           <p:cNvPr id="14" name="Hộp Văn bản 13">
             <a:extLst>
               <a:ext uri="{FF2B5EF4-FFF2-40B4-BE49-F238E27FC236}">
-                <a16:creationId xmlns:a16="http://schemas.microsoft.com/office/drawing/2014/main" id="{ABBB02AF-C8DC-71AB-DD12-C9C75AADEDB3}"/>
+                <a16:creationId xmlns:a16="http://schemas.microsoft.com/office/drawing/2014/main" id="{3590291E-CEAC-8DBE-67B5-9485828898AD}"/>
               </a:ext>
             </a:extLst>
           </p:cNvPr>
@@ -19533,7 +19533,7 @@
           <p:cNvPr id="15" name="Hộp Văn bản 14">
             <a:extLst>
               <a:ext uri="{FF2B5EF4-FFF2-40B4-BE49-F238E27FC236}">
-                <a16:creationId xmlns:a16="http://schemas.microsoft.com/office/drawing/2014/main" id="{0B7DFBC7-B8C1-BFA7-A4EB-3484A9D9F8E9}"/>
+                <a16:creationId xmlns:a16="http://schemas.microsoft.com/office/drawing/2014/main" id="{D3972250-9357-2FCB-6135-056A38C70693}"/>
               </a:ext>
             </a:extLst>
           </p:cNvPr>
@@ -19685,7 +19685,7 @@
     </p:spTree>
     <p:extLst>
       <p:ext uri="{BB962C8B-B14F-4D97-AF65-F5344CB8AC3E}">
-        <p14:creationId xmlns:p14="http://schemas.microsoft.com/office/powerpoint/2010/main" val="463461378"/>
+        <p14:creationId xmlns:p14="http://schemas.microsoft.com/office/powerpoint/2010/main" val="1555902049"/>
       </p:ext>
     </p:extLst>
   </p:cSld>

</xml_diff>